<commit_message>
fixes and template improvements
</commit_message>
<xml_diff>
--- a/_extensions/IDV-Share/quarto-presentation-templates/reference/IDV-template.pptx
+++ b/_extensions/IDV-Share/quarto-presentation-templates/reference/IDV-template.pptx
@@ -125,6 +125,9 @@
         </p15:guide>
       </p15:sldGuideLst>
     </p:ext>
+    <p:ext uri="{2D200454-40CA-4A62-9FC3-DE9A4176ACB9}">
+      <p15:notesGuideLst xmlns:p15="http://schemas.microsoft.com/office/powerpoint/2012/main"/>
+    </p:ext>
   </p:extLst>
 </p:presentation>
 </file>
@@ -211,7 +214,7 @@
           <a:p>
             <a:fld id="{0F9C1CCF-B725-44A7-AA57-5E433BD85C9F}" type="datetimeFigureOut">
               <a:rPr lang="en-US" smtClean="0"/>
-              <a:t>2/7/2026</a:t>
+              <a:t>2/8/26</a:t>
             </a:fld>
             <a:endParaRPr lang="en-US"/>
           </a:p>
@@ -899,7 +902,7 @@
           <a:p>
             <a:fld id="{241EB5C9-1307-BA42-ABA2-0BC069CD8E7F}" type="datetimeFigureOut">
               <a:rPr lang="en-US" smtClean="0"/>
-              <a:t>2/7/2026</a:t>
+              <a:t>2/8/26</a:t>
             </a:fld>
             <a:endParaRPr lang="en-US"/>
           </a:p>
@@ -1097,7 +1100,7 @@
           <a:p>
             <a:fld id="{241EB5C9-1307-BA42-ABA2-0BC069CD8E7F}" type="datetimeFigureOut">
               <a:rPr lang="en-US" smtClean="0"/>
-              <a:t>2/7/2026</a:t>
+              <a:t>2/8/26</a:t>
             </a:fld>
             <a:endParaRPr lang="en-US"/>
           </a:p>
@@ -1420,7 +1423,7 @@
           </a:lstStyle>
           <a:p>
             <a:r>
-              <a:rPr lang="en-US"/>
+              <a:rPr lang="en-US" dirty="0"/>
               <a:t>Click to edit Master title style</a:t>
             </a:r>
           </a:p>
@@ -1448,19 +1451,19 @@
           </a:bodyPr>
           <a:lstStyle>
             <a:lvl1pPr>
-              <a:defRPr sz="2000"/>
+              <a:defRPr sz="1600"/>
             </a:lvl1pPr>
             <a:lvl2pPr>
-              <a:defRPr sz="2000"/>
+              <a:defRPr sz="1600"/>
             </a:lvl2pPr>
             <a:lvl3pPr>
-              <a:defRPr sz="1600"/>
+              <a:defRPr sz="1200"/>
             </a:lvl3pPr>
             <a:lvl4pPr>
-              <a:defRPr sz="1400"/>
+              <a:defRPr sz="1100"/>
             </a:lvl4pPr>
             <a:lvl5pPr>
-              <a:defRPr sz="1400"/>
+              <a:defRPr sz="1100"/>
             </a:lvl5pPr>
             <a:lvl6pPr>
               <a:defRPr sz="1500"/>
@@ -1571,7 +1574,7 @@
           <a:p>
             <a:pPr lvl="0"/>
             <a:r>
-              <a:rPr lang="en-US"/>
+              <a:rPr lang="en-US" dirty="0"/>
               <a:t>Click to edit Master text styles</a:t>
             </a:r>
           </a:p>
@@ -1605,7 +1608,7 @@
           <a:p>
             <a:fld id="{241EB5C9-1307-BA42-ABA2-0BC069CD8E7F}" type="datetimeFigureOut">
               <a:rPr lang="en-US" smtClean="0"/>
-              <a:t>2/7/2026</a:t>
+              <a:t>2/8/26</a:t>
             </a:fld>
             <a:endParaRPr lang="en-US"/>
           </a:p>
@@ -1928,7 +1931,7 @@
           </a:lstStyle>
           <a:p>
             <a:r>
-              <a:rPr lang="en-US"/>
+              <a:rPr lang="en-US" dirty="0"/>
               <a:t>Click to edit Master title style</a:t>
             </a:r>
           </a:p>
@@ -2012,11 +2015,13 @@
           </a:xfrm>
         </p:spPr>
         <p:txBody>
-          <a:bodyPr/>
+          <a:bodyPr>
+            <a:normAutofit/>
+          </a:bodyPr>
           <a:lstStyle>
             <a:lvl1pPr marL="0" indent="0">
               <a:buNone/>
-              <a:defRPr sz="1050"/>
+              <a:defRPr sz="800"/>
             </a:lvl1pPr>
             <a:lvl2pPr marL="342900" indent="0">
               <a:buNone/>
@@ -2054,7 +2059,7 @@
           <a:p>
             <a:pPr lvl="0"/>
             <a:r>
-              <a:rPr lang="en-US"/>
+              <a:rPr lang="en-US" dirty="0"/>
               <a:t>Click to edit Master text styles</a:t>
             </a:r>
           </a:p>
@@ -2088,7 +2093,7 @@
           <a:p>
             <a:fld id="{241EB5C9-1307-BA42-ABA2-0BC069CD8E7F}" type="datetimeFigureOut">
               <a:rPr lang="en-US" smtClean="0"/>
-              <a:t>2/7/2026</a:t>
+              <a:t>2/8/26</a:t>
             </a:fld>
             <a:endParaRPr lang="en-US"/>
           </a:p>
@@ -2500,7 +2505,7 @@
           <a:p>
             <a:fld id="{241EB5C9-1307-BA42-ABA2-0BC069CD8E7F}" type="datetimeFigureOut">
               <a:rPr lang="en-US" smtClean="0"/>
-              <a:t>2/7/2026</a:t>
+              <a:t>2/8/26</a:t>
             </a:fld>
             <a:endParaRPr lang="en-US"/>
           </a:p>
@@ -2926,7 +2931,7 @@
           <a:p>
             <a:fld id="{241EB5C9-1307-BA42-ABA2-0BC069CD8E7F}" type="datetimeFigureOut">
               <a:rPr lang="en-US" smtClean="0"/>
-              <a:t>2/7/2026</a:t>
+              <a:t>2/8/26</a:t>
             </a:fld>
             <a:endParaRPr lang="en-US"/>
           </a:p>
@@ -3412,7 +3417,7 @@
           <a:p>
             <a:fld id="{241EB5C9-1307-BA42-ABA2-0BC069CD8E7F}" type="datetimeFigureOut">
               <a:rPr lang="en-US" smtClean="0"/>
-              <a:t>2/7/2026</a:t>
+              <a:t>2/8/26</a:t>
             </a:fld>
             <a:endParaRPr lang="en-US"/>
           </a:p>
@@ -3916,7 +3921,7 @@
           <a:p>
             <a:fld id="{241EB5C9-1307-BA42-ABA2-0BC069CD8E7F}" type="datetimeFigureOut">
               <a:rPr lang="en-US" smtClean="0"/>
-              <a:t>2/7/2026</a:t>
+              <a:t>2/8/26</a:t>
             </a:fld>
             <a:endParaRPr lang="en-US"/>
           </a:p>
@@ -4406,7 +4411,7 @@
           <a:p>
             <a:fld id="{241EB5C9-1307-BA42-ABA2-0BC069CD8E7F}" type="datetimeFigureOut">
               <a:rPr lang="en-US" smtClean="0"/>
-              <a:t>2/7/2026</a:t>
+              <a:t>2/8/26</a:t>
             </a:fld>
             <a:endParaRPr lang="en-US"/>
           </a:p>
@@ -4891,7 +4896,7 @@
           <a:p>
             <a:fld id="{241EB5C9-1307-BA42-ABA2-0BC069CD8E7F}" type="datetimeFigureOut">
               <a:rPr lang="en-US" smtClean="0"/>
-              <a:t>2/7/2026</a:t>
+              <a:t>2/8/26</a:t>
             </a:fld>
             <a:endParaRPr lang="en-US"/>
           </a:p>
@@ -5485,22 +5490,24 @@
           </a:xfrm>
         </p:spPr>
         <p:txBody>
-          <a:bodyPr/>
+          <a:bodyPr>
+            <a:normAutofit/>
+          </a:bodyPr>
           <a:lstStyle>
             <a:lvl1pPr>
-              <a:defRPr sz="2100"/>
+              <a:defRPr sz="1600"/>
             </a:lvl1pPr>
             <a:lvl2pPr>
-              <a:defRPr sz="1800"/>
+              <a:defRPr sz="1200"/>
             </a:lvl2pPr>
             <a:lvl3pPr>
-              <a:defRPr sz="1500"/>
+              <a:defRPr sz="1100"/>
             </a:lvl3pPr>
             <a:lvl4pPr>
-              <a:defRPr sz="1350"/>
+              <a:defRPr sz="1050"/>
             </a:lvl4pPr>
             <a:lvl5pPr>
-              <a:defRPr sz="1350"/>
+              <a:defRPr sz="1050"/>
             </a:lvl5pPr>
             <a:lvl6pPr>
               <a:defRPr sz="1350"/>
@@ -5518,35 +5525,35 @@
           <a:p>
             <a:pPr lvl="0"/>
             <a:r>
-              <a:rPr lang="en-US"/>
+              <a:rPr lang="en-US" dirty="0"/>
               <a:t>Click to edit Master text styles</a:t>
             </a:r>
           </a:p>
           <a:p>
             <a:pPr lvl="1"/>
             <a:r>
-              <a:rPr lang="en-US"/>
+              <a:rPr lang="en-US" dirty="0"/>
               <a:t>Second level</a:t>
             </a:r>
           </a:p>
           <a:p>
             <a:pPr lvl="2"/>
             <a:r>
-              <a:rPr lang="en-US"/>
+              <a:rPr lang="en-US" dirty="0"/>
               <a:t>Third level</a:t>
             </a:r>
           </a:p>
           <a:p>
             <a:pPr lvl="3"/>
             <a:r>
-              <a:rPr lang="en-US"/>
+              <a:rPr lang="en-US" dirty="0"/>
               <a:t>Fourth level</a:t>
             </a:r>
           </a:p>
           <a:p>
             <a:pPr lvl="4"/>
             <a:r>
-              <a:rPr lang="en-US"/>
+              <a:rPr lang="en-US" dirty="0"/>
               <a:t>Fifth level</a:t>
             </a:r>
           </a:p>
@@ -5569,22 +5576,24 @@
           </a:xfrm>
         </p:spPr>
         <p:txBody>
-          <a:bodyPr/>
+          <a:bodyPr>
+            <a:normAutofit/>
+          </a:bodyPr>
           <a:lstStyle>
             <a:lvl1pPr>
-              <a:defRPr sz="2100"/>
+              <a:defRPr sz="1600"/>
             </a:lvl1pPr>
             <a:lvl2pPr>
-              <a:defRPr sz="1800"/>
+              <a:defRPr sz="1200"/>
             </a:lvl2pPr>
             <a:lvl3pPr>
-              <a:defRPr sz="1500"/>
+              <a:defRPr sz="1100"/>
             </a:lvl3pPr>
             <a:lvl4pPr>
-              <a:defRPr sz="1350"/>
+              <a:defRPr sz="1050"/>
             </a:lvl4pPr>
             <a:lvl5pPr>
-              <a:defRPr sz="1350"/>
+              <a:defRPr sz="1050"/>
             </a:lvl5pPr>
             <a:lvl6pPr>
               <a:defRPr sz="1350"/>
@@ -5602,35 +5611,35 @@
           <a:p>
             <a:pPr lvl="0"/>
             <a:r>
-              <a:rPr lang="en-US"/>
+              <a:rPr lang="en-US" dirty="0"/>
               <a:t>Click to edit Master text styles</a:t>
             </a:r>
           </a:p>
           <a:p>
             <a:pPr lvl="1"/>
             <a:r>
-              <a:rPr lang="en-US"/>
+              <a:rPr lang="en-US" dirty="0"/>
               <a:t>Second level</a:t>
             </a:r>
           </a:p>
           <a:p>
             <a:pPr lvl="2"/>
             <a:r>
-              <a:rPr lang="en-US"/>
+              <a:rPr lang="en-US" dirty="0"/>
               <a:t>Third level</a:t>
             </a:r>
           </a:p>
           <a:p>
             <a:pPr lvl="3"/>
             <a:r>
-              <a:rPr lang="en-US"/>
+              <a:rPr lang="en-US" dirty="0"/>
               <a:t>Fourth level</a:t>
             </a:r>
           </a:p>
           <a:p>
             <a:pPr lvl="4"/>
             <a:r>
-              <a:rPr lang="en-US"/>
+              <a:rPr lang="en-US" dirty="0"/>
               <a:t>Fifth level</a:t>
             </a:r>
           </a:p>
@@ -5664,7 +5673,7 @@
           <a:p>
             <a:fld id="{241EB5C9-1307-BA42-ABA2-0BC069CD8E7F}" type="datetimeFigureOut">
               <a:rPr lang="en-US" smtClean="0"/>
-              <a:t>2/7/2026</a:t>
+              <a:t>2/8/26</a:t>
             </a:fld>
             <a:endParaRPr lang="en-US"/>
           </a:p>
@@ -5946,7 +5955,7 @@
 </file>
 
 <file path=ppt/slideLayouts/slideLayout8.xml><?xml version="1.0" encoding="utf-8"?>
-<p:sldLayout xmlns:a="http://schemas.openxmlformats.org/drawingml/2006/main" xmlns:r="http://schemas.openxmlformats.org/officeDocument/2006/relationships" xmlns:p="http://schemas.openxmlformats.org/presentationml/2006/main" type="twoTxTwoObj" preserve="1">
+<p:sldLayout xmlns:a="http://schemas.openxmlformats.org/drawingml/2006/main" xmlns:r="http://schemas.openxmlformats.org/officeDocument/2006/relationships" xmlns:p="http://schemas.openxmlformats.org/presentationml/2006/main" preserve="1" userDrawn="1">
   <p:cSld name="Comparison">
     <p:spTree>
       <p:nvGrpSpPr>
@@ -6018,11 +6027,13 @@
           </a:xfrm>
         </p:spPr>
         <p:txBody>
-          <a:bodyPr anchor="b"/>
+          <a:bodyPr anchor="b">
+            <a:normAutofit/>
+          </a:bodyPr>
           <a:lstStyle>
             <a:lvl1pPr marL="0" indent="0">
               <a:buNone/>
-              <a:defRPr sz="1800" b="1"/>
+              <a:defRPr sz="1600" b="1"/>
             </a:lvl1pPr>
             <a:lvl2pPr marL="342900" indent="0">
               <a:buNone/>
@@ -6060,7 +6071,7 @@
           <a:p>
             <a:pPr lvl="0"/>
             <a:r>
-              <a:rPr lang="en-US"/>
+              <a:rPr lang="en-US" dirty="0"/>
               <a:t>Click to edit Master text styles</a:t>
             </a:r>
           </a:p>
@@ -6083,22 +6094,24 @@
           </a:xfrm>
         </p:spPr>
         <p:txBody>
-          <a:bodyPr/>
+          <a:bodyPr>
+            <a:normAutofit/>
+          </a:bodyPr>
           <a:lstStyle>
             <a:lvl1pPr>
-              <a:defRPr sz="1800"/>
+              <a:defRPr sz="1400"/>
             </a:lvl1pPr>
             <a:lvl2pPr>
-              <a:defRPr sz="1500"/>
+              <a:defRPr sz="1200"/>
             </a:lvl2pPr>
             <a:lvl3pPr>
-              <a:defRPr sz="1350"/>
+              <a:defRPr sz="1100"/>
             </a:lvl3pPr>
             <a:lvl4pPr>
-              <a:defRPr sz="1200"/>
+              <a:defRPr sz="1050"/>
             </a:lvl4pPr>
             <a:lvl5pPr>
-              <a:defRPr sz="1200"/>
+              <a:defRPr sz="1050"/>
             </a:lvl5pPr>
             <a:lvl6pPr>
               <a:defRPr sz="1200"/>
@@ -6116,35 +6129,35 @@
           <a:p>
             <a:pPr lvl="0"/>
             <a:r>
-              <a:rPr lang="en-US"/>
+              <a:rPr lang="en-US" dirty="0"/>
               <a:t>Click to edit Master text styles</a:t>
             </a:r>
           </a:p>
           <a:p>
             <a:pPr lvl="1"/>
             <a:r>
-              <a:rPr lang="en-US"/>
+              <a:rPr lang="en-US" dirty="0"/>
               <a:t>Second level</a:t>
             </a:r>
           </a:p>
           <a:p>
             <a:pPr lvl="2"/>
             <a:r>
-              <a:rPr lang="en-US"/>
+              <a:rPr lang="en-US" dirty="0"/>
               <a:t>Third level</a:t>
             </a:r>
           </a:p>
           <a:p>
             <a:pPr lvl="3"/>
             <a:r>
-              <a:rPr lang="en-US"/>
+              <a:rPr lang="en-US" dirty="0"/>
               <a:t>Fourth level</a:t>
             </a:r>
           </a:p>
           <a:p>
             <a:pPr lvl="4"/>
             <a:r>
-              <a:rPr lang="en-US"/>
+              <a:rPr lang="en-US" dirty="0"/>
               <a:t>Fifth level</a:t>
             </a:r>
           </a:p>
@@ -6167,11 +6180,13 @@
           </a:xfrm>
         </p:spPr>
         <p:txBody>
-          <a:bodyPr anchor="b"/>
+          <a:bodyPr anchor="b">
+            <a:normAutofit/>
+          </a:bodyPr>
           <a:lstStyle>
             <a:lvl1pPr marL="0" indent="0">
               <a:buNone/>
-              <a:defRPr sz="1800" b="1"/>
+              <a:defRPr sz="1600" b="1"/>
             </a:lvl1pPr>
             <a:lvl2pPr marL="342900" indent="0">
               <a:buNone/>
@@ -6209,7 +6224,7 @@
           <a:p>
             <a:pPr lvl="0"/>
             <a:r>
-              <a:rPr lang="en-US"/>
+              <a:rPr lang="en-US" dirty="0"/>
               <a:t>Click to edit Master text styles</a:t>
             </a:r>
           </a:p>
@@ -6232,22 +6247,24 @@
           </a:xfrm>
         </p:spPr>
         <p:txBody>
-          <a:bodyPr/>
+          <a:bodyPr>
+            <a:normAutofit/>
+          </a:bodyPr>
           <a:lstStyle>
             <a:lvl1pPr>
-              <a:defRPr sz="1800"/>
+              <a:defRPr sz="1400"/>
             </a:lvl1pPr>
             <a:lvl2pPr>
-              <a:defRPr sz="1500"/>
+              <a:defRPr sz="1200"/>
             </a:lvl2pPr>
             <a:lvl3pPr>
-              <a:defRPr sz="1350"/>
+              <a:defRPr sz="1100"/>
             </a:lvl3pPr>
             <a:lvl4pPr>
-              <a:defRPr sz="1200"/>
+              <a:defRPr sz="1050"/>
             </a:lvl4pPr>
             <a:lvl5pPr>
-              <a:defRPr sz="1200"/>
+              <a:defRPr sz="1050"/>
             </a:lvl5pPr>
             <a:lvl6pPr>
               <a:defRPr sz="1200"/>
@@ -6265,35 +6282,35 @@
           <a:p>
             <a:pPr lvl="0"/>
             <a:r>
-              <a:rPr lang="en-US"/>
+              <a:rPr lang="en-US" dirty="0"/>
               <a:t>Click to edit Master text styles</a:t>
             </a:r>
           </a:p>
           <a:p>
             <a:pPr lvl="1"/>
             <a:r>
-              <a:rPr lang="en-US"/>
+              <a:rPr lang="en-US" dirty="0"/>
               <a:t>Second level</a:t>
             </a:r>
           </a:p>
           <a:p>
             <a:pPr lvl="2"/>
             <a:r>
-              <a:rPr lang="en-US"/>
+              <a:rPr lang="en-US" dirty="0"/>
               <a:t>Third level</a:t>
             </a:r>
           </a:p>
           <a:p>
             <a:pPr lvl="3"/>
             <a:r>
-              <a:rPr lang="en-US"/>
+              <a:rPr lang="en-US" dirty="0"/>
               <a:t>Fourth level</a:t>
             </a:r>
           </a:p>
           <a:p>
             <a:pPr lvl="4"/>
             <a:r>
-              <a:rPr lang="en-US"/>
+              <a:rPr lang="en-US" dirty="0"/>
               <a:t>Fifth level</a:t>
             </a:r>
           </a:p>
@@ -6327,7 +6344,7 @@
           <a:p>
             <a:fld id="{241EB5C9-1307-BA42-ABA2-0BC069CD8E7F}" type="datetimeFigureOut">
               <a:rPr lang="en-US" smtClean="0"/>
-              <a:t>2/7/2026</a:t>
+              <a:t>2/8/26</a:t>
             </a:fld>
             <a:endParaRPr lang="en-US"/>
           </a:p>
@@ -6692,7 +6709,7 @@
           <a:p>
             <a:fld id="{241EB5C9-1307-BA42-ABA2-0BC069CD8E7F}" type="datetimeFigureOut">
               <a:rPr lang="en-US" smtClean="0"/>
-              <a:t>2/7/2026</a:t>
+              <a:t>2/8/26</a:t>
             </a:fld>
             <a:endParaRPr lang="en-US"/>
           </a:p>
@@ -7123,7 +7140,7 @@
           <a:p>
             <a:fld id="{241EB5C9-1307-BA42-ABA2-0BC069CD8E7F}" type="datetimeFigureOut">
               <a:rPr lang="en-US" smtClean="0"/>
-              <a:t>2/7/2026</a:t>
+              <a:t>2/8/26</a:t>
             </a:fld>
             <a:endParaRPr lang="en-US"/>
           </a:p>
@@ -7255,7 +7272,7 @@
         </a:spcBef>
         <a:buFont typeface="Arial"/>
         <a:buChar char="•"/>
-        <a:defRPr sz="2000" kern="1200">
+        <a:defRPr sz="1600" kern="1200">
           <a:solidFill>
             <a:schemeClr val="tx1"/>
           </a:solidFill>
@@ -7270,7 +7287,7 @@
         </a:spcBef>
         <a:buFont typeface="Arial"/>
         <a:buChar char="–"/>
-        <a:defRPr sz="2000" kern="1200">
+        <a:defRPr sz="1600" kern="1200">
           <a:solidFill>
             <a:schemeClr val="tx1"/>
           </a:solidFill>
@@ -7285,7 +7302,7 @@
         </a:spcBef>
         <a:buFont typeface="Arial"/>
         <a:buChar char="•"/>
-        <a:defRPr sz="1600" kern="1200">
+        <a:defRPr sz="1200" kern="1200">
           <a:solidFill>
             <a:schemeClr val="tx1"/>
           </a:solidFill>
@@ -7300,7 +7317,7 @@
         </a:spcBef>
         <a:buFont typeface="Arial"/>
         <a:buChar char="–"/>
-        <a:defRPr sz="1400" kern="1200">
+        <a:defRPr sz="1100" kern="1200">
           <a:solidFill>
             <a:schemeClr val="tx1"/>
           </a:solidFill>
@@ -7315,7 +7332,7 @@
         </a:spcBef>
         <a:buFont typeface="Arial"/>
         <a:buChar char="»"/>
-        <a:defRPr sz="1400" kern="1200">
+        <a:defRPr sz="1100" kern="1200">
           <a:solidFill>
             <a:schemeClr val="tx1"/>
           </a:solidFill>
@@ -7617,11 +7634,7 @@
             </a:pPr>
             <a:r>
               <a:rPr lang="en-US" dirty="0"/>
-              <a:t>Hello</a:t>
-            </a:r>
-            <a:r>
-              <a:rPr lang="en-US"/>
-              <a:t>, world.</a:t>
+              <a:t>Hello, world.</a:t>
             </a:r>
           </a:p>
         </p:txBody>
@@ -7698,7 +7711,7 @@
           <a:bodyPr/>
           <a:lstStyle/>
           <a:p>
-            <a:endParaRPr lang="en-US"/>
+            <a:endParaRPr lang="en-US" dirty="0"/>
           </a:p>
         </p:txBody>
       </p:sp>
@@ -8137,6 +8150,19 @@
         </a:fontRef>
       </a:style>
     </a:lnDef>
+    <a:txDef>
+      <a:spPr>
+        <a:noFill/>
+      </a:spPr>
+      <a:bodyPr wrap="square" rtlCol="0">
+        <a:spAutoFit/>
+      </a:bodyPr>
+      <a:lstStyle>
+        <a:defPPr algn="l">
+          <a:defRPr sz="900" dirty="0"/>
+        </a:defPPr>
+      </a:lstStyle>
+    </a:txDef>
   </a:objectDefaults>
   <a:extraClrSchemeLst/>
 </a:theme>

</xml_diff>

<commit_message>
added page numbering and date in pptx reference file
</commit_message>
<xml_diff>
--- a/_extensions/IDV-Share/quarto-presentation-templates/reference/IDV-template.pptx
+++ b/_extensions/IDV-Share/quarto-presentation-templates/reference/IDV-template.pptx
@@ -900,9 +900,9 @@
           <a:bodyPr/>
           <a:lstStyle/>
           <a:p>
-            <a:fld id="{241EB5C9-1307-BA42-ABA2-0BC069CD8E7F}" type="datetimeFigureOut">
-              <a:rPr lang="en-US" smtClean="0"/>
-              <a:t>2/8/26</a:t>
+            <a:fld id="{2D7DBF7F-F54F-1C49-8F76-19ACADAD9270}" type="datetime1">
+              <a:rPr lang="it-IT" smtClean="0"/>
+              <a:t>08/02/26</a:t>
             </a:fld>
             <a:endParaRPr lang="en-US"/>
           </a:p>
@@ -1098,9 +1098,9 @@
           <a:bodyPr/>
           <a:lstStyle/>
           <a:p>
-            <a:fld id="{241EB5C9-1307-BA42-ABA2-0BC069CD8E7F}" type="datetimeFigureOut">
-              <a:rPr lang="en-US" smtClean="0"/>
-              <a:t>2/8/26</a:t>
+            <a:fld id="{85454C68-2B9C-2243-9426-8AA164CE3511}" type="datetime1">
+              <a:rPr lang="it-IT" smtClean="0"/>
+              <a:t>08/02/26</a:t>
             </a:fld>
             <a:endParaRPr lang="en-US"/>
           </a:p>
@@ -1368,6 +1368,75 @@
           </a:prstGeom>
         </p:spPr>
       </p:pic>
+      <p:sp>
+        <p:nvSpPr>
+          <p:cNvPr id="2" name="TextBox 1">
+            <a:extLst>
+              <a:ext uri="{FF2B5EF4-FFF2-40B4-BE49-F238E27FC236}">
+                <a16:creationId xmlns:a16="http://schemas.microsoft.com/office/drawing/2014/main" id="{5ECDEA0F-CD3F-E988-8F7E-CF36959BCCB4}"/>
+              </a:ext>
+            </a:extLst>
+          </p:cNvPr>
+          <p:cNvSpPr txBox="1"/>
+          <p:nvPr userDrawn="1"/>
+        </p:nvSpPr>
+        <p:spPr>
+          <a:xfrm>
+            <a:off x="1499801" y="5009681"/>
+            <a:ext cx="6144397" cy="184666"/>
+          </a:xfrm>
+          <a:prstGeom prst="rect">
+            <a:avLst/>
+          </a:prstGeom>
+          <a:noFill/>
+        </p:spPr>
+        <p:txBody>
+          <a:bodyPr wrap="square">
+            <a:spAutoFit/>
+          </a:bodyPr>
+          <a:lstStyle/>
+          <a:p>
+            <a:pPr algn="ctr"/>
+            <a:r>
+              <a:rPr lang="en-US" sz="600" spc="-10" baseline="0" dirty="0">
+                <a:solidFill>
+                  <a:srgbClr val="929292"/>
+                </a:solidFill>
+                <a:latin typeface="Arial" panose="020B0604020202020204" pitchFamily="34" charset="0"/>
+                <a:cs typeface="Arial" panose="020B0604020202020204" pitchFamily="34" charset="0"/>
+              </a:rPr>
+              <a:t>Contains confidential proprietary and trade secrets information of IVECO </a:t>
+            </a:r>
+            <a:r>
+              <a:rPr lang="en-US" sz="600" spc="-10" baseline="0" dirty="0" err="1">
+                <a:solidFill>
+                  <a:srgbClr val="929292"/>
+                </a:solidFill>
+                <a:latin typeface="Arial" panose="020B0604020202020204" pitchFamily="34" charset="0"/>
+                <a:cs typeface="Arial" panose="020B0604020202020204" pitchFamily="34" charset="0"/>
+              </a:rPr>
+              <a:t>Defence</a:t>
+            </a:r>
+            <a:r>
+              <a:rPr lang="en-US" sz="600" spc="-10" baseline="0" dirty="0">
+                <a:solidFill>
+                  <a:srgbClr val="929292"/>
+                </a:solidFill>
+                <a:latin typeface="Arial" panose="020B0604020202020204" pitchFamily="34" charset="0"/>
+                <a:cs typeface="Arial" panose="020B0604020202020204" pitchFamily="34" charset="0"/>
+              </a:rPr>
+              <a:t> Vehicles. Any use of this work without express written consent is strictly prohibited.</a:t>
+            </a:r>
+            <a:endParaRPr lang="it-IT" sz="600" spc="-10" baseline="0" dirty="0">
+              <a:solidFill>
+                <a:srgbClr val="929292"/>
+              </a:solidFill>
+              <a:latin typeface="Arial" panose="020B0604020202020204" pitchFamily="34" charset="0"/>
+              <a:cs typeface="Arial" panose="020B0604020202020204" pitchFamily="34" charset="0"/>
+            </a:endParaRPr>
+          </a:p>
+        </p:txBody>
+      </p:sp>
     </p:spTree>
     <p:extLst>
       <p:ext uri="{BB962C8B-B14F-4D97-AF65-F5344CB8AC3E}">
@@ -1606,9 +1675,9 @@
           <a:bodyPr/>
           <a:lstStyle/>
           <a:p>
-            <a:fld id="{241EB5C9-1307-BA42-ABA2-0BC069CD8E7F}" type="datetimeFigureOut">
-              <a:rPr lang="en-US" smtClean="0"/>
-              <a:t>2/8/26</a:t>
+            <a:fld id="{D6CE0B0B-E3C5-EF4A-87B2-86DF446F39DB}" type="datetime1">
+              <a:rPr lang="it-IT" smtClean="0"/>
+              <a:t>08/02/26</a:t>
             </a:fld>
             <a:endParaRPr lang="en-US"/>
           </a:p>
@@ -1876,6 +1945,75 @@
           </a:prstGeom>
         </p:spPr>
       </p:pic>
+      <p:sp>
+        <p:nvSpPr>
+          <p:cNvPr id="5" name="TextBox 4">
+            <a:extLst>
+              <a:ext uri="{FF2B5EF4-FFF2-40B4-BE49-F238E27FC236}">
+                <a16:creationId xmlns:a16="http://schemas.microsoft.com/office/drawing/2014/main" id="{E08D9B6F-D6D8-AE83-7546-E14BE6C2E410}"/>
+              </a:ext>
+            </a:extLst>
+          </p:cNvPr>
+          <p:cNvSpPr txBox="1"/>
+          <p:nvPr userDrawn="1"/>
+        </p:nvSpPr>
+        <p:spPr>
+          <a:xfrm>
+            <a:off x="1499801" y="5009681"/>
+            <a:ext cx="6144397" cy="184666"/>
+          </a:xfrm>
+          <a:prstGeom prst="rect">
+            <a:avLst/>
+          </a:prstGeom>
+          <a:noFill/>
+        </p:spPr>
+        <p:txBody>
+          <a:bodyPr wrap="square">
+            <a:spAutoFit/>
+          </a:bodyPr>
+          <a:lstStyle/>
+          <a:p>
+            <a:pPr algn="ctr"/>
+            <a:r>
+              <a:rPr lang="en-US" sz="600" spc="-10" baseline="0" dirty="0">
+                <a:solidFill>
+                  <a:srgbClr val="929292"/>
+                </a:solidFill>
+                <a:latin typeface="Arial" panose="020B0604020202020204" pitchFamily="34" charset="0"/>
+                <a:cs typeface="Arial" panose="020B0604020202020204" pitchFamily="34" charset="0"/>
+              </a:rPr>
+              <a:t>Contains confidential proprietary and trade secrets information of IVECO </a:t>
+            </a:r>
+            <a:r>
+              <a:rPr lang="en-US" sz="600" spc="-10" baseline="0" dirty="0" err="1">
+                <a:solidFill>
+                  <a:srgbClr val="929292"/>
+                </a:solidFill>
+                <a:latin typeface="Arial" panose="020B0604020202020204" pitchFamily="34" charset="0"/>
+                <a:cs typeface="Arial" panose="020B0604020202020204" pitchFamily="34" charset="0"/>
+              </a:rPr>
+              <a:t>Defence</a:t>
+            </a:r>
+            <a:r>
+              <a:rPr lang="en-US" sz="600" spc="-10" baseline="0" dirty="0">
+                <a:solidFill>
+                  <a:srgbClr val="929292"/>
+                </a:solidFill>
+                <a:latin typeface="Arial" panose="020B0604020202020204" pitchFamily="34" charset="0"/>
+                <a:cs typeface="Arial" panose="020B0604020202020204" pitchFamily="34" charset="0"/>
+              </a:rPr>
+              <a:t> Vehicles. Any use of this work without express written consent is strictly prohibited.</a:t>
+            </a:r>
+            <a:endParaRPr lang="it-IT" sz="600" spc="-10" baseline="0" dirty="0">
+              <a:solidFill>
+                <a:srgbClr val="929292"/>
+              </a:solidFill>
+              <a:latin typeface="Arial" panose="020B0604020202020204" pitchFamily="34" charset="0"/>
+              <a:cs typeface="Arial" panose="020B0604020202020204" pitchFamily="34" charset="0"/>
+            </a:endParaRPr>
+          </a:p>
+        </p:txBody>
+      </p:sp>
     </p:spTree>
     <p:extLst>
       <p:ext uri="{BB962C8B-B14F-4D97-AF65-F5344CB8AC3E}">
@@ -2091,9 +2229,9 @@
           <a:bodyPr/>
           <a:lstStyle/>
           <a:p>
-            <a:fld id="{241EB5C9-1307-BA42-ABA2-0BC069CD8E7F}" type="datetimeFigureOut">
-              <a:rPr lang="en-US" smtClean="0"/>
-              <a:t>2/8/26</a:t>
+            <a:fld id="{AE4AF135-7764-144C-811C-680358D4FB0C}" type="datetime1">
+              <a:rPr lang="it-IT" smtClean="0"/>
+              <a:t>08/02/26</a:t>
             </a:fld>
             <a:endParaRPr lang="en-US"/>
           </a:p>
@@ -2361,6 +2499,75 @@
           </a:prstGeom>
         </p:spPr>
       </p:pic>
+      <p:sp>
+        <p:nvSpPr>
+          <p:cNvPr id="5" name="TextBox 4">
+            <a:extLst>
+              <a:ext uri="{FF2B5EF4-FFF2-40B4-BE49-F238E27FC236}">
+                <a16:creationId xmlns:a16="http://schemas.microsoft.com/office/drawing/2014/main" id="{FDDE0A73-7F0F-1EE2-B8F1-2B2B4B0427D3}"/>
+              </a:ext>
+            </a:extLst>
+          </p:cNvPr>
+          <p:cNvSpPr txBox="1"/>
+          <p:nvPr userDrawn="1"/>
+        </p:nvSpPr>
+        <p:spPr>
+          <a:xfrm>
+            <a:off x="1499801" y="5009681"/>
+            <a:ext cx="6144397" cy="184666"/>
+          </a:xfrm>
+          <a:prstGeom prst="rect">
+            <a:avLst/>
+          </a:prstGeom>
+          <a:noFill/>
+        </p:spPr>
+        <p:txBody>
+          <a:bodyPr wrap="square">
+            <a:spAutoFit/>
+          </a:bodyPr>
+          <a:lstStyle/>
+          <a:p>
+            <a:pPr algn="ctr"/>
+            <a:r>
+              <a:rPr lang="en-US" sz="600" spc="-10" baseline="0" dirty="0">
+                <a:solidFill>
+                  <a:srgbClr val="929292"/>
+                </a:solidFill>
+                <a:latin typeface="Arial" panose="020B0604020202020204" pitchFamily="34" charset="0"/>
+                <a:cs typeface="Arial" panose="020B0604020202020204" pitchFamily="34" charset="0"/>
+              </a:rPr>
+              <a:t>Contains confidential proprietary and trade secrets information of IVECO </a:t>
+            </a:r>
+            <a:r>
+              <a:rPr lang="en-US" sz="600" spc="-10" baseline="0" dirty="0" err="1">
+                <a:solidFill>
+                  <a:srgbClr val="929292"/>
+                </a:solidFill>
+                <a:latin typeface="Arial" panose="020B0604020202020204" pitchFamily="34" charset="0"/>
+                <a:cs typeface="Arial" panose="020B0604020202020204" pitchFamily="34" charset="0"/>
+              </a:rPr>
+              <a:t>Defence</a:t>
+            </a:r>
+            <a:r>
+              <a:rPr lang="en-US" sz="600" spc="-10" baseline="0" dirty="0">
+                <a:solidFill>
+                  <a:srgbClr val="929292"/>
+                </a:solidFill>
+                <a:latin typeface="Arial" panose="020B0604020202020204" pitchFamily="34" charset="0"/>
+                <a:cs typeface="Arial" panose="020B0604020202020204" pitchFamily="34" charset="0"/>
+              </a:rPr>
+              <a:t> Vehicles. Any use of this work without express written consent is strictly prohibited.</a:t>
+            </a:r>
+            <a:endParaRPr lang="it-IT" sz="600" spc="-10" baseline="0" dirty="0">
+              <a:solidFill>
+                <a:srgbClr val="929292"/>
+              </a:solidFill>
+              <a:latin typeface="Arial" panose="020B0604020202020204" pitchFamily="34" charset="0"/>
+              <a:cs typeface="Arial" panose="020B0604020202020204" pitchFamily="34" charset="0"/>
+            </a:endParaRPr>
+          </a:p>
+        </p:txBody>
+      </p:sp>
     </p:spTree>
     <p:extLst>
       <p:ext uri="{BB962C8B-B14F-4D97-AF65-F5344CB8AC3E}">
@@ -2503,9 +2710,9 @@
           <a:bodyPr/>
           <a:lstStyle/>
           <a:p>
-            <a:fld id="{241EB5C9-1307-BA42-ABA2-0BC069CD8E7F}" type="datetimeFigureOut">
-              <a:rPr lang="en-US" smtClean="0"/>
-              <a:t>2/8/26</a:t>
+            <a:fld id="{D7720BFA-E534-EF4D-9BC9-39AC6AC2A1F1}" type="datetime1">
+              <a:rPr lang="it-IT" smtClean="0"/>
+              <a:t>08/02/26</a:t>
             </a:fld>
             <a:endParaRPr lang="en-US"/>
           </a:p>
@@ -2773,6 +2980,75 @@
           </a:prstGeom>
         </p:spPr>
       </p:pic>
+      <p:sp>
+        <p:nvSpPr>
+          <p:cNvPr id="4" name="TextBox 3">
+            <a:extLst>
+              <a:ext uri="{FF2B5EF4-FFF2-40B4-BE49-F238E27FC236}">
+                <a16:creationId xmlns:a16="http://schemas.microsoft.com/office/drawing/2014/main" id="{F1D6BA0C-FCB1-B18B-A578-8A41AB44F39E}"/>
+              </a:ext>
+            </a:extLst>
+          </p:cNvPr>
+          <p:cNvSpPr txBox="1"/>
+          <p:nvPr userDrawn="1"/>
+        </p:nvSpPr>
+        <p:spPr>
+          <a:xfrm>
+            <a:off x="1499801" y="5009681"/>
+            <a:ext cx="6144397" cy="184666"/>
+          </a:xfrm>
+          <a:prstGeom prst="rect">
+            <a:avLst/>
+          </a:prstGeom>
+          <a:noFill/>
+        </p:spPr>
+        <p:txBody>
+          <a:bodyPr wrap="square">
+            <a:spAutoFit/>
+          </a:bodyPr>
+          <a:lstStyle/>
+          <a:p>
+            <a:pPr algn="ctr"/>
+            <a:r>
+              <a:rPr lang="en-US" sz="600" spc="-10" baseline="0" dirty="0">
+                <a:solidFill>
+                  <a:srgbClr val="929292"/>
+                </a:solidFill>
+                <a:latin typeface="Arial" panose="020B0604020202020204" pitchFamily="34" charset="0"/>
+                <a:cs typeface="Arial" panose="020B0604020202020204" pitchFamily="34" charset="0"/>
+              </a:rPr>
+              <a:t>Contains confidential proprietary and trade secrets information of IVECO </a:t>
+            </a:r>
+            <a:r>
+              <a:rPr lang="en-US" sz="600" spc="-10" baseline="0" dirty="0" err="1">
+                <a:solidFill>
+                  <a:srgbClr val="929292"/>
+                </a:solidFill>
+                <a:latin typeface="Arial" panose="020B0604020202020204" pitchFamily="34" charset="0"/>
+                <a:cs typeface="Arial" panose="020B0604020202020204" pitchFamily="34" charset="0"/>
+              </a:rPr>
+              <a:t>Defence</a:t>
+            </a:r>
+            <a:r>
+              <a:rPr lang="en-US" sz="600" spc="-10" baseline="0" dirty="0">
+                <a:solidFill>
+                  <a:srgbClr val="929292"/>
+                </a:solidFill>
+                <a:latin typeface="Arial" panose="020B0604020202020204" pitchFamily="34" charset="0"/>
+                <a:cs typeface="Arial" panose="020B0604020202020204" pitchFamily="34" charset="0"/>
+              </a:rPr>
+              <a:t> Vehicles. Any use of this work without express written consent is strictly prohibited.</a:t>
+            </a:r>
+            <a:endParaRPr lang="it-IT" sz="600" spc="-10" baseline="0" dirty="0">
+              <a:solidFill>
+                <a:srgbClr val="929292"/>
+              </a:solidFill>
+              <a:latin typeface="Arial" panose="020B0604020202020204" pitchFamily="34" charset="0"/>
+              <a:cs typeface="Arial" panose="020B0604020202020204" pitchFamily="34" charset="0"/>
+            </a:endParaRPr>
+          </a:p>
+        </p:txBody>
+      </p:sp>
     </p:spTree>
     <p:extLst>
       <p:ext uri="{BB962C8B-B14F-4D97-AF65-F5344CB8AC3E}">
@@ -2929,9 +3205,9 @@
           <a:bodyPr/>
           <a:lstStyle/>
           <a:p>
-            <a:fld id="{241EB5C9-1307-BA42-ABA2-0BC069CD8E7F}" type="datetimeFigureOut">
-              <a:rPr lang="en-US" smtClean="0"/>
-              <a:t>2/8/26</a:t>
+            <a:fld id="{B20FCA3A-31A1-034E-9624-8CD1F736D4F6}" type="datetime1">
+              <a:rPr lang="it-IT" smtClean="0"/>
+              <a:t>08/02/26</a:t>
             </a:fld>
             <a:endParaRPr lang="en-US"/>
           </a:p>
@@ -3199,6 +3475,75 @@
           </a:prstGeom>
         </p:spPr>
       </p:pic>
+      <p:sp>
+        <p:nvSpPr>
+          <p:cNvPr id="4" name="TextBox 3">
+            <a:extLst>
+              <a:ext uri="{FF2B5EF4-FFF2-40B4-BE49-F238E27FC236}">
+                <a16:creationId xmlns:a16="http://schemas.microsoft.com/office/drawing/2014/main" id="{116057FF-9082-1A59-4CD5-DE9592F83772}"/>
+              </a:ext>
+            </a:extLst>
+          </p:cNvPr>
+          <p:cNvSpPr txBox="1"/>
+          <p:nvPr userDrawn="1"/>
+        </p:nvSpPr>
+        <p:spPr>
+          <a:xfrm>
+            <a:off x="1499801" y="5009681"/>
+            <a:ext cx="6144397" cy="184666"/>
+          </a:xfrm>
+          <a:prstGeom prst="rect">
+            <a:avLst/>
+          </a:prstGeom>
+          <a:noFill/>
+        </p:spPr>
+        <p:txBody>
+          <a:bodyPr wrap="square">
+            <a:spAutoFit/>
+          </a:bodyPr>
+          <a:lstStyle/>
+          <a:p>
+            <a:pPr algn="ctr"/>
+            <a:r>
+              <a:rPr lang="en-US" sz="600" spc="-10" baseline="0" dirty="0">
+                <a:solidFill>
+                  <a:srgbClr val="929292"/>
+                </a:solidFill>
+                <a:latin typeface="Arial" panose="020B0604020202020204" pitchFamily="34" charset="0"/>
+                <a:cs typeface="Arial" panose="020B0604020202020204" pitchFamily="34" charset="0"/>
+              </a:rPr>
+              <a:t>Contains confidential proprietary and trade secrets information of IVECO </a:t>
+            </a:r>
+            <a:r>
+              <a:rPr lang="en-US" sz="600" spc="-10" baseline="0" dirty="0" err="1">
+                <a:solidFill>
+                  <a:srgbClr val="929292"/>
+                </a:solidFill>
+                <a:latin typeface="Arial" panose="020B0604020202020204" pitchFamily="34" charset="0"/>
+                <a:cs typeface="Arial" panose="020B0604020202020204" pitchFamily="34" charset="0"/>
+              </a:rPr>
+              <a:t>Defence</a:t>
+            </a:r>
+            <a:r>
+              <a:rPr lang="en-US" sz="600" spc="-10" baseline="0" dirty="0">
+                <a:solidFill>
+                  <a:srgbClr val="929292"/>
+                </a:solidFill>
+                <a:latin typeface="Arial" panose="020B0604020202020204" pitchFamily="34" charset="0"/>
+                <a:cs typeface="Arial" panose="020B0604020202020204" pitchFamily="34" charset="0"/>
+              </a:rPr>
+              <a:t> Vehicles. Any use of this work without express written consent is strictly prohibited.</a:t>
+            </a:r>
+            <a:endParaRPr lang="it-IT" sz="600" spc="-10" baseline="0" dirty="0">
+              <a:solidFill>
+                <a:srgbClr val="929292"/>
+              </a:solidFill>
+              <a:latin typeface="Arial" panose="020B0604020202020204" pitchFamily="34" charset="0"/>
+              <a:cs typeface="Arial" panose="020B0604020202020204" pitchFamily="34" charset="0"/>
+            </a:endParaRPr>
+          </a:p>
+        </p:txBody>
+      </p:sp>
     </p:spTree>
     <p:extLst>
       <p:ext uri="{BB962C8B-B14F-4D97-AF65-F5344CB8AC3E}">
@@ -3415,9 +3760,9 @@
           <a:bodyPr/>
           <a:lstStyle/>
           <a:p>
-            <a:fld id="{241EB5C9-1307-BA42-ABA2-0BC069CD8E7F}" type="datetimeFigureOut">
-              <a:rPr lang="en-US" smtClean="0"/>
-              <a:t>2/8/26</a:t>
+            <a:fld id="{B5A3235C-A5F5-CE4E-B015-39F4D75EC196}" type="datetime1">
+              <a:rPr lang="it-IT" smtClean="0"/>
+              <a:t>08/02/26</a:t>
             </a:fld>
             <a:endParaRPr lang="en-US"/>
           </a:p>
@@ -3703,6 +4048,75 @@
           </a:prstGeom>
         </p:spPr>
       </p:pic>
+      <p:sp>
+        <p:nvSpPr>
+          <p:cNvPr id="12" name="TextBox 11">
+            <a:extLst>
+              <a:ext uri="{FF2B5EF4-FFF2-40B4-BE49-F238E27FC236}">
+                <a16:creationId xmlns:a16="http://schemas.microsoft.com/office/drawing/2014/main" id="{9F7F4A68-C94D-DD3E-7EA3-485F462469CC}"/>
+              </a:ext>
+            </a:extLst>
+          </p:cNvPr>
+          <p:cNvSpPr txBox="1"/>
+          <p:nvPr userDrawn="1"/>
+        </p:nvSpPr>
+        <p:spPr>
+          <a:xfrm>
+            <a:off x="1499801" y="5009681"/>
+            <a:ext cx="6144397" cy="184666"/>
+          </a:xfrm>
+          <a:prstGeom prst="rect">
+            <a:avLst/>
+          </a:prstGeom>
+          <a:noFill/>
+        </p:spPr>
+        <p:txBody>
+          <a:bodyPr wrap="square">
+            <a:spAutoFit/>
+          </a:bodyPr>
+          <a:lstStyle/>
+          <a:p>
+            <a:pPr algn="ctr"/>
+            <a:r>
+              <a:rPr lang="en-US" sz="600" spc="-10" baseline="0" dirty="0">
+                <a:solidFill>
+                  <a:srgbClr val="929292"/>
+                </a:solidFill>
+                <a:latin typeface="Arial" panose="020B0604020202020204" pitchFamily="34" charset="0"/>
+                <a:cs typeface="Arial" panose="020B0604020202020204" pitchFamily="34" charset="0"/>
+              </a:rPr>
+              <a:t>Contains confidential proprietary and trade secrets information of IVECO </a:t>
+            </a:r>
+            <a:r>
+              <a:rPr lang="en-US" sz="600" spc="-10" baseline="0" dirty="0" err="1">
+                <a:solidFill>
+                  <a:srgbClr val="929292"/>
+                </a:solidFill>
+                <a:latin typeface="Arial" panose="020B0604020202020204" pitchFamily="34" charset="0"/>
+                <a:cs typeface="Arial" panose="020B0604020202020204" pitchFamily="34" charset="0"/>
+              </a:rPr>
+              <a:t>Defence</a:t>
+            </a:r>
+            <a:r>
+              <a:rPr lang="en-US" sz="600" spc="-10" baseline="0" dirty="0">
+                <a:solidFill>
+                  <a:srgbClr val="929292"/>
+                </a:solidFill>
+                <a:latin typeface="Arial" panose="020B0604020202020204" pitchFamily="34" charset="0"/>
+                <a:cs typeface="Arial" panose="020B0604020202020204" pitchFamily="34" charset="0"/>
+              </a:rPr>
+              <a:t> Vehicles. Any use of this work without express written consent is strictly prohibited.</a:t>
+            </a:r>
+            <a:endParaRPr lang="it-IT" sz="600" spc="-10" baseline="0" dirty="0">
+              <a:solidFill>
+                <a:srgbClr val="929292"/>
+              </a:solidFill>
+              <a:latin typeface="Arial" panose="020B0604020202020204" pitchFamily="34" charset="0"/>
+              <a:cs typeface="Arial" panose="020B0604020202020204" pitchFamily="34" charset="0"/>
+            </a:endParaRPr>
+          </a:p>
+        </p:txBody>
+      </p:sp>
     </p:spTree>
     <p:extLst>
       <p:ext uri="{BB962C8B-B14F-4D97-AF65-F5344CB8AC3E}">
@@ -3919,9 +4333,9 @@
           <a:bodyPr/>
           <a:lstStyle/>
           <a:p>
-            <a:fld id="{241EB5C9-1307-BA42-ABA2-0BC069CD8E7F}" type="datetimeFigureOut">
-              <a:rPr lang="en-US" smtClean="0"/>
-              <a:t>2/8/26</a:t>
+            <a:fld id="{9FC0F10B-4FCD-A840-811B-58139C9D20D6}" type="datetime1">
+              <a:rPr lang="it-IT" smtClean="0"/>
+              <a:t>08/02/26</a:t>
             </a:fld>
             <a:endParaRPr lang="en-US"/>
           </a:p>
@@ -4228,6 +4642,75 @@
           </a:prstGeom>
         </p:spPr>
       </p:pic>
+      <p:sp>
+        <p:nvSpPr>
+          <p:cNvPr id="9" name="TextBox 8">
+            <a:extLst>
+              <a:ext uri="{FF2B5EF4-FFF2-40B4-BE49-F238E27FC236}">
+                <a16:creationId xmlns:a16="http://schemas.microsoft.com/office/drawing/2014/main" id="{B38D46BD-367F-3481-A8D8-E3AB2C324A8C}"/>
+              </a:ext>
+            </a:extLst>
+          </p:cNvPr>
+          <p:cNvSpPr txBox="1"/>
+          <p:nvPr userDrawn="1"/>
+        </p:nvSpPr>
+        <p:spPr>
+          <a:xfrm>
+            <a:off x="1499801" y="5009681"/>
+            <a:ext cx="6144397" cy="184666"/>
+          </a:xfrm>
+          <a:prstGeom prst="rect">
+            <a:avLst/>
+          </a:prstGeom>
+          <a:noFill/>
+        </p:spPr>
+        <p:txBody>
+          <a:bodyPr wrap="square">
+            <a:spAutoFit/>
+          </a:bodyPr>
+          <a:lstStyle/>
+          <a:p>
+            <a:pPr algn="ctr"/>
+            <a:r>
+              <a:rPr lang="en-US" sz="600" spc="-10" baseline="0" dirty="0">
+                <a:solidFill>
+                  <a:srgbClr val="929292"/>
+                </a:solidFill>
+                <a:latin typeface="Arial" panose="020B0604020202020204" pitchFamily="34" charset="0"/>
+                <a:cs typeface="Arial" panose="020B0604020202020204" pitchFamily="34" charset="0"/>
+              </a:rPr>
+              <a:t>Contains confidential proprietary and trade secrets information of IVECO </a:t>
+            </a:r>
+            <a:r>
+              <a:rPr lang="en-US" sz="600" spc="-10" baseline="0" dirty="0" err="1">
+                <a:solidFill>
+                  <a:srgbClr val="929292"/>
+                </a:solidFill>
+                <a:latin typeface="Arial" panose="020B0604020202020204" pitchFamily="34" charset="0"/>
+                <a:cs typeface="Arial" panose="020B0604020202020204" pitchFamily="34" charset="0"/>
+              </a:rPr>
+              <a:t>Defence</a:t>
+            </a:r>
+            <a:r>
+              <a:rPr lang="en-US" sz="600" spc="-10" baseline="0" dirty="0">
+                <a:solidFill>
+                  <a:srgbClr val="929292"/>
+                </a:solidFill>
+                <a:latin typeface="Arial" panose="020B0604020202020204" pitchFamily="34" charset="0"/>
+                <a:cs typeface="Arial" panose="020B0604020202020204" pitchFamily="34" charset="0"/>
+              </a:rPr>
+              <a:t> Vehicles. Any use of this work without express written consent is strictly prohibited.</a:t>
+            </a:r>
+            <a:endParaRPr lang="it-IT" sz="600" spc="-10" baseline="0" dirty="0">
+              <a:solidFill>
+                <a:srgbClr val="929292"/>
+              </a:solidFill>
+              <a:latin typeface="Arial" panose="020B0604020202020204" pitchFamily="34" charset="0"/>
+              <a:cs typeface="Arial" panose="020B0604020202020204" pitchFamily="34" charset="0"/>
+            </a:endParaRPr>
+          </a:p>
+        </p:txBody>
+      </p:sp>
     </p:spTree>
     <p:extLst>
       <p:ext uri="{BB962C8B-B14F-4D97-AF65-F5344CB8AC3E}">
@@ -4409,9 +4892,9 @@
           <a:bodyPr/>
           <a:lstStyle/>
           <a:p>
-            <a:fld id="{241EB5C9-1307-BA42-ABA2-0BC069CD8E7F}" type="datetimeFigureOut">
-              <a:rPr lang="en-US" smtClean="0"/>
-              <a:t>2/8/26</a:t>
+            <a:fld id="{88C27D80-F3A7-A741-A1BF-A0356AB69374}" type="datetime1">
+              <a:rPr lang="it-IT" smtClean="0"/>
+              <a:t>08/02/26</a:t>
             </a:fld>
             <a:endParaRPr lang="en-US"/>
           </a:p>
@@ -4697,6 +5180,75 @@
           </a:prstGeom>
         </p:spPr>
       </p:pic>
+      <p:sp>
+        <p:nvSpPr>
+          <p:cNvPr id="7" name="TextBox 6">
+            <a:extLst>
+              <a:ext uri="{FF2B5EF4-FFF2-40B4-BE49-F238E27FC236}">
+                <a16:creationId xmlns:a16="http://schemas.microsoft.com/office/drawing/2014/main" id="{DC0F4838-F6BF-C30B-C410-5E532DCDEE34}"/>
+              </a:ext>
+            </a:extLst>
+          </p:cNvPr>
+          <p:cNvSpPr txBox="1"/>
+          <p:nvPr userDrawn="1"/>
+        </p:nvSpPr>
+        <p:spPr>
+          <a:xfrm>
+            <a:off x="1499801" y="5009681"/>
+            <a:ext cx="6144397" cy="184666"/>
+          </a:xfrm>
+          <a:prstGeom prst="rect">
+            <a:avLst/>
+          </a:prstGeom>
+          <a:noFill/>
+        </p:spPr>
+        <p:txBody>
+          <a:bodyPr wrap="square">
+            <a:spAutoFit/>
+          </a:bodyPr>
+          <a:lstStyle/>
+          <a:p>
+            <a:pPr algn="ctr"/>
+            <a:r>
+              <a:rPr lang="en-US" sz="600" spc="-10" baseline="0" dirty="0">
+                <a:solidFill>
+                  <a:srgbClr val="929292"/>
+                </a:solidFill>
+                <a:latin typeface="Arial" panose="020B0604020202020204" pitchFamily="34" charset="0"/>
+                <a:cs typeface="Arial" panose="020B0604020202020204" pitchFamily="34" charset="0"/>
+              </a:rPr>
+              <a:t>Contains confidential proprietary and trade secrets information of IVECO </a:t>
+            </a:r>
+            <a:r>
+              <a:rPr lang="en-US" sz="600" spc="-10" baseline="0" dirty="0" err="1">
+                <a:solidFill>
+                  <a:srgbClr val="929292"/>
+                </a:solidFill>
+                <a:latin typeface="Arial" panose="020B0604020202020204" pitchFamily="34" charset="0"/>
+                <a:cs typeface="Arial" panose="020B0604020202020204" pitchFamily="34" charset="0"/>
+              </a:rPr>
+              <a:t>Defence</a:t>
+            </a:r>
+            <a:r>
+              <a:rPr lang="en-US" sz="600" spc="-10" baseline="0" dirty="0">
+                <a:solidFill>
+                  <a:srgbClr val="929292"/>
+                </a:solidFill>
+                <a:latin typeface="Arial" panose="020B0604020202020204" pitchFamily="34" charset="0"/>
+                <a:cs typeface="Arial" panose="020B0604020202020204" pitchFamily="34" charset="0"/>
+              </a:rPr>
+              <a:t> Vehicles. Any use of this work without express written consent is strictly prohibited.</a:t>
+            </a:r>
+            <a:endParaRPr lang="it-IT" sz="600" spc="-10" baseline="0" dirty="0">
+              <a:solidFill>
+                <a:srgbClr val="929292"/>
+              </a:solidFill>
+              <a:latin typeface="Arial" panose="020B0604020202020204" pitchFamily="34" charset="0"/>
+              <a:cs typeface="Arial" panose="020B0604020202020204" pitchFamily="34" charset="0"/>
+            </a:endParaRPr>
+          </a:p>
+        </p:txBody>
+      </p:sp>
     </p:spTree>
     <p:extLst>
       <p:ext uri="{BB962C8B-B14F-4D97-AF65-F5344CB8AC3E}">
@@ -4894,9 +5446,9 @@
           <a:bodyPr/>
           <a:lstStyle/>
           <a:p>
-            <a:fld id="{241EB5C9-1307-BA42-ABA2-0BC069CD8E7F}" type="datetimeFigureOut">
-              <a:rPr lang="en-US" smtClean="0"/>
-              <a:t>2/8/26</a:t>
+            <a:fld id="{E06934FA-7FD1-0D46-8E1C-1AFE08A73439}" type="datetime1">
+              <a:rPr lang="it-IT" smtClean="0"/>
+              <a:t>08/02/26</a:t>
             </a:fld>
             <a:endParaRPr lang="en-US"/>
           </a:p>
@@ -5182,6 +5734,75 @@
           </a:prstGeom>
         </p:spPr>
       </p:pic>
+      <p:sp>
+        <p:nvSpPr>
+          <p:cNvPr id="7" name="TextBox 6">
+            <a:extLst>
+              <a:ext uri="{FF2B5EF4-FFF2-40B4-BE49-F238E27FC236}">
+                <a16:creationId xmlns:a16="http://schemas.microsoft.com/office/drawing/2014/main" id="{E9A57DD2-0334-0E93-EF42-3A16A5997397}"/>
+              </a:ext>
+            </a:extLst>
+          </p:cNvPr>
+          <p:cNvSpPr txBox="1"/>
+          <p:nvPr userDrawn="1"/>
+        </p:nvSpPr>
+        <p:spPr>
+          <a:xfrm>
+            <a:off x="1499801" y="5009681"/>
+            <a:ext cx="6144397" cy="184666"/>
+          </a:xfrm>
+          <a:prstGeom prst="rect">
+            <a:avLst/>
+          </a:prstGeom>
+          <a:noFill/>
+        </p:spPr>
+        <p:txBody>
+          <a:bodyPr wrap="square">
+            <a:spAutoFit/>
+          </a:bodyPr>
+          <a:lstStyle/>
+          <a:p>
+            <a:pPr algn="ctr"/>
+            <a:r>
+              <a:rPr lang="en-US" sz="600" spc="-10" baseline="0" dirty="0">
+                <a:solidFill>
+                  <a:srgbClr val="929292"/>
+                </a:solidFill>
+                <a:latin typeface="Arial" panose="020B0604020202020204" pitchFamily="34" charset="0"/>
+                <a:cs typeface="Arial" panose="020B0604020202020204" pitchFamily="34" charset="0"/>
+              </a:rPr>
+              <a:t>Contains confidential proprietary and trade secrets information of IVECO </a:t>
+            </a:r>
+            <a:r>
+              <a:rPr lang="en-US" sz="600" spc="-10" baseline="0" dirty="0" err="1">
+                <a:solidFill>
+                  <a:srgbClr val="929292"/>
+                </a:solidFill>
+                <a:latin typeface="Arial" panose="020B0604020202020204" pitchFamily="34" charset="0"/>
+                <a:cs typeface="Arial" panose="020B0604020202020204" pitchFamily="34" charset="0"/>
+              </a:rPr>
+              <a:t>Defence</a:t>
+            </a:r>
+            <a:r>
+              <a:rPr lang="en-US" sz="600" spc="-10" baseline="0" dirty="0">
+                <a:solidFill>
+                  <a:srgbClr val="929292"/>
+                </a:solidFill>
+                <a:latin typeface="Arial" panose="020B0604020202020204" pitchFamily="34" charset="0"/>
+                <a:cs typeface="Arial" panose="020B0604020202020204" pitchFamily="34" charset="0"/>
+              </a:rPr>
+              <a:t> Vehicles. Any use of this work without express written consent is strictly prohibited.</a:t>
+            </a:r>
+            <a:endParaRPr lang="it-IT" sz="600" spc="-10" baseline="0" dirty="0">
+              <a:solidFill>
+                <a:srgbClr val="929292"/>
+              </a:solidFill>
+              <a:latin typeface="Arial" panose="020B0604020202020204" pitchFamily="34" charset="0"/>
+              <a:cs typeface="Arial" panose="020B0604020202020204" pitchFamily="34" charset="0"/>
+            </a:endParaRPr>
+          </a:p>
+        </p:txBody>
+      </p:sp>
     </p:spTree>
     <p:extLst>
       <p:ext uri="{BB962C8B-B14F-4D97-AF65-F5344CB8AC3E}">
@@ -5671,9 +6292,9 @@
           <a:bodyPr/>
           <a:lstStyle/>
           <a:p>
-            <a:fld id="{241EB5C9-1307-BA42-ABA2-0BC069CD8E7F}" type="datetimeFigureOut">
-              <a:rPr lang="en-US" smtClean="0"/>
-              <a:t>2/8/26</a:t>
+            <a:fld id="{21E9D82B-7A2C-DA4C-B24C-1024813AE2F0}" type="datetime1">
+              <a:rPr lang="it-IT" smtClean="0"/>
+              <a:t>08/02/26</a:t>
             </a:fld>
             <a:endParaRPr lang="en-US"/>
           </a:p>
@@ -5941,6 +6562,75 @@
           </a:prstGeom>
         </p:spPr>
       </p:pic>
+      <p:sp>
+        <p:nvSpPr>
+          <p:cNvPr id="5" name="TextBox 4">
+            <a:extLst>
+              <a:ext uri="{FF2B5EF4-FFF2-40B4-BE49-F238E27FC236}">
+                <a16:creationId xmlns:a16="http://schemas.microsoft.com/office/drawing/2014/main" id="{36A728D5-5BBE-C9BE-C8CB-7E6F35D77231}"/>
+              </a:ext>
+            </a:extLst>
+          </p:cNvPr>
+          <p:cNvSpPr txBox="1"/>
+          <p:nvPr userDrawn="1"/>
+        </p:nvSpPr>
+        <p:spPr>
+          <a:xfrm>
+            <a:off x="1499801" y="5009681"/>
+            <a:ext cx="6144397" cy="184666"/>
+          </a:xfrm>
+          <a:prstGeom prst="rect">
+            <a:avLst/>
+          </a:prstGeom>
+          <a:noFill/>
+        </p:spPr>
+        <p:txBody>
+          <a:bodyPr wrap="square">
+            <a:spAutoFit/>
+          </a:bodyPr>
+          <a:lstStyle/>
+          <a:p>
+            <a:pPr algn="ctr"/>
+            <a:r>
+              <a:rPr lang="en-US" sz="600" spc="-10" baseline="0" dirty="0">
+                <a:solidFill>
+                  <a:srgbClr val="929292"/>
+                </a:solidFill>
+                <a:latin typeface="Arial" panose="020B0604020202020204" pitchFamily="34" charset="0"/>
+                <a:cs typeface="Arial" panose="020B0604020202020204" pitchFamily="34" charset="0"/>
+              </a:rPr>
+              <a:t>Contains confidential proprietary and trade secrets information of IVECO </a:t>
+            </a:r>
+            <a:r>
+              <a:rPr lang="en-US" sz="600" spc="-10" baseline="0" dirty="0" err="1">
+                <a:solidFill>
+                  <a:srgbClr val="929292"/>
+                </a:solidFill>
+                <a:latin typeface="Arial" panose="020B0604020202020204" pitchFamily="34" charset="0"/>
+                <a:cs typeface="Arial" panose="020B0604020202020204" pitchFamily="34" charset="0"/>
+              </a:rPr>
+              <a:t>Defence</a:t>
+            </a:r>
+            <a:r>
+              <a:rPr lang="en-US" sz="600" spc="-10" baseline="0" dirty="0">
+                <a:solidFill>
+                  <a:srgbClr val="929292"/>
+                </a:solidFill>
+                <a:latin typeface="Arial" panose="020B0604020202020204" pitchFamily="34" charset="0"/>
+                <a:cs typeface="Arial" panose="020B0604020202020204" pitchFamily="34" charset="0"/>
+              </a:rPr>
+              <a:t> Vehicles. Any use of this work without express written consent is strictly prohibited.</a:t>
+            </a:r>
+            <a:endParaRPr lang="it-IT" sz="600" spc="-10" baseline="0" dirty="0">
+              <a:solidFill>
+                <a:srgbClr val="929292"/>
+              </a:solidFill>
+              <a:latin typeface="Arial" panose="020B0604020202020204" pitchFamily="34" charset="0"/>
+              <a:cs typeface="Arial" panose="020B0604020202020204" pitchFamily="34" charset="0"/>
+            </a:endParaRPr>
+          </a:p>
+        </p:txBody>
+      </p:sp>
     </p:spTree>
     <p:extLst>
       <p:ext uri="{BB962C8B-B14F-4D97-AF65-F5344CB8AC3E}">
@@ -6342,9 +7032,9 @@
           <a:bodyPr/>
           <a:lstStyle/>
           <a:p>
-            <a:fld id="{241EB5C9-1307-BA42-ABA2-0BC069CD8E7F}" type="datetimeFigureOut">
-              <a:rPr lang="en-US" smtClean="0"/>
-              <a:t>2/8/26</a:t>
+            <a:fld id="{9429820C-B789-AB43-B4E1-4B378514779B}" type="datetime1">
+              <a:rPr lang="it-IT" smtClean="0"/>
+              <a:t>08/02/26</a:t>
             </a:fld>
             <a:endParaRPr lang="en-US"/>
           </a:p>
@@ -6612,6 +7302,75 @@
           </a:prstGeom>
         </p:spPr>
       </p:pic>
+      <p:sp>
+        <p:nvSpPr>
+          <p:cNvPr id="7" name="TextBox 6">
+            <a:extLst>
+              <a:ext uri="{FF2B5EF4-FFF2-40B4-BE49-F238E27FC236}">
+                <a16:creationId xmlns:a16="http://schemas.microsoft.com/office/drawing/2014/main" id="{2AAF3200-A4E9-67DF-6962-7DE8759EEE6D}"/>
+              </a:ext>
+            </a:extLst>
+          </p:cNvPr>
+          <p:cNvSpPr txBox="1"/>
+          <p:nvPr userDrawn="1"/>
+        </p:nvSpPr>
+        <p:spPr>
+          <a:xfrm>
+            <a:off x="1499801" y="5009681"/>
+            <a:ext cx="6144397" cy="184666"/>
+          </a:xfrm>
+          <a:prstGeom prst="rect">
+            <a:avLst/>
+          </a:prstGeom>
+          <a:noFill/>
+        </p:spPr>
+        <p:txBody>
+          <a:bodyPr wrap="square">
+            <a:spAutoFit/>
+          </a:bodyPr>
+          <a:lstStyle/>
+          <a:p>
+            <a:pPr algn="ctr"/>
+            <a:r>
+              <a:rPr lang="en-US" sz="600" spc="-10" baseline="0" dirty="0">
+                <a:solidFill>
+                  <a:srgbClr val="929292"/>
+                </a:solidFill>
+                <a:latin typeface="Arial" panose="020B0604020202020204" pitchFamily="34" charset="0"/>
+                <a:cs typeface="Arial" panose="020B0604020202020204" pitchFamily="34" charset="0"/>
+              </a:rPr>
+              <a:t>Contains confidential proprietary and trade secrets information of IVECO </a:t>
+            </a:r>
+            <a:r>
+              <a:rPr lang="en-US" sz="600" spc="-10" baseline="0" dirty="0" err="1">
+                <a:solidFill>
+                  <a:srgbClr val="929292"/>
+                </a:solidFill>
+                <a:latin typeface="Arial" panose="020B0604020202020204" pitchFamily="34" charset="0"/>
+                <a:cs typeface="Arial" panose="020B0604020202020204" pitchFamily="34" charset="0"/>
+              </a:rPr>
+              <a:t>Defence</a:t>
+            </a:r>
+            <a:r>
+              <a:rPr lang="en-US" sz="600" spc="-10" baseline="0" dirty="0">
+                <a:solidFill>
+                  <a:srgbClr val="929292"/>
+                </a:solidFill>
+                <a:latin typeface="Arial" panose="020B0604020202020204" pitchFamily="34" charset="0"/>
+                <a:cs typeface="Arial" panose="020B0604020202020204" pitchFamily="34" charset="0"/>
+              </a:rPr>
+              <a:t> Vehicles. Any use of this work without express written consent is strictly prohibited.</a:t>
+            </a:r>
+            <a:endParaRPr lang="it-IT" sz="600" spc="-10" baseline="0" dirty="0">
+              <a:solidFill>
+                <a:srgbClr val="929292"/>
+              </a:solidFill>
+              <a:latin typeface="Arial" panose="020B0604020202020204" pitchFamily="34" charset="0"/>
+              <a:cs typeface="Arial" panose="020B0604020202020204" pitchFamily="34" charset="0"/>
+            </a:endParaRPr>
+          </a:p>
+        </p:txBody>
+      </p:sp>
     </p:spTree>
     <p:extLst>
       <p:ext uri="{BB962C8B-B14F-4D97-AF65-F5344CB8AC3E}">
@@ -6707,9 +7466,9 @@
           <a:bodyPr/>
           <a:lstStyle/>
           <a:p>
-            <a:fld id="{241EB5C9-1307-BA42-ABA2-0BC069CD8E7F}" type="datetimeFigureOut">
-              <a:rPr lang="en-US" smtClean="0"/>
-              <a:t>2/8/26</a:t>
+            <a:fld id="{EC46D180-6558-4140-957D-A04D35F919BF}" type="datetime1">
+              <a:rPr lang="it-IT" smtClean="0"/>
+              <a:t>08/02/26</a:t>
             </a:fld>
             <a:endParaRPr lang="en-US"/>
           </a:p>
@@ -6977,6 +7736,75 @@
           </a:prstGeom>
         </p:spPr>
       </p:pic>
+      <p:sp>
+        <p:nvSpPr>
+          <p:cNvPr id="3" name="TextBox 2">
+            <a:extLst>
+              <a:ext uri="{FF2B5EF4-FFF2-40B4-BE49-F238E27FC236}">
+                <a16:creationId xmlns:a16="http://schemas.microsoft.com/office/drawing/2014/main" id="{8F0BB32C-C6A2-82A8-490B-7538697EFCED}"/>
+              </a:ext>
+            </a:extLst>
+          </p:cNvPr>
+          <p:cNvSpPr txBox="1"/>
+          <p:nvPr userDrawn="1"/>
+        </p:nvSpPr>
+        <p:spPr>
+          <a:xfrm>
+            <a:off x="1499801" y="5009681"/>
+            <a:ext cx="6144397" cy="184666"/>
+          </a:xfrm>
+          <a:prstGeom prst="rect">
+            <a:avLst/>
+          </a:prstGeom>
+          <a:noFill/>
+        </p:spPr>
+        <p:txBody>
+          <a:bodyPr wrap="square">
+            <a:spAutoFit/>
+          </a:bodyPr>
+          <a:lstStyle/>
+          <a:p>
+            <a:pPr algn="ctr"/>
+            <a:r>
+              <a:rPr lang="en-US" sz="600" spc="-10" baseline="0" dirty="0">
+                <a:solidFill>
+                  <a:srgbClr val="929292"/>
+                </a:solidFill>
+                <a:latin typeface="Arial" panose="020B0604020202020204" pitchFamily="34" charset="0"/>
+                <a:cs typeface="Arial" panose="020B0604020202020204" pitchFamily="34" charset="0"/>
+              </a:rPr>
+              <a:t>Contains confidential proprietary and trade secrets information of IVECO </a:t>
+            </a:r>
+            <a:r>
+              <a:rPr lang="en-US" sz="600" spc="-10" baseline="0" dirty="0" err="1">
+                <a:solidFill>
+                  <a:srgbClr val="929292"/>
+                </a:solidFill>
+                <a:latin typeface="Arial" panose="020B0604020202020204" pitchFamily="34" charset="0"/>
+                <a:cs typeface="Arial" panose="020B0604020202020204" pitchFamily="34" charset="0"/>
+              </a:rPr>
+              <a:t>Defence</a:t>
+            </a:r>
+            <a:r>
+              <a:rPr lang="en-US" sz="600" spc="-10" baseline="0" dirty="0">
+                <a:solidFill>
+                  <a:srgbClr val="929292"/>
+                </a:solidFill>
+                <a:latin typeface="Arial" panose="020B0604020202020204" pitchFamily="34" charset="0"/>
+                <a:cs typeface="Arial" panose="020B0604020202020204" pitchFamily="34" charset="0"/>
+              </a:rPr>
+              <a:t> Vehicles. Any use of this work without express written consent is strictly prohibited.</a:t>
+            </a:r>
+            <a:endParaRPr lang="it-IT" sz="600" spc="-10" baseline="0" dirty="0">
+              <a:solidFill>
+                <a:srgbClr val="929292"/>
+              </a:solidFill>
+              <a:latin typeface="Arial" panose="020B0604020202020204" pitchFamily="34" charset="0"/>
+              <a:cs typeface="Arial" panose="020B0604020202020204" pitchFamily="34" charset="0"/>
+            </a:endParaRPr>
+          </a:p>
+        </p:txBody>
+      </p:sp>
     </p:spTree>
     <p:extLst>
       <p:ext uri="{BB962C8B-B14F-4D97-AF65-F5344CB8AC3E}">
@@ -7138,9 +7966,9 @@
             </a:lvl1pPr>
           </a:lstStyle>
           <a:p>
-            <a:fld id="{241EB5C9-1307-BA42-ABA2-0BC069CD8E7F}" type="datetimeFigureOut">
-              <a:rPr lang="en-US" smtClean="0"/>
-              <a:t>2/8/26</a:t>
+            <a:fld id="{4EE47AEE-98EC-0C43-8D64-9D05BF501A01}" type="datetime1">
+              <a:rPr lang="it-IT" smtClean="0"/>
+              <a:t>08/02/26</a:t>
             </a:fld>
             <a:endParaRPr lang="en-US"/>
           </a:p>
@@ -7248,6 +8076,7 @@
     <p:sldLayoutId id="2147483658" r:id="rId13"/>
     <p:sldLayoutId id="2147483659" r:id="rId14"/>
   </p:sldLayoutIdLst>
+  <p:hf hdr="0"/>
   <p:txStyles>
     <p:titleStyle>
       <a:lvl1pPr algn="l" defTabSz="342900" rtl="0" eaLnBrk="1" latinLnBrk="0" hangingPunct="1">
@@ -7562,6 +8391,35 @@
           </a:p>
         </p:txBody>
       </p:sp>
+      <p:sp>
+        <p:nvSpPr>
+          <p:cNvPr id="5" name="Date Placeholder 4">
+            <a:extLst>
+              <a:ext uri="{FF2B5EF4-FFF2-40B4-BE49-F238E27FC236}">
+                <a16:creationId xmlns:a16="http://schemas.microsoft.com/office/drawing/2014/main" id="{61C89709-A8A7-390C-7AC7-DE3839609B3D}"/>
+              </a:ext>
+            </a:extLst>
+          </p:cNvPr>
+          <p:cNvSpPr>
+            <a:spLocks noGrp="1"/>
+          </p:cNvSpPr>
+          <p:nvPr>
+            <p:ph type="dt" sz="half" idx="10"/>
+          </p:nvPr>
+        </p:nvSpPr>
+        <p:spPr/>
+        <p:txBody>
+          <a:bodyPr/>
+          <a:lstStyle/>
+          <a:p>
+            <a:fld id="{D1602D0C-839A-CF4F-9D15-89FD2575D155}" type="datetime1">
+              <a:rPr lang="it-IT" smtClean="0"/>
+              <a:t>08/02/26</a:t>
+            </a:fld>
+            <a:endParaRPr lang="en-US"/>
+          </a:p>
+        </p:txBody>
+      </p:sp>
     </p:spTree>
     <p:extLst>
       <p:ext uri="{BB962C8B-B14F-4D97-AF65-F5344CB8AC3E}">
@@ -7639,6 +8497,90 @@
           </a:p>
         </p:txBody>
       </p:sp>
+      <p:sp>
+        <p:nvSpPr>
+          <p:cNvPr id="4" name="Slide Number Placeholder 3">
+            <a:extLst>
+              <a:ext uri="{FF2B5EF4-FFF2-40B4-BE49-F238E27FC236}">
+                <a16:creationId xmlns:a16="http://schemas.microsoft.com/office/drawing/2014/main" id="{B5C437CA-2166-DEEB-87CD-41B620B6BDFF}"/>
+              </a:ext>
+            </a:extLst>
+          </p:cNvPr>
+          <p:cNvSpPr>
+            <a:spLocks noGrp="1"/>
+          </p:cNvSpPr>
+          <p:nvPr>
+            <p:ph type="sldNum" sz="quarter" idx="12"/>
+          </p:nvPr>
+        </p:nvSpPr>
+        <p:spPr/>
+        <p:txBody>
+          <a:bodyPr/>
+          <a:lstStyle/>
+          <a:p>
+            <a:fld id="{C5EF2332-01BF-834F-8236-50238282D533}" type="slidenum">
+              <a:rPr lang="en-US" smtClean="0"/>
+              <a:pPr/>
+              <a:t>2</a:t>
+            </a:fld>
+            <a:endParaRPr lang="en-US" dirty="0"/>
+          </a:p>
+        </p:txBody>
+      </p:sp>
+      <p:sp>
+        <p:nvSpPr>
+          <p:cNvPr id="5" name="Date Placeholder 4">
+            <a:extLst>
+              <a:ext uri="{FF2B5EF4-FFF2-40B4-BE49-F238E27FC236}">
+                <a16:creationId xmlns:a16="http://schemas.microsoft.com/office/drawing/2014/main" id="{43D63DC9-7BB4-E652-0799-718F53EFC864}"/>
+              </a:ext>
+            </a:extLst>
+          </p:cNvPr>
+          <p:cNvSpPr>
+            <a:spLocks noGrp="1"/>
+          </p:cNvSpPr>
+          <p:nvPr>
+            <p:ph type="dt" sz="half" idx="10"/>
+          </p:nvPr>
+        </p:nvSpPr>
+        <p:spPr/>
+        <p:txBody>
+          <a:bodyPr/>
+          <a:lstStyle/>
+          <a:p>
+            <a:fld id="{9C7945CA-8852-CF4A-A88C-560042723BA1}" type="datetime1">
+              <a:rPr lang="it-IT" smtClean="0"/>
+              <a:t>08/02/26</a:t>
+            </a:fld>
+            <a:endParaRPr lang="en-US"/>
+          </a:p>
+        </p:txBody>
+      </p:sp>
+      <p:sp>
+        <p:nvSpPr>
+          <p:cNvPr id="6" name="Footer Placeholder 5">
+            <a:extLst>
+              <a:ext uri="{FF2B5EF4-FFF2-40B4-BE49-F238E27FC236}">
+                <a16:creationId xmlns:a16="http://schemas.microsoft.com/office/drawing/2014/main" id="{E1059A00-728F-A95D-6FAE-B2017A99C92D}"/>
+              </a:ext>
+            </a:extLst>
+          </p:cNvPr>
+          <p:cNvSpPr>
+            <a:spLocks noGrp="1"/>
+          </p:cNvSpPr>
+          <p:nvPr>
+            <p:ph type="ftr" sz="quarter" idx="11"/>
+          </p:nvPr>
+        </p:nvSpPr>
+        <p:spPr/>
+        <p:txBody>
+          <a:bodyPr/>
+          <a:lstStyle/>
+          <a:p>
+            <a:endParaRPr lang="en-US" dirty="0"/>
+          </a:p>
+        </p:txBody>
+      </p:sp>
     </p:spTree>
     <p:extLst>
       <p:ext uri="{BB962C8B-B14F-4D97-AF65-F5344CB8AC3E}">
@@ -7819,6 +8761,90 @@
               <a:rPr lang="en-US" dirty="0"/>
               <a:t>Some content on the right.</a:t>
             </a:r>
+          </a:p>
+        </p:txBody>
+      </p:sp>
+      <p:sp>
+        <p:nvSpPr>
+          <p:cNvPr id="2" name="Slide Number Placeholder 1">
+            <a:extLst>
+              <a:ext uri="{FF2B5EF4-FFF2-40B4-BE49-F238E27FC236}">
+                <a16:creationId xmlns:a16="http://schemas.microsoft.com/office/drawing/2014/main" id="{08EB18E8-0B93-7B8C-611E-7E0542BE7A6A}"/>
+              </a:ext>
+            </a:extLst>
+          </p:cNvPr>
+          <p:cNvSpPr>
+            <a:spLocks noGrp="1"/>
+          </p:cNvSpPr>
+          <p:nvPr>
+            <p:ph type="sldNum" sz="quarter" idx="12"/>
+          </p:nvPr>
+        </p:nvSpPr>
+        <p:spPr/>
+        <p:txBody>
+          <a:bodyPr/>
+          <a:lstStyle/>
+          <a:p>
+            <a:fld id="{C5EF2332-01BF-834F-8236-50238282D533}" type="slidenum">
+              <a:rPr lang="en-US" smtClean="0"/>
+              <a:pPr/>
+              <a:t>4</a:t>
+            </a:fld>
+            <a:endParaRPr lang="en-US" dirty="0"/>
+          </a:p>
+        </p:txBody>
+      </p:sp>
+      <p:sp>
+        <p:nvSpPr>
+          <p:cNvPr id="3" name="Date Placeholder 2">
+            <a:extLst>
+              <a:ext uri="{FF2B5EF4-FFF2-40B4-BE49-F238E27FC236}">
+                <a16:creationId xmlns:a16="http://schemas.microsoft.com/office/drawing/2014/main" id="{94A656B8-AA82-1140-46D6-805A4637863A}"/>
+              </a:ext>
+            </a:extLst>
+          </p:cNvPr>
+          <p:cNvSpPr>
+            <a:spLocks noGrp="1"/>
+          </p:cNvSpPr>
+          <p:nvPr>
+            <p:ph type="dt" sz="half" idx="10"/>
+          </p:nvPr>
+        </p:nvSpPr>
+        <p:spPr/>
+        <p:txBody>
+          <a:bodyPr/>
+          <a:lstStyle/>
+          <a:p>
+            <a:fld id="{64E14661-1291-564D-ADDE-841126F5283D}" type="datetime1">
+              <a:rPr lang="it-IT" smtClean="0"/>
+              <a:t>08/02/26</a:t>
+            </a:fld>
+            <a:endParaRPr lang="en-US"/>
+          </a:p>
+        </p:txBody>
+      </p:sp>
+      <p:sp>
+        <p:nvSpPr>
+          <p:cNvPr id="7" name="Footer Placeholder 6">
+            <a:extLst>
+              <a:ext uri="{FF2B5EF4-FFF2-40B4-BE49-F238E27FC236}">
+                <a16:creationId xmlns:a16="http://schemas.microsoft.com/office/drawing/2014/main" id="{F7238D61-7B8E-55A3-78CB-6554D4A6A002}"/>
+              </a:ext>
+            </a:extLst>
+          </p:cNvPr>
+          <p:cNvSpPr>
+            <a:spLocks noGrp="1"/>
+          </p:cNvSpPr>
+          <p:nvPr>
+            <p:ph type="ftr" sz="quarter" idx="11"/>
+          </p:nvPr>
+        </p:nvSpPr>
+        <p:spPr/>
+        <p:txBody>
+          <a:bodyPr/>
+          <a:lstStyle/>
+          <a:p>
+            <a:endParaRPr lang="en-US" dirty="0"/>
           </a:p>
         </p:txBody>
       </p:sp>
@@ -8113,21 +9139,29 @@
   </a:themeElements>
   <a:objectDefaults>
     <a:spDef>
-      <a:spPr/>
-      <a:bodyPr/>
-      <a:lstStyle/>
+      <a:spPr>
+        <a:ln>
+          <a:noFill/>
+        </a:ln>
+      </a:spPr>
+      <a:bodyPr rtlCol="0" anchor="ctr"/>
+      <a:lstStyle>
+        <a:defPPr algn="ctr">
+          <a:defRPr sz="900" dirty="0"/>
+        </a:defPPr>
+      </a:lstStyle>
       <a:style>
-        <a:lnRef idx="1">
-          <a:schemeClr val="accent1"/>
+        <a:lnRef idx="2">
+          <a:schemeClr val="dk1"/>
         </a:lnRef>
-        <a:fillRef idx="3">
-          <a:schemeClr val="accent1"/>
+        <a:fillRef idx="1">
+          <a:schemeClr val="lt1"/>
         </a:fillRef>
-        <a:effectRef idx="2">
-          <a:schemeClr val="accent1"/>
+        <a:effectRef idx="0">
+          <a:schemeClr val="dk1"/>
         </a:effectRef>
         <a:fontRef idx="minor">
-          <a:schemeClr val="lt1"/>
+          <a:schemeClr val="dk1"/>
         </a:fontRef>
       </a:style>
     </a:spDef>

</xml_diff>

<commit_message>
WIP on major layout configurations
</commit_message>
<xml_diff>
--- a/_extensions/IDV-Share/quarto-presentation-templates/reference/IDV-template.pptx
+++ b/_extensions/IDV-Share/quarto-presentation-templates/reference/IDV-template.pptx
@@ -132,752 +132,6 @@
 </p:presentation>
 </file>
 
-<file path=ppt/revisionInfo.xml><?xml version="1.0" encoding="utf-8"?>
-<p1510:revInfo xmlns:a="http://schemas.openxmlformats.org/drawingml/2006/main" xmlns:r="http://schemas.openxmlformats.org/officeDocument/2006/relationships" xmlns:p1510="http://schemas.microsoft.com/office/powerpoint/2015/10/main">
-  <p1510:revLst>
-    <p1510:client id="{C0C99BD7-623F-4809-B01E-CFB7750E2573}" v="11" dt="2026-02-10T18:06:58.428"/>
-  </p1510:revLst>
-</p1510:revInfo>
-</file>
-
-<file path=ppt/changesInfos/changesInfo1.xml><?xml version="1.0" encoding="utf-8"?>
-<pc:chgInfo xmlns:a="http://schemas.openxmlformats.org/drawingml/2006/main" xmlns:r="http://schemas.openxmlformats.org/officeDocument/2006/relationships" xmlns:ac="http://schemas.microsoft.com/office/drawing/2013/main/command" xmlns:pc="http://schemas.microsoft.com/office/powerpoint/2013/main/command">
-  <pc:docChgLst>
-    <pc:chgData name="LARCHER MATTEO (IDV Group)" userId="db0184d6-40e4-497e-a5fe-b974eecd6a99" providerId="ADAL" clId="{C0C99BD7-623F-4809-B01E-CFB7750E2573}"/>
-    <pc:docChg chg="undo custSel modMainMaster">
-      <pc:chgData name="LARCHER MATTEO (IDV Group)" userId="db0184d6-40e4-497e-a5fe-b974eecd6a99" providerId="ADAL" clId="{C0C99BD7-623F-4809-B01E-CFB7750E2573}" dt="2026-02-10T18:06:58.428" v="55"/>
-      <pc:docMkLst>
-        <pc:docMk/>
-      </pc:docMkLst>
-      <pc:sldMasterChg chg="modSldLayout">
-        <pc:chgData name="LARCHER MATTEO (IDV Group)" userId="db0184d6-40e4-497e-a5fe-b974eecd6a99" providerId="ADAL" clId="{C0C99BD7-623F-4809-B01E-CFB7750E2573}" dt="2026-02-10T18:06:58.428" v="55"/>
-        <pc:sldMasterMkLst>
-          <pc:docMk/>
-          <pc:sldMasterMk cId="3676200875" sldId="2147483648"/>
-        </pc:sldMasterMkLst>
-        <pc:sldLayoutChg chg="addSp delSp modSp mod">
-          <pc:chgData name="LARCHER MATTEO (IDV Group)" userId="db0184d6-40e4-497e-a5fe-b974eecd6a99" providerId="ADAL" clId="{C0C99BD7-623F-4809-B01E-CFB7750E2573}" dt="2026-02-10T18:05:24.636" v="19"/>
-          <pc:sldLayoutMkLst>
-            <pc:docMk/>
-            <pc:sldMasterMk cId="3676200875" sldId="2147483648"/>
-            <pc:sldLayoutMk cId="338346009" sldId="2147483650"/>
-          </pc:sldLayoutMkLst>
-          <pc:spChg chg="del">
-            <ac:chgData name="LARCHER MATTEO (IDV Group)" userId="db0184d6-40e4-497e-a5fe-b974eecd6a99" providerId="ADAL" clId="{C0C99BD7-623F-4809-B01E-CFB7750E2573}" dt="2026-02-10T18:05:17.884" v="16" actId="478"/>
-            <ac:spMkLst>
-              <pc:docMk/>
-              <pc:sldMasterMk cId="3676200875" sldId="2147483648"/>
-              <pc:sldLayoutMk cId="338346009" sldId="2147483650"/>
-              <ac:spMk id="4" creationId="{00000000-0000-0000-0000-000000000000}"/>
-            </ac:spMkLst>
-          </pc:spChg>
-          <pc:spChg chg="del">
-            <ac:chgData name="LARCHER MATTEO (IDV Group)" userId="db0184d6-40e4-497e-a5fe-b974eecd6a99" providerId="ADAL" clId="{C0C99BD7-623F-4809-B01E-CFB7750E2573}" dt="2026-02-10T18:05:19.515" v="17" actId="478"/>
-            <ac:spMkLst>
-              <pc:docMk/>
-              <pc:sldMasterMk cId="3676200875" sldId="2147483648"/>
-              <pc:sldLayoutMk cId="338346009" sldId="2147483650"/>
-              <ac:spMk id="5" creationId="{00000000-0000-0000-0000-000000000000}"/>
-            </ac:spMkLst>
-          </pc:spChg>
-          <pc:spChg chg="del">
-            <ac:chgData name="LARCHER MATTEO (IDV Group)" userId="db0184d6-40e4-497e-a5fe-b974eecd6a99" providerId="ADAL" clId="{C0C99BD7-623F-4809-B01E-CFB7750E2573}" dt="2026-02-10T18:05:20.989" v="18" actId="478"/>
-            <ac:spMkLst>
-              <pc:docMk/>
-              <pc:sldMasterMk cId="3676200875" sldId="2147483648"/>
-              <pc:sldLayoutMk cId="338346009" sldId="2147483650"/>
-              <ac:spMk id="7" creationId="{DC0F4838-F6BF-C30B-C410-5E532DCDEE34}"/>
-            </ac:spMkLst>
-          </pc:spChg>
-          <pc:spChg chg="add mod">
-            <ac:chgData name="LARCHER MATTEO (IDV Group)" userId="db0184d6-40e4-497e-a5fe-b974eecd6a99" providerId="ADAL" clId="{C0C99BD7-623F-4809-B01E-CFB7750E2573}" dt="2026-02-10T18:05:24.636" v="19"/>
-            <ac:spMkLst>
-              <pc:docMk/>
-              <pc:sldMasterMk cId="3676200875" sldId="2147483648"/>
-              <pc:sldLayoutMk cId="338346009" sldId="2147483650"/>
-              <ac:spMk id="8" creationId="{41E08C21-258C-AE13-75FE-C21C90539E06}"/>
-            </ac:spMkLst>
-          </pc:spChg>
-          <pc:spChg chg="add mod">
-            <ac:chgData name="LARCHER MATTEO (IDV Group)" userId="db0184d6-40e4-497e-a5fe-b974eecd6a99" providerId="ADAL" clId="{C0C99BD7-623F-4809-B01E-CFB7750E2573}" dt="2026-02-10T18:05:24.636" v="19"/>
-            <ac:spMkLst>
-              <pc:docMk/>
-              <pc:sldMasterMk cId="3676200875" sldId="2147483648"/>
-              <pc:sldLayoutMk cId="338346009" sldId="2147483650"/>
-              <ac:spMk id="12" creationId="{41FF191B-B050-8EC2-28F4-138E94F7812D}"/>
-            </ac:spMkLst>
-          </pc:spChg>
-          <pc:spChg chg="add mod">
-            <ac:chgData name="LARCHER MATTEO (IDV Group)" userId="db0184d6-40e4-497e-a5fe-b974eecd6a99" providerId="ADAL" clId="{C0C99BD7-623F-4809-B01E-CFB7750E2573}" dt="2026-02-10T18:05:24.636" v="19"/>
-            <ac:spMkLst>
-              <pc:docMk/>
-              <pc:sldMasterMk cId="3676200875" sldId="2147483648"/>
-              <pc:sldLayoutMk cId="338346009" sldId="2147483650"/>
-              <ac:spMk id="13" creationId="{94B64F0D-639F-48C9-18D3-58ADDF542781}"/>
-            </ac:spMkLst>
-          </pc:spChg>
-        </pc:sldLayoutChg>
-        <pc:sldLayoutChg chg="addSp delSp modSp mod">
-          <pc:chgData name="LARCHER MATTEO (IDV Group)" userId="db0184d6-40e4-497e-a5fe-b974eecd6a99" providerId="ADAL" clId="{C0C99BD7-623F-4809-B01E-CFB7750E2573}" dt="2026-02-10T18:05:52.660" v="27"/>
-          <pc:sldLayoutMkLst>
-            <pc:docMk/>
-            <pc:sldMasterMk cId="3676200875" sldId="2147483648"/>
-            <pc:sldLayoutMk cId="2619886245" sldId="2147483652"/>
-          </pc:sldLayoutMkLst>
-          <pc:spChg chg="del">
-            <ac:chgData name="LARCHER MATTEO (IDV Group)" userId="db0184d6-40e4-497e-a5fe-b974eecd6a99" providerId="ADAL" clId="{C0C99BD7-623F-4809-B01E-CFB7750E2573}" dt="2026-02-10T18:05:48.042" v="25" actId="478"/>
-            <ac:spMkLst>
-              <pc:docMk/>
-              <pc:sldMasterMk cId="3676200875" sldId="2147483648"/>
-              <pc:sldLayoutMk cId="2619886245" sldId="2147483652"/>
-              <ac:spMk id="5" creationId="{36A728D5-5BBE-C9BE-C8CB-7E6F35D77231}"/>
-            </ac:spMkLst>
-          </pc:spChg>
-          <pc:spChg chg="add mod">
-            <ac:chgData name="LARCHER MATTEO (IDV Group)" userId="db0184d6-40e4-497e-a5fe-b974eecd6a99" providerId="ADAL" clId="{C0C99BD7-623F-4809-B01E-CFB7750E2573}" dt="2026-02-10T18:05:52.660" v="27"/>
-            <ac:spMkLst>
-              <pc:docMk/>
-              <pc:sldMasterMk cId="3676200875" sldId="2147483648"/>
-              <pc:sldLayoutMk cId="2619886245" sldId="2147483652"/>
-              <ac:spMk id="6" creationId="{3D0F4771-8AB8-078F-DC78-B397B4F3D0A1}"/>
-            </ac:spMkLst>
-          </pc:spChg>
-          <pc:spChg chg="add mod">
-            <ac:chgData name="LARCHER MATTEO (IDV Group)" userId="db0184d6-40e4-497e-a5fe-b974eecd6a99" providerId="ADAL" clId="{C0C99BD7-623F-4809-B01E-CFB7750E2573}" dt="2026-02-10T18:05:52.660" v="27"/>
-            <ac:spMkLst>
-              <pc:docMk/>
-              <pc:sldMasterMk cId="3676200875" sldId="2147483648"/>
-              <pc:sldLayoutMk cId="2619886245" sldId="2147483652"/>
-              <ac:spMk id="7" creationId="{8101B048-30E1-B224-4B98-3A9EBBB3F171}"/>
-            </ac:spMkLst>
-          </pc:spChg>
-          <pc:spChg chg="add mod">
-            <ac:chgData name="LARCHER MATTEO (IDV Group)" userId="db0184d6-40e4-497e-a5fe-b974eecd6a99" providerId="ADAL" clId="{C0C99BD7-623F-4809-B01E-CFB7750E2573}" dt="2026-02-10T18:05:52.660" v="27"/>
-            <ac:spMkLst>
-              <pc:docMk/>
-              <pc:sldMasterMk cId="3676200875" sldId="2147483648"/>
-              <pc:sldLayoutMk cId="2619886245" sldId="2147483652"/>
-              <ac:spMk id="8" creationId="{2F6EFAC2-B140-4F02-2719-6ACA51832925}"/>
-            </ac:spMkLst>
-          </pc:spChg>
-          <pc:spChg chg="del">
-            <ac:chgData name="LARCHER MATTEO (IDV Group)" userId="db0184d6-40e4-497e-a5fe-b974eecd6a99" providerId="ADAL" clId="{C0C99BD7-623F-4809-B01E-CFB7750E2573}" dt="2026-02-10T18:05:46.684" v="24" actId="478"/>
-            <ac:spMkLst>
-              <pc:docMk/>
-              <pc:sldMasterMk cId="3676200875" sldId="2147483648"/>
-              <pc:sldLayoutMk cId="2619886245" sldId="2147483652"/>
-              <ac:spMk id="9" creationId="{C4053F5D-6FBA-B899-9B82-B9093E335267}"/>
-            </ac:spMkLst>
-          </pc:spChg>
-          <pc:spChg chg="del">
-            <ac:chgData name="LARCHER MATTEO (IDV Group)" userId="db0184d6-40e4-497e-a5fe-b974eecd6a99" providerId="ADAL" clId="{C0C99BD7-623F-4809-B01E-CFB7750E2573}" dt="2026-02-10T18:05:51.259" v="26" actId="478"/>
-            <ac:spMkLst>
-              <pc:docMk/>
-              <pc:sldMasterMk cId="3676200875" sldId="2147483648"/>
-              <pc:sldLayoutMk cId="2619886245" sldId="2147483652"/>
-              <ac:spMk id="10" creationId="{BB17D917-DE37-B43C-7F01-65FA3EFC88FA}"/>
-            </ac:spMkLst>
-          </pc:spChg>
-        </pc:sldLayoutChg>
-        <pc:sldLayoutChg chg="addSp delSp modSp mod">
-          <pc:chgData name="LARCHER MATTEO (IDV Group)" userId="db0184d6-40e4-497e-a5fe-b974eecd6a99" providerId="ADAL" clId="{C0C99BD7-623F-4809-B01E-CFB7750E2573}" dt="2026-02-10T18:06:01.644" v="31"/>
-          <pc:sldLayoutMkLst>
-            <pc:docMk/>
-            <pc:sldMasterMk cId="3676200875" sldId="2147483648"/>
-            <pc:sldLayoutMk cId="2535793967" sldId="2147483653"/>
-          </pc:sldLayoutMkLst>
-          <pc:spChg chg="del">
-            <ac:chgData name="LARCHER MATTEO (IDV Group)" userId="db0184d6-40e4-497e-a5fe-b974eecd6a99" providerId="ADAL" clId="{C0C99BD7-623F-4809-B01E-CFB7750E2573}" dt="2026-02-10T18:05:58.650" v="29" actId="478"/>
-            <ac:spMkLst>
-              <pc:docMk/>
-              <pc:sldMasterMk cId="3676200875" sldId="2147483648"/>
-              <pc:sldLayoutMk cId="2535793967" sldId="2147483653"/>
-              <ac:spMk id="7" creationId="{2AAF3200-A4E9-67DF-6962-7DE8759EEE6D}"/>
-            </ac:spMkLst>
-          </pc:spChg>
-          <pc:spChg chg="add mod">
-            <ac:chgData name="LARCHER MATTEO (IDV Group)" userId="db0184d6-40e4-497e-a5fe-b974eecd6a99" providerId="ADAL" clId="{C0C99BD7-623F-4809-B01E-CFB7750E2573}" dt="2026-02-10T18:06:01.644" v="31"/>
-            <ac:spMkLst>
-              <pc:docMk/>
-              <pc:sldMasterMk cId="3676200875" sldId="2147483648"/>
-              <pc:sldLayoutMk cId="2535793967" sldId="2147483653"/>
-              <ac:spMk id="8" creationId="{83FEA519-AFF1-9BAC-77EE-613D983768EC}"/>
-            </ac:spMkLst>
-          </pc:spChg>
-          <pc:spChg chg="add mod">
-            <ac:chgData name="LARCHER MATTEO (IDV Group)" userId="db0184d6-40e4-497e-a5fe-b974eecd6a99" providerId="ADAL" clId="{C0C99BD7-623F-4809-B01E-CFB7750E2573}" dt="2026-02-10T18:06:01.644" v="31"/>
-            <ac:spMkLst>
-              <pc:docMk/>
-              <pc:sldMasterMk cId="3676200875" sldId="2147483648"/>
-              <pc:sldLayoutMk cId="2535793967" sldId="2147483653"/>
-              <ac:spMk id="9" creationId="{DC18DF14-CD00-67F5-96D3-71A18578BF00}"/>
-            </ac:spMkLst>
-          </pc:spChg>
-          <pc:spChg chg="add mod">
-            <ac:chgData name="LARCHER MATTEO (IDV Group)" userId="db0184d6-40e4-497e-a5fe-b974eecd6a99" providerId="ADAL" clId="{C0C99BD7-623F-4809-B01E-CFB7750E2573}" dt="2026-02-10T18:06:01.644" v="31"/>
-            <ac:spMkLst>
-              <pc:docMk/>
-              <pc:sldMasterMk cId="3676200875" sldId="2147483648"/>
-              <pc:sldLayoutMk cId="2535793967" sldId="2147483653"/>
-              <ac:spMk id="10" creationId="{05F4EA1A-7BC8-CB03-4BE7-88B7F503D813}"/>
-            </ac:spMkLst>
-          </pc:spChg>
-          <pc:spChg chg="del">
-            <ac:chgData name="LARCHER MATTEO (IDV Group)" userId="db0184d6-40e4-497e-a5fe-b974eecd6a99" providerId="ADAL" clId="{C0C99BD7-623F-4809-B01E-CFB7750E2573}" dt="2026-02-10T18:05:57.083" v="28" actId="478"/>
-            <ac:spMkLst>
-              <pc:docMk/>
-              <pc:sldMasterMk cId="3676200875" sldId="2147483648"/>
-              <pc:sldLayoutMk cId="2535793967" sldId="2147483653"/>
-              <ac:spMk id="11" creationId="{49F71F15-28F7-2AFB-0561-2D46D21B76B0}"/>
-            </ac:spMkLst>
-          </pc:spChg>
-          <pc:spChg chg="del">
-            <ac:chgData name="LARCHER MATTEO (IDV Group)" userId="db0184d6-40e4-497e-a5fe-b974eecd6a99" providerId="ADAL" clId="{C0C99BD7-623F-4809-B01E-CFB7750E2573}" dt="2026-02-10T18:06:00.251" v="30" actId="478"/>
-            <ac:spMkLst>
-              <pc:docMk/>
-              <pc:sldMasterMk cId="3676200875" sldId="2147483648"/>
-              <pc:sldLayoutMk cId="2535793967" sldId="2147483653"/>
-              <ac:spMk id="12" creationId="{8F417543-5403-66B4-114C-C61D3E3DBB66}"/>
-            </ac:spMkLst>
-          </pc:spChg>
-        </pc:sldLayoutChg>
-        <pc:sldLayoutChg chg="addSp delSp modSp mod">
-          <pc:chgData name="LARCHER MATTEO (IDV Group)" userId="db0184d6-40e4-497e-a5fe-b974eecd6a99" providerId="ADAL" clId="{C0C99BD7-623F-4809-B01E-CFB7750E2573}" dt="2026-02-10T18:06:10.954" v="35"/>
-          <pc:sldLayoutMkLst>
-            <pc:docMk/>
-            <pc:sldMasterMk cId="3676200875" sldId="2147483648"/>
-            <pc:sldLayoutMk cId="3472721253" sldId="2147483654"/>
-          </pc:sldLayoutMkLst>
-          <pc:spChg chg="del">
-            <ac:chgData name="LARCHER MATTEO (IDV Group)" userId="db0184d6-40e4-497e-a5fe-b974eecd6a99" providerId="ADAL" clId="{C0C99BD7-623F-4809-B01E-CFB7750E2573}" dt="2026-02-10T18:06:09.651" v="34" actId="478"/>
-            <ac:spMkLst>
-              <pc:docMk/>
-              <pc:sldMasterMk cId="3676200875" sldId="2147483648"/>
-              <pc:sldLayoutMk cId="3472721253" sldId="2147483654"/>
-              <ac:spMk id="3" creationId="{8F0BB32C-C6A2-82A8-490B-7538697EFCED}"/>
-            </ac:spMkLst>
-          </pc:spChg>
-          <pc:spChg chg="add mod">
-            <ac:chgData name="LARCHER MATTEO (IDV Group)" userId="db0184d6-40e4-497e-a5fe-b974eecd6a99" providerId="ADAL" clId="{C0C99BD7-623F-4809-B01E-CFB7750E2573}" dt="2026-02-10T18:06:10.954" v="35"/>
-            <ac:spMkLst>
-              <pc:docMk/>
-              <pc:sldMasterMk cId="3676200875" sldId="2147483648"/>
-              <pc:sldLayoutMk cId="3472721253" sldId="2147483654"/>
-              <ac:spMk id="4" creationId="{410D6FD3-F0A6-9E97-8EC0-E1CCC2B7E703}"/>
-            </ac:spMkLst>
-          </pc:spChg>
-          <pc:spChg chg="add mod">
-            <ac:chgData name="LARCHER MATTEO (IDV Group)" userId="db0184d6-40e4-497e-a5fe-b974eecd6a99" providerId="ADAL" clId="{C0C99BD7-623F-4809-B01E-CFB7750E2573}" dt="2026-02-10T18:06:10.954" v="35"/>
-            <ac:spMkLst>
-              <pc:docMk/>
-              <pc:sldMasterMk cId="3676200875" sldId="2147483648"/>
-              <pc:sldLayoutMk cId="3472721253" sldId="2147483654"/>
-              <ac:spMk id="5" creationId="{BB534351-4221-27F8-F02E-7F05F1EBD0DE}"/>
-            </ac:spMkLst>
-          </pc:spChg>
-          <pc:spChg chg="add mod">
-            <ac:chgData name="LARCHER MATTEO (IDV Group)" userId="db0184d6-40e4-497e-a5fe-b974eecd6a99" providerId="ADAL" clId="{C0C99BD7-623F-4809-B01E-CFB7750E2573}" dt="2026-02-10T18:06:10.954" v="35"/>
-            <ac:spMkLst>
-              <pc:docMk/>
-              <pc:sldMasterMk cId="3676200875" sldId="2147483648"/>
-              <pc:sldLayoutMk cId="3472721253" sldId="2147483654"/>
-              <ac:spMk id="6" creationId="{C4822D55-90CB-F8AF-3E85-2686202A21A8}"/>
-            </ac:spMkLst>
-          </pc:spChg>
-          <pc:spChg chg="del">
-            <ac:chgData name="LARCHER MATTEO (IDV Group)" userId="db0184d6-40e4-497e-a5fe-b974eecd6a99" providerId="ADAL" clId="{C0C99BD7-623F-4809-B01E-CFB7750E2573}" dt="2026-02-10T18:06:07.043" v="32" actId="478"/>
-            <ac:spMkLst>
-              <pc:docMk/>
-              <pc:sldMasterMk cId="3676200875" sldId="2147483648"/>
-              <pc:sldLayoutMk cId="3472721253" sldId="2147483654"/>
-              <ac:spMk id="7" creationId="{3E3EC6A0-D5A9-CC66-04AC-E97B0756CB15}"/>
-            </ac:spMkLst>
-          </pc:spChg>
-          <pc:spChg chg="del">
-            <ac:chgData name="LARCHER MATTEO (IDV Group)" userId="db0184d6-40e4-497e-a5fe-b974eecd6a99" providerId="ADAL" clId="{C0C99BD7-623F-4809-B01E-CFB7750E2573}" dt="2026-02-10T18:06:08.577" v="33" actId="478"/>
-            <ac:spMkLst>
-              <pc:docMk/>
-              <pc:sldMasterMk cId="3676200875" sldId="2147483648"/>
-              <pc:sldLayoutMk cId="3472721253" sldId="2147483654"/>
-              <ac:spMk id="8" creationId="{DB2FD283-0D8C-247C-BFEE-0557A57D0063}"/>
-            </ac:spMkLst>
-          </pc:spChg>
-        </pc:sldLayoutChg>
-        <pc:sldLayoutChg chg="addSp delSp modSp mod">
-          <pc:chgData name="LARCHER MATTEO (IDV Group)" userId="db0184d6-40e4-497e-a5fe-b974eecd6a99" providerId="ADAL" clId="{C0C99BD7-623F-4809-B01E-CFB7750E2573}" dt="2026-02-10T18:06:19.267" v="39"/>
-          <pc:sldLayoutMkLst>
-            <pc:docMk/>
-            <pc:sldMasterMk cId="3676200875" sldId="2147483648"/>
-            <pc:sldLayoutMk cId="2130901097" sldId="2147483655"/>
-          </pc:sldLayoutMkLst>
-          <pc:spChg chg="del">
-            <ac:chgData name="LARCHER MATTEO (IDV Group)" userId="db0184d6-40e4-497e-a5fe-b974eecd6a99" providerId="ADAL" clId="{C0C99BD7-623F-4809-B01E-CFB7750E2573}" dt="2026-02-10T18:06:15.962" v="37" actId="478"/>
-            <ac:spMkLst>
-              <pc:docMk/>
-              <pc:sldMasterMk cId="3676200875" sldId="2147483648"/>
-              <pc:sldLayoutMk cId="2130901097" sldId="2147483655"/>
-              <ac:spMk id="2" creationId="{5ECDEA0F-CD3F-E988-8F7E-CF36959BCCB4}"/>
-            </ac:spMkLst>
-          </pc:spChg>
-          <pc:spChg chg="add mod">
-            <ac:chgData name="LARCHER MATTEO (IDV Group)" userId="db0184d6-40e4-497e-a5fe-b974eecd6a99" providerId="ADAL" clId="{C0C99BD7-623F-4809-B01E-CFB7750E2573}" dt="2026-02-10T18:06:19.267" v="39"/>
-            <ac:spMkLst>
-              <pc:docMk/>
-              <pc:sldMasterMk cId="3676200875" sldId="2147483648"/>
-              <pc:sldLayoutMk cId="2130901097" sldId="2147483655"/>
-              <ac:spMk id="3" creationId="{C80F4F23-3D03-8950-5BED-B52565587EEA}"/>
-            </ac:spMkLst>
-          </pc:spChg>
-          <pc:spChg chg="add mod">
-            <ac:chgData name="LARCHER MATTEO (IDV Group)" userId="db0184d6-40e4-497e-a5fe-b974eecd6a99" providerId="ADAL" clId="{C0C99BD7-623F-4809-B01E-CFB7750E2573}" dt="2026-02-10T18:06:19.267" v="39"/>
-            <ac:spMkLst>
-              <pc:docMk/>
-              <pc:sldMasterMk cId="3676200875" sldId="2147483648"/>
-              <pc:sldLayoutMk cId="2130901097" sldId="2147483655"/>
-              <ac:spMk id="4" creationId="{EE7AFD33-9FB5-12FB-E54E-8CD8F3271062}"/>
-            </ac:spMkLst>
-          </pc:spChg>
-          <pc:spChg chg="add mod">
-            <ac:chgData name="LARCHER MATTEO (IDV Group)" userId="db0184d6-40e4-497e-a5fe-b974eecd6a99" providerId="ADAL" clId="{C0C99BD7-623F-4809-B01E-CFB7750E2573}" dt="2026-02-10T18:06:19.267" v="39"/>
-            <ac:spMkLst>
-              <pc:docMk/>
-              <pc:sldMasterMk cId="3676200875" sldId="2147483648"/>
-              <pc:sldLayoutMk cId="2130901097" sldId="2147483655"/>
-              <ac:spMk id="5" creationId="{931C25FA-D200-3E45-5218-5E7FF21E9CE4}"/>
-            </ac:spMkLst>
-          </pc:spChg>
-          <pc:spChg chg="del">
-            <ac:chgData name="LARCHER MATTEO (IDV Group)" userId="db0184d6-40e4-497e-a5fe-b974eecd6a99" providerId="ADAL" clId="{C0C99BD7-623F-4809-B01E-CFB7750E2573}" dt="2026-02-10T18:06:14.138" v="36" actId="478"/>
-            <ac:spMkLst>
-              <pc:docMk/>
-              <pc:sldMasterMk cId="3676200875" sldId="2147483648"/>
-              <pc:sldLayoutMk cId="2130901097" sldId="2147483655"/>
-              <ac:spMk id="6" creationId="{9D7B9609-DC00-77FF-632B-7CA52E337E03}"/>
-            </ac:spMkLst>
-          </pc:spChg>
-          <pc:spChg chg="del">
-            <ac:chgData name="LARCHER MATTEO (IDV Group)" userId="db0184d6-40e4-497e-a5fe-b974eecd6a99" providerId="ADAL" clId="{C0C99BD7-623F-4809-B01E-CFB7750E2573}" dt="2026-02-10T18:06:17.635" v="38" actId="478"/>
-            <ac:spMkLst>
-              <pc:docMk/>
-              <pc:sldMasterMk cId="3676200875" sldId="2147483648"/>
-              <pc:sldLayoutMk cId="2130901097" sldId="2147483655"/>
-              <ac:spMk id="7" creationId="{E05F8820-21D2-6E53-F11B-4CA5D1C131A4}"/>
-            </ac:spMkLst>
-          </pc:spChg>
-        </pc:sldLayoutChg>
-        <pc:sldLayoutChg chg="addSp delSp modSp mod">
-          <pc:chgData name="LARCHER MATTEO (IDV Group)" userId="db0184d6-40e4-497e-a5fe-b974eecd6a99" providerId="ADAL" clId="{C0C99BD7-623F-4809-B01E-CFB7750E2573}" dt="2026-02-10T18:06:30.935" v="43"/>
-          <pc:sldLayoutMkLst>
-            <pc:docMk/>
-            <pc:sldMasterMk cId="3676200875" sldId="2147483648"/>
-            <pc:sldLayoutMk cId="3540895647" sldId="2147483656"/>
-          </pc:sldLayoutMkLst>
-          <pc:spChg chg="del">
-            <ac:chgData name="LARCHER MATTEO (IDV Group)" userId="db0184d6-40e4-497e-a5fe-b974eecd6a99" providerId="ADAL" clId="{C0C99BD7-623F-4809-B01E-CFB7750E2573}" dt="2026-02-10T18:06:27.730" v="41" actId="478"/>
-            <ac:spMkLst>
-              <pc:docMk/>
-              <pc:sldMasterMk cId="3676200875" sldId="2147483648"/>
-              <pc:sldLayoutMk cId="3540895647" sldId="2147483656"/>
-              <ac:spMk id="5" creationId="{E08D9B6F-D6D8-AE83-7546-E14BE6C2E410}"/>
-            </ac:spMkLst>
-          </pc:spChg>
-          <pc:spChg chg="add mod">
-            <ac:chgData name="LARCHER MATTEO (IDV Group)" userId="db0184d6-40e4-497e-a5fe-b974eecd6a99" providerId="ADAL" clId="{C0C99BD7-623F-4809-B01E-CFB7750E2573}" dt="2026-02-10T18:06:30.935" v="43"/>
-            <ac:spMkLst>
-              <pc:docMk/>
-              <pc:sldMasterMk cId="3676200875" sldId="2147483648"/>
-              <pc:sldLayoutMk cId="3540895647" sldId="2147483656"/>
-              <ac:spMk id="6" creationId="{1FB3E479-3FB2-2124-8CDC-FA3D202BBC7D}"/>
-            </ac:spMkLst>
-          </pc:spChg>
-          <pc:spChg chg="add mod">
-            <ac:chgData name="LARCHER MATTEO (IDV Group)" userId="db0184d6-40e4-497e-a5fe-b974eecd6a99" providerId="ADAL" clId="{C0C99BD7-623F-4809-B01E-CFB7750E2573}" dt="2026-02-10T18:06:30.935" v="43"/>
-            <ac:spMkLst>
-              <pc:docMk/>
-              <pc:sldMasterMk cId="3676200875" sldId="2147483648"/>
-              <pc:sldLayoutMk cId="3540895647" sldId="2147483656"/>
-              <ac:spMk id="7" creationId="{30D704D9-B764-0534-65D0-DCA588F88C80}"/>
-            </ac:spMkLst>
-          </pc:spChg>
-          <pc:spChg chg="add mod">
-            <ac:chgData name="LARCHER MATTEO (IDV Group)" userId="db0184d6-40e4-497e-a5fe-b974eecd6a99" providerId="ADAL" clId="{C0C99BD7-623F-4809-B01E-CFB7750E2573}" dt="2026-02-10T18:06:30.935" v="43"/>
-            <ac:spMkLst>
-              <pc:docMk/>
-              <pc:sldMasterMk cId="3676200875" sldId="2147483648"/>
-              <pc:sldLayoutMk cId="3540895647" sldId="2147483656"/>
-              <ac:spMk id="8" creationId="{2600830C-D3CF-63CF-DBB0-F4615FFF3167}"/>
-            </ac:spMkLst>
-          </pc:spChg>
-          <pc:spChg chg="del">
-            <ac:chgData name="LARCHER MATTEO (IDV Group)" userId="db0184d6-40e4-497e-a5fe-b974eecd6a99" providerId="ADAL" clId="{C0C99BD7-623F-4809-B01E-CFB7750E2573}" dt="2026-02-10T18:06:26.571" v="40" actId="478"/>
-            <ac:spMkLst>
-              <pc:docMk/>
-              <pc:sldMasterMk cId="3676200875" sldId="2147483648"/>
-              <pc:sldLayoutMk cId="3540895647" sldId="2147483656"/>
-              <ac:spMk id="9" creationId="{C8F14B97-C2FE-7D33-9A73-677B703E4162}"/>
-            </ac:spMkLst>
-          </pc:spChg>
-          <pc:spChg chg="del">
-            <ac:chgData name="LARCHER MATTEO (IDV Group)" userId="db0184d6-40e4-497e-a5fe-b974eecd6a99" providerId="ADAL" clId="{C0C99BD7-623F-4809-B01E-CFB7750E2573}" dt="2026-02-10T18:06:29.099" v="42" actId="478"/>
-            <ac:spMkLst>
-              <pc:docMk/>
-              <pc:sldMasterMk cId="3676200875" sldId="2147483648"/>
-              <pc:sldLayoutMk cId="3540895647" sldId="2147483656"/>
-              <ac:spMk id="10" creationId="{2732B988-C56E-F0AF-F481-B574EF281DCE}"/>
-            </ac:spMkLst>
-          </pc:spChg>
-        </pc:sldLayoutChg>
-        <pc:sldLayoutChg chg="addSp delSp modSp mod">
-          <pc:chgData name="LARCHER MATTEO (IDV Group)" userId="db0184d6-40e4-497e-a5fe-b974eecd6a99" providerId="ADAL" clId="{C0C99BD7-623F-4809-B01E-CFB7750E2573}" dt="2026-02-10T18:06:40.283" v="47"/>
-          <pc:sldLayoutMkLst>
-            <pc:docMk/>
-            <pc:sldMasterMk cId="3676200875" sldId="2147483648"/>
-            <pc:sldLayoutMk cId="3566899855" sldId="2147483657"/>
-          </pc:sldLayoutMkLst>
-          <pc:spChg chg="del">
-            <ac:chgData name="LARCHER MATTEO (IDV Group)" userId="db0184d6-40e4-497e-a5fe-b974eecd6a99" providerId="ADAL" clId="{C0C99BD7-623F-4809-B01E-CFB7750E2573}" dt="2026-02-10T18:06:38.907" v="46" actId="478"/>
-            <ac:spMkLst>
-              <pc:docMk/>
-              <pc:sldMasterMk cId="3676200875" sldId="2147483648"/>
-              <pc:sldLayoutMk cId="3566899855" sldId="2147483657"/>
-              <ac:spMk id="5" creationId="{FDDE0A73-7F0F-1EE2-B8F1-2B2B4B0427D3}"/>
-            </ac:spMkLst>
-          </pc:spChg>
-          <pc:spChg chg="add mod">
-            <ac:chgData name="LARCHER MATTEO (IDV Group)" userId="db0184d6-40e4-497e-a5fe-b974eecd6a99" providerId="ADAL" clId="{C0C99BD7-623F-4809-B01E-CFB7750E2573}" dt="2026-02-10T18:06:40.283" v="47"/>
-            <ac:spMkLst>
-              <pc:docMk/>
-              <pc:sldMasterMk cId="3676200875" sldId="2147483648"/>
-              <pc:sldLayoutMk cId="3566899855" sldId="2147483657"/>
-              <ac:spMk id="6" creationId="{C1CC02D2-8DCF-0B10-B0E8-2819DBB1B3F7}"/>
-            </ac:spMkLst>
-          </pc:spChg>
-          <pc:spChg chg="add mod">
-            <ac:chgData name="LARCHER MATTEO (IDV Group)" userId="db0184d6-40e4-497e-a5fe-b974eecd6a99" providerId="ADAL" clId="{C0C99BD7-623F-4809-B01E-CFB7750E2573}" dt="2026-02-10T18:06:40.283" v="47"/>
-            <ac:spMkLst>
-              <pc:docMk/>
-              <pc:sldMasterMk cId="3676200875" sldId="2147483648"/>
-              <pc:sldLayoutMk cId="3566899855" sldId="2147483657"/>
-              <ac:spMk id="7" creationId="{DF32FAF4-4D9D-6BF7-909C-B06B057F2B85}"/>
-            </ac:spMkLst>
-          </pc:spChg>
-          <pc:spChg chg="add mod">
-            <ac:chgData name="LARCHER MATTEO (IDV Group)" userId="db0184d6-40e4-497e-a5fe-b974eecd6a99" providerId="ADAL" clId="{C0C99BD7-623F-4809-B01E-CFB7750E2573}" dt="2026-02-10T18:06:40.283" v="47"/>
-            <ac:spMkLst>
-              <pc:docMk/>
-              <pc:sldMasterMk cId="3676200875" sldId="2147483648"/>
-              <pc:sldLayoutMk cId="3566899855" sldId="2147483657"/>
-              <ac:spMk id="8" creationId="{EF4B1562-25A7-4119-69B7-C0434CF5E65C}"/>
-            </ac:spMkLst>
-          </pc:spChg>
-          <pc:spChg chg="del">
-            <ac:chgData name="LARCHER MATTEO (IDV Group)" userId="db0184d6-40e4-497e-a5fe-b974eecd6a99" providerId="ADAL" clId="{C0C99BD7-623F-4809-B01E-CFB7750E2573}" dt="2026-02-10T18:06:35.141" v="44" actId="478"/>
-            <ac:spMkLst>
-              <pc:docMk/>
-              <pc:sldMasterMk cId="3676200875" sldId="2147483648"/>
-              <pc:sldLayoutMk cId="3566899855" sldId="2147483657"/>
-              <ac:spMk id="9" creationId="{55C1476F-4732-ED78-4526-CECED718B05F}"/>
-            </ac:spMkLst>
-          </pc:spChg>
-          <pc:spChg chg="del">
-            <ac:chgData name="LARCHER MATTEO (IDV Group)" userId="db0184d6-40e4-497e-a5fe-b974eecd6a99" providerId="ADAL" clId="{C0C99BD7-623F-4809-B01E-CFB7750E2573}" dt="2026-02-10T18:06:37.179" v="45" actId="478"/>
-            <ac:spMkLst>
-              <pc:docMk/>
-              <pc:sldMasterMk cId="3676200875" sldId="2147483648"/>
-              <pc:sldLayoutMk cId="3566899855" sldId="2147483657"/>
-              <ac:spMk id="10" creationId="{90E4D274-C795-B39D-7EA8-FFEF6000E5B7}"/>
-            </ac:spMkLst>
-          </pc:spChg>
-        </pc:sldLayoutChg>
-        <pc:sldLayoutChg chg="addSp delSp modSp mod">
-          <pc:chgData name="LARCHER MATTEO (IDV Group)" userId="db0184d6-40e4-497e-a5fe-b974eecd6a99" providerId="ADAL" clId="{C0C99BD7-623F-4809-B01E-CFB7750E2573}" dt="2026-02-10T18:06:49.971" v="51"/>
-          <pc:sldLayoutMkLst>
-            <pc:docMk/>
-            <pc:sldMasterMk cId="3676200875" sldId="2147483648"/>
-            <pc:sldLayoutMk cId="313914798" sldId="2147483658"/>
-          </pc:sldLayoutMkLst>
-          <pc:spChg chg="del">
-            <ac:chgData name="LARCHER MATTEO (IDV Group)" userId="db0184d6-40e4-497e-a5fe-b974eecd6a99" providerId="ADAL" clId="{C0C99BD7-623F-4809-B01E-CFB7750E2573}" dt="2026-02-10T18:06:48.699" v="50" actId="478"/>
-            <ac:spMkLst>
-              <pc:docMk/>
-              <pc:sldMasterMk cId="3676200875" sldId="2147483648"/>
-              <pc:sldLayoutMk cId="313914798" sldId="2147483658"/>
-              <ac:spMk id="4" creationId="{F1D6BA0C-FCB1-B18B-A578-8A41AB44F39E}"/>
-            </ac:spMkLst>
-          </pc:spChg>
-          <pc:spChg chg="add mod">
-            <ac:chgData name="LARCHER MATTEO (IDV Group)" userId="db0184d6-40e4-497e-a5fe-b974eecd6a99" providerId="ADAL" clId="{C0C99BD7-623F-4809-B01E-CFB7750E2573}" dt="2026-02-10T18:06:49.971" v="51"/>
-            <ac:spMkLst>
-              <pc:docMk/>
-              <pc:sldMasterMk cId="3676200875" sldId="2147483648"/>
-              <pc:sldLayoutMk cId="313914798" sldId="2147483658"/>
-              <ac:spMk id="5" creationId="{2B44B578-3548-6B56-FCB6-E9B0D2B8FA62}"/>
-            </ac:spMkLst>
-          </pc:spChg>
-          <pc:spChg chg="add mod">
-            <ac:chgData name="LARCHER MATTEO (IDV Group)" userId="db0184d6-40e4-497e-a5fe-b974eecd6a99" providerId="ADAL" clId="{C0C99BD7-623F-4809-B01E-CFB7750E2573}" dt="2026-02-10T18:06:49.971" v="51"/>
-            <ac:spMkLst>
-              <pc:docMk/>
-              <pc:sldMasterMk cId="3676200875" sldId="2147483648"/>
-              <pc:sldLayoutMk cId="313914798" sldId="2147483658"/>
-              <ac:spMk id="6" creationId="{15CB9C6F-1936-3F66-F552-139775221040}"/>
-            </ac:spMkLst>
-          </pc:spChg>
-          <pc:spChg chg="add mod">
-            <ac:chgData name="LARCHER MATTEO (IDV Group)" userId="db0184d6-40e4-497e-a5fe-b974eecd6a99" providerId="ADAL" clId="{C0C99BD7-623F-4809-B01E-CFB7750E2573}" dt="2026-02-10T18:06:49.971" v="51"/>
-            <ac:spMkLst>
-              <pc:docMk/>
-              <pc:sldMasterMk cId="3676200875" sldId="2147483648"/>
-              <pc:sldLayoutMk cId="313914798" sldId="2147483658"/>
-              <ac:spMk id="7" creationId="{8881B6CA-FF45-A357-2046-86F3BBB29499}"/>
-            </ac:spMkLst>
-          </pc:spChg>
-          <pc:spChg chg="del">
-            <ac:chgData name="LARCHER MATTEO (IDV Group)" userId="db0184d6-40e4-497e-a5fe-b974eecd6a99" providerId="ADAL" clId="{C0C99BD7-623F-4809-B01E-CFB7750E2573}" dt="2026-02-10T18:06:45.587" v="48" actId="478"/>
-            <ac:spMkLst>
-              <pc:docMk/>
-              <pc:sldMasterMk cId="3676200875" sldId="2147483648"/>
-              <pc:sldLayoutMk cId="313914798" sldId="2147483658"/>
-              <ac:spMk id="8" creationId="{EF5C7BAF-E8DA-2864-BFF7-17DD2169EA66}"/>
-            </ac:spMkLst>
-          </pc:spChg>
-          <pc:spChg chg="del">
-            <ac:chgData name="LARCHER MATTEO (IDV Group)" userId="db0184d6-40e4-497e-a5fe-b974eecd6a99" providerId="ADAL" clId="{C0C99BD7-623F-4809-B01E-CFB7750E2573}" dt="2026-02-10T18:06:47.346" v="49" actId="478"/>
-            <ac:spMkLst>
-              <pc:docMk/>
-              <pc:sldMasterMk cId="3676200875" sldId="2147483648"/>
-              <pc:sldLayoutMk cId="313914798" sldId="2147483658"/>
-              <ac:spMk id="9" creationId="{AF96C2D0-8F28-04A9-CEC0-F21F6C30BD81}"/>
-            </ac:spMkLst>
-          </pc:spChg>
-        </pc:sldLayoutChg>
-        <pc:sldLayoutChg chg="addSp delSp modSp mod">
-          <pc:chgData name="LARCHER MATTEO (IDV Group)" userId="db0184d6-40e4-497e-a5fe-b974eecd6a99" providerId="ADAL" clId="{C0C99BD7-623F-4809-B01E-CFB7750E2573}" dt="2026-02-10T18:06:58.428" v="55"/>
-          <pc:sldLayoutMkLst>
-            <pc:docMk/>
-            <pc:sldMasterMk cId="3676200875" sldId="2147483648"/>
-            <pc:sldLayoutMk cId="2581529045" sldId="2147483659"/>
-          </pc:sldLayoutMkLst>
-          <pc:spChg chg="del">
-            <ac:chgData name="LARCHER MATTEO (IDV Group)" userId="db0184d6-40e4-497e-a5fe-b974eecd6a99" providerId="ADAL" clId="{C0C99BD7-623F-4809-B01E-CFB7750E2573}" dt="2026-02-10T18:06:57.179" v="54" actId="478"/>
-            <ac:spMkLst>
-              <pc:docMk/>
-              <pc:sldMasterMk cId="3676200875" sldId="2147483648"/>
-              <pc:sldLayoutMk cId="2581529045" sldId="2147483659"/>
-              <ac:spMk id="4" creationId="{116057FF-9082-1A59-4CD5-DE9592F83772}"/>
-            </ac:spMkLst>
-          </pc:spChg>
-          <pc:spChg chg="add mod">
-            <ac:chgData name="LARCHER MATTEO (IDV Group)" userId="db0184d6-40e4-497e-a5fe-b974eecd6a99" providerId="ADAL" clId="{C0C99BD7-623F-4809-B01E-CFB7750E2573}" dt="2026-02-10T18:06:58.428" v="55"/>
-            <ac:spMkLst>
-              <pc:docMk/>
-              <pc:sldMasterMk cId="3676200875" sldId="2147483648"/>
-              <pc:sldLayoutMk cId="2581529045" sldId="2147483659"/>
-              <ac:spMk id="5" creationId="{6A79D479-814B-574B-BF84-3E5E13D1555A}"/>
-            </ac:spMkLst>
-          </pc:spChg>
-          <pc:spChg chg="add mod">
-            <ac:chgData name="LARCHER MATTEO (IDV Group)" userId="db0184d6-40e4-497e-a5fe-b974eecd6a99" providerId="ADAL" clId="{C0C99BD7-623F-4809-B01E-CFB7750E2573}" dt="2026-02-10T18:06:58.428" v="55"/>
-            <ac:spMkLst>
-              <pc:docMk/>
-              <pc:sldMasterMk cId="3676200875" sldId="2147483648"/>
-              <pc:sldLayoutMk cId="2581529045" sldId="2147483659"/>
-              <ac:spMk id="6" creationId="{63F67F98-1CC1-5752-5836-1D2FFA15E894}"/>
-            </ac:spMkLst>
-          </pc:spChg>
-          <pc:spChg chg="add mod">
-            <ac:chgData name="LARCHER MATTEO (IDV Group)" userId="db0184d6-40e4-497e-a5fe-b974eecd6a99" providerId="ADAL" clId="{C0C99BD7-623F-4809-B01E-CFB7750E2573}" dt="2026-02-10T18:06:58.428" v="55"/>
-            <ac:spMkLst>
-              <pc:docMk/>
-              <pc:sldMasterMk cId="3676200875" sldId="2147483648"/>
-              <pc:sldLayoutMk cId="2581529045" sldId="2147483659"/>
-              <ac:spMk id="7" creationId="{22F81732-5582-1029-EB9C-969D882FB2B1}"/>
-            </ac:spMkLst>
-          </pc:spChg>
-          <pc:spChg chg="del">
-            <ac:chgData name="LARCHER MATTEO (IDV Group)" userId="db0184d6-40e4-497e-a5fe-b974eecd6a99" providerId="ADAL" clId="{C0C99BD7-623F-4809-B01E-CFB7750E2573}" dt="2026-02-10T18:06:54.418" v="52" actId="478"/>
-            <ac:spMkLst>
-              <pc:docMk/>
-              <pc:sldMasterMk cId="3676200875" sldId="2147483648"/>
-              <pc:sldLayoutMk cId="2581529045" sldId="2147483659"/>
-              <ac:spMk id="8" creationId="{30853B47-A73B-7DD5-78CA-F403E3F053C4}"/>
-            </ac:spMkLst>
-          </pc:spChg>
-          <pc:spChg chg="del">
-            <ac:chgData name="LARCHER MATTEO (IDV Group)" userId="db0184d6-40e4-497e-a5fe-b974eecd6a99" providerId="ADAL" clId="{C0C99BD7-623F-4809-B01E-CFB7750E2573}" dt="2026-02-10T18:06:55.858" v="53" actId="478"/>
-            <ac:spMkLst>
-              <pc:docMk/>
-              <pc:sldMasterMk cId="3676200875" sldId="2147483648"/>
-              <pc:sldLayoutMk cId="2581529045" sldId="2147483659"/>
-              <ac:spMk id="9" creationId="{FDF63EFB-6751-8738-21EA-82881632393C}"/>
-            </ac:spMkLst>
-          </pc:spChg>
-        </pc:sldLayoutChg>
-        <pc:sldLayoutChg chg="addSp delSp modSp mod">
-          <pc:chgData name="LARCHER MATTEO (IDV Group)" userId="db0184d6-40e4-497e-a5fe-b974eecd6a99" providerId="ADAL" clId="{C0C99BD7-623F-4809-B01E-CFB7750E2573}" dt="2026-02-10T18:05:13.992" v="15"/>
-          <pc:sldLayoutMkLst>
-            <pc:docMk/>
-            <pc:sldMasterMk cId="3676200875" sldId="2147483648"/>
-            <pc:sldLayoutMk cId="3842282995" sldId="2147483660"/>
-          </pc:sldLayoutMkLst>
-          <pc:spChg chg="del">
-            <ac:chgData name="LARCHER MATTEO (IDV Group)" userId="db0184d6-40e4-497e-a5fe-b974eecd6a99" providerId="ADAL" clId="{C0C99BD7-623F-4809-B01E-CFB7750E2573}" dt="2026-02-10T18:05:08.052" v="10" actId="478"/>
-            <ac:spMkLst>
-              <pc:docMk/>
-              <pc:sldMasterMk cId="3676200875" sldId="2147483648"/>
-              <pc:sldLayoutMk cId="3842282995" sldId="2147483660"/>
-              <ac:spMk id="4" creationId="{00000000-0000-0000-0000-000000000000}"/>
-            </ac:spMkLst>
-          </pc:spChg>
-          <pc:spChg chg="del">
-            <ac:chgData name="LARCHER MATTEO (IDV Group)" userId="db0184d6-40e4-497e-a5fe-b974eecd6a99" providerId="ADAL" clId="{C0C99BD7-623F-4809-B01E-CFB7750E2573}" dt="2026-02-10T18:05:10.857" v="12" actId="478"/>
-            <ac:spMkLst>
-              <pc:docMk/>
-              <pc:sldMasterMk cId="3676200875" sldId="2147483648"/>
-              <pc:sldLayoutMk cId="3842282995" sldId="2147483660"/>
-              <ac:spMk id="5" creationId="{00000000-0000-0000-0000-000000000000}"/>
-            </ac:spMkLst>
-          </pc:spChg>
-          <pc:spChg chg="del mod">
-            <ac:chgData name="LARCHER MATTEO (IDV Group)" userId="db0184d6-40e4-497e-a5fe-b974eecd6a99" providerId="ADAL" clId="{C0C99BD7-623F-4809-B01E-CFB7750E2573}" dt="2026-02-10T18:05:12.355" v="14" actId="478"/>
-            <ac:spMkLst>
-              <pc:docMk/>
-              <pc:sldMasterMk cId="3676200875" sldId="2147483648"/>
-              <pc:sldLayoutMk cId="3842282995" sldId="2147483660"/>
-              <ac:spMk id="9" creationId="{B38D46BD-367F-3481-A8D8-E3AB2C324A8C}"/>
-            </ac:spMkLst>
-          </pc:spChg>
-          <pc:spChg chg="add mod">
-            <ac:chgData name="LARCHER MATTEO (IDV Group)" userId="db0184d6-40e4-497e-a5fe-b974eecd6a99" providerId="ADAL" clId="{C0C99BD7-623F-4809-B01E-CFB7750E2573}" dt="2026-02-10T18:05:13.992" v="15"/>
-            <ac:spMkLst>
-              <pc:docMk/>
-              <pc:sldMasterMk cId="3676200875" sldId="2147483648"/>
-              <pc:sldLayoutMk cId="3842282995" sldId="2147483660"/>
-              <ac:spMk id="11" creationId="{8A08C1F1-8355-8159-96D8-906760B08FF8}"/>
-            </ac:spMkLst>
-          </pc:spChg>
-          <pc:spChg chg="add mod">
-            <ac:chgData name="LARCHER MATTEO (IDV Group)" userId="db0184d6-40e4-497e-a5fe-b974eecd6a99" providerId="ADAL" clId="{C0C99BD7-623F-4809-B01E-CFB7750E2573}" dt="2026-02-10T18:05:13.992" v="15"/>
-            <ac:spMkLst>
-              <pc:docMk/>
-              <pc:sldMasterMk cId="3676200875" sldId="2147483648"/>
-              <pc:sldLayoutMk cId="3842282995" sldId="2147483660"/>
-              <ac:spMk id="13" creationId="{D5273E9D-BB0F-192B-BD2D-B23EB031957F}"/>
-            </ac:spMkLst>
-          </pc:spChg>
-          <pc:spChg chg="add mod">
-            <ac:chgData name="LARCHER MATTEO (IDV Group)" userId="db0184d6-40e4-497e-a5fe-b974eecd6a99" providerId="ADAL" clId="{C0C99BD7-623F-4809-B01E-CFB7750E2573}" dt="2026-02-10T18:05:13.992" v="15"/>
-            <ac:spMkLst>
-              <pc:docMk/>
-              <pc:sldMasterMk cId="3676200875" sldId="2147483648"/>
-              <pc:sldLayoutMk cId="3842282995" sldId="2147483660"/>
-              <ac:spMk id="14" creationId="{2CA377EC-4940-8F86-BE3D-4090836D167A}"/>
-            </ac:spMkLst>
-          </pc:spChg>
-        </pc:sldLayoutChg>
-        <pc:sldLayoutChg chg="modSp mod">
-          <pc:chgData name="LARCHER MATTEO (IDV Group)" userId="db0184d6-40e4-497e-a5fe-b974eecd6a99" providerId="ADAL" clId="{C0C99BD7-623F-4809-B01E-CFB7750E2573}" dt="2026-02-10T18:04:28.408" v="9" actId="1076"/>
-          <pc:sldLayoutMkLst>
-            <pc:docMk/>
-            <pc:sldMasterMk cId="3676200875" sldId="2147483648"/>
-            <pc:sldLayoutMk cId="2127477481" sldId="2147483661"/>
-          </pc:sldLayoutMkLst>
-          <pc:spChg chg="mod">
-            <ac:chgData name="LARCHER MATTEO (IDV Group)" userId="db0184d6-40e4-497e-a5fe-b974eecd6a99" providerId="ADAL" clId="{C0C99BD7-623F-4809-B01E-CFB7750E2573}" dt="2026-02-10T18:03:19.842" v="3" actId="14100"/>
-            <ac:spMkLst>
-              <pc:docMk/>
-              <pc:sldMasterMk cId="3676200875" sldId="2147483648"/>
-              <pc:sldLayoutMk cId="2127477481" sldId="2147483661"/>
-              <ac:spMk id="4" creationId="{00000000-0000-0000-0000-000000000000}"/>
-            </ac:spMkLst>
-          </pc:spChg>
-          <pc:spChg chg="mod">
-            <ac:chgData name="LARCHER MATTEO (IDV Group)" userId="db0184d6-40e4-497e-a5fe-b974eecd6a99" providerId="ADAL" clId="{C0C99BD7-623F-4809-B01E-CFB7750E2573}" dt="2026-02-10T18:03:13.130" v="2" actId="14100"/>
-            <ac:spMkLst>
-              <pc:docMk/>
-              <pc:sldMasterMk cId="3676200875" sldId="2147483648"/>
-              <pc:sldLayoutMk cId="2127477481" sldId="2147483661"/>
-              <ac:spMk id="5" creationId="{00000000-0000-0000-0000-000000000000}"/>
-            </ac:spMkLst>
-          </pc:spChg>
-          <pc:spChg chg="mod">
-            <ac:chgData name="LARCHER MATTEO (IDV Group)" userId="db0184d6-40e4-497e-a5fe-b974eecd6a99" providerId="ADAL" clId="{C0C99BD7-623F-4809-B01E-CFB7750E2573}" dt="2026-02-10T18:04:28.408" v="9" actId="1076"/>
-            <ac:spMkLst>
-              <pc:docMk/>
-              <pc:sldMasterMk cId="3676200875" sldId="2147483648"/>
-              <pc:sldLayoutMk cId="2127477481" sldId="2147483661"/>
-              <ac:spMk id="12" creationId="{9F7F4A68-C94D-DD3E-7EA3-485F462469CC}"/>
-            </ac:spMkLst>
-          </pc:spChg>
-        </pc:sldLayoutChg>
-        <pc:sldLayoutChg chg="addSp delSp modSp mod">
-          <pc:chgData name="LARCHER MATTEO (IDV Group)" userId="db0184d6-40e4-497e-a5fe-b974eecd6a99" providerId="ADAL" clId="{C0C99BD7-623F-4809-B01E-CFB7750E2573}" dt="2026-02-10T18:05:33.881" v="23"/>
-          <pc:sldLayoutMkLst>
-            <pc:docMk/>
-            <pc:sldMasterMk cId="3676200875" sldId="2147483648"/>
-            <pc:sldLayoutMk cId="1234733671" sldId="2147483662"/>
-          </pc:sldLayoutMkLst>
-          <pc:spChg chg="del">
-            <ac:chgData name="LARCHER MATTEO (IDV Group)" userId="db0184d6-40e4-497e-a5fe-b974eecd6a99" providerId="ADAL" clId="{C0C99BD7-623F-4809-B01E-CFB7750E2573}" dt="2026-02-10T18:05:29.612" v="20" actId="478"/>
-            <ac:spMkLst>
-              <pc:docMk/>
-              <pc:sldMasterMk cId="3676200875" sldId="2147483648"/>
-              <pc:sldLayoutMk cId="1234733671" sldId="2147483662"/>
-              <ac:spMk id="4" creationId="{00000000-0000-0000-0000-000000000000}"/>
-            </ac:spMkLst>
-          </pc:spChg>
-          <pc:spChg chg="del">
-            <ac:chgData name="LARCHER MATTEO (IDV Group)" userId="db0184d6-40e4-497e-a5fe-b974eecd6a99" providerId="ADAL" clId="{C0C99BD7-623F-4809-B01E-CFB7750E2573}" dt="2026-02-10T18:05:30.779" v="21" actId="478"/>
-            <ac:spMkLst>
-              <pc:docMk/>
-              <pc:sldMasterMk cId="3676200875" sldId="2147483648"/>
-              <pc:sldLayoutMk cId="1234733671" sldId="2147483662"/>
-              <ac:spMk id="5" creationId="{00000000-0000-0000-0000-000000000000}"/>
-            </ac:spMkLst>
-          </pc:spChg>
-          <pc:spChg chg="del">
-            <ac:chgData name="LARCHER MATTEO (IDV Group)" userId="db0184d6-40e4-497e-a5fe-b974eecd6a99" providerId="ADAL" clId="{C0C99BD7-623F-4809-B01E-CFB7750E2573}" dt="2026-02-10T18:05:32.453" v="22" actId="478"/>
-            <ac:spMkLst>
-              <pc:docMk/>
-              <pc:sldMasterMk cId="3676200875" sldId="2147483648"/>
-              <pc:sldLayoutMk cId="1234733671" sldId="2147483662"/>
-              <ac:spMk id="7" creationId="{E9A57DD2-0334-0E93-EF42-3A16A5997397}"/>
-            </ac:spMkLst>
-          </pc:spChg>
-          <pc:spChg chg="add mod">
-            <ac:chgData name="LARCHER MATTEO (IDV Group)" userId="db0184d6-40e4-497e-a5fe-b974eecd6a99" providerId="ADAL" clId="{C0C99BD7-623F-4809-B01E-CFB7750E2573}" dt="2026-02-10T18:05:33.881" v="23"/>
-            <ac:spMkLst>
-              <pc:docMk/>
-              <pc:sldMasterMk cId="3676200875" sldId="2147483648"/>
-              <pc:sldLayoutMk cId="1234733671" sldId="2147483662"/>
-              <ac:spMk id="8" creationId="{96582A6A-3CF7-5A19-FF3A-37EBF79C06E1}"/>
-            </ac:spMkLst>
-          </pc:spChg>
-          <pc:spChg chg="add mod">
-            <ac:chgData name="LARCHER MATTEO (IDV Group)" userId="db0184d6-40e4-497e-a5fe-b974eecd6a99" providerId="ADAL" clId="{C0C99BD7-623F-4809-B01E-CFB7750E2573}" dt="2026-02-10T18:05:33.881" v="23"/>
-            <ac:spMkLst>
-              <pc:docMk/>
-              <pc:sldMasterMk cId="3676200875" sldId="2147483648"/>
-              <pc:sldLayoutMk cId="1234733671" sldId="2147483662"/>
-              <ac:spMk id="12" creationId="{EBEC9217-8D04-21E0-7443-07013C127199}"/>
-            </ac:spMkLst>
-          </pc:spChg>
-          <pc:spChg chg="add mod">
-            <ac:chgData name="LARCHER MATTEO (IDV Group)" userId="db0184d6-40e4-497e-a5fe-b974eecd6a99" providerId="ADAL" clId="{C0C99BD7-623F-4809-B01E-CFB7750E2573}" dt="2026-02-10T18:05:33.881" v="23"/>
-            <ac:spMkLst>
-              <pc:docMk/>
-              <pc:sldMasterMk cId="3676200875" sldId="2147483648"/>
-              <pc:sldLayoutMk cId="1234733671" sldId="2147483662"/>
-              <ac:spMk id="13" creationId="{00A54290-737F-5224-6141-FCC7995B7DBE}"/>
-            </ac:spMkLst>
-          </pc:spChg>
-        </pc:sldLayoutChg>
-      </pc:sldMasterChg>
-    </pc:docChg>
-  </pc:docChgLst>
-</pc:chgInfo>
-</file>
-
 <file path=ppt/notesMasters/notesMaster1.xml><?xml version="1.0" encoding="utf-8"?>
 <p:notesMaster xmlns:a="http://schemas.openxmlformats.org/drawingml/2006/main" xmlns:r="http://schemas.openxmlformats.org/officeDocument/2006/relationships" xmlns:p="http://schemas.openxmlformats.org/presentationml/2006/main">
   <p:cSld>
@@ -960,7 +214,7 @@
           <a:p>
             <a:fld id="{0F9C1CCF-B725-44A7-AA57-5E433BD85C9F}" type="datetimeFigureOut">
               <a:rPr lang="en-US" smtClean="0"/>
-              <a:t>2/10/2026</a:t>
+              <a:t>2/8/26</a:t>
             </a:fld>
             <a:endParaRPr lang="en-US"/>
           </a:p>
@@ -1648,7 +902,7 @@
           <a:p>
             <a:fld id="{2D7DBF7F-F54F-1C49-8F76-19ACADAD9270}" type="datetime1">
               <a:rPr lang="it-IT" smtClean="0"/>
-              <a:t>10/02/2026</a:t>
+              <a:t>08/02/26</a:t>
             </a:fld>
             <a:endParaRPr lang="en-US"/>
           </a:p>
@@ -1818,6 +1072,70 @@
           <a:chExt cx="0" cy="0"/>
         </a:xfrm>
       </p:grpSpPr>
+      <p:sp>
+        <p:nvSpPr>
+          <p:cNvPr id="6" name="Date Placeholder 3">
+            <a:extLst>
+              <a:ext uri="{FF2B5EF4-FFF2-40B4-BE49-F238E27FC236}">
+                <a16:creationId xmlns:a16="http://schemas.microsoft.com/office/drawing/2014/main" id="{9D7B9609-DC00-77FF-632B-7CA52E337E03}"/>
+              </a:ext>
+            </a:extLst>
+          </p:cNvPr>
+          <p:cNvSpPr>
+            <a:spLocks noGrp="1"/>
+          </p:cNvSpPr>
+          <p:nvPr>
+            <p:ph type="dt" sz="half" idx="10"/>
+          </p:nvPr>
+        </p:nvSpPr>
+        <p:spPr>
+          <a:xfrm>
+            <a:off x="1984248" y="4775147"/>
+            <a:ext cx="1078992" cy="273844"/>
+          </a:xfrm>
+        </p:spPr>
+        <p:txBody>
+          <a:bodyPr/>
+          <a:lstStyle/>
+          <a:p>
+            <a:fld id="{85454C68-2B9C-2243-9426-8AA164CE3511}" type="datetime1">
+              <a:rPr lang="it-IT" smtClean="0"/>
+              <a:t>08/02/26</a:t>
+            </a:fld>
+            <a:endParaRPr lang="en-US"/>
+          </a:p>
+        </p:txBody>
+      </p:sp>
+      <p:sp>
+        <p:nvSpPr>
+          <p:cNvPr id="7" name="Footer Placeholder 4">
+            <a:extLst>
+              <a:ext uri="{FF2B5EF4-FFF2-40B4-BE49-F238E27FC236}">
+                <a16:creationId xmlns:a16="http://schemas.microsoft.com/office/drawing/2014/main" id="{E05F8820-21D2-6E53-F11B-4CA5D1C131A4}"/>
+              </a:ext>
+            </a:extLst>
+          </p:cNvPr>
+          <p:cNvSpPr>
+            <a:spLocks noGrp="1"/>
+          </p:cNvSpPr>
+          <p:nvPr>
+            <p:ph type="ftr" sz="quarter" idx="11"/>
+          </p:nvPr>
+        </p:nvSpPr>
+        <p:spPr>
+          <a:xfrm>
+            <a:off x="3235878" y="4775147"/>
+            <a:ext cx="3847247" cy="273844"/>
+          </a:xfrm>
+        </p:spPr>
+        <p:txBody>
+          <a:bodyPr/>
+          <a:lstStyle/>
+          <a:p>
+            <a:endParaRPr lang="en-US" dirty="0"/>
+          </a:p>
+        </p:txBody>
+      </p:sp>
       <p:sp>
         <p:nvSpPr>
           <p:cNvPr id="8" name="Slide Number Placeholder 5">
@@ -2052,74 +1370,10 @@
       </p:pic>
       <p:sp>
         <p:nvSpPr>
-          <p:cNvPr id="3" name="Date Placeholder 3">
+          <p:cNvPr id="2" name="TextBox 1">
             <a:extLst>
               <a:ext uri="{FF2B5EF4-FFF2-40B4-BE49-F238E27FC236}">
-                <a16:creationId xmlns:a16="http://schemas.microsoft.com/office/drawing/2014/main" id="{C80F4F23-3D03-8950-5BED-B52565587EEA}"/>
-              </a:ext>
-            </a:extLst>
-          </p:cNvPr>
-          <p:cNvSpPr>
-            <a:spLocks noGrp="1"/>
-          </p:cNvSpPr>
-          <p:nvPr>
-            <p:ph type="dt" sz="half" idx="10"/>
-          </p:nvPr>
-        </p:nvSpPr>
-        <p:spPr>
-          <a:xfrm>
-            <a:off x="1650045" y="4775147"/>
-            <a:ext cx="1532408" cy="273844"/>
-          </a:xfrm>
-        </p:spPr>
-        <p:txBody>
-          <a:bodyPr/>
-          <a:lstStyle/>
-          <a:p>
-            <a:fld id="{B5A3235C-A5F5-CE4E-B015-39F4D75EC196}" type="datetime1">
-              <a:rPr lang="it-IT" smtClean="0"/>
-              <a:t>10/02/2026</a:t>
-            </a:fld>
-            <a:endParaRPr lang="en-US" dirty="0"/>
-          </a:p>
-        </p:txBody>
-      </p:sp>
-      <p:sp>
-        <p:nvSpPr>
-          <p:cNvPr id="4" name="Footer Placeholder 4">
-            <a:extLst>
-              <a:ext uri="{FF2B5EF4-FFF2-40B4-BE49-F238E27FC236}">
-                <a16:creationId xmlns:a16="http://schemas.microsoft.com/office/drawing/2014/main" id="{EE7AFD33-9FB5-12FB-E54E-8CD8F3271062}"/>
-              </a:ext>
-            </a:extLst>
-          </p:cNvPr>
-          <p:cNvSpPr>
-            <a:spLocks noGrp="1"/>
-          </p:cNvSpPr>
-          <p:nvPr>
-            <p:ph type="ftr" sz="quarter" idx="11"/>
-          </p:nvPr>
-        </p:nvSpPr>
-        <p:spPr>
-          <a:xfrm>
-            <a:off x="3355092" y="4775147"/>
-            <a:ext cx="3728033" cy="273844"/>
-          </a:xfrm>
-        </p:spPr>
-        <p:txBody>
-          <a:bodyPr/>
-          <a:lstStyle/>
-          <a:p>
-            <a:endParaRPr lang="en-US" dirty="0"/>
-          </a:p>
-        </p:txBody>
-      </p:sp>
-      <p:sp>
-        <p:nvSpPr>
-          <p:cNvPr id="5" name="TextBox 4">
-            <a:extLst>
-              <a:ext uri="{FF2B5EF4-FFF2-40B4-BE49-F238E27FC236}">
-                <a16:creationId xmlns:a16="http://schemas.microsoft.com/office/drawing/2014/main" id="{931C25FA-D200-3E45-5218-5E7FF21E9CE4}"/>
+                <a16:creationId xmlns:a16="http://schemas.microsoft.com/office/drawing/2014/main" id="{5ECDEA0F-CD3F-E988-8F7E-CF36959BCCB4}"/>
               </a:ext>
             </a:extLst>
           </p:cNvPr>
@@ -2128,7 +1382,7 @@
         </p:nvSpPr>
         <p:spPr>
           <a:xfrm>
-            <a:off x="1499801" y="4963082"/>
+            <a:off x="1499801" y="5009681"/>
             <a:ext cx="6144397" cy="184666"/>
           </a:xfrm>
           <a:prstGeom prst="rect">
@@ -2392,6 +1646,70 @@
               <a:rPr lang="en-US" dirty="0"/>
               <a:t>Click to edit Master text styles</a:t>
             </a:r>
+          </a:p>
+        </p:txBody>
+      </p:sp>
+      <p:sp>
+        <p:nvSpPr>
+          <p:cNvPr id="9" name="Date Placeholder 3">
+            <a:extLst>
+              <a:ext uri="{FF2B5EF4-FFF2-40B4-BE49-F238E27FC236}">
+                <a16:creationId xmlns:a16="http://schemas.microsoft.com/office/drawing/2014/main" id="{C8F14B97-C2FE-7D33-9A73-677B703E4162}"/>
+              </a:ext>
+            </a:extLst>
+          </p:cNvPr>
+          <p:cNvSpPr>
+            <a:spLocks noGrp="1"/>
+          </p:cNvSpPr>
+          <p:nvPr>
+            <p:ph type="dt" sz="half" idx="10"/>
+          </p:nvPr>
+        </p:nvSpPr>
+        <p:spPr>
+          <a:xfrm>
+            <a:off x="1984248" y="4775147"/>
+            <a:ext cx="1078992" cy="273844"/>
+          </a:xfrm>
+        </p:spPr>
+        <p:txBody>
+          <a:bodyPr/>
+          <a:lstStyle/>
+          <a:p>
+            <a:fld id="{D6CE0B0B-E3C5-EF4A-87B2-86DF446F39DB}" type="datetime1">
+              <a:rPr lang="it-IT" smtClean="0"/>
+              <a:t>08/02/26</a:t>
+            </a:fld>
+            <a:endParaRPr lang="en-US"/>
+          </a:p>
+        </p:txBody>
+      </p:sp>
+      <p:sp>
+        <p:nvSpPr>
+          <p:cNvPr id="10" name="Footer Placeholder 4">
+            <a:extLst>
+              <a:ext uri="{FF2B5EF4-FFF2-40B4-BE49-F238E27FC236}">
+                <a16:creationId xmlns:a16="http://schemas.microsoft.com/office/drawing/2014/main" id="{2732B988-C56E-F0AF-F481-B574EF281DCE}"/>
+              </a:ext>
+            </a:extLst>
+          </p:cNvPr>
+          <p:cNvSpPr>
+            <a:spLocks noGrp="1"/>
+          </p:cNvSpPr>
+          <p:nvPr>
+            <p:ph type="ftr" sz="quarter" idx="11"/>
+          </p:nvPr>
+        </p:nvSpPr>
+        <p:spPr>
+          <a:xfrm>
+            <a:off x="3235878" y="4775147"/>
+            <a:ext cx="3847247" cy="273844"/>
+          </a:xfrm>
+        </p:spPr>
+        <p:txBody>
+          <a:bodyPr/>
+          <a:lstStyle/>
+          <a:p>
+            <a:endParaRPr lang="en-US" dirty="0"/>
           </a:p>
         </p:txBody>
       </p:sp>
@@ -2629,74 +1947,10 @@
       </p:pic>
       <p:sp>
         <p:nvSpPr>
-          <p:cNvPr id="6" name="Date Placeholder 3">
+          <p:cNvPr id="5" name="TextBox 4">
             <a:extLst>
               <a:ext uri="{FF2B5EF4-FFF2-40B4-BE49-F238E27FC236}">
-                <a16:creationId xmlns:a16="http://schemas.microsoft.com/office/drawing/2014/main" id="{1FB3E479-3FB2-2124-8CDC-FA3D202BBC7D}"/>
-              </a:ext>
-            </a:extLst>
-          </p:cNvPr>
-          <p:cNvSpPr>
-            <a:spLocks noGrp="1"/>
-          </p:cNvSpPr>
-          <p:nvPr>
-            <p:ph type="dt" sz="half" idx="10"/>
-          </p:nvPr>
-        </p:nvSpPr>
-        <p:spPr>
-          <a:xfrm>
-            <a:off x="1650045" y="4775147"/>
-            <a:ext cx="1532408" cy="273844"/>
-          </a:xfrm>
-        </p:spPr>
-        <p:txBody>
-          <a:bodyPr/>
-          <a:lstStyle/>
-          <a:p>
-            <a:fld id="{B5A3235C-A5F5-CE4E-B015-39F4D75EC196}" type="datetime1">
-              <a:rPr lang="it-IT" smtClean="0"/>
-              <a:t>10/02/2026</a:t>
-            </a:fld>
-            <a:endParaRPr lang="en-US" dirty="0"/>
-          </a:p>
-        </p:txBody>
-      </p:sp>
-      <p:sp>
-        <p:nvSpPr>
-          <p:cNvPr id="7" name="Footer Placeholder 4">
-            <a:extLst>
-              <a:ext uri="{FF2B5EF4-FFF2-40B4-BE49-F238E27FC236}">
-                <a16:creationId xmlns:a16="http://schemas.microsoft.com/office/drawing/2014/main" id="{30D704D9-B764-0534-65D0-DCA588F88C80}"/>
-              </a:ext>
-            </a:extLst>
-          </p:cNvPr>
-          <p:cNvSpPr>
-            <a:spLocks noGrp="1"/>
-          </p:cNvSpPr>
-          <p:nvPr>
-            <p:ph type="ftr" sz="quarter" idx="11"/>
-          </p:nvPr>
-        </p:nvSpPr>
-        <p:spPr>
-          <a:xfrm>
-            <a:off x="3355092" y="4775147"/>
-            <a:ext cx="3728033" cy="273844"/>
-          </a:xfrm>
-        </p:spPr>
-        <p:txBody>
-          <a:bodyPr/>
-          <a:lstStyle/>
-          <a:p>
-            <a:endParaRPr lang="en-US" dirty="0"/>
-          </a:p>
-        </p:txBody>
-      </p:sp>
-      <p:sp>
-        <p:nvSpPr>
-          <p:cNvPr id="8" name="TextBox 7">
-            <a:extLst>
-              <a:ext uri="{FF2B5EF4-FFF2-40B4-BE49-F238E27FC236}">
-                <a16:creationId xmlns:a16="http://schemas.microsoft.com/office/drawing/2014/main" id="{2600830C-D3CF-63CF-DBB0-F4615FFF3167}"/>
+                <a16:creationId xmlns:a16="http://schemas.microsoft.com/office/drawing/2014/main" id="{E08D9B6F-D6D8-AE83-7546-E14BE6C2E410}"/>
               </a:ext>
             </a:extLst>
           </p:cNvPr>
@@ -2705,7 +1959,7 @@
         </p:nvSpPr>
         <p:spPr>
           <a:xfrm>
-            <a:off x="1499801" y="4963082"/>
+            <a:off x="1499801" y="5009681"/>
             <a:ext cx="6144397" cy="184666"/>
           </a:xfrm>
           <a:prstGeom prst="rect">
@@ -2946,6 +2200,70 @@
               <a:rPr lang="en-US" dirty="0"/>
               <a:t>Click to edit Master text styles</a:t>
             </a:r>
+          </a:p>
+        </p:txBody>
+      </p:sp>
+      <p:sp>
+        <p:nvSpPr>
+          <p:cNvPr id="9" name="Date Placeholder 3">
+            <a:extLst>
+              <a:ext uri="{FF2B5EF4-FFF2-40B4-BE49-F238E27FC236}">
+                <a16:creationId xmlns:a16="http://schemas.microsoft.com/office/drawing/2014/main" id="{55C1476F-4732-ED78-4526-CECED718B05F}"/>
+              </a:ext>
+            </a:extLst>
+          </p:cNvPr>
+          <p:cNvSpPr>
+            <a:spLocks noGrp="1"/>
+          </p:cNvSpPr>
+          <p:nvPr>
+            <p:ph type="dt" sz="half" idx="10"/>
+          </p:nvPr>
+        </p:nvSpPr>
+        <p:spPr>
+          <a:xfrm>
+            <a:off x="1984248" y="4775147"/>
+            <a:ext cx="1078992" cy="273844"/>
+          </a:xfrm>
+        </p:spPr>
+        <p:txBody>
+          <a:bodyPr/>
+          <a:lstStyle/>
+          <a:p>
+            <a:fld id="{AE4AF135-7764-144C-811C-680358D4FB0C}" type="datetime1">
+              <a:rPr lang="it-IT" smtClean="0"/>
+              <a:t>08/02/26</a:t>
+            </a:fld>
+            <a:endParaRPr lang="en-US"/>
+          </a:p>
+        </p:txBody>
+      </p:sp>
+      <p:sp>
+        <p:nvSpPr>
+          <p:cNvPr id="10" name="Footer Placeholder 4">
+            <a:extLst>
+              <a:ext uri="{FF2B5EF4-FFF2-40B4-BE49-F238E27FC236}">
+                <a16:creationId xmlns:a16="http://schemas.microsoft.com/office/drawing/2014/main" id="{90E4D274-C795-B39D-7EA8-FFEF6000E5B7}"/>
+              </a:ext>
+            </a:extLst>
+          </p:cNvPr>
+          <p:cNvSpPr>
+            <a:spLocks noGrp="1"/>
+          </p:cNvSpPr>
+          <p:nvPr>
+            <p:ph type="ftr" sz="quarter" idx="11"/>
+          </p:nvPr>
+        </p:nvSpPr>
+        <p:spPr>
+          <a:xfrm>
+            <a:off x="3235878" y="4775147"/>
+            <a:ext cx="3847247" cy="273844"/>
+          </a:xfrm>
+        </p:spPr>
+        <p:txBody>
+          <a:bodyPr/>
+          <a:lstStyle/>
+          <a:p>
+            <a:endParaRPr lang="en-US" dirty="0"/>
           </a:p>
         </p:txBody>
       </p:sp>
@@ -3183,74 +2501,10 @@
       </p:pic>
       <p:sp>
         <p:nvSpPr>
-          <p:cNvPr id="6" name="Date Placeholder 3">
+          <p:cNvPr id="5" name="TextBox 4">
             <a:extLst>
               <a:ext uri="{FF2B5EF4-FFF2-40B4-BE49-F238E27FC236}">
-                <a16:creationId xmlns:a16="http://schemas.microsoft.com/office/drawing/2014/main" id="{C1CC02D2-8DCF-0B10-B0E8-2819DBB1B3F7}"/>
-              </a:ext>
-            </a:extLst>
-          </p:cNvPr>
-          <p:cNvSpPr>
-            <a:spLocks noGrp="1"/>
-          </p:cNvSpPr>
-          <p:nvPr>
-            <p:ph type="dt" sz="half" idx="10"/>
-          </p:nvPr>
-        </p:nvSpPr>
-        <p:spPr>
-          <a:xfrm>
-            <a:off x="1650045" y="4775147"/>
-            <a:ext cx="1532408" cy="273844"/>
-          </a:xfrm>
-        </p:spPr>
-        <p:txBody>
-          <a:bodyPr/>
-          <a:lstStyle/>
-          <a:p>
-            <a:fld id="{B5A3235C-A5F5-CE4E-B015-39F4D75EC196}" type="datetime1">
-              <a:rPr lang="it-IT" smtClean="0"/>
-              <a:t>10/02/2026</a:t>
-            </a:fld>
-            <a:endParaRPr lang="en-US" dirty="0"/>
-          </a:p>
-        </p:txBody>
-      </p:sp>
-      <p:sp>
-        <p:nvSpPr>
-          <p:cNvPr id="7" name="Footer Placeholder 4">
-            <a:extLst>
-              <a:ext uri="{FF2B5EF4-FFF2-40B4-BE49-F238E27FC236}">
-                <a16:creationId xmlns:a16="http://schemas.microsoft.com/office/drawing/2014/main" id="{DF32FAF4-4D9D-6BF7-909C-B06B057F2B85}"/>
-              </a:ext>
-            </a:extLst>
-          </p:cNvPr>
-          <p:cNvSpPr>
-            <a:spLocks noGrp="1"/>
-          </p:cNvSpPr>
-          <p:nvPr>
-            <p:ph type="ftr" sz="quarter" idx="11"/>
-          </p:nvPr>
-        </p:nvSpPr>
-        <p:spPr>
-          <a:xfrm>
-            <a:off x="3355092" y="4775147"/>
-            <a:ext cx="3728033" cy="273844"/>
-          </a:xfrm>
-        </p:spPr>
-        <p:txBody>
-          <a:bodyPr/>
-          <a:lstStyle/>
-          <a:p>
-            <a:endParaRPr lang="en-US" dirty="0"/>
-          </a:p>
-        </p:txBody>
-      </p:sp>
-      <p:sp>
-        <p:nvSpPr>
-          <p:cNvPr id="8" name="TextBox 7">
-            <a:extLst>
-              <a:ext uri="{FF2B5EF4-FFF2-40B4-BE49-F238E27FC236}">
-                <a16:creationId xmlns:a16="http://schemas.microsoft.com/office/drawing/2014/main" id="{EF4B1562-25A7-4119-69B7-C0434CF5E65C}"/>
+                <a16:creationId xmlns:a16="http://schemas.microsoft.com/office/drawing/2014/main" id="{FDDE0A73-7F0F-1EE2-B8F1-2B2B4B0427D3}"/>
               </a:ext>
             </a:extLst>
           </p:cNvPr>
@@ -3259,7 +2513,7 @@
         </p:nvSpPr>
         <p:spPr>
           <a:xfrm>
-            <a:off x="1499801" y="4963082"/>
+            <a:off x="1499801" y="5009681"/>
             <a:ext cx="6144397" cy="184666"/>
           </a:xfrm>
           <a:prstGeom prst="rect">
@@ -3427,6 +2681,70 @@
               <a:rPr lang="en-US" dirty="0"/>
               <a:t>Fifth level</a:t>
             </a:r>
+          </a:p>
+        </p:txBody>
+      </p:sp>
+      <p:sp>
+        <p:nvSpPr>
+          <p:cNvPr id="8" name="Date Placeholder 3">
+            <a:extLst>
+              <a:ext uri="{FF2B5EF4-FFF2-40B4-BE49-F238E27FC236}">
+                <a16:creationId xmlns:a16="http://schemas.microsoft.com/office/drawing/2014/main" id="{EF5C7BAF-E8DA-2864-BFF7-17DD2169EA66}"/>
+              </a:ext>
+            </a:extLst>
+          </p:cNvPr>
+          <p:cNvSpPr>
+            <a:spLocks noGrp="1"/>
+          </p:cNvSpPr>
+          <p:nvPr>
+            <p:ph type="dt" sz="half" idx="10"/>
+          </p:nvPr>
+        </p:nvSpPr>
+        <p:spPr>
+          <a:xfrm>
+            <a:off x="1984248" y="4775147"/>
+            <a:ext cx="1078992" cy="273844"/>
+          </a:xfrm>
+        </p:spPr>
+        <p:txBody>
+          <a:bodyPr/>
+          <a:lstStyle/>
+          <a:p>
+            <a:fld id="{D7720BFA-E534-EF4D-9BC9-39AC6AC2A1F1}" type="datetime1">
+              <a:rPr lang="it-IT" smtClean="0"/>
+              <a:t>08/02/26</a:t>
+            </a:fld>
+            <a:endParaRPr lang="en-US"/>
+          </a:p>
+        </p:txBody>
+      </p:sp>
+      <p:sp>
+        <p:nvSpPr>
+          <p:cNvPr id="9" name="Footer Placeholder 4">
+            <a:extLst>
+              <a:ext uri="{FF2B5EF4-FFF2-40B4-BE49-F238E27FC236}">
+                <a16:creationId xmlns:a16="http://schemas.microsoft.com/office/drawing/2014/main" id="{AF96C2D0-8F28-04A9-CEC0-F21F6C30BD81}"/>
+              </a:ext>
+            </a:extLst>
+          </p:cNvPr>
+          <p:cNvSpPr>
+            <a:spLocks noGrp="1"/>
+          </p:cNvSpPr>
+          <p:nvPr>
+            <p:ph type="ftr" sz="quarter" idx="11"/>
+          </p:nvPr>
+        </p:nvSpPr>
+        <p:spPr>
+          <a:xfrm>
+            <a:off x="3235878" y="4775147"/>
+            <a:ext cx="3847247" cy="273844"/>
+          </a:xfrm>
+        </p:spPr>
+        <p:txBody>
+          <a:bodyPr/>
+          <a:lstStyle/>
+          <a:p>
+            <a:endParaRPr lang="en-US" dirty="0"/>
           </a:p>
         </p:txBody>
       </p:sp>
@@ -3664,74 +2982,10 @@
       </p:pic>
       <p:sp>
         <p:nvSpPr>
-          <p:cNvPr id="5" name="Date Placeholder 3">
+          <p:cNvPr id="4" name="TextBox 3">
             <a:extLst>
               <a:ext uri="{FF2B5EF4-FFF2-40B4-BE49-F238E27FC236}">
-                <a16:creationId xmlns:a16="http://schemas.microsoft.com/office/drawing/2014/main" id="{2B44B578-3548-6B56-FCB6-E9B0D2B8FA62}"/>
-              </a:ext>
-            </a:extLst>
-          </p:cNvPr>
-          <p:cNvSpPr>
-            <a:spLocks noGrp="1"/>
-          </p:cNvSpPr>
-          <p:nvPr>
-            <p:ph type="dt" sz="half" idx="10"/>
-          </p:nvPr>
-        </p:nvSpPr>
-        <p:spPr>
-          <a:xfrm>
-            <a:off x="1650045" y="4775147"/>
-            <a:ext cx="1532408" cy="273844"/>
-          </a:xfrm>
-        </p:spPr>
-        <p:txBody>
-          <a:bodyPr/>
-          <a:lstStyle/>
-          <a:p>
-            <a:fld id="{B5A3235C-A5F5-CE4E-B015-39F4D75EC196}" type="datetime1">
-              <a:rPr lang="it-IT" smtClean="0"/>
-              <a:t>10/02/2026</a:t>
-            </a:fld>
-            <a:endParaRPr lang="en-US" dirty="0"/>
-          </a:p>
-        </p:txBody>
-      </p:sp>
-      <p:sp>
-        <p:nvSpPr>
-          <p:cNvPr id="6" name="Footer Placeholder 4">
-            <a:extLst>
-              <a:ext uri="{FF2B5EF4-FFF2-40B4-BE49-F238E27FC236}">
-                <a16:creationId xmlns:a16="http://schemas.microsoft.com/office/drawing/2014/main" id="{15CB9C6F-1936-3F66-F552-139775221040}"/>
-              </a:ext>
-            </a:extLst>
-          </p:cNvPr>
-          <p:cNvSpPr>
-            <a:spLocks noGrp="1"/>
-          </p:cNvSpPr>
-          <p:nvPr>
-            <p:ph type="ftr" sz="quarter" idx="11"/>
-          </p:nvPr>
-        </p:nvSpPr>
-        <p:spPr>
-          <a:xfrm>
-            <a:off x="3355092" y="4775147"/>
-            <a:ext cx="3728033" cy="273844"/>
-          </a:xfrm>
-        </p:spPr>
-        <p:txBody>
-          <a:bodyPr/>
-          <a:lstStyle/>
-          <a:p>
-            <a:endParaRPr lang="en-US" dirty="0"/>
-          </a:p>
-        </p:txBody>
-      </p:sp>
-      <p:sp>
-        <p:nvSpPr>
-          <p:cNvPr id="7" name="TextBox 6">
-            <a:extLst>
-              <a:ext uri="{FF2B5EF4-FFF2-40B4-BE49-F238E27FC236}">
-                <a16:creationId xmlns:a16="http://schemas.microsoft.com/office/drawing/2014/main" id="{8881B6CA-FF45-A357-2046-86F3BBB29499}"/>
+                <a16:creationId xmlns:a16="http://schemas.microsoft.com/office/drawing/2014/main" id="{F1D6BA0C-FCB1-B18B-A578-8A41AB44F39E}"/>
               </a:ext>
             </a:extLst>
           </p:cNvPr>
@@ -3740,7 +2994,7 @@
         </p:nvSpPr>
         <p:spPr>
           <a:xfrm>
-            <a:off x="1499801" y="4963082"/>
+            <a:off x="1499801" y="5009681"/>
             <a:ext cx="6144397" cy="184666"/>
           </a:xfrm>
           <a:prstGeom prst="rect">
@@ -3922,6 +3176,70 @@
               <a:rPr lang="en-US"/>
               <a:t>Fifth level</a:t>
             </a:r>
+          </a:p>
+        </p:txBody>
+      </p:sp>
+      <p:sp>
+        <p:nvSpPr>
+          <p:cNvPr id="8" name="Date Placeholder 3">
+            <a:extLst>
+              <a:ext uri="{FF2B5EF4-FFF2-40B4-BE49-F238E27FC236}">
+                <a16:creationId xmlns:a16="http://schemas.microsoft.com/office/drawing/2014/main" id="{30853B47-A73B-7DD5-78CA-F403E3F053C4}"/>
+              </a:ext>
+            </a:extLst>
+          </p:cNvPr>
+          <p:cNvSpPr>
+            <a:spLocks noGrp="1"/>
+          </p:cNvSpPr>
+          <p:nvPr>
+            <p:ph type="dt" sz="half" idx="10"/>
+          </p:nvPr>
+        </p:nvSpPr>
+        <p:spPr>
+          <a:xfrm>
+            <a:off x="1984248" y="4775147"/>
+            <a:ext cx="1078992" cy="273844"/>
+          </a:xfrm>
+        </p:spPr>
+        <p:txBody>
+          <a:bodyPr/>
+          <a:lstStyle/>
+          <a:p>
+            <a:fld id="{B20FCA3A-31A1-034E-9624-8CD1F736D4F6}" type="datetime1">
+              <a:rPr lang="it-IT" smtClean="0"/>
+              <a:t>08/02/26</a:t>
+            </a:fld>
+            <a:endParaRPr lang="en-US"/>
+          </a:p>
+        </p:txBody>
+      </p:sp>
+      <p:sp>
+        <p:nvSpPr>
+          <p:cNvPr id="9" name="Footer Placeholder 4">
+            <a:extLst>
+              <a:ext uri="{FF2B5EF4-FFF2-40B4-BE49-F238E27FC236}">
+                <a16:creationId xmlns:a16="http://schemas.microsoft.com/office/drawing/2014/main" id="{FDF63EFB-6751-8738-21EA-82881632393C}"/>
+              </a:ext>
+            </a:extLst>
+          </p:cNvPr>
+          <p:cNvSpPr>
+            <a:spLocks noGrp="1"/>
+          </p:cNvSpPr>
+          <p:nvPr>
+            <p:ph type="ftr" sz="quarter" idx="11"/>
+          </p:nvPr>
+        </p:nvSpPr>
+        <p:spPr>
+          <a:xfrm>
+            <a:off x="3235878" y="4775147"/>
+            <a:ext cx="3847247" cy="273844"/>
+          </a:xfrm>
+        </p:spPr>
+        <p:txBody>
+          <a:bodyPr/>
+          <a:lstStyle/>
+          <a:p>
+            <a:endParaRPr lang="en-US" dirty="0"/>
           </a:p>
         </p:txBody>
       </p:sp>
@@ -4159,74 +3477,10 @@
       </p:pic>
       <p:sp>
         <p:nvSpPr>
-          <p:cNvPr id="5" name="Date Placeholder 3">
+          <p:cNvPr id="4" name="TextBox 3">
             <a:extLst>
               <a:ext uri="{FF2B5EF4-FFF2-40B4-BE49-F238E27FC236}">
-                <a16:creationId xmlns:a16="http://schemas.microsoft.com/office/drawing/2014/main" id="{6A79D479-814B-574B-BF84-3E5E13D1555A}"/>
-              </a:ext>
-            </a:extLst>
-          </p:cNvPr>
-          <p:cNvSpPr>
-            <a:spLocks noGrp="1"/>
-          </p:cNvSpPr>
-          <p:nvPr>
-            <p:ph type="dt" sz="half" idx="10"/>
-          </p:nvPr>
-        </p:nvSpPr>
-        <p:spPr>
-          <a:xfrm>
-            <a:off x="1650045" y="4775147"/>
-            <a:ext cx="1532408" cy="273844"/>
-          </a:xfrm>
-        </p:spPr>
-        <p:txBody>
-          <a:bodyPr/>
-          <a:lstStyle/>
-          <a:p>
-            <a:fld id="{B5A3235C-A5F5-CE4E-B015-39F4D75EC196}" type="datetime1">
-              <a:rPr lang="it-IT" smtClean="0"/>
-              <a:t>10/02/2026</a:t>
-            </a:fld>
-            <a:endParaRPr lang="en-US" dirty="0"/>
-          </a:p>
-        </p:txBody>
-      </p:sp>
-      <p:sp>
-        <p:nvSpPr>
-          <p:cNvPr id="6" name="Footer Placeholder 4">
-            <a:extLst>
-              <a:ext uri="{FF2B5EF4-FFF2-40B4-BE49-F238E27FC236}">
-                <a16:creationId xmlns:a16="http://schemas.microsoft.com/office/drawing/2014/main" id="{63F67F98-1CC1-5752-5836-1D2FFA15E894}"/>
-              </a:ext>
-            </a:extLst>
-          </p:cNvPr>
-          <p:cNvSpPr>
-            <a:spLocks noGrp="1"/>
-          </p:cNvSpPr>
-          <p:nvPr>
-            <p:ph type="ftr" sz="quarter" idx="11"/>
-          </p:nvPr>
-        </p:nvSpPr>
-        <p:spPr>
-          <a:xfrm>
-            <a:off x="3355092" y="4775147"/>
-            <a:ext cx="3728033" cy="273844"/>
-          </a:xfrm>
-        </p:spPr>
-        <p:txBody>
-          <a:bodyPr/>
-          <a:lstStyle/>
-          <a:p>
-            <a:endParaRPr lang="en-US" dirty="0"/>
-          </a:p>
-        </p:txBody>
-      </p:sp>
-      <p:sp>
-        <p:nvSpPr>
-          <p:cNvPr id="7" name="TextBox 6">
-            <a:extLst>
-              <a:ext uri="{FF2B5EF4-FFF2-40B4-BE49-F238E27FC236}">
-                <a16:creationId xmlns:a16="http://schemas.microsoft.com/office/drawing/2014/main" id="{22F81732-5582-1029-EB9C-969D882FB2B1}"/>
+                <a16:creationId xmlns:a16="http://schemas.microsoft.com/office/drawing/2014/main" id="{116057FF-9082-1A59-4CD5-DE9592F83772}"/>
               </a:ext>
             </a:extLst>
           </p:cNvPr>
@@ -4235,7 +3489,7 @@
         </p:nvSpPr>
         <p:spPr>
           <a:xfrm>
-            <a:off x="1499801" y="4963082"/>
+            <a:off x="1499801" y="5009681"/>
             <a:ext cx="6144397" cy="184666"/>
           </a:xfrm>
           <a:prstGeom prst="rect">
@@ -4498,8 +3752,8 @@
         </p:nvSpPr>
         <p:spPr>
           <a:xfrm>
-            <a:off x="1650045" y="4775147"/>
-            <a:ext cx="1532408" cy="273844"/>
+            <a:off x="1984248" y="4775147"/>
+            <a:ext cx="1078992" cy="273844"/>
           </a:xfrm>
         </p:spPr>
         <p:txBody>
@@ -4508,9 +3762,9 @@
           <a:p>
             <a:fld id="{B5A3235C-A5F5-CE4E-B015-39F4D75EC196}" type="datetime1">
               <a:rPr lang="it-IT" smtClean="0"/>
-              <a:t>10/02/2026</a:t>
+              <a:t>08/02/26</a:t>
             </a:fld>
-            <a:endParaRPr lang="en-US" dirty="0"/>
+            <a:endParaRPr lang="en-US"/>
           </a:p>
         </p:txBody>
       </p:sp>
@@ -4526,8 +3780,8 @@
         </p:nvSpPr>
         <p:spPr>
           <a:xfrm>
-            <a:off x="3355092" y="4775147"/>
-            <a:ext cx="3728033" cy="273844"/>
+            <a:off x="3235878" y="4775147"/>
+            <a:ext cx="3847247" cy="273844"/>
           </a:xfrm>
         </p:spPr>
         <p:txBody>
@@ -4808,7 +4062,7 @@
         </p:nvSpPr>
         <p:spPr>
           <a:xfrm>
-            <a:off x="1499801" y="4963082"/>
+            <a:off x="1499801" y="5009681"/>
             <a:ext cx="6144397" cy="184666"/>
           </a:xfrm>
           <a:prstGeom prst="rect">
@@ -5056,6 +4310,58 @@
               <a:rPr lang="en-US" dirty="0"/>
               <a:t>Fifth level</a:t>
             </a:r>
+          </a:p>
+        </p:txBody>
+      </p:sp>
+      <p:sp>
+        <p:nvSpPr>
+          <p:cNvPr id="4" name="Date Placeholder 3"/>
+          <p:cNvSpPr>
+            <a:spLocks noGrp="1"/>
+          </p:cNvSpPr>
+          <p:nvPr>
+            <p:ph type="dt" sz="half" idx="10"/>
+          </p:nvPr>
+        </p:nvSpPr>
+        <p:spPr>
+          <a:xfrm>
+            <a:off x="1984248" y="4775147"/>
+            <a:ext cx="1078992" cy="273844"/>
+          </a:xfrm>
+        </p:spPr>
+        <p:txBody>
+          <a:bodyPr/>
+          <a:lstStyle/>
+          <a:p>
+            <a:fld id="{9FC0F10B-4FCD-A840-811B-58139C9D20D6}" type="datetime1">
+              <a:rPr lang="it-IT" smtClean="0"/>
+              <a:t>08/02/26</a:t>
+            </a:fld>
+            <a:endParaRPr lang="en-US"/>
+          </a:p>
+        </p:txBody>
+      </p:sp>
+      <p:sp>
+        <p:nvSpPr>
+          <p:cNvPr id="5" name="Footer Placeholder 4"/>
+          <p:cNvSpPr>
+            <a:spLocks noGrp="1"/>
+          </p:cNvSpPr>
+          <p:nvPr>
+            <p:ph type="ftr" sz="quarter" idx="11"/>
+          </p:nvPr>
+        </p:nvSpPr>
+        <p:spPr>
+          <a:xfrm>
+            <a:off x="3235878" y="4775147"/>
+            <a:ext cx="3847247" cy="273844"/>
+          </a:xfrm>
+        </p:spPr>
+        <p:txBody>
+          <a:bodyPr/>
+          <a:lstStyle/>
+          <a:p>
+            <a:endParaRPr lang="en-US" dirty="0"/>
           </a:p>
         </p:txBody>
       </p:sp>
@@ -5338,74 +4644,10 @@
       </p:pic>
       <p:sp>
         <p:nvSpPr>
-          <p:cNvPr id="11" name="Date Placeholder 3">
+          <p:cNvPr id="9" name="TextBox 8">
             <a:extLst>
               <a:ext uri="{FF2B5EF4-FFF2-40B4-BE49-F238E27FC236}">
-                <a16:creationId xmlns:a16="http://schemas.microsoft.com/office/drawing/2014/main" id="{8A08C1F1-8355-8159-96D8-906760B08FF8}"/>
-              </a:ext>
-            </a:extLst>
-          </p:cNvPr>
-          <p:cNvSpPr>
-            <a:spLocks noGrp="1"/>
-          </p:cNvSpPr>
-          <p:nvPr>
-            <p:ph type="dt" sz="half" idx="10"/>
-          </p:nvPr>
-        </p:nvSpPr>
-        <p:spPr>
-          <a:xfrm>
-            <a:off x="1650045" y="4775147"/>
-            <a:ext cx="1532408" cy="273844"/>
-          </a:xfrm>
-        </p:spPr>
-        <p:txBody>
-          <a:bodyPr/>
-          <a:lstStyle/>
-          <a:p>
-            <a:fld id="{B5A3235C-A5F5-CE4E-B015-39F4D75EC196}" type="datetime1">
-              <a:rPr lang="it-IT" smtClean="0"/>
-              <a:t>10/02/2026</a:t>
-            </a:fld>
-            <a:endParaRPr lang="en-US" dirty="0"/>
-          </a:p>
-        </p:txBody>
-      </p:sp>
-      <p:sp>
-        <p:nvSpPr>
-          <p:cNvPr id="13" name="Footer Placeholder 4">
-            <a:extLst>
-              <a:ext uri="{FF2B5EF4-FFF2-40B4-BE49-F238E27FC236}">
-                <a16:creationId xmlns:a16="http://schemas.microsoft.com/office/drawing/2014/main" id="{D5273E9D-BB0F-192B-BD2D-B23EB031957F}"/>
-              </a:ext>
-            </a:extLst>
-          </p:cNvPr>
-          <p:cNvSpPr>
-            <a:spLocks noGrp="1"/>
-          </p:cNvSpPr>
-          <p:nvPr>
-            <p:ph type="ftr" sz="quarter" idx="11"/>
-          </p:nvPr>
-        </p:nvSpPr>
-        <p:spPr>
-          <a:xfrm>
-            <a:off x="3355092" y="4775147"/>
-            <a:ext cx="3728033" cy="273844"/>
-          </a:xfrm>
-        </p:spPr>
-        <p:txBody>
-          <a:bodyPr/>
-          <a:lstStyle/>
-          <a:p>
-            <a:endParaRPr lang="en-US" dirty="0"/>
-          </a:p>
-        </p:txBody>
-      </p:sp>
-      <p:sp>
-        <p:nvSpPr>
-          <p:cNvPr id="14" name="TextBox 13">
-            <a:extLst>
-              <a:ext uri="{FF2B5EF4-FFF2-40B4-BE49-F238E27FC236}">
-                <a16:creationId xmlns:a16="http://schemas.microsoft.com/office/drawing/2014/main" id="{2CA377EC-4940-8F86-BE3D-4090836D167A}"/>
+                <a16:creationId xmlns:a16="http://schemas.microsoft.com/office/drawing/2014/main" id="{B38D46BD-367F-3481-A8D8-E3AB2C324A8C}"/>
               </a:ext>
             </a:extLst>
           </p:cNvPr>
@@ -5414,7 +4656,7 @@
         </p:nvSpPr>
         <p:spPr>
           <a:xfrm>
-            <a:off x="1499801" y="4963082"/>
+            <a:off x="1499801" y="5009681"/>
             <a:ext cx="6144397" cy="184666"/>
           </a:xfrm>
           <a:prstGeom prst="rect">
@@ -5627,6 +4869,58 @@
               <a:rPr lang="en-US" dirty="0"/>
               <a:t>Fifth level</a:t>
             </a:r>
+          </a:p>
+        </p:txBody>
+      </p:sp>
+      <p:sp>
+        <p:nvSpPr>
+          <p:cNvPr id="4" name="Date Placeholder 3"/>
+          <p:cNvSpPr>
+            <a:spLocks noGrp="1"/>
+          </p:cNvSpPr>
+          <p:nvPr>
+            <p:ph type="dt" sz="half" idx="10"/>
+          </p:nvPr>
+        </p:nvSpPr>
+        <p:spPr>
+          <a:xfrm>
+            <a:off x="1984248" y="4775147"/>
+            <a:ext cx="1078992" cy="273844"/>
+          </a:xfrm>
+        </p:spPr>
+        <p:txBody>
+          <a:bodyPr/>
+          <a:lstStyle/>
+          <a:p>
+            <a:fld id="{88C27D80-F3A7-A741-A1BF-A0356AB69374}" type="datetime1">
+              <a:rPr lang="it-IT" smtClean="0"/>
+              <a:t>08/02/26</a:t>
+            </a:fld>
+            <a:endParaRPr lang="en-US"/>
+          </a:p>
+        </p:txBody>
+      </p:sp>
+      <p:sp>
+        <p:nvSpPr>
+          <p:cNvPr id="5" name="Footer Placeholder 4"/>
+          <p:cNvSpPr>
+            <a:spLocks noGrp="1"/>
+          </p:cNvSpPr>
+          <p:nvPr>
+            <p:ph type="ftr" sz="quarter" idx="11"/>
+          </p:nvPr>
+        </p:nvSpPr>
+        <p:spPr>
+          <a:xfrm>
+            <a:off x="3235878" y="4775147"/>
+            <a:ext cx="3847247" cy="273844"/>
+          </a:xfrm>
+        </p:spPr>
+        <p:txBody>
+          <a:bodyPr/>
+          <a:lstStyle/>
+          <a:p>
+            <a:endParaRPr lang="en-US" dirty="0"/>
           </a:p>
         </p:txBody>
       </p:sp>
@@ -5888,74 +5182,10 @@
       </p:pic>
       <p:sp>
         <p:nvSpPr>
-          <p:cNvPr id="8" name="Date Placeholder 3">
+          <p:cNvPr id="7" name="TextBox 6">
             <a:extLst>
               <a:ext uri="{FF2B5EF4-FFF2-40B4-BE49-F238E27FC236}">
-                <a16:creationId xmlns:a16="http://schemas.microsoft.com/office/drawing/2014/main" id="{41E08C21-258C-AE13-75FE-C21C90539E06}"/>
-              </a:ext>
-            </a:extLst>
-          </p:cNvPr>
-          <p:cNvSpPr>
-            <a:spLocks noGrp="1"/>
-          </p:cNvSpPr>
-          <p:nvPr>
-            <p:ph type="dt" sz="half" idx="10"/>
-          </p:nvPr>
-        </p:nvSpPr>
-        <p:spPr>
-          <a:xfrm>
-            <a:off x="1650045" y="4775147"/>
-            <a:ext cx="1532408" cy="273844"/>
-          </a:xfrm>
-        </p:spPr>
-        <p:txBody>
-          <a:bodyPr/>
-          <a:lstStyle/>
-          <a:p>
-            <a:fld id="{B5A3235C-A5F5-CE4E-B015-39F4D75EC196}" type="datetime1">
-              <a:rPr lang="it-IT" smtClean="0"/>
-              <a:t>10/02/2026</a:t>
-            </a:fld>
-            <a:endParaRPr lang="en-US" dirty="0"/>
-          </a:p>
-        </p:txBody>
-      </p:sp>
-      <p:sp>
-        <p:nvSpPr>
-          <p:cNvPr id="12" name="Footer Placeholder 4">
-            <a:extLst>
-              <a:ext uri="{FF2B5EF4-FFF2-40B4-BE49-F238E27FC236}">
-                <a16:creationId xmlns:a16="http://schemas.microsoft.com/office/drawing/2014/main" id="{41FF191B-B050-8EC2-28F4-138E94F7812D}"/>
-              </a:ext>
-            </a:extLst>
-          </p:cNvPr>
-          <p:cNvSpPr>
-            <a:spLocks noGrp="1"/>
-          </p:cNvSpPr>
-          <p:nvPr>
-            <p:ph type="ftr" sz="quarter" idx="11"/>
-          </p:nvPr>
-        </p:nvSpPr>
-        <p:spPr>
-          <a:xfrm>
-            <a:off x="3355092" y="4775147"/>
-            <a:ext cx="3728033" cy="273844"/>
-          </a:xfrm>
-        </p:spPr>
-        <p:txBody>
-          <a:bodyPr/>
-          <a:lstStyle/>
-          <a:p>
-            <a:endParaRPr lang="en-US" dirty="0"/>
-          </a:p>
-        </p:txBody>
-      </p:sp>
-      <p:sp>
-        <p:nvSpPr>
-          <p:cNvPr id="13" name="TextBox 12">
-            <a:extLst>
-              <a:ext uri="{FF2B5EF4-FFF2-40B4-BE49-F238E27FC236}">
-                <a16:creationId xmlns:a16="http://schemas.microsoft.com/office/drawing/2014/main" id="{94B64F0D-639F-48C9-18D3-58ADDF542781}"/>
+                <a16:creationId xmlns:a16="http://schemas.microsoft.com/office/drawing/2014/main" id="{DC0F4838-F6BF-C30B-C410-5E532DCDEE34}"/>
               </a:ext>
             </a:extLst>
           </p:cNvPr>
@@ -5964,7 +5194,7 @@
         </p:nvSpPr>
         <p:spPr>
           <a:xfrm>
-            <a:off x="1499801" y="4963082"/>
+            <a:off x="1499801" y="5009681"/>
             <a:ext cx="6144397" cy="184666"/>
           </a:xfrm>
           <a:prstGeom prst="rect">
@@ -6193,6 +5423,58 @@
               <a:rPr lang="en-US" dirty="0"/>
               <a:t>Fifth level</a:t>
             </a:r>
+          </a:p>
+        </p:txBody>
+      </p:sp>
+      <p:sp>
+        <p:nvSpPr>
+          <p:cNvPr id="4" name="Date Placeholder 3"/>
+          <p:cNvSpPr>
+            <a:spLocks noGrp="1"/>
+          </p:cNvSpPr>
+          <p:nvPr>
+            <p:ph type="dt" sz="half" idx="10"/>
+          </p:nvPr>
+        </p:nvSpPr>
+        <p:spPr>
+          <a:xfrm>
+            <a:off x="1984248" y="4775147"/>
+            <a:ext cx="1078992" cy="273844"/>
+          </a:xfrm>
+        </p:spPr>
+        <p:txBody>
+          <a:bodyPr/>
+          <a:lstStyle/>
+          <a:p>
+            <a:fld id="{E06934FA-7FD1-0D46-8E1C-1AFE08A73439}" type="datetime1">
+              <a:rPr lang="it-IT" smtClean="0"/>
+              <a:t>08/02/26</a:t>
+            </a:fld>
+            <a:endParaRPr lang="en-US"/>
+          </a:p>
+        </p:txBody>
+      </p:sp>
+      <p:sp>
+        <p:nvSpPr>
+          <p:cNvPr id="5" name="Footer Placeholder 4"/>
+          <p:cNvSpPr>
+            <a:spLocks noGrp="1"/>
+          </p:cNvSpPr>
+          <p:nvPr>
+            <p:ph type="ftr" sz="quarter" idx="11"/>
+          </p:nvPr>
+        </p:nvSpPr>
+        <p:spPr>
+          <a:xfrm>
+            <a:off x="3235878" y="4775147"/>
+            <a:ext cx="3847247" cy="273844"/>
+          </a:xfrm>
+        </p:spPr>
+        <p:txBody>
+          <a:bodyPr/>
+          <a:lstStyle/>
+          <a:p>
+            <a:endParaRPr lang="en-US" dirty="0"/>
           </a:p>
         </p:txBody>
       </p:sp>
@@ -6454,74 +5736,10 @@
       </p:pic>
       <p:sp>
         <p:nvSpPr>
-          <p:cNvPr id="8" name="Date Placeholder 3">
+          <p:cNvPr id="7" name="TextBox 6">
             <a:extLst>
               <a:ext uri="{FF2B5EF4-FFF2-40B4-BE49-F238E27FC236}">
-                <a16:creationId xmlns:a16="http://schemas.microsoft.com/office/drawing/2014/main" id="{96582A6A-3CF7-5A19-FF3A-37EBF79C06E1}"/>
-              </a:ext>
-            </a:extLst>
-          </p:cNvPr>
-          <p:cNvSpPr>
-            <a:spLocks noGrp="1"/>
-          </p:cNvSpPr>
-          <p:nvPr>
-            <p:ph type="dt" sz="half" idx="10"/>
-          </p:nvPr>
-        </p:nvSpPr>
-        <p:spPr>
-          <a:xfrm>
-            <a:off x="1650045" y="4775147"/>
-            <a:ext cx="1532408" cy="273844"/>
-          </a:xfrm>
-        </p:spPr>
-        <p:txBody>
-          <a:bodyPr/>
-          <a:lstStyle/>
-          <a:p>
-            <a:fld id="{B5A3235C-A5F5-CE4E-B015-39F4D75EC196}" type="datetime1">
-              <a:rPr lang="it-IT" smtClean="0"/>
-              <a:t>10/02/2026</a:t>
-            </a:fld>
-            <a:endParaRPr lang="en-US" dirty="0"/>
-          </a:p>
-        </p:txBody>
-      </p:sp>
-      <p:sp>
-        <p:nvSpPr>
-          <p:cNvPr id="12" name="Footer Placeholder 4">
-            <a:extLst>
-              <a:ext uri="{FF2B5EF4-FFF2-40B4-BE49-F238E27FC236}">
-                <a16:creationId xmlns:a16="http://schemas.microsoft.com/office/drawing/2014/main" id="{EBEC9217-8D04-21E0-7443-07013C127199}"/>
-              </a:ext>
-            </a:extLst>
-          </p:cNvPr>
-          <p:cNvSpPr>
-            <a:spLocks noGrp="1"/>
-          </p:cNvSpPr>
-          <p:nvPr>
-            <p:ph type="ftr" sz="quarter" idx="11"/>
-          </p:nvPr>
-        </p:nvSpPr>
-        <p:spPr>
-          <a:xfrm>
-            <a:off x="3355092" y="4775147"/>
-            <a:ext cx="3728033" cy="273844"/>
-          </a:xfrm>
-        </p:spPr>
-        <p:txBody>
-          <a:bodyPr/>
-          <a:lstStyle/>
-          <a:p>
-            <a:endParaRPr lang="en-US" dirty="0"/>
-          </a:p>
-        </p:txBody>
-      </p:sp>
-      <p:sp>
-        <p:nvSpPr>
-          <p:cNvPr id="13" name="TextBox 12">
-            <a:extLst>
-              <a:ext uri="{FF2B5EF4-FFF2-40B4-BE49-F238E27FC236}">
-                <a16:creationId xmlns:a16="http://schemas.microsoft.com/office/drawing/2014/main" id="{00A54290-737F-5224-6141-FCC7995B7DBE}"/>
+                <a16:creationId xmlns:a16="http://schemas.microsoft.com/office/drawing/2014/main" id="{E9A57DD2-0334-0E93-EF42-3A16A5997397}"/>
               </a:ext>
             </a:extLst>
           </p:cNvPr>
@@ -6530,7 +5748,7 @@
         </p:nvSpPr>
         <p:spPr>
           <a:xfrm>
-            <a:off x="1499801" y="4963082"/>
+            <a:off x="1499801" y="5009681"/>
             <a:ext cx="6144397" cy="184666"/>
           </a:xfrm>
           <a:prstGeom prst="rect">
@@ -7045,6 +6263,70 @@
               <a:rPr lang="en-US" dirty="0"/>
               <a:t>Fifth level</a:t>
             </a:r>
+          </a:p>
+        </p:txBody>
+      </p:sp>
+      <p:sp>
+        <p:nvSpPr>
+          <p:cNvPr id="9" name="Date Placeholder 3">
+            <a:extLst>
+              <a:ext uri="{FF2B5EF4-FFF2-40B4-BE49-F238E27FC236}">
+                <a16:creationId xmlns:a16="http://schemas.microsoft.com/office/drawing/2014/main" id="{C4053F5D-6FBA-B899-9B82-B9093E335267}"/>
+              </a:ext>
+            </a:extLst>
+          </p:cNvPr>
+          <p:cNvSpPr>
+            <a:spLocks noGrp="1"/>
+          </p:cNvSpPr>
+          <p:nvPr>
+            <p:ph type="dt" sz="half" idx="10"/>
+          </p:nvPr>
+        </p:nvSpPr>
+        <p:spPr>
+          <a:xfrm>
+            <a:off x="1984248" y="4775147"/>
+            <a:ext cx="1078992" cy="273844"/>
+          </a:xfrm>
+        </p:spPr>
+        <p:txBody>
+          <a:bodyPr/>
+          <a:lstStyle/>
+          <a:p>
+            <a:fld id="{21E9D82B-7A2C-DA4C-B24C-1024813AE2F0}" type="datetime1">
+              <a:rPr lang="it-IT" smtClean="0"/>
+              <a:t>08/02/26</a:t>
+            </a:fld>
+            <a:endParaRPr lang="en-US"/>
+          </a:p>
+        </p:txBody>
+      </p:sp>
+      <p:sp>
+        <p:nvSpPr>
+          <p:cNvPr id="10" name="Footer Placeholder 4">
+            <a:extLst>
+              <a:ext uri="{FF2B5EF4-FFF2-40B4-BE49-F238E27FC236}">
+                <a16:creationId xmlns:a16="http://schemas.microsoft.com/office/drawing/2014/main" id="{BB17D917-DE37-B43C-7F01-65FA3EFC88FA}"/>
+              </a:ext>
+            </a:extLst>
+          </p:cNvPr>
+          <p:cNvSpPr>
+            <a:spLocks noGrp="1"/>
+          </p:cNvSpPr>
+          <p:nvPr>
+            <p:ph type="ftr" sz="quarter" idx="11"/>
+          </p:nvPr>
+        </p:nvSpPr>
+        <p:spPr>
+          <a:xfrm>
+            <a:off x="3235878" y="4775147"/>
+            <a:ext cx="3847247" cy="273844"/>
+          </a:xfrm>
+        </p:spPr>
+        <p:txBody>
+          <a:bodyPr/>
+          <a:lstStyle/>
+          <a:p>
+            <a:endParaRPr lang="en-US" dirty="0"/>
           </a:p>
         </p:txBody>
       </p:sp>
@@ -7282,74 +6564,10 @@
       </p:pic>
       <p:sp>
         <p:nvSpPr>
-          <p:cNvPr id="6" name="Date Placeholder 3">
+          <p:cNvPr id="5" name="TextBox 4">
             <a:extLst>
               <a:ext uri="{FF2B5EF4-FFF2-40B4-BE49-F238E27FC236}">
-                <a16:creationId xmlns:a16="http://schemas.microsoft.com/office/drawing/2014/main" id="{3D0F4771-8AB8-078F-DC78-B397B4F3D0A1}"/>
-              </a:ext>
-            </a:extLst>
-          </p:cNvPr>
-          <p:cNvSpPr>
-            <a:spLocks noGrp="1"/>
-          </p:cNvSpPr>
-          <p:nvPr>
-            <p:ph type="dt" sz="half" idx="10"/>
-          </p:nvPr>
-        </p:nvSpPr>
-        <p:spPr>
-          <a:xfrm>
-            <a:off x="1650045" y="4775147"/>
-            <a:ext cx="1532408" cy="273844"/>
-          </a:xfrm>
-        </p:spPr>
-        <p:txBody>
-          <a:bodyPr/>
-          <a:lstStyle/>
-          <a:p>
-            <a:fld id="{B5A3235C-A5F5-CE4E-B015-39F4D75EC196}" type="datetime1">
-              <a:rPr lang="it-IT" smtClean="0"/>
-              <a:t>10/02/2026</a:t>
-            </a:fld>
-            <a:endParaRPr lang="en-US" dirty="0"/>
-          </a:p>
-        </p:txBody>
-      </p:sp>
-      <p:sp>
-        <p:nvSpPr>
-          <p:cNvPr id="7" name="Footer Placeholder 4">
-            <a:extLst>
-              <a:ext uri="{FF2B5EF4-FFF2-40B4-BE49-F238E27FC236}">
-                <a16:creationId xmlns:a16="http://schemas.microsoft.com/office/drawing/2014/main" id="{8101B048-30E1-B224-4B98-3A9EBBB3F171}"/>
-              </a:ext>
-            </a:extLst>
-          </p:cNvPr>
-          <p:cNvSpPr>
-            <a:spLocks noGrp="1"/>
-          </p:cNvSpPr>
-          <p:nvPr>
-            <p:ph type="ftr" sz="quarter" idx="11"/>
-          </p:nvPr>
-        </p:nvSpPr>
-        <p:spPr>
-          <a:xfrm>
-            <a:off x="3355092" y="4775147"/>
-            <a:ext cx="3728033" cy="273844"/>
-          </a:xfrm>
-        </p:spPr>
-        <p:txBody>
-          <a:bodyPr/>
-          <a:lstStyle/>
-          <a:p>
-            <a:endParaRPr lang="en-US" dirty="0"/>
-          </a:p>
-        </p:txBody>
-      </p:sp>
-      <p:sp>
-        <p:nvSpPr>
-          <p:cNvPr id="8" name="TextBox 7">
-            <a:extLst>
-              <a:ext uri="{FF2B5EF4-FFF2-40B4-BE49-F238E27FC236}">
-                <a16:creationId xmlns:a16="http://schemas.microsoft.com/office/drawing/2014/main" id="{2F6EFAC2-B140-4F02-2719-6ACA51832925}"/>
+                <a16:creationId xmlns:a16="http://schemas.microsoft.com/office/drawing/2014/main" id="{36A728D5-5BBE-C9BE-C8CB-7E6F35D77231}"/>
               </a:ext>
             </a:extLst>
           </p:cNvPr>
@@ -7358,7 +6576,7 @@
         </p:nvSpPr>
         <p:spPr>
           <a:xfrm>
-            <a:off x="1499801" y="4963082"/>
+            <a:off x="1499801" y="5009681"/>
             <a:ext cx="6144397" cy="184666"/>
           </a:xfrm>
           <a:prstGeom prst="rect">
@@ -7785,6 +7003,70 @@
               <a:rPr lang="en-US" dirty="0"/>
               <a:t>Fifth level</a:t>
             </a:r>
+          </a:p>
+        </p:txBody>
+      </p:sp>
+      <p:sp>
+        <p:nvSpPr>
+          <p:cNvPr id="11" name="Date Placeholder 3">
+            <a:extLst>
+              <a:ext uri="{FF2B5EF4-FFF2-40B4-BE49-F238E27FC236}">
+                <a16:creationId xmlns:a16="http://schemas.microsoft.com/office/drawing/2014/main" id="{49F71F15-28F7-2AFB-0561-2D46D21B76B0}"/>
+              </a:ext>
+            </a:extLst>
+          </p:cNvPr>
+          <p:cNvSpPr>
+            <a:spLocks noGrp="1"/>
+          </p:cNvSpPr>
+          <p:nvPr>
+            <p:ph type="dt" sz="half" idx="10"/>
+          </p:nvPr>
+        </p:nvSpPr>
+        <p:spPr>
+          <a:xfrm>
+            <a:off x="1984248" y="4775147"/>
+            <a:ext cx="1078992" cy="273844"/>
+          </a:xfrm>
+        </p:spPr>
+        <p:txBody>
+          <a:bodyPr/>
+          <a:lstStyle/>
+          <a:p>
+            <a:fld id="{9429820C-B789-AB43-B4E1-4B378514779B}" type="datetime1">
+              <a:rPr lang="it-IT" smtClean="0"/>
+              <a:t>08/02/26</a:t>
+            </a:fld>
+            <a:endParaRPr lang="en-US"/>
+          </a:p>
+        </p:txBody>
+      </p:sp>
+      <p:sp>
+        <p:nvSpPr>
+          <p:cNvPr id="12" name="Footer Placeholder 4">
+            <a:extLst>
+              <a:ext uri="{FF2B5EF4-FFF2-40B4-BE49-F238E27FC236}">
+                <a16:creationId xmlns:a16="http://schemas.microsoft.com/office/drawing/2014/main" id="{8F417543-5403-66B4-114C-C61D3E3DBB66}"/>
+              </a:ext>
+            </a:extLst>
+          </p:cNvPr>
+          <p:cNvSpPr>
+            <a:spLocks noGrp="1"/>
+          </p:cNvSpPr>
+          <p:nvPr>
+            <p:ph type="ftr" sz="quarter" idx="11"/>
+          </p:nvPr>
+        </p:nvSpPr>
+        <p:spPr>
+          <a:xfrm>
+            <a:off x="3235878" y="4775147"/>
+            <a:ext cx="3847247" cy="273844"/>
+          </a:xfrm>
+        </p:spPr>
+        <p:txBody>
+          <a:bodyPr/>
+          <a:lstStyle/>
+          <a:p>
+            <a:endParaRPr lang="en-US" dirty="0"/>
           </a:p>
         </p:txBody>
       </p:sp>
@@ -8022,74 +7304,10 @@
       </p:pic>
       <p:sp>
         <p:nvSpPr>
-          <p:cNvPr id="8" name="Date Placeholder 3">
+          <p:cNvPr id="7" name="TextBox 6">
             <a:extLst>
               <a:ext uri="{FF2B5EF4-FFF2-40B4-BE49-F238E27FC236}">
-                <a16:creationId xmlns:a16="http://schemas.microsoft.com/office/drawing/2014/main" id="{83FEA519-AFF1-9BAC-77EE-613D983768EC}"/>
-              </a:ext>
-            </a:extLst>
-          </p:cNvPr>
-          <p:cNvSpPr>
-            <a:spLocks noGrp="1"/>
-          </p:cNvSpPr>
-          <p:nvPr>
-            <p:ph type="dt" sz="half" idx="10"/>
-          </p:nvPr>
-        </p:nvSpPr>
-        <p:spPr>
-          <a:xfrm>
-            <a:off x="1650045" y="4775147"/>
-            <a:ext cx="1532408" cy="273844"/>
-          </a:xfrm>
-        </p:spPr>
-        <p:txBody>
-          <a:bodyPr/>
-          <a:lstStyle/>
-          <a:p>
-            <a:fld id="{B5A3235C-A5F5-CE4E-B015-39F4D75EC196}" type="datetime1">
-              <a:rPr lang="it-IT" smtClean="0"/>
-              <a:t>10/02/2026</a:t>
-            </a:fld>
-            <a:endParaRPr lang="en-US" dirty="0"/>
-          </a:p>
-        </p:txBody>
-      </p:sp>
-      <p:sp>
-        <p:nvSpPr>
-          <p:cNvPr id="9" name="Footer Placeholder 4">
-            <a:extLst>
-              <a:ext uri="{FF2B5EF4-FFF2-40B4-BE49-F238E27FC236}">
-                <a16:creationId xmlns:a16="http://schemas.microsoft.com/office/drawing/2014/main" id="{DC18DF14-CD00-67F5-96D3-71A18578BF00}"/>
-              </a:ext>
-            </a:extLst>
-          </p:cNvPr>
-          <p:cNvSpPr>
-            <a:spLocks noGrp="1"/>
-          </p:cNvSpPr>
-          <p:nvPr>
-            <p:ph type="ftr" sz="quarter" idx="11"/>
-          </p:nvPr>
-        </p:nvSpPr>
-        <p:spPr>
-          <a:xfrm>
-            <a:off x="3355092" y="4775147"/>
-            <a:ext cx="3728033" cy="273844"/>
-          </a:xfrm>
-        </p:spPr>
-        <p:txBody>
-          <a:bodyPr/>
-          <a:lstStyle/>
-          <a:p>
-            <a:endParaRPr lang="en-US" dirty="0"/>
-          </a:p>
-        </p:txBody>
-      </p:sp>
-      <p:sp>
-        <p:nvSpPr>
-          <p:cNvPr id="10" name="TextBox 9">
-            <a:extLst>
-              <a:ext uri="{FF2B5EF4-FFF2-40B4-BE49-F238E27FC236}">
-                <a16:creationId xmlns:a16="http://schemas.microsoft.com/office/drawing/2014/main" id="{05F4EA1A-7BC8-CB03-4BE7-88B7F503D813}"/>
+                <a16:creationId xmlns:a16="http://schemas.microsoft.com/office/drawing/2014/main" id="{2AAF3200-A4E9-67DF-6962-7DE8759EEE6D}"/>
               </a:ext>
             </a:extLst>
           </p:cNvPr>
@@ -8098,7 +7316,7 @@
         </p:nvSpPr>
         <p:spPr>
           <a:xfrm>
-            <a:off x="1499801" y="4963082"/>
+            <a:off x="1499801" y="5009681"/>
             <a:ext cx="6144397" cy="184666"/>
           </a:xfrm>
           <a:prstGeom prst="rect">
@@ -8219,6 +7437,70 @@
               <a:rPr lang="en-US" dirty="0"/>
               <a:t>CLICK TO EDIT MASTER TITLE STYLE</a:t>
             </a:r>
+          </a:p>
+        </p:txBody>
+      </p:sp>
+      <p:sp>
+        <p:nvSpPr>
+          <p:cNvPr id="7" name="Date Placeholder 3">
+            <a:extLst>
+              <a:ext uri="{FF2B5EF4-FFF2-40B4-BE49-F238E27FC236}">
+                <a16:creationId xmlns:a16="http://schemas.microsoft.com/office/drawing/2014/main" id="{3E3EC6A0-D5A9-CC66-04AC-E97B0756CB15}"/>
+              </a:ext>
+            </a:extLst>
+          </p:cNvPr>
+          <p:cNvSpPr>
+            <a:spLocks noGrp="1"/>
+          </p:cNvSpPr>
+          <p:nvPr>
+            <p:ph type="dt" sz="half" idx="10"/>
+          </p:nvPr>
+        </p:nvSpPr>
+        <p:spPr>
+          <a:xfrm>
+            <a:off x="1984248" y="4775147"/>
+            <a:ext cx="1078992" cy="273844"/>
+          </a:xfrm>
+        </p:spPr>
+        <p:txBody>
+          <a:bodyPr/>
+          <a:lstStyle/>
+          <a:p>
+            <a:fld id="{EC46D180-6558-4140-957D-A04D35F919BF}" type="datetime1">
+              <a:rPr lang="it-IT" smtClean="0"/>
+              <a:t>08/02/26</a:t>
+            </a:fld>
+            <a:endParaRPr lang="en-US"/>
+          </a:p>
+        </p:txBody>
+      </p:sp>
+      <p:sp>
+        <p:nvSpPr>
+          <p:cNvPr id="8" name="Footer Placeholder 4">
+            <a:extLst>
+              <a:ext uri="{FF2B5EF4-FFF2-40B4-BE49-F238E27FC236}">
+                <a16:creationId xmlns:a16="http://schemas.microsoft.com/office/drawing/2014/main" id="{DB2FD283-0D8C-247C-BFEE-0557A57D0063}"/>
+              </a:ext>
+            </a:extLst>
+          </p:cNvPr>
+          <p:cNvSpPr>
+            <a:spLocks noGrp="1"/>
+          </p:cNvSpPr>
+          <p:nvPr>
+            <p:ph type="ftr" sz="quarter" idx="11"/>
+          </p:nvPr>
+        </p:nvSpPr>
+        <p:spPr>
+          <a:xfrm>
+            <a:off x="3235878" y="4775147"/>
+            <a:ext cx="3847247" cy="273844"/>
+          </a:xfrm>
+        </p:spPr>
+        <p:txBody>
+          <a:bodyPr/>
+          <a:lstStyle/>
+          <a:p>
+            <a:endParaRPr lang="en-US" dirty="0"/>
           </a:p>
         </p:txBody>
       </p:sp>
@@ -8456,74 +7738,10 @@
       </p:pic>
       <p:sp>
         <p:nvSpPr>
-          <p:cNvPr id="4" name="Date Placeholder 3">
+          <p:cNvPr id="3" name="TextBox 2">
             <a:extLst>
               <a:ext uri="{FF2B5EF4-FFF2-40B4-BE49-F238E27FC236}">
-                <a16:creationId xmlns:a16="http://schemas.microsoft.com/office/drawing/2014/main" id="{410D6FD3-F0A6-9E97-8EC0-E1CCC2B7E703}"/>
-              </a:ext>
-            </a:extLst>
-          </p:cNvPr>
-          <p:cNvSpPr>
-            <a:spLocks noGrp="1"/>
-          </p:cNvSpPr>
-          <p:nvPr>
-            <p:ph type="dt" sz="half" idx="10"/>
-          </p:nvPr>
-        </p:nvSpPr>
-        <p:spPr>
-          <a:xfrm>
-            <a:off x="1650045" y="4775147"/>
-            <a:ext cx="1532408" cy="273844"/>
-          </a:xfrm>
-        </p:spPr>
-        <p:txBody>
-          <a:bodyPr/>
-          <a:lstStyle/>
-          <a:p>
-            <a:fld id="{B5A3235C-A5F5-CE4E-B015-39F4D75EC196}" type="datetime1">
-              <a:rPr lang="it-IT" smtClean="0"/>
-              <a:t>10/02/2026</a:t>
-            </a:fld>
-            <a:endParaRPr lang="en-US" dirty="0"/>
-          </a:p>
-        </p:txBody>
-      </p:sp>
-      <p:sp>
-        <p:nvSpPr>
-          <p:cNvPr id="5" name="Footer Placeholder 4">
-            <a:extLst>
-              <a:ext uri="{FF2B5EF4-FFF2-40B4-BE49-F238E27FC236}">
-                <a16:creationId xmlns:a16="http://schemas.microsoft.com/office/drawing/2014/main" id="{BB534351-4221-27F8-F02E-7F05F1EBD0DE}"/>
-              </a:ext>
-            </a:extLst>
-          </p:cNvPr>
-          <p:cNvSpPr>
-            <a:spLocks noGrp="1"/>
-          </p:cNvSpPr>
-          <p:nvPr>
-            <p:ph type="ftr" sz="quarter" idx="11"/>
-          </p:nvPr>
-        </p:nvSpPr>
-        <p:spPr>
-          <a:xfrm>
-            <a:off x="3355092" y="4775147"/>
-            <a:ext cx="3728033" cy="273844"/>
-          </a:xfrm>
-        </p:spPr>
-        <p:txBody>
-          <a:bodyPr/>
-          <a:lstStyle/>
-          <a:p>
-            <a:endParaRPr lang="en-US" dirty="0"/>
-          </a:p>
-        </p:txBody>
-      </p:sp>
-      <p:sp>
-        <p:nvSpPr>
-          <p:cNvPr id="6" name="TextBox 5">
-            <a:extLst>
-              <a:ext uri="{FF2B5EF4-FFF2-40B4-BE49-F238E27FC236}">
-                <a16:creationId xmlns:a16="http://schemas.microsoft.com/office/drawing/2014/main" id="{C4822D55-90CB-F8AF-3E85-2686202A21A8}"/>
+                <a16:creationId xmlns:a16="http://schemas.microsoft.com/office/drawing/2014/main" id="{8F0BB32C-C6A2-82A8-490B-7538697EFCED}"/>
               </a:ext>
             </a:extLst>
           </p:cNvPr>
@@ -8532,7 +7750,7 @@
         </p:nvSpPr>
         <p:spPr>
           <a:xfrm>
-            <a:off x="1499801" y="4963082"/>
+            <a:off x="1499801" y="5009681"/>
             <a:ext cx="6144397" cy="184666"/>
           </a:xfrm>
           <a:prstGeom prst="rect">
@@ -8750,7 +7968,7 @@
           <a:p>
             <a:fld id="{4EE47AEE-98EC-0C43-8D64-9D05BF501A01}" type="datetime1">
               <a:rPr lang="it-IT" smtClean="0"/>
-              <a:t>10/02/2026</a:t>
+              <a:t>08/02/26</a:t>
             </a:fld>
             <a:endParaRPr lang="en-US"/>
           </a:p>
@@ -9196,7 +8414,7 @@
           <a:p>
             <a:fld id="{D1602D0C-839A-CF4F-9D15-89FD2575D155}" type="datetime1">
               <a:rPr lang="it-IT" smtClean="0"/>
-              <a:t>10/02/2026</a:t>
+              <a:t>08/02/26</a:t>
             </a:fld>
             <a:endParaRPr lang="en-US"/>
           </a:p>
@@ -9325,19 +8543,14 @@
             <p:ph type="dt" sz="half" idx="10"/>
           </p:nvPr>
         </p:nvSpPr>
-        <p:spPr>
-          <a:xfrm>
-            <a:off x="1984248" y="4775147"/>
-            <a:ext cx="1078992" cy="273844"/>
-          </a:xfrm>
-        </p:spPr>
+        <p:spPr/>
         <p:txBody>
           <a:bodyPr/>
           <a:lstStyle/>
           <a:p>
             <a:fld id="{9C7945CA-8852-CF4A-A88C-560042723BA1}" type="datetime1">
               <a:rPr lang="it-IT" smtClean="0"/>
-              <a:t>10/02/2026</a:t>
+              <a:t>08/02/26</a:t>
             </a:fld>
             <a:endParaRPr lang="en-US"/>
           </a:p>
@@ -9359,12 +8572,7 @@
             <p:ph type="ftr" sz="quarter" idx="11"/>
           </p:nvPr>
         </p:nvSpPr>
-        <p:spPr>
-          <a:xfrm>
-            <a:off x="3235878" y="4775147"/>
-            <a:ext cx="3847247" cy="273844"/>
-          </a:xfrm>
-        </p:spPr>
+        <p:spPr/>
         <p:txBody>
           <a:bodyPr/>
           <a:lstStyle/>
@@ -9602,19 +8810,14 @@
             <p:ph type="dt" sz="half" idx="10"/>
           </p:nvPr>
         </p:nvSpPr>
-        <p:spPr>
-          <a:xfrm>
-            <a:off x="1984248" y="4775147"/>
-            <a:ext cx="1078992" cy="273844"/>
-          </a:xfrm>
-        </p:spPr>
+        <p:spPr/>
         <p:txBody>
           <a:bodyPr/>
           <a:lstStyle/>
           <a:p>
             <a:fld id="{64E14661-1291-564D-ADDE-841126F5283D}" type="datetime1">
               <a:rPr lang="it-IT" smtClean="0"/>
-              <a:t>10/02/2026</a:t>
+              <a:t>08/02/26</a:t>
             </a:fld>
             <a:endParaRPr lang="en-US"/>
           </a:p>
@@ -9636,12 +8839,7 @@
             <p:ph type="ftr" sz="quarter" idx="11"/>
           </p:nvPr>
         </p:nvSpPr>
-        <p:spPr>
-          <a:xfrm>
-            <a:off x="3235878" y="4775147"/>
-            <a:ext cx="3847247" cy="273844"/>
-          </a:xfrm>
-        </p:spPr>
+        <p:spPr/>
         <p:txBody>
           <a:bodyPr/>
           <a:lstStyle/>

</xml_diff>

<commit_message>
[FIX] minor fixes to pptx reference file
</commit_message>
<xml_diff>
--- a/_extensions/IDV-Share/quarto-presentation-templates/reference/IDV-template.pptx
+++ b/_extensions/IDV-Share/quarto-presentation-templates/reference/IDV-template.pptx
@@ -132,6 +132,562 @@
 </p:presentation>
 </file>
 
+<file path=ppt/revisionInfo.xml><?xml version="1.0" encoding="utf-8"?>
+<p1510:revInfo xmlns:a="http://schemas.openxmlformats.org/drawingml/2006/main" xmlns:r="http://schemas.openxmlformats.org/officeDocument/2006/relationships" xmlns:p1510="http://schemas.microsoft.com/office/powerpoint/2015/10/main">
+  <p1510:revLst>
+    <p1510:client id="{C0C99BD7-623F-4809-B01E-CFB7750E2573}" v="11" dt="2026-02-16T23:49:20.002"/>
+  </p1510:revLst>
+</p1510:revInfo>
+</file>
+
+<file path=ppt/changesInfos/changesInfo1.xml><?xml version="1.0" encoding="utf-8"?>
+<pc:chgInfo xmlns:a="http://schemas.openxmlformats.org/drawingml/2006/main" xmlns:r="http://schemas.openxmlformats.org/officeDocument/2006/relationships" xmlns:ac="http://schemas.microsoft.com/office/drawing/2013/main/command" xmlns:pc="http://schemas.microsoft.com/office/powerpoint/2013/main/command">
+  <pc:docChgLst>
+    <pc:chgData name="LARCHER MATTEO (IDV Group)" userId="db0184d6-40e4-497e-a5fe-b974eecd6a99" providerId="ADAL" clId="{C0C99BD7-623F-4809-B01E-CFB7750E2573}"/>
+    <pc:docChg chg="custSel modMainMaster">
+      <pc:chgData name="LARCHER MATTEO (IDV Group)" userId="db0184d6-40e4-497e-a5fe-b974eecd6a99" providerId="ADAL" clId="{C0C99BD7-623F-4809-B01E-CFB7750E2573}" dt="2026-02-16T23:49:20.002" v="61"/>
+      <pc:docMkLst>
+        <pc:docMk/>
+      </pc:docMkLst>
+      <pc:sldMasterChg chg="modSldLayout">
+        <pc:chgData name="LARCHER MATTEO (IDV Group)" userId="db0184d6-40e4-497e-a5fe-b974eecd6a99" providerId="ADAL" clId="{C0C99BD7-623F-4809-B01E-CFB7750E2573}" dt="2026-02-16T23:49:20.002" v="61"/>
+        <pc:sldMasterMkLst>
+          <pc:docMk/>
+          <pc:sldMasterMk cId="3676200875" sldId="2147483648"/>
+        </pc:sldMasterMkLst>
+        <pc:sldLayoutChg chg="modSp mod">
+          <pc:chgData name="LARCHER MATTEO (IDV Group)" userId="db0184d6-40e4-497e-a5fe-b974eecd6a99" providerId="ADAL" clId="{C0C99BD7-623F-4809-B01E-CFB7750E2573}" dt="2026-02-16T23:47:14.802" v="24" actId="1038"/>
+          <pc:sldLayoutMkLst>
+            <pc:docMk/>
+            <pc:sldMasterMk cId="3676200875" sldId="2147483648"/>
+            <pc:sldLayoutMk cId="1444357513" sldId="2147483649"/>
+          </pc:sldLayoutMkLst>
+          <pc:spChg chg="mod">
+            <ac:chgData name="LARCHER MATTEO (IDV Group)" userId="db0184d6-40e4-497e-a5fe-b974eecd6a99" providerId="ADAL" clId="{C0C99BD7-623F-4809-B01E-CFB7750E2573}" dt="2026-02-16T23:47:14.802" v="24" actId="1038"/>
+            <ac:spMkLst>
+              <pc:docMk/>
+              <pc:sldMasterMk cId="3676200875" sldId="2147483648"/>
+              <pc:sldLayoutMk cId="1444357513" sldId="2147483649"/>
+              <ac:spMk id="3" creationId="{00000000-0000-0000-0000-000000000000}"/>
+            </ac:spMkLst>
+          </pc:spChg>
+        </pc:sldLayoutChg>
+        <pc:sldLayoutChg chg="addSp delSp modSp mod">
+          <pc:chgData name="LARCHER MATTEO (IDV Group)" userId="db0184d6-40e4-497e-a5fe-b974eecd6a99" providerId="ADAL" clId="{C0C99BD7-623F-4809-B01E-CFB7750E2573}" dt="2026-02-16T23:48:17.689" v="33"/>
+          <pc:sldLayoutMkLst>
+            <pc:docMk/>
+            <pc:sldMasterMk cId="3676200875" sldId="2147483648"/>
+            <pc:sldLayoutMk cId="338346009" sldId="2147483650"/>
+          </pc:sldLayoutMkLst>
+          <pc:spChg chg="del">
+            <ac:chgData name="LARCHER MATTEO (IDV Group)" userId="db0184d6-40e4-497e-a5fe-b974eecd6a99" providerId="ADAL" clId="{C0C99BD7-623F-4809-B01E-CFB7750E2573}" dt="2026-02-16T23:48:16.589" v="32" actId="478"/>
+            <ac:spMkLst>
+              <pc:docMk/>
+              <pc:sldMasterMk cId="3676200875" sldId="2147483648"/>
+              <pc:sldLayoutMk cId="338346009" sldId="2147483650"/>
+              <ac:spMk id="4" creationId="{00000000-0000-0000-0000-000000000000}"/>
+            </ac:spMkLst>
+          </pc:spChg>
+          <pc:spChg chg="del mod">
+            <ac:chgData name="LARCHER MATTEO (IDV Group)" userId="db0184d6-40e4-497e-a5fe-b974eecd6a99" providerId="ADAL" clId="{C0C99BD7-623F-4809-B01E-CFB7750E2573}" dt="2026-02-16T23:48:14.800" v="31" actId="478"/>
+            <ac:spMkLst>
+              <pc:docMk/>
+              <pc:sldMasterMk cId="3676200875" sldId="2147483648"/>
+              <pc:sldLayoutMk cId="338346009" sldId="2147483650"/>
+              <ac:spMk id="7" creationId="{DC0F4838-F6BF-C30B-C410-5E532DCDEE34}"/>
+            </ac:spMkLst>
+          </pc:spChg>
+          <pc:spChg chg="add mod">
+            <ac:chgData name="LARCHER MATTEO (IDV Group)" userId="db0184d6-40e4-497e-a5fe-b974eecd6a99" providerId="ADAL" clId="{C0C99BD7-623F-4809-B01E-CFB7750E2573}" dt="2026-02-16T23:48:17.689" v="33"/>
+            <ac:spMkLst>
+              <pc:docMk/>
+              <pc:sldMasterMk cId="3676200875" sldId="2147483648"/>
+              <pc:sldLayoutMk cId="338346009" sldId="2147483650"/>
+              <ac:spMk id="8" creationId="{23853EF7-9530-9CE3-8AAC-163A81EF4EAE}"/>
+            </ac:spMkLst>
+          </pc:spChg>
+          <pc:spChg chg="add mod">
+            <ac:chgData name="LARCHER MATTEO (IDV Group)" userId="db0184d6-40e4-497e-a5fe-b974eecd6a99" providerId="ADAL" clId="{C0C99BD7-623F-4809-B01E-CFB7750E2573}" dt="2026-02-16T23:48:17.689" v="33"/>
+            <ac:spMkLst>
+              <pc:docMk/>
+              <pc:sldMasterMk cId="3676200875" sldId="2147483648"/>
+              <pc:sldLayoutMk cId="338346009" sldId="2147483650"/>
+              <ac:spMk id="12" creationId="{0BCF4466-819F-2857-3C33-DB2BFD6F8B49}"/>
+            </ac:spMkLst>
+          </pc:spChg>
+        </pc:sldLayoutChg>
+        <pc:sldLayoutChg chg="addSp delSp modSp mod">
+          <pc:chgData name="LARCHER MATTEO (IDV Group)" userId="db0184d6-40e4-497e-a5fe-b974eecd6a99" providerId="ADAL" clId="{C0C99BD7-623F-4809-B01E-CFB7750E2573}" dt="2026-02-16T23:48:35.326" v="40"/>
+          <pc:sldLayoutMkLst>
+            <pc:docMk/>
+            <pc:sldMasterMk cId="3676200875" sldId="2147483648"/>
+            <pc:sldLayoutMk cId="2619886245" sldId="2147483652"/>
+          </pc:sldLayoutMkLst>
+          <pc:spChg chg="del">
+            <ac:chgData name="LARCHER MATTEO (IDV Group)" userId="db0184d6-40e4-497e-a5fe-b974eecd6a99" providerId="ADAL" clId="{C0C99BD7-623F-4809-B01E-CFB7750E2573}" dt="2026-02-16T23:48:34.365" v="39" actId="478"/>
+            <ac:spMkLst>
+              <pc:docMk/>
+              <pc:sldMasterMk cId="3676200875" sldId="2147483648"/>
+              <pc:sldLayoutMk cId="2619886245" sldId="2147483652"/>
+              <ac:spMk id="5" creationId="{36A728D5-5BBE-C9BE-C8CB-7E6F35D77231}"/>
+            </ac:spMkLst>
+          </pc:spChg>
+          <pc:spChg chg="add mod">
+            <ac:chgData name="LARCHER MATTEO (IDV Group)" userId="db0184d6-40e4-497e-a5fe-b974eecd6a99" providerId="ADAL" clId="{C0C99BD7-623F-4809-B01E-CFB7750E2573}" dt="2026-02-16T23:48:35.326" v="40"/>
+            <ac:spMkLst>
+              <pc:docMk/>
+              <pc:sldMasterMk cId="3676200875" sldId="2147483648"/>
+              <pc:sldLayoutMk cId="2619886245" sldId="2147483652"/>
+              <ac:spMk id="6" creationId="{9DC74560-9E05-FD16-6AD6-A28A46251192}"/>
+            </ac:spMkLst>
+          </pc:spChg>
+          <pc:spChg chg="add mod">
+            <ac:chgData name="LARCHER MATTEO (IDV Group)" userId="db0184d6-40e4-497e-a5fe-b974eecd6a99" providerId="ADAL" clId="{C0C99BD7-623F-4809-B01E-CFB7750E2573}" dt="2026-02-16T23:48:35.326" v="40"/>
+            <ac:spMkLst>
+              <pc:docMk/>
+              <pc:sldMasterMk cId="3676200875" sldId="2147483648"/>
+              <pc:sldLayoutMk cId="2619886245" sldId="2147483652"/>
+              <ac:spMk id="7" creationId="{920AA42E-3654-E284-069F-FC32E2EBEBCE}"/>
+            </ac:spMkLst>
+          </pc:spChg>
+          <pc:spChg chg="del">
+            <ac:chgData name="LARCHER MATTEO (IDV Group)" userId="db0184d6-40e4-497e-a5fe-b974eecd6a99" providerId="ADAL" clId="{C0C99BD7-623F-4809-B01E-CFB7750E2573}" dt="2026-02-16T23:48:32.159" v="38" actId="478"/>
+            <ac:spMkLst>
+              <pc:docMk/>
+              <pc:sldMasterMk cId="3676200875" sldId="2147483648"/>
+              <pc:sldLayoutMk cId="2619886245" sldId="2147483652"/>
+              <ac:spMk id="9" creationId="{C4053F5D-6FBA-B899-9B82-B9093E335267}"/>
+            </ac:spMkLst>
+          </pc:spChg>
+        </pc:sldLayoutChg>
+        <pc:sldLayoutChg chg="addSp delSp modSp mod">
+          <pc:chgData name="LARCHER MATTEO (IDV Group)" userId="db0184d6-40e4-497e-a5fe-b974eecd6a99" providerId="ADAL" clId="{C0C99BD7-623F-4809-B01E-CFB7750E2573}" dt="2026-02-16T23:48:41.814" v="43"/>
+          <pc:sldLayoutMkLst>
+            <pc:docMk/>
+            <pc:sldMasterMk cId="3676200875" sldId="2147483648"/>
+            <pc:sldLayoutMk cId="2535793967" sldId="2147483653"/>
+          </pc:sldLayoutMkLst>
+          <pc:spChg chg="del">
+            <ac:chgData name="LARCHER MATTEO (IDV Group)" userId="db0184d6-40e4-497e-a5fe-b974eecd6a99" providerId="ADAL" clId="{C0C99BD7-623F-4809-B01E-CFB7750E2573}" dt="2026-02-16T23:48:41.021" v="42" actId="478"/>
+            <ac:spMkLst>
+              <pc:docMk/>
+              <pc:sldMasterMk cId="3676200875" sldId="2147483648"/>
+              <pc:sldLayoutMk cId="2535793967" sldId="2147483653"/>
+              <ac:spMk id="7" creationId="{2AAF3200-A4E9-67DF-6962-7DE8759EEE6D}"/>
+            </ac:spMkLst>
+          </pc:spChg>
+          <pc:spChg chg="add mod">
+            <ac:chgData name="LARCHER MATTEO (IDV Group)" userId="db0184d6-40e4-497e-a5fe-b974eecd6a99" providerId="ADAL" clId="{C0C99BD7-623F-4809-B01E-CFB7750E2573}" dt="2026-02-16T23:48:41.814" v="43"/>
+            <ac:spMkLst>
+              <pc:docMk/>
+              <pc:sldMasterMk cId="3676200875" sldId="2147483648"/>
+              <pc:sldLayoutMk cId="2535793967" sldId="2147483653"/>
+              <ac:spMk id="8" creationId="{1E5CD868-795A-80DD-B851-3B7D64C62FB0}"/>
+            </ac:spMkLst>
+          </pc:spChg>
+          <pc:spChg chg="add mod">
+            <ac:chgData name="LARCHER MATTEO (IDV Group)" userId="db0184d6-40e4-497e-a5fe-b974eecd6a99" providerId="ADAL" clId="{C0C99BD7-623F-4809-B01E-CFB7750E2573}" dt="2026-02-16T23:48:41.814" v="43"/>
+            <ac:spMkLst>
+              <pc:docMk/>
+              <pc:sldMasterMk cId="3676200875" sldId="2147483648"/>
+              <pc:sldLayoutMk cId="2535793967" sldId="2147483653"/>
+              <ac:spMk id="9" creationId="{51D9E150-9323-088D-1DAC-64A83CEBCA7A}"/>
+            </ac:spMkLst>
+          </pc:spChg>
+          <pc:spChg chg="del">
+            <ac:chgData name="LARCHER MATTEO (IDV Group)" userId="db0184d6-40e4-497e-a5fe-b974eecd6a99" providerId="ADAL" clId="{C0C99BD7-623F-4809-B01E-CFB7750E2573}" dt="2026-02-16T23:48:39.085" v="41" actId="478"/>
+            <ac:spMkLst>
+              <pc:docMk/>
+              <pc:sldMasterMk cId="3676200875" sldId="2147483648"/>
+              <pc:sldLayoutMk cId="2535793967" sldId="2147483653"/>
+              <ac:spMk id="11" creationId="{49F71F15-28F7-2AFB-0561-2D46D21B76B0}"/>
+            </ac:spMkLst>
+          </pc:spChg>
+        </pc:sldLayoutChg>
+        <pc:sldLayoutChg chg="addSp delSp modSp mod">
+          <pc:chgData name="LARCHER MATTEO (IDV Group)" userId="db0184d6-40e4-497e-a5fe-b974eecd6a99" providerId="ADAL" clId="{C0C99BD7-623F-4809-B01E-CFB7750E2573}" dt="2026-02-16T23:48:47.911" v="46"/>
+          <pc:sldLayoutMkLst>
+            <pc:docMk/>
+            <pc:sldMasterMk cId="3676200875" sldId="2147483648"/>
+            <pc:sldLayoutMk cId="3472721253" sldId="2147483654"/>
+          </pc:sldLayoutMkLst>
+          <pc:spChg chg="del">
+            <ac:chgData name="LARCHER MATTEO (IDV Group)" userId="db0184d6-40e4-497e-a5fe-b974eecd6a99" providerId="ADAL" clId="{C0C99BD7-623F-4809-B01E-CFB7750E2573}" dt="2026-02-16T23:48:47.044" v="45" actId="478"/>
+            <ac:spMkLst>
+              <pc:docMk/>
+              <pc:sldMasterMk cId="3676200875" sldId="2147483648"/>
+              <pc:sldLayoutMk cId="3472721253" sldId="2147483654"/>
+              <ac:spMk id="3" creationId="{8F0BB32C-C6A2-82A8-490B-7538697EFCED}"/>
+            </ac:spMkLst>
+          </pc:spChg>
+          <pc:spChg chg="add mod">
+            <ac:chgData name="LARCHER MATTEO (IDV Group)" userId="db0184d6-40e4-497e-a5fe-b974eecd6a99" providerId="ADAL" clId="{C0C99BD7-623F-4809-B01E-CFB7750E2573}" dt="2026-02-16T23:48:47.911" v="46"/>
+            <ac:spMkLst>
+              <pc:docMk/>
+              <pc:sldMasterMk cId="3676200875" sldId="2147483648"/>
+              <pc:sldLayoutMk cId="3472721253" sldId="2147483654"/>
+              <ac:spMk id="4" creationId="{E3F17EBA-EE67-E39D-B24B-51E6B4430B34}"/>
+            </ac:spMkLst>
+          </pc:spChg>
+          <pc:spChg chg="add mod">
+            <ac:chgData name="LARCHER MATTEO (IDV Group)" userId="db0184d6-40e4-497e-a5fe-b974eecd6a99" providerId="ADAL" clId="{C0C99BD7-623F-4809-B01E-CFB7750E2573}" dt="2026-02-16T23:48:47.911" v="46"/>
+            <ac:spMkLst>
+              <pc:docMk/>
+              <pc:sldMasterMk cId="3676200875" sldId="2147483648"/>
+              <pc:sldLayoutMk cId="3472721253" sldId="2147483654"/>
+              <ac:spMk id="5" creationId="{69BA34CF-6BBA-00F0-8C23-D1A0A4CA02B5}"/>
+            </ac:spMkLst>
+          </pc:spChg>
+          <pc:spChg chg="del">
+            <ac:chgData name="LARCHER MATTEO (IDV Group)" userId="db0184d6-40e4-497e-a5fe-b974eecd6a99" providerId="ADAL" clId="{C0C99BD7-623F-4809-B01E-CFB7750E2573}" dt="2026-02-16T23:48:44.764" v="44" actId="478"/>
+            <ac:spMkLst>
+              <pc:docMk/>
+              <pc:sldMasterMk cId="3676200875" sldId="2147483648"/>
+              <pc:sldLayoutMk cId="3472721253" sldId="2147483654"/>
+              <ac:spMk id="7" creationId="{3E3EC6A0-D5A9-CC66-04AC-E97B0756CB15}"/>
+            </ac:spMkLst>
+          </pc:spChg>
+        </pc:sldLayoutChg>
+        <pc:sldLayoutChg chg="addSp delSp modSp mod">
+          <pc:chgData name="LARCHER MATTEO (IDV Group)" userId="db0184d6-40e4-497e-a5fe-b974eecd6a99" providerId="ADAL" clId="{C0C99BD7-623F-4809-B01E-CFB7750E2573}" dt="2026-02-16T23:48:54.079" v="49"/>
+          <pc:sldLayoutMkLst>
+            <pc:docMk/>
+            <pc:sldMasterMk cId="3676200875" sldId="2147483648"/>
+            <pc:sldLayoutMk cId="2130901097" sldId="2147483655"/>
+          </pc:sldLayoutMkLst>
+          <pc:spChg chg="del">
+            <ac:chgData name="LARCHER MATTEO (IDV Group)" userId="db0184d6-40e4-497e-a5fe-b974eecd6a99" providerId="ADAL" clId="{C0C99BD7-623F-4809-B01E-CFB7750E2573}" dt="2026-02-16T23:48:51.809" v="47" actId="478"/>
+            <ac:spMkLst>
+              <pc:docMk/>
+              <pc:sldMasterMk cId="3676200875" sldId="2147483648"/>
+              <pc:sldLayoutMk cId="2130901097" sldId="2147483655"/>
+              <ac:spMk id="2" creationId="{5ECDEA0F-CD3F-E988-8F7E-CF36959BCCB4}"/>
+            </ac:spMkLst>
+          </pc:spChg>
+          <pc:spChg chg="add mod">
+            <ac:chgData name="LARCHER MATTEO (IDV Group)" userId="db0184d6-40e4-497e-a5fe-b974eecd6a99" providerId="ADAL" clId="{C0C99BD7-623F-4809-B01E-CFB7750E2573}" dt="2026-02-16T23:48:54.079" v="49"/>
+            <ac:spMkLst>
+              <pc:docMk/>
+              <pc:sldMasterMk cId="3676200875" sldId="2147483648"/>
+              <pc:sldLayoutMk cId="2130901097" sldId="2147483655"/>
+              <ac:spMk id="3" creationId="{1B942665-9C8D-E154-B4A7-2A3AAC87EFB1}"/>
+            </ac:spMkLst>
+          </pc:spChg>
+          <pc:spChg chg="add mod">
+            <ac:chgData name="LARCHER MATTEO (IDV Group)" userId="db0184d6-40e4-497e-a5fe-b974eecd6a99" providerId="ADAL" clId="{C0C99BD7-623F-4809-B01E-CFB7750E2573}" dt="2026-02-16T23:48:54.079" v="49"/>
+            <ac:spMkLst>
+              <pc:docMk/>
+              <pc:sldMasterMk cId="3676200875" sldId="2147483648"/>
+              <pc:sldLayoutMk cId="2130901097" sldId="2147483655"/>
+              <ac:spMk id="4" creationId="{CFE2E3C1-BE6E-42B1-100C-CFB62BCCA84E}"/>
+            </ac:spMkLst>
+          </pc:spChg>
+          <pc:spChg chg="del">
+            <ac:chgData name="LARCHER MATTEO (IDV Group)" userId="db0184d6-40e4-497e-a5fe-b974eecd6a99" providerId="ADAL" clId="{C0C99BD7-623F-4809-B01E-CFB7750E2573}" dt="2026-02-16T23:48:53.499" v="48" actId="478"/>
+            <ac:spMkLst>
+              <pc:docMk/>
+              <pc:sldMasterMk cId="3676200875" sldId="2147483648"/>
+              <pc:sldLayoutMk cId="2130901097" sldId="2147483655"/>
+              <ac:spMk id="6" creationId="{9D7B9609-DC00-77FF-632B-7CA52E337E03}"/>
+            </ac:spMkLst>
+          </pc:spChg>
+        </pc:sldLayoutChg>
+        <pc:sldLayoutChg chg="addSp delSp modSp mod">
+          <pc:chgData name="LARCHER MATTEO (IDV Group)" userId="db0184d6-40e4-497e-a5fe-b974eecd6a99" providerId="ADAL" clId="{C0C99BD7-623F-4809-B01E-CFB7750E2573}" dt="2026-02-16T23:49:00.292" v="52"/>
+          <pc:sldLayoutMkLst>
+            <pc:docMk/>
+            <pc:sldMasterMk cId="3676200875" sldId="2147483648"/>
+            <pc:sldLayoutMk cId="3540895647" sldId="2147483656"/>
+          </pc:sldLayoutMkLst>
+          <pc:spChg chg="del">
+            <ac:chgData name="LARCHER MATTEO (IDV Group)" userId="db0184d6-40e4-497e-a5fe-b974eecd6a99" providerId="ADAL" clId="{C0C99BD7-623F-4809-B01E-CFB7750E2573}" dt="2026-02-16T23:48:57.544" v="50" actId="478"/>
+            <ac:spMkLst>
+              <pc:docMk/>
+              <pc:sldMasterMk cId="3676200875" sldId="2147483648"/>
+              <pc:sldLayoutMk cId="3540895647" sldId="2147483656"/>
+              <ac:spMk id="5" creationId="{E08D9B6F-D6D8-AE83-7546-E14BE6C2E410}"/>
+            </ac:spMkLst>
+          </pc:spChg>
+          <pc:spChg chg="add mod">
+            <ac:chgData name="LARCHER MATTEO (IDV Group)" userId="db0184d6-40e4-497e-a5fe-b974eecd6a99" providerId="ADAL" clId="{C0C99BD7-623F-4809-B01E-CFB7750E2573}" dt="2026-02-16T23:49:00.292" v="52"/>
+            <ac:spMkLst>
+              <pc:docMk/>
+              <pc:sldMasterMk cId="3676200875" sldId="2147483648"/>
+              <pc:sldLayoutMk cId="3540895647" sldId="2147483656"/>
+              <ac:spMk id="6" creationId="{F2CAF3CD-0E8D-01F0-19BA-701272483671}"/>
+            </ac:spMkLst>
+          </pc:spChg>
+          <pc:spChg chg="add mod">
+            <ac:chgData name="LARCHER MATTEO (IDV Group)" userId="db0184d6-40e4-497e-a5fe-b974eecd6a99" providerId="ADAL" clId="{C0C99BD7-623F-4809-B01E-CFB7750E2573}" dt="2026-02-16T23:49:00.292" v="52"/>
+            <ac:spMkLst>
+              <pc:docMk/>
+              <pc:sldMasterMk cId="3676200875" sldId="2147483648"/>
+              <pc:sldLayoutMk cId="3540895647" sldId="2147483656"/>
+              <ac:spMk id="7" creationId="{819FA1F3-6C25-0F24-6531-CEB107608D04}"/>
+            </ac:spMkLst>
+          </pc:spChg>
+          <pc:spChg chg="del">
+            <ac:chgData name="LARCHER MATTEO (IDV Group)" userId="db0184d6-40e4-497e-a5fe-b974eecd6a99" providerId="ADAL" clId="{C0C99BD7-623F-4809-B01E-CFB7750E2573}" dt="2026-02-16T23:48:59.517" v="51" actId="478"/>
+            <ac:spMkLst>
+              <pc:docMk/>
+              <pc:sldMasterMk cId="3676200875" sldId="2147483648"/>
+              <pc:sldLayoutMk cId="3540895647" sldId="2147483656"/>
+              <ac:spMk id="9" creationId="{C8F14B97-C2FE-7D33-9A73-677B703E4162}"/>
+            </ac:spMkLst>
+          </pc:spChg>
+        </pc:sldLayoutChg>
+        <pc:sldLayoutChg chg="addSp delSp modSp mod">
+          <pc:chgData name="LARCHER MATTEO (IDV Group)" userId="db0184d6-40e4-497e-a5fe-b974eecd6a99" providerId="ADAL" clId="{C0C99BD7-623F-4809-B01E-CFB7750E2573}" dt="2026-02-16T23:49:07.165" v="55"/>
+          <pc:sldLayoutMkLst>
+            <pc:docMk/>
+            <pc:sldMasterMk cId="3676200875" sldId="2147483648"/>
+            <pc:sldLayoutMk cId="3566899855" sldId="2147483657"/>
+          </pc:sldLayoutMkLst>
+          <pc:spChg chg="del">
+            <ac:chgData name="LARCHER MATTEO (IDV Group)" userId="db0184d6-40e4-497e-a5fe-b974eecd6a99" providerId="ADAL" clId="{C0C99BD7-623F-4809-B01E-CFB7750E2573}" dt="2026-02-16T23:49:04.405" v="53" actId="478"/>
+            <ac:spMkLst>
+              <pc:docMk/>
+              <pc:sldMasterMk cId="3676200875" sldId="2147483648"/>
+              <pc:sldLayoutMk cId="3566899855" sldId="2147483657"/>
+              <ac:spMk id="5" creationId="{FDDE0A73-7F0F-1EE2-B8F1-2B2B4B0427D3}"/>
+            </ac:spMkLst>
+          </pc:spChg>
+          <pc:spChg chg="add mod">
+            <ac:chgData name="LARCHER MATTEO (IDV Group)" userId="db0184d6-40e4-497e-a5fe-b974eecd6a99" providerId="ADAL" clId="{C0C99BD7-623F-4809-B01E-CFB7750E2573}" dt="2026-02-16T23:49:07.165" v="55"/>
+            <ac:spMkLst>
+              <pc:docMk/>
+              <pc:sldMasterMk cId="3676200875" sldId="2147483648"/>
+              <pc:sldLayoutMk cId="3566899855" sldId="2147483657"/>
+              <ac:spMk id="6" creationId="{FE9F7795-AD43-4C27-8F8D-8FA396FDFCB0}"/>
+            </ac:spMkLst>
+          </pc:spChg>
+          <pc:spChg chg="add mod">
+            <ac:chgData name="LARCHER MATTEO (IDV Group)" userId="db0184d6-40e4-497e-a5fe-b974eecd6a99" providerId="ADAL" clId="{C0C99BD7-623F-4809-B01E-CFB7750E2573}" dt="2026-02-16T23:49:07.165" v="55"/>
+            <ac:spMkLst>
+              <pc:docMk/>
+              <pc:sldMasterMk cId="3676200875" sldId="2147483648"/>
+              <pc:sldLayoutMk cId="3566899855" sldId="2147483657"/>
+              <ac:spMk id="7" creationId="{42F1B687-FDBC-951B-A6F8-6A6E00B75E32}"/>
+            </ac:spMkLst>
+          </pc:spChg>
+          <pc:spChg chg="del">
+            <ac:chgData name="LARCHER MATTEO (IDV Group)" userId="db0184d6-40e4-497e-a5fe-b974eecd6a99" providerId="ADAL" clId="{C0C99BD7-623F-4809-B01E-CFB7750E2573}" dt="2026-02-16T23:49:06.237" v="54" actId="478"/>
+            <ac:spMkLst>
+              <pc:docMk/>
+              <pc:sldMasterMk cId="3676200875" sldId="2147483648"/>
+              <pc:sldLayoutMk cId="3566899855" sldId="2147483657"/>
+              <ac:spMk id="9" creationId="{55C1476F-4732-ED78-4526-CECED718B05F}"/>
+            </ac:spMkLst>
+          </pc:spChg>
+        </pc:sldLayoutChg>
+        <pc:sldLayoutChg chg="addSp delSp modSp mod">
+          <pc:chgData name="LARCHER MATTEO (IDV Group)" userId="db0184d6-40e4-497e-a5fe-b974eecd6a99" providerId="ADAL" clId="{C0C99BD7-623F-4809-B01E-CFB7750E2573}" dt="2026-02-16T23:49:13.940" v="58"/>
+          <pc:sldLayoutMkLst>
+            <pc:docMk/>
+            <pc:sldMasterMk cId="3676200875" sldId="2147483648"/>
+            <pc:sldLayoutMk cId="313914798" sldId="2147483658"/>
+          </pc:sldLayoutMkLst>
+          <pc:spChg chg="del">
+            <ac:chgData name="LARCHER MATTEO (IDV Group)" userId="db0184d6-40e4-497e-a5fe-b974eecd6a99" providerId="ADAL" clId="{C0C99BD7-623F-4809-B01E-CFB7750E2573}" dt="2026-02-16T23:49:11.726" v="56" actId="478"/>
+            <ac:spMkLst>
+              <pc:docMk/>
+              <pc:sldMasterMk cId="3676200875" sldId="2147483648"/>
+              <pc:sldLayoutMk cId="313914798" sldId="2147483658"/>
+              <ac:spMk id="4" creationId="{F1D6BA0C-FCB1-B18B-A578-8A41AB44F39E}"/>
+            </ac:spMkLst>
+          </pc:spChg>
+          <pc:spChg chg="add mod">
+            <ac:chgData name="LARCHER MATTEO (IDV Group)" userId="db0184d6-40e4-497e-a5fe-b974eecd6a99" providerId="ADAL" clId="{C0C99BD7-623F-4809-B01E-CFB7750E2573}" dt="2026-02-16T23:49:13.940" v="58"/>
+            <ac:spMkLst>
+              <pc:docMk/>
+              <pc:sldMasterMk cId="3676200875" sldId="2147483648"/>
+              <pc:sldLayoutMk cId="313914798" sldId="2147483658"/>
+              <ac:spMk id="5" creationId="{CB1422D4-6CB0-409D-2EF3-11E3418B85C3}"/>
+            </ac:spMkLst>
+          </pc:spChg>
+          <pc:spChg chg="add mod">
+            <ac:chgData name="LARCHER MATTEO (IDV Group)" userId="db0184d6-40e4-497e-a5fe-b974eecd6a99" providerId="ADAL" clId="{C0C99BD7-623F-4809-B01E-CFB7750E2573}" dt="2026-02-16T23:49:13.940" v="58"/>
+            <ac:spMkLst>
+              <pc:docMk/>
+              <pc:sldMasterMk cId="3676200875" sldId="2147483648"/>
+              <pc:sldLayoutMk cId="313914798" sldId="2147483658"/>
+              <ac:spMk id="6" creationId="{ED7B2ECE-9761-BD59-79BA-A1348B20D990}"/>
+            </ac:spMkLst>
+          </pc:spChg>
+          <pc:spChg chg="del">
+            <ac:chgData name="LARCHER MATTEO (IDV Group)" userId="db0184d6-40e4-497e-a5fe-b974eecd6a99" providerId="ADAL" clId="{C0C99BD7-623F-4809-B01E-CFB7750E2573}" dt="2026-02-16T23:49:13.173" v="57" actId="478"/>
+            <ac:spMkLst>
+              <pc:docMk/>
+              <pc:sldMasterMk cId="3676200875" sldId="2147483648"/>
+              <pc:sldLayoutMk cId="313914798" sldId="2147483658"/>
+              <ac:spMk id="8" creationId="{EF5C7BAF-E8DA-2864-BFF7-17DD2169EA66}"/>
+            </ac:spMkLst>
+          </pc:spChg>
+        </pc:sldLayoutChg>
+        <pc:sldLayoutChg chg="addSp delSp modSp mod">
+          <pc:chgData name="LARCHER MATTEO (IDV Group)" userId="db0184d6-40e4-497e-a5fe-b974eecd6a99" providerId="ADAL" clId="{C0C99BD7-623F-4809-B01E-CFB7750E2573}" dt="2026-02-16T23:49:20.002" v="61"/>
+          <pc:sldLayoutMkLst>
+            <pc:docMk/>
+            <pc:sldMasterMk cId="3676200875" sldId="2147483648"/>
+            <pc:sldLayoutMk cId="2581529045" sldId="2147483659"/>
+          </pc:sldLayoutMkLst>
+          <pc:spChg chg="del">
+            <ac:chgData name="LARCHER MATTEO (IDV Group)" userId="db0184d6-40e4-497e-a5fe-b974eecd6a99" providerId="ADAL" clId="{C0C99BD7-623F-4809-B01E-CFB7750E2573}" dt="2026-02-16T23:49:19.270" v="60" actId="478"/>
+            <ac:spMkLst>
+              <pc:docMk/>
+              <pc:sldMasterMk cId="3676200875" sldId="2147483648"/>
+              <pc:sldLayoutMk cId="2581529045" sldId="2147483659"/>
+              <ac:spMk id="4" creationId="{116057FF-9082-1A59-4CD5-DE9592F83772}"/>
+            </ac:spMkLst>
+          </pc:spChg>
+          <pc:spChg chg="add mod">
+            <ac:chgData name="LARCHER MATTEO (IDV Group)" userId="db0184d6-40e4-497e-a5fe-b974eecd6a99" providerId="ADAL" clId="{C0C99BD7-623F-4809-B01E-CFB7750E2573}" dt="2026-02-16T23:49:20.002" v="61"/>
+            <ac:spMkLst>
+              <pc:docMk/>
+              <pc:sldMasterMk cId="3676200875" sldId="2147483648"/>
+              <pc:sldLayoutMk cId="2581529045" sldId="2147483659"/>
+              <ac:spMk id="5" creationId="{2E69A76C-B460-2AE3-A17A-1505DDD7451B}"/>
+            </ac:spMkLst>
+          </pc:spChg>
+          <pc:spChg chg="add mod">
+            <ac:chgData name="LARCHER MATTEO (IDV Group)" userId="db0184d6-40e4-497e-a5fe-b974eecd6a99" providerId="ADAL" clId="{C0C99BD7-623F-4809-B01E-CFB7750E2573}" dt="2026-02-16T23:49:20.002" v="61"/>
+            <ac:spMkLst>
+              <pc:docMk/>
+              <pc:sldMasterMk cId="3676200875" sldId="2147483648"/>
+              <pc:sldLayoutMk cId="2581529045" sldId="2147483659"/>
+              <ac:spMk id="6" creationId="{E8B94D98-12F9-B72F-B3E7-937DF9D430A5}"/>
+            </ac:spMkLst>
+          </pc:spChg>
+          <pc:spChg chg="del">
+            <ac:chgData name="LARCHER MATTEO (IDV Group)" userId="db0184d6-40e4-497e-a5fe-b974eecd6a99" providerId="ADAL" clId="{C0C99BD7-623F-4809-B01E-CFB7750E2573}" dt="2026-02-16T23:49:16.653" v="59" actId="478"/>
+            <ac:spMkLst>
+              <pc:docMk/>
+              <pc:sldMasterMk cId="3676200875" sldId="2147483648"/>
+              <pc:sldLayoutMk cId="2581529045" sldId="2147483659"/>
+              <ac:spMk id="8" creationId="{30853B47-A73B-7DD5-78CA-F403E3F053C4}"/>
+            </ac:spMkLst>
+          </pc:spChg>
+        </pc:sldLayoutChg>
+        <pc:sldLayoutChg chg="addSp delSp modSp mod">
+          <pc:chgData name="LARCHER MATTEO (IDV Group)" userId="db0184d6-40e4-497e-a5fe-b974eecd6a99" providerId="ADAL" clId="{C0C99BD7-623F-4809-B01E-CFB7750E2573}" dt="2026-02-16T23:48:07.943" v="29"/>
+          <pc:sldLayoutMkLst>
+            <pc:docMk/>
+            <pc:sldMasterMk cId="3676200875" sldId="2147483648"/>
+            <pc:sldLayoutMk cId="3842282995" sldId="2147483660"/>
+          </pc:sldLayoutMkLst>
+          <pc:spChg chg="del">
+            <ac:chgData name="LARCHER MATTEO (IDV Group)" userId="db0184d6-40e4-497e-a5fe-b974eecd6a99" providerId="ADAL" clId="{C0C99BD7-623F-4809-B01E-CFB7750E2573}" dt="2026-02-16T23:48:04.724" v="27" actId="478"/>
+            <ac:spMkLst>
+              <pc:docMk/>
+              <pc:sldMasterMk cId="3676200875" sldId="2147483648"/>
+              <pc:sldLayoutMk cId="3842282995" sldId="2147483660"/>
+              <ac:spMk id="4" creationId="{00000000-0000-0000-0000-000000000000}"/>
+            </ac:spMkLst>
+          </pc:spChg>
+          <pc:spChg chg="del">
+            <ac:chgData name="LARCHER MATTEO (IDV Group)" userId="db0184d6-40e4-497e-a5fe-b974eecd6a99" providerId="ADAL" clId="{C0C99BD7-623F-4809-B01E-CFB7750E2573}" dt="2026-02-16T23:48:06.908" v="28" actId="478"/>
+            <ac:spMkLst>
+              <pc:docMk/>
+              <pc:sldMasterMk cId="3676200875" sldId="2147483648"/>
+              <pc:sldLayoutMk cId="3842282995" sldId="2147483660"/>
+              <ac:spMk id="9" creationId="{B38D46BD-367F-3481-A8D8-E3AB2C324A8C}"/>
+            </ac:spMkLst>
+          </pc:spChg>
+          <pc:spChg chg="add mod">
+            <ac:chgData name="LARCHER MATTEO (IDV Group)" userId="db0184d6-40e4-497e-a5fe-b974eecd6a99" providerId="ADAL" clId="{C0C99BD7-623F-4809-B01E-CFB7750E2573}" dt="2026-02-16T23:48:07.943" v="29"/>
+            <ac:spMkLst>
+              <pc:docMk/>
+              <pc:sldMasterMk cId="3676200875" sldId="2147483648"/>
+              <pc:sldLayoutMk cId="3842282995" sldId="2147483660"/>
+              <ac:spMk id="11" creationId="{2243B617-D1BA-70F0-AB8D-57BB8F9271D0}"/>
+            </ac:spMkLst>
+          </pc:spChg>
+          <pc:spChg chg="add mod">
+            <ac:chgData name="LARCHER MATTEO (IDV Group)" userId="db0184d6-40e4-497e-a5fe-b974eecd6a99" providerId="ADAL" clId="{C0C99BD7-623F-4809-B01E-CFB7750E2573}" dt="2026-02-16T23:48:07.943" v="29"/>
+            <ac:spMkLst>
+              <pc:docMk/>
+              <pc:sldMasterMk cId="3676200875" sldId="2147483648"/>
+              <pc:sldLayoutMk cId="3842282995" sldId="2147483660"/>
+              <ac:spMk id="13" creationId="{A136ED69-A993-F796-0E91-8ED593E08259}"/>
+            </ac:spMkLst>
+          </pc:spChg>
+        </pc:sldLayoutChg>
+        <pc:sldLayoutChg chg="modSp mod">
+          <pc:chgData name="LARCHER MATTEO (IDV Group)" userId="db0184d6-40e4-497e-a5fe-b974eecd6a99" providerId="ADAL" clId="{C0C99BD7-623F-4809-B01E-CFB7750E2573}" dt="2026-02-16T23:47:47.317" v="26" actId="1076"/>
+          <pc:sldLayoutMkLst>
+            <pc:docMk/>
+            <pc:sldMasterMk cId="3676200875" sldId="2147483648"/>
+            <pc:sldLayoutMk cId="2127477481" sldId="2147483661"/>
+          </pc:sldLayoutMkLst>
+          <pc:spChg chg="mod">
+            <ac:chgData name="LARCHER MATTEO (IDV Group)" userId="db0184d6-40e4-497e-a5fe-b974eecd6a99" providerId="ADAL" clId="{C0C99BD7-623F-4809-B01E-CFB7750E2573}" dt="2026-02-16T23:47:34.346" v="25" actId="14100"/>
+            <ac:spMkLst>
+              <pc:docMk/>
+              <pc:sldMasterMk cId="3676200875" sldId="2147483648"/>
+              <pc:sldLayoutMk cId="2127477481" sldId="2147483661"/>
+              <ac:spMk id="4" creationId="{00000000-0000-0000-0000-000000000000}"/>
+            </ac:spMkLst>
+          </pc:spChg>
+          <pc:spChg chg="mod">
+            <ac:chgData name="LARCHER MATTEO (IDV Group)" userId="db0184d6-40e4-497e-a5fe-b974eecd6a99" providerId="ADAL" clId="{C0C99BD7-623F-4809-B01E-CFB7750E2573}" dt="2026-02-16T23:47:47.317" v="26" actId="1076"/>
+            <ac:spMkLst>
+              <pc:docMk/>
+              <pc:sldMasterMk cId="3676200875" sldId="2147483648"/>
+              <pc:sldLayoutMk cId="2127477481" sldId="2147483661"/>
+              <ac:spMk id="12" creationId="{9F7F4A68-C94D-DD3E-7EA3-485F462469CC}"/>
+            </ac:spMkLst>
+          </pc:spChg>
+        </pc:sldLayoutChg>
+        <pc:sldLayoutChg chg="addSp delSp modSp mod">
+          <pc:chgData name="LARCHER MATTEO (IDV Group)" userId="db0184d6-40e4-497e-a5fe-b974eecd6a99" providerId="ADAL" clId="{C0C99BD7-623F-4809-B01E-CFB7750E2573}" dt="2026-02-16T23:48:25.841" v="37"/>
+          <pc:sldLayoutMkLst>
+            <pc:docMk/>
+            <pc:sldMasterMk cId="3676200875" sldId="2147483648"/>
+            <pc:sldLayoutMk cId="1234733671" sldId="2147483662"/>
+          </pc:sldLayoutMkLst>
+          <pc:spChg chg="del">
+            <ac:chgData name="LARCHER MATTEO (IDV Group)" userId="db0184d6-40e4-497e-a5fe-b974eecd6a99" providerId="ADAL" clId="{C0C99BD7-623F-4809-B01E-CFB7750E2573}" dt="2026-02-16T23:48:21.542" v="34" actId="478"/>
+            <ac:spMkLst>
+              <pc:docMk/>
+              <pc:sldMasterMk cId="3676200875" sldId="2147483648"/>
+              <pc:sldLayoutMk cId="1234733671" sldId="2147483662"/>
+              <ac:spMk id="4" creationId="{00000000-0000-0000-0000-000000000000}"/>
+            </ac:spMkLst>
+          </pc:spChg>
+          <pc:spChg chg="del mod">
+            <ac:chgData name="LARCHER MATTEO (IDV Group)" userId="db0184d6-40e4-497e-a5fe-b974eecd6a99" providerId="ADAL" clId="{C0C99BD7-623F-4809-B01E-CFB7750E2573}" dt="2026-02-16T23:48:24.921" v="36" actId="478"/>
+            <ac:spMkLst>
+              <pc:docMk/>
+              <pc:sldMasterMk cId="3676200875" sldId="2147483648"/>
+              <pc:sldLayoutMk cId="1234733671" sldId="2147483662"/>
+              <ac:spMk id="7" creationId="{E9A57DD2-0334-0E93-EF42-3A16A5997397}"/>
+            </ac:spMkLst>
+          </pc:spChg>
+          <pc:spChg chg="add mod">
+            <ac:chgData name="LARCHER MATTEO (IDV Group)" userId="db0184d6-40e4-497e-a5fe-b974eecd6a99" providerId="ADAL" clId="{C0C99BD7-623F-4809-B01E-CFB7750E2573}" dt="2026-02-16T23:48:25.841" v="37"/>
+            <ac:spMkLst>
+              <pc:docMk/>
+              <pc:sldMasterMk cId="3676200875" sldId="2147483648"/>
+              <pc:sldLayoutMk cId="1234733671" sldId="2147483662"/>
+              <ac:spMk id="8" creationId="{31778DD8-2E90-7C87-5D64-2149E05D61F3}"/>
+            </ac:spMkLst>
+          </pc:spChg>
+          <pc:spChg chg="add mod">
+            <ac:chgData name="LARCHER MATTEO (IDV Group)" userId="db0184d6-40e4-497e-a5fe-b974eecd6a99" providerId="ADAL" clId="{C0C99BD7-623F-4809-B01E-CFB7750E2573}" dt="2026-02-16T23:48:25.841" v="37"/>
+            <ac:spMkLst>
+              <pc:docMk/>
+              <pc:sldMasterMk cId="3676200875" sldId="2147483648"/>
+              <pc:sldLayoutMk cId="1234733671" sldId="2147483662"/>
+              <ac:spMk id="12" creationId="{231476A2-463A-5A82-D914-E99D9D8159EB}"/>
+            </ac:spMkLst>
+          </pc:spChg>
+        </pc:sldLayoutChg>
+      </pc:sldMasterChg>
+    </pc:docChg>
+  </pc:docChgLst>
+</pc:chgInfo>
+</file>
+
 <file path=ppt/notesMasters/notesMaster1.xml><?xml version="1.0" encoding="utf-8"?>
 <p:notesMaster xmlns:a="http://schemas.openxmlformats.org/drawingml/2006/main" xmlns:r="http://schemas.openxmlformats.org/officeDocument/2006/relationships" xmlns:p="http://schemas.openxmlformats.org/presentationml/2006/main">
   <p:cSld>
@@ -214,7 +770,7 @@
           <a:p>
             <a:fld id="{0F9C1CCF-B725-44A7-AA57-5E433BD85C9F}" type="datetimeFigureOut">
               <a:rPr lang="en-US" smtClean="0"/>
-              <a:t>2/8/26</a:t>
+              <a:t>2/17/2026</a:t>
             </a:fld>
             <a:endParaRPr lang="en-US"/>
           </a:p>
@@ -771,7 +1327,7 @@
         </p:nvSpPr>
         <p:spPr>
           <a:xfrm>
-            <a:off x="1326779" y="2679608"/>
+            <a:off x="1241203" y="2679608"/>
             <a:ext cx="3935506" cy="614922"/>
           </a:xfrm>
         </p:spPr>
@@ -902,7 +1458,7 @@
           <a:p>
             <a:fld id="{2D7DBF7F-F54F-1C49-8F76-19ACADAD9270}" type="datetime1">
               <a:rPr lang="it-IT" smtClean="0"/>
-              <a:t>08/02/26</a:t>
+              <a:t>17/02/2026</a:t>
             </a:fld>
             <a:endParaRPr lang="en-US"/>
           </a:p>
@@ -1072,40 +1628,6 @@
           <a:chExt cx="0" cy="0"/>
         </a:xfrm>
       </p:grpSpPr>
-      <p:sp>
-        <p:nvSpPr>
-          <p:cNvPr id="6" name="Date Placeholder 3">
-            <a:extLst>
-              <a:ext uri="{FF2B5EF4-FFF2-40B4-BE49-F238E27FC236}">
-                <a16:creationId xmlns:a16="http://schemas.microsoft.com/office/drawing/2014/main" id="{9D7B9609-DC00-77FF-632B-7CA52E337E03}"/>
-              </a:ext>
-            </a:extLst>
-          </p:cNvPr>
-          <p:cNvSpPr>
-            <a:spLocks noGrp="1"/>
-          </p:cNvSpPr>
-          <p:nvPr>
-            <p:ph type="dt" sz="half" idx="10"/>
-          </p:nvPr>
-        </p:nvSpPr>
-        <p:spPr>
-          <a:xfrm>
-            <a:off x="1984248" y="4775147"/>
-            <a:ext cx="1078992" cy="273844"/>
-          </a:xfrm>
-        </p:spPr>
-        <p:txBody>
-          <a:bodyPr/>
-          <a:lstStyle/>
-          <a:p>
-            <a:fld id="{85454C68-2B9C-2243-9426-8AA164CE3511}" type="datetime1">
-              <a:rPr lang="it-IT" smtClean="0"/>
-              <a:t>08/02/26</a:t>
-            </a:fld>
-            <a:endParaRPr lang="en-US"/>
-          </a:p>
-        </p:txBody>
-      </p:sp>
       <p:sp>
         <p:nvSpPr>
           <p:cNvPr id="7" name="Footer Placeholder 4">
@@ -1370,10 +1892,44 @@
       </p:pic>
       <p:sp>
         <p:nvSpPr>
-          <p:cNvPr id="2" name="TextBox 1">
+          <p:cNvPr id="3" name="Date Placeholder 3">
             <a:extLst>
               <a:ext uri="{FF2B5EF4-FFF2-40B4-BE49-F238E27FC236}">
-                <a16:creationId xmlns:a16="http://schemas.microsoft.com/office/drawing/2014/main" id="{5ECDEA0F-CD3F-E988-8F7E-CF36959BCCB4}"/>
+                <a16:creationId xmlns:a16="http://schemas.microsoft.com/office/drawing/2014/main" id="{1B942665-9C8D-E154-B4A7-2A3AAC87EFB1}"/>
+              </a:ext>
+            </a:extLst>
+          </p:cNvPr>
+          <p:cNvSpPr>
+            <a:spLocks noGrp="1"/>
+          </p:cNvSpPr>
+          <p:nvPr>
+            <p:ph type="dt" sz="half" idx="10"/>
+          </p:nvPr>
+        </p:nvSpPr>
+        <p:spPr>
+          <a:xfrm>
+            <a:off x="1771427" y="4775147"/>
+            <a:ext cx="1291813" cy="273844"/>
+          </a:xfrm>
+        </p:spPr>
+        <p:txBody>
+          <a:bodyPr/>
+          <a:lstStyle/>
+          <a:p>
+            <a:fld id="{B5A3235C-A5F5-CE4E-B015-39F4D75EC196}" type="datetime1">
+              <a:rPr lang="it-IT" smtClean="0"/>
+              <a:t>17/02/2026</a:t>
+            </a:fld>
+            <a:endParaRPr lang="en-US"/>
+          </a:p>
+        </p:txBody>
+      </p:sp>
+      <p:sp>
+        <p:nvSpPr>
+          <p:cNvPr id="4" name="TextBox 3">
+            <a:extLst>
+              <a:ext uri="{FF2B5EF4-FFF2-40B4-BE49-F238E27FC236}">
+                <a16:creationId xmlns:a16="http://schemas.microsoft.com/office/drawing/2014/main" id="{CFE2E3C1-BE6E-42B1-100C-CFB62BCCA84E}"/>
               </a:ext>
             </a:extLst>
           </p:cNvPr>
@@ -1382,7 +1938,7 @@
         </p:nvSpPr>
         <p:spPr>
           <a:xfrm>
-            <a:off x="1499801" y="5009681"/>
+            <a:off x="1499801" y="4604556"/>
             <a:ext cx="6144397" cy="184666"/>
           </a:xfrm>
           <a:prstGeom prst="rect">
@@ -1646,40 +2202,6 @@
               <a:rPr lang="en-US" dirty="0"/>
               <a:t>Click to edit Master text styles</a:t>
             </a:r>
-          </a:p>
-        </p:txBody>
-      </p:sp>
-      <p:sp>
-        <p:nvSpPr>
-          <p:cNvPr id="9" name="Date Placeholder 3">
-            <a:extLst>
-              <a:ext uri="{FF2B5EF4-FFF2-40B4-BE49-F238E27FC236}">
-                <a16:creationId xmlns:a16="http://schemas.microsoft.com/office/drawing/2014/main" id="{C8F14B97-C2FE-7D33-9A73-677B703E4162}"/>
-              </a:ext>
-            </a:extLst>
-          </p:cNvPr>
-          <p:cNvSpPr>
-            <a:spLocks noGrp="1"/>
-          </p:cNvSpPr>
-          <p:nvPr>
-            <p:ph type="dt" sz="half" idx="10"/>
-          </p:nvPr>
-        </p:nvSpPr>
-        <p:spPr>
-          <a:xfrm>
-            <a:off x="1984248" y="4775147"/>
-            <a:ext cx="1078992" cy="273844"/>
-          </a:xfrm>
-        </p:spPr>
-        <p:txBody>
-          <a:bodyPr/>
-          <a:lstStyle/>
-          <a:p>
-            <a:fld id="{D6CE0B0B-E3C5-EF4A-87B2-86DF446F39DB}" type="datetime1">
-              <a:rPr lang="it-IT" smtClean="0"/>
-              <a:t>08/02/26</a:t>
-            </a:fld>
-            <a:endParaRPr lang="en-US"/>
           </a:p>
         </p:txBody>
       </p:sp>
@@ -1947,10 +2469,44 @@
       </p:pic>
       <p:sp>
         <p:nvSpPr>
-          <p:cNvPr id="5" name="TextBox 4">
+          <p:cNvPr id="6" name="Date Placeholder 3">
             <a:extLst>
               <a:ext uri="{FF2B5EF4-FFF2-40B4-BE49-F238E27FC236}">
-                <a16:creationId xmlns:a16="http://schemas.microsoft.com/office/drawing/2014/main" id="{E08D9B6F-D6D8-AE83-7546-E14BE6C2E410}"/>
+                <a16:creationId xmlns:a16="http://schemas.microsoft.com/office/drawing/2014/main" id="{F2CAF3CD-0E8D-01F0-19BA-701272483671}"/>
+              </a:ext>
+            </a:extLst>
+          </p:cNvPr>
+          <p:cNvSpPr>
+            <a:spLocks noGrp="1"/>
+          </p:cNvSpPr>
+          <p:nvPr>
+            <p:ph type="dt" sz="half" idx="10"/>
+          </p:nvPr>
+        </p:nvSpPr>
+        <p:spPr>
+          <a:xfrm>
+            <a:off x="1771427" y="4775147"/>
+            <a:ext cx="1291813" cy="273844"/>
+          </a:xfrm>
+        </p:spPr>
+        <p:txBody>
+          <a:bodyPr/>
+          <a:lstStyle/>
+          <a:p>
+            <a:fld id="{B5A3235C-A5F5-CE4E-B015-39F4D75EC196}" type="datetime1">
+              <a:rPr lang="it-IT" smtClean="0"/>
+              <a:t>17/02/2026</a:t>
+            </a:fld>
+            <a:endParaRPr lang="en-US"/>
+          </a:p>
+        </p:txBody>
+      </p:sp>
+      <p:sp>
+        <p:nvSpPr>
+          <p:cNvPr id="7" name="TextBox 6">
+            <a:extLst>
+              <a:ext uri="{FF2B5EF4-FFF2-40B4-BE49-F238E27FC236}">
+                <a16:creationId xmlns:a16="http://schemas.microsoft.com/office/drawing/2014/main" id="{819FA1F3-6C25-0F24-6531-CEB107608D04}"/>
               </a:ext>
             </a:extLst>
           </p:cNvPr>
@@ -1959,7 +2515,7 @@
         </p:nvSpPr>
         <p:spPr>
           <a:xfrm>
-            <a:off x="1499801" y="5009681"/>
+            <a:off x="1499801" y="4604556"/>
             <a:ext cx="6144397" cy="184666"/>
           </a:xfrm>
           <a:prstGeom prst="rect">
@@ -2200,40 +2756,6 @@
               <a:rPr lang="en-US" dirty="0"/>
               <a:t>Click to edit Master text styles</a:t>
             </a:r>
-          </a:p>
-        </p:txBody>
-      </p:sp>
-      <p:sp>
-        <p:nvSpPr>
-          <p:cNvPr id="9" name="Date Placeholder 3">
-            <a:extLst>
-              <a:ext uri="{FF2B5EF4-FFF2-40B4-BE49-F238E27FC236}">
-                <a16:creationId xmlns:a16="http://schemas.microsoft.com/office/drawing/2014/main" id="{55C1476F-4732-ED78-4526-CECED718B05F}"/>
-              </a:ext>
-            </a:extLst>
-          </p:cNvPr>
-          <p:cNvSpPr>
-            <a:spLocks noGrp="1"/>
-          </p:cNvSpPr>
-          <p:nvPr>
-            <p:ph type="dt" sz="half" idx="10"/>
-          </p:nvPr>
-        </p:nvSpPr>
-        <p:spPr>
-          <a:xfrm>
-            <a:off x="1984248" y="4775147"/>
-            <a:ext cx="1078992" cy="273844"/>
-          </a:xfrm>
-        </p:spPr>
-        <p:txBody>
-          <a:bodyPr/>
-          <a:lstStyle/>
-          <a:p>
-            <a:fld id="{AE4AF135-7764-144C-811C-680358D4FB0C}" type="datetime1">
-              <a:rPr lang="it-IT" smtClean="0"/>
-              <a:t>08/02/26</a:t>
-            </a:fld>
-            <a:endParaRPr lang="en-US"/>
           </a:p>
         </p:txBody>
       </p:sp>
@@ -2501,10 +3023,44 @@
       </p:pic>
       <p:sp>
         <p:nvSpPr>
-          <p:cNvPr id="5" name="TextBox 4">
+          <p:cNvPr id="6" name="Date Placeholder 3">
             <a:extLst>
               <a:ext uri="{FF2B5EF4-FFF2-40B4-BE49-F238E27FC236}">
-                <a16:creationId xmlns:a16="http://schemas.microsoft.com/office/drawing/2014/main" id="{FDDE0A73-7F0F-1EE2-B8F1-2B2B4B0427D3}"/>
+                <a16:creationId xmlns:a16="http://schemas.microsoft.com/office/drawing/2014/main" id="{FE9F7795-AD43-4C27-8F8D-8FA396FDFCB0}"/>
+              </a:ext>
+            </a:extLst>
+          </p:cNvPr>
+          <p:cNvSpPr>
+            <a:spLocks noGrp="1"/>
+          </p:cNvSpPr>
+          <p:nvPr>
+            <p:ph type="dt" sz="half" idx="10"/>
+          </p:nvPr>
+        </p:nvSpPr>
+        <p:spPr>
+          <a:xfrm>
+            <a:off x="1771427" y="4775147"/>
+            <a:ext cx="1291813" cy="273844"/>
+          </a:xfrm>
+        </p:spPr>
+        <p:txBody>
+          <a:bodyPr/>
+          <a:lstStyle/>
+          <a:p>
+            <a:fld id="{B5A3235C-A5F5-CE4E-B015-39F4D75EC196}" type="datetime1">
+              <a:rPr lang="it-IT" smtClean="0"/>
+              <a:t>17/02/2026</a:t>
+            </a:fld>
+            <a:endParaRPr lang="en-US"/>
+          </a:p>
+        </p:txBody>
+      </p:sp>
+      <p:sp>
+        <p:nvSpPr>
+          <p:cNvPr id="7" name="TextBox 6">
+            <a:extLst>
+              <a:ext uri="{FF2B5EF4-FFF2-40B4-BE49-F238E27FC236}">
+                <a16:creationId xmlns:a16="http://schemas.microsoft.com/office/drawing/2014/main" id="{42F1B687-FDBC-951B-A6F8-6A6E00B75E32}"/>
               </a:ext>
             </a:extLst>
           </p:cNvPr>
@@ -2513,7 +3069,7 @@
         </p:nvSpPr>
         <p:spPr>
           <a:xfrm>
-            <a:off x="1499801" y="5009681"/>
+            <a:off x="1499801" y="4604556"/>
             <a:ext cx="6144397" cy="184666"/>
           </a:xfrm>
           <a:prstGeom prst="rect">
@@ -2681,40 +3237,6 @@
               <a:rPr lang="en-US" dirty="0"/>
               <a:t>Fifth level</a:t>
             </a:r>
-          </a:p>
-        </p:txBody>
-      </p:sp>
-      <p:sp>
-        <p:nvSpPr>
-          <p:cNvPr id="8" name="Date Placeholder 3">
-            <a:extLst>
-              <a:ext uri="{FF2B5EF4-FFF2-40B4-BE49-F238E27FC236}">
-                <a16:creationId xmlns:a16="http://schemas.microsoft.com/office/drawing/2014/main" id="{EF5C7BAF-E8DA-2864-BFF7-17DD2169EA66}"/>
-              </a:ext>
-            </a:extLst>
-          </p:cNvPr>
-          <p:cNvSpPr>
-            <a:spLocks noGrp="1"/>
-          </p:cNvSpPr>
-          <p:nvPr>
-            <p:ph type="dt" sz="half" idx="10"/>
-          </p:nvPr>
-        </p:nvSpPr>
-        <p:spPr>
-          <a:xfrm>
-            <a:off x="1984248" y="4775147"/>
-            <a:ext cx="1078992" cy="273844"/>
-          </a:xfrm>
-        </p:spPr>
-        <p:txBody>
-          <a:bodyPr/>
-          <a:lstStyle/>
-          <a:p>
-            <a:fld id="{D7720BFA-E534-EF4D-9BC9-39AC6AC2A1F1}" type="datetime1">
-              <a:rPr lang="it-IT" smtClean="0"/>
-              <a:t>08/02/26</a:t>
-            </a:fld>
-            <a:endParaRPr lang="en-US"/>
           </a:p>
         </p:txBody>
       </p:sp>
@@ -2982,10 +3504,44 @@
       </p:pic>
       <p:sp>
         <p:nvSpPr>
-          <p:cNvPr id="4" name="TextBox 3">
+          <p:cNvPr id="5" name="Date Placeholder 3">
             <a:extLst>
               <a:ext uri="{FF2B5EF4-FFF2-40B4-BE49-F238E27FC236}">
-                <a16:creationId xmlns:a16="http://schemas.microsoft.com/office/drawing/2014/main" id="{F1D6BA0C-FCB1-B18B-A578-8A41AB44F39E}"/>
+                <a16:creationId xmlns:a16="http://schemas.microsoft.com/office/drawing/2014/main" id="{CB1422D4-6CB0-409D-2EF3-11E3418B85C3}"/>
+              </a:ext>
+            </a:extLst>
+          </p:cNvPr>
+          <p:cNvSpPr>
+            <a:spLocks noGrp="1"/>
+          </p:cNvSpPr>
+          <p:nvPr>
+            <p:ph type="dt" sz="half" idx="10"/>
+          </p:nvPr>
+        </p:nvSpPr>
+        <p:spPr>
+          <a:xfrm>
+            <a:off x="1771427" y="4775147"/>
+            <a:ext cx="1291813" cy="273844"/>
+          </a:xfrm>
+        </p:spPr>
+        <p:txBody>
+          <a:bodyPr/>
+          <a:lstStyle/>
+          <a:p>
+            <a:fld id="{B5A3235C-A5F5-CE4E-B015-39F4D75EC196}" type="datetime1">
+              <a:rPr lang="it-IT" smtClean="0"/>
+              <a:t>17/02/2026</a:t>
+            </a:fld>
+            <a:endParaRPr lang="en-US"/>
+          </a:p>
+        </p:txBody>
+      </p:sp>
+      <p:sp>
+        <p:nvSpPr>
+          <p:cNvPr id="6" name="TextBox 5">
+            <a:extLst>
+              <a:ext uri="{FF2B5EF4-FFF2-40B4-BE49-F238E27FC236}">
+                <a16:creationId xmlns:a16="http://schemas.microsoft.com/office/drawing/2014/main" id="{ED7B2ECE-9761-BD59-79BA-A1348B20D990}"/>
               </a:ext>
             </a:extLst>
           </p:cNvPr>
@@ -2994,7 +3550,7 @@
         </p:nvSpPr>
         <p:spPr>
           <a:xfrm>
-            <a:off x="1499801" y="5009681"/>
+            <a:off x="1499801" y="4604556"/>
             <a:ext cx="6144397" cy="184666"/>
           </a:xfrm>
           <a:prstGeom prst="rect">
@@ -3176,40 +3732,6 @@
               <a:rPr lang="en-US"/>
               <a:t>Fifth level</a:t>
             </a:r>
-          </a:p>
-        </p:txBody>
-      </p:sp>
-      <p:sp>
-        <p:nvSpPr>
-          <p:cNvPr id="8" name="Date Placeholder 3">
-            <a:extLst>
-              <a:ext uri="{FF2B5EF4-FFF2-40B4-BE49-F238E27FC236}">
-                <a16:creationId xmlns:a16="http://schemas.microsoft.com/office/drawing/2014/main" id="{30853B47-A73B-7DD5-78CA-F403E3F053C4}"/>
-              </a:ext>
-            </a:extLst>
-          </p:cNvPr>
-          <p:cNvSpPr>
-            <a:spLocks noGrp="1"/>
-          </p:cNvSpPr>
-          <p:nvPr>
-            <p:ph type="dt" sz="half" idx="10"/>
-          </p:nvPr>
-        </p:nvSpPr>
-        <p:spPr>
-          <a:xfrm>
-            <a:off x="1984248" y="4775147"/>
-            <a:ext cx="1078992" cy="273844"/>
-          </a:xfrm>
-        </p:spPr>
-        <p:txBody>
-          <a:bodyPr/>
-          <a:lstStyle/>
-          <a:p>
-            <a:fld id="{B20FCA3A-31A1-034E-9624-8CD1F736D4F6}" type="datetime1">
-              <a:rPr lang="it-IT" smtClean="0"/>
-              <a:t>08/02/26</a:t>
-            </a:fld>
-            <a:endParaRPr lang="en-US"/>
           </a:p>
         </p:txBody>
       </p:sp>
@@ -3477,10 +3999,44 @@
       </p:pic>
       <p:sp>
         <p:nvSpPr>
-          <p:cNvPr id="4" name="TextBox 3">
+          <p:cNvPr id="5" name="Date Placeholder 3">
             <a:extLst>
               <a:ext uri="{FF2B5EF4-FFF2-40B4-BE49-F238E27FC236}">
-                <a16:creationId xmlns:a16="http://schemas.microsoft.com/office/drawing/2014/main" id="{116057FF-9082-1A59-4CD5-DE9592F83772}"/>
+                <a16:creationId xmlns:a16="http://schemas.microsoft.com/office/drawing/2014/main" id="{2E69A76C-B460-2AE3-A17A-1505DDD7451B}"/>
+              </a:ext>
+            </a:extLst>
+          </p:cNvPr>
+          <p:cNvSpPr>
+            <a:spLocks noGrp="1"/>
+          </p:cNvSpPr>
+          <p:nvPr>
+            <p:ph type="dt" sz="half" idx="10"/>
+          </p:nvPr>
+        </p:nvSpPr>
+        <p:spPr>
+          <a:xfrm>
+            <a:off x="1771427" y="4775147"/>
+            <a:ext cx="1291813" cy="273844"/>
+          </a:xfrm>
+        </p:spPr>
+        <p:txBody>
+          <a:bodyPr/>
+          <a:lstStyle/>
+          <a:p>
+            <a:fld id="{B5A3235C-A5F5-CE4E-B015-39F4D75EC196}" type="datetime1">
+              <a:rPr lang="it-IT" smtClean="0"/>
+              <a:t>17/02/2026</a:t>
+            </a:fld>
+            <a:endParaRPr lang="en-US"/>
+          </a:p>
+        </p:txBody>
+      </p:sp>
+      <p:sp>
+        <p:nvSpPr>
+          <p:cNvPr id="6" name="TextBox 5">
+            <a:extLst>
+              <a:ext uri="{FF2B5EF4-FFF2-40B4-BE49-F238E27FC236}">
+                <a16:creationId xmlns:a16="http://schemas.microsoft.com/office/drawing/2014/main" id="{E8B94D98-12F9-B72F-B3E7-937DF9D430A5}"/>
               </a:ext>
             </a:extLst>
           </p:cNvPr>
@@ -3489,7 +4045,7 @@
         </p:nvSpPr>
         <p:spPr>
           <a:xfrm>
-            <a:off x="1499801" y="5009681"/>
+            <a:off x="1499801" y="4604556"/>
             <a:ext cx="6144397" cy="184666"/>
           </a:xfrm>
           <a:prstGeom prst="rect">
@@ -3752,8 +4308,8 @@
         </p:nvSpPr>
         <p:spPr>
           <a:xfrm>
-            <a:off x="1984248" y="4775147"/>
-            <a:ext cx="1078992" cy="273844"/>
+            <a:off x="1771427" y="4775147"/>
+            <a:ext cx="1291813" cy="273844"/>
           </a:xfrm>
         </p:spPr>
         <p:txBody>
@@ -3762,7 +4318,7 @@
           <a:p>
             <a:fld id="{B5A3235C-A5F5-CE4E-B015-39F4D75EC196}" type="datetime1">
               <a:rPr lang="it-IT" smtClean="0"/>
-              <a:t>08/02/26</a:t>
+              <a:t>17/02/2026</a:t>
             </a:fld>
             <a:endParaRPr lang="en-US"/>
           </a:p>
@@ -4062,7 +4618,7 @@
         </p:nvSpPr>
         <p:spPr>
           <a:xfrm>
-            <a:off x="1499801" y="5009681"/>
+            <a:off x="1499801" y="4604556"/>
             <a:ext cx="6144397" cy="184666"/>
           </a:xfrm>
           <a:prstGeom prst="rect">
@@ -4310,34 +4866,6 @@
               <a:rPr lang="en-US" dirty="0"/>
               <a:t>Fifth level</a:t>
             </a:r>
-          </a:p>
-        </p:txBody>
-      </p:sp>
-      <p:sp>
-        <p:nvSpPr>
-          <p:cNvPr id="4" name="Date Placeholder 3"/>
-          <p:cNvSpPr>
-            <a:spLocks noGrp="1"/>
-          </p:cNvSpPr>
-          <p:nvPr>
-            <p:ph type="dt" sz="half" idx="10"/>
-          </p:nvPr>
-        </p:nvSpPr>
-        <p:spPr>
-          <a:xfrm>
-            <a:off x="1984248" y="4775147"/>
-            <a:ext cx="1078992" cy="273844"/>
-          </a:xfrm>
-        </p:spPr>
-        <p:txBody>
-          <a:bodyPr/>
-          <a:lstStyle/>
-          <a:p>
-            <a:fld id="{9FC0F10B-4FCD-A840-811B-58139C9D20D6}" type="datetime1">
-              <a:rPr lang="it-IT" smtClean="0"/>
-              <a:t>08/02/26</a:t>
-            </a:fld>
-            <a:endParaRPr lang="en-US"/>
           </a:p>
         </p:txBody>
       </p:sp>
@@ -4644,10 +5172,44 @@
       </p:pic>
       <p:sp>
         <p:nvSpPr>
-          <p:cNvPr id="9" name="TextBox 8">
+          <p:cNvPr id="11" name="Date Placeholder 3">
             <a:extLst>
               <a:ext uri="{FF2B5EF4-FFF2-40B4-BE49-F238E27FC236}">
-                <a16:creationId xmlns:a16="http://schemas.microsoft.com/office/drawing/2014/main" id="{B38D46BD-367F-3481-A8D8-E3AB2C324A8C}"/>
+                <a16:creationId xmlns:a16="http://schemas.microsoft.com/office/drawing/2014/main" id="{2243B617-D1BA-70F0-AB8D-57BB8F9271D0}"/>
+              </a:ext>
+            </a:extLst>
+          </p:cNvPr>
+          <p:cNvSpPr>
+            <a:spLocks noGrp="1"/>
+          </p:cNvSpPr>
+          <p:nvPr>
+            <p:ph type="dt" sz="half" idx="10"/>
+          </p:nvPr>
+        </p:nvSpPr>
+        <p:spPr>
+          <a:xfrm>
+            <a:off x="1771427" y="4775147"/>
+            <a:ext cx="1291813" cy="273844"/>
+          </a:xfrm>
+        </p:spPr>
+        <p:txBody>
+          <a:bodyPr/>
+          <a:lstStyle/>
+          <a:p>
+            <a:fld id="{B5A3235C-A5F5-CE4E-B015-39F4D75EC196}" type="datetime1">
+              <a:rPr lang="it-IT" smtClean="0"/>
+              <a:t>17/02/2026</a:t>
+            </a:fld>
+            <a:endParaRPr lang="en-US"/>
+          </a:p>
+        </p:txBody>
+      </p:sp>
+      <p:sp>
+        <p:nvSpPr>
+          <p:cNvPr id="13" name="TextBox 12">
+            <a:extLst>
+              <a:ext uri="{FF2B5EF4-FFF2-40B4-BE49-F238E27FC236}">
+                <a16:creationId xmlns:a16="http://schemas.microsoft.com/office/drawing/2014/main" id="{A136ED69-A993-F796-0E91-8ED593E08259}"/>
               </a:ext>
             </a:extLst>
           </p:cNvPr>
@@ -4656,7 +5218,7 @@
         </p:nvSpPr>
         <p:spPr>
           <a:xfrm>
-            <a:off x="1499801" y="5009681"/>
+            <a:off x="1499801" y="4604556"/>
             <a:ext cx="6144397" cy="184666"/>
           </a:xfrm>
           <a:prstGeom prst="rect">
@@ -4869,34 +5431,6 @@
               <a:rPr lang="en-US" dirty="0"/>
               <a:t>Fifth level</a:t>
             </a:r>
-          </a:p>
-        </p:txBody>
-      </p:sp>
-      <p:sp>
-        <p:nvSpPr>
-          <p:cNvPr id="4" name="Date Placeholder 3"/>
-          <p:cNvSpPr>
-            <a:spLocks noGrp="1"/>
-          </p:cNvSpPr>
-          <p:nvPr>
-            <p:ph type="dt" sz="half" idx="10"/>
-          </p:nvPr>
-        </p:nvSpPr>
-        <p:spPr>
-          <a:xfrm>
-            <a:off x="1984248" y="4775147"/>
-            <a:ext cx="1078992" cy="273844"/>
-          </a:xfrm>
-        </p:spPr>
-        <p:txBody>
-          <a:bodyPr/>
-          <a:lstStyle/>
-          <a:p>
-            <a:fld id="{88C27D80-F3A7-A741-A1BF-A0356AB69374}" type="datetime1">
-              <a:rPr lang="it-IT" smtClean="0"/>
-              <a:t>08/02/26</a:t>
-            </a:fld>
-            <a:endParaRPr lang="en-US"/>
           </a:p>
         </p:txBody>
       </p:sp>
@@ -5182,10 +5716,44 @@
       </p:pic>
       <p:sp>
         <p:nvSpPr>
-          <p:cNvPr id="7" name="TextBox 6">
+          <p:cNvPr id="8" name="Date Placeholder 3">
             <a:extLst>
               <a:ext uri="{FF2B5EF4-FFF2-40B4-BE49-F238E27FC236}">
-                <a16:creationId xmlns:a16="http://schemas.microsoft.com/office/drawing/2014/main" id="{DC0F4838-F6BF-C30B-C410-5E532DCDEE34}"/>
+                <a16:creationId xmlns:a16="http://schemas.microsoft.com/office/drawing/2014/main" id="{23853EF7-9530-9CE3-8AAC-163A81EF4EAE}"/>
+              </a:ext>
+            </a:extLst>
+          </p:cNvPr>
+          <p:cNvSpPr>
+            <a:spLocks noGrp="1"/>
+          </p:cNvSpPr>
+          <p:nvPr>
+            <p:ph type="dt" sz="half" idx="10"/>
+          </p:nvPr>
+        </p:nvSpPr>
+        <p:spPr>
+          <a:xfrm>
+            <a:off x="1771427" y="4775147"/>
+            <a:ext cx="1291813" cy="273844"/>
+          </a:xfrm>
+        </p:spPr>
+        <p:txBody>
+          <a:bodyPr/>
+          <a:lstStyle/>
+          <a:p>
+            <a:fld id="{B5A3235C-A5F5-CE4E-B015-39F4D75EC196}" type="datetime1">
+              <a:rPr lang="it-IT" smtClean="0"/>
+              <a:t>17/02/2026</a:t>
+            </a:fld>
+            <a:endParaRPr lang="en-US"/>
+          </a:p>
+        </p:txBody>
+      </p:sp>
+      <p:sp>
+        <p:nvSpPr>
+          <p:cNvPr id="12" name="TextBox 11">
+            <a:extLst>
+              <a:ext uri="{FF2B5EF4-FFF2-40B4-BE49-F238E27FC236}">
+                <a16:creationId xmlns:a16="http://schemas.microsoft.com/office/drawing/2014/main" id="{0BCF4466-819F-2857-3C33-DB2BFD6F8B49}"/>
               </a:ext>
             </a:extLst>
           </p:cNvPr>
@@ -5194,7 +5762,7 @@
         </p:nvSpPr>
         <p:spPr>
           <a:xfrm>
-            <a:off x="1499801" y="5009681"/>
+            <a:off x="1499801" y="4604556"/>
             <a:ext cx="6144397" cy="184666"/>
           </a:xfrm>
           <a:prstGeom prst="rect">
@@ -5423,34 +5991,6 @@
               <a:rPr lang="en-US" dirty="0"/>
               <a:t>Fifth level</a:t>
             </a:r>
-          </a:p>
-        </p:txBody>
-      </p:sp>
-      <p:sp>
-        <p:nvSpPr>
-          <p:cNvPr id="4" name="Date Placeholder 3"/>
-          <p:cNvSpPr>
-            <a:spLocks noGrp="1"/>
-          </p:cNvSpPr>
-          <p:nvPr>
-            <p:ph type="dt" sz="half" idx="10"/>
-          </p:nvPr>
-        </p:nvSpPr>
-        <p:spPr>
-          <a:xfrm>
-            <a:off x="1984248" y="4775147"/>
-            <a:ext cx="1078992" cy="273844"/>
-          </a:xfrm>
-        </p:spPr>
-        <p:txBody>
-          <a:bodyPr/>
-          <a:lstStyle/>
-          <a:p>
-            <a:fld id="{E06934FA-7FD1-0D46-8E1C-1AFE08A73439}" type="datetime1">
-              <a:rPr lang="it-IT" smtClean="0"/>
-              <a:t>08/02/26</a:t>
-            </a:fld>
-            <a:endParaRPr lang="en-US"/>
           </a:p>
         </p:txBody>
       </p:sp>
@@ -5736,10 +6276,44 @@
       </p:pic>
       <p:sp>
         <p:nvSpPr>
-          <p:cNvPr id="7" name="TextBox 6">
+          <p:cNvPr id="8" name="Date Placeholder 3">
             <a:extLst>
               <a:ext uri="{FF2B5EF4-FFF2-40B4-BE49-F238E27FC236}">
-                <a16:creationId xmlns:a16="http://schemas.microsoft.com/office/drawing/2014/main" id="{E9A57DD2-0334-0E93-EF42-3A16A5997397}"/>
+                <a16:creationId xmlns:a16="http://schemas.microsoft.com/office/drawing/2014/main" id="{31778DD8-2E90-7C87-5D64-2149E05D61F3}"/>
+              </a:ext>
+            </a:extLst>
+          </p:cNvPr>
+          <p:cNvSpPr>
+            <a:spLocks noGrp="1"/>
+          </p:cNvSpPr>
+          <p:nvPr>
+            <p:ph type="dt" sz="half" idx="10"/>
+          </p:nvPr>
+        </p:nvSpPr>
+        <p:spPr>
+          <a:xfrm>
+            <a:off x="1771427" y="4775147"/>
+            <a:ext cx="1291813" cy="273844"/>
+          </a:xfrm>
+        </p:spPr>
+        <p:txBody>
+          <a:bodyPr/>
+          <a:lstStyle/>
+          <a:p>
+            <a:fld id="{B5A3235C-A5F5-CE4E-B015-39F4D75EC196}" type="datetime1">
+              <a:rPr lang="it-IT" smtClean="0"/>
+              <a:t>17/02/2026</a:t>
+            </a:fld>
+            <a:endParaRPr lang="en-US"/>
+          </a:p>
+        </p:txBody>
+      </p:sp>
+      <p:sp>
+        <p:nvSpPr>
+          <p:cNvPr id="12" name="TextBox 11">
+            <a:extLst>
+              <a:ext uri="{FF2B5EF4-FFF2-40B4-BE49-F238E27FC236}">
+                <a16:creationId xmlns:a16="http://schemas.microsoft.com/office/drawing/2014/main" id="{231476A2-463A-5A82-D914-E99D9D8159EB}"/>
               </a:ext>
             </a:extLst>
           </p:cNvPr>
@@ -5748,7 +6322,7 @@
         </p:nvSpPr>
         <p:spPr>
           <a:xfrm>
-            <a:off x="1499801" y="5009681"/>
+            <a:off x="1499801" y="4604556"/>
             <a:ext cx="6144397" cy="184666"/>
           </a:xfrm>
           <a:prstGeom prst="rect">
@@ -6263,40 +6837,6 @@
               <a:rPr lang="en-US" dirty="0"/>
               <a:t>Fifth level</a:t>
             </a:r>
-          </a:p>
-        </p:txBody>
-      </p:sp>
-      <p:sp>
-        <p:nvSpPr>
-          <p:cNvPr id="9" name="Date Placeholder 3">
-            <a:extLst>
-              <a:ext uri="{FF2B5EF4-FFF2-40B4-BE49-F238E27FC236}">
-                <a16:creationId xmlns:a16="http://schemas.microsoft.com/office/drawing/2014/main" id="{C4053F5D-6FBA-B899-9B82-B9093E335267}"/>
-              </a:ext>
-            </a:extLst>
-          </p:cNvPr>
-          <p:cNvSpPr>
-            <a:spLocks noGrp="1"/>
-          </p:cNvSpPr>
-          <p:nvPr>
-            <p:ph type="dt" sz="half" idx="10"/>
-          </p:nvPr>
-        </p:nvSpPr>
-        <p:spPr>
-          <a:xfrm>
-            <a:off x="1984248" y="4775147"/>
-            <a:ext cx="1078992" cy="273844"/>
-          </a:xfrm>
-        </p:spPr>
-        <p:txBody>
-          <a:bodyPr/>
-          <a:lstStyle/>
-          <a:p>
-            <a:fld id="{21E9D82B-7A2C-DA4C-B24C-1024813AE2F0}" type="datetime1">
-              <a:rPr lang="it-IT" smtClean="0"/>
-              <a:t>08/02/26</a:t>
-            </a:fld>
-            <a:endParaRPr lang="en-US"/>
           </a:p>
         </p:txBody>
       </p:sp>
@@ -6564,10 +7104,44 @@
       </p:pic>
       <p:sp>
         <p:nvSpPr>
-          <p:cNvPr id="5" name="TextBox 4">
+          <p:cNvPr id="6" name="Date Placeholder 3">
             <a:extLst>
               <a:ext uri="{FF2B5EF4-FFF2-40B4-BE49-F238E27FC236}">
-                <a16:creationId xmlns:a16="http://schemas.microsoft.com/office/drawing/2014/main" id="{36A728D5-5BBE-C9BE-C8CB-7E6F35D77231}"/>
+                <a16:creationId xmlns:a16="http://schemas.microsoft.com/office/drawing/2014/main" id="{9DC74560-9E05-FD16-6AD6-A28A46251192}"/>
+              </a:ext>
+            </a:extLst>
+          </p:cNvPr>
+          <p:cNvSpPr>
+            <a:spLocks noGrp="1"/>
+          </p:cNvSpPr>
+          <p:nvPr>
+            <p:ph type="dt" sz="half" idx="10"/>
+          </p:nvPr>
+        </p:nvSpPr>
+        <p:spPr>
+          <a:xfrm>
+            <a:off x="1771427" y="4775147"/>
+            <a:ext cx="1291813" cy="273844"/>
+          </a:xfrm>
+        </p:spPr>
+        <p:txBody>
+          <a:bodyPr/>
+          <a:lstStyle/>
+          <a:p>
+            <a:fld id="{B5A3235C-A5F5-CE4E-B015-39F4D75EC196}" type="datetime1">
+              <a:rPr lang="it-IT" smtClean="0"/>
+              <a:t>17/02/2026</a:t>
+            </a:fld>
+            <a:endParaRPr lang="en-US"/>
+          </a:p>
+        </p:txBody>
+      </p:sp>
+      <p:sp>
+        <p:nvSpPr>
+          <p:cNvPr id="7" name="TextBox 6">
+            <a:extLst>
+              <a:ext uri="{FF2B5EF4-FFF2-40B4-BE49-F238E27FC236}">
+                <a16:creationId xmlns:a16="http://schemas.microsoft.com/office/drawing/2014/main" id="{920AA42E-3654-E284-069F-FC32E2EBEBCE}"/>
               </a:ext>
             </a:extLst>
           </p:cNvPr>
@@ -6576,7 +7150,7 @@
         </p:nvSpPr>
         <p:spPr>
           <a:xfrm>
-            <a:off x="1499801" y="5009681"/>
+            <a:off x="1499801" y="4604556"/>
             <a:ext cx="6144397" cy="184666"/>
           </a:xfrm>
           <a:prstGeom prst="rect">
@@ -7003,40 +7577,6 @@
               <a:rPr lang="en-US" dirty="0"/>
               <a:t>Fifth level</a:t>
             </a:r>
-          </a:p>
-        </p:txBody>
-      </p:sp>
-      <p:sp>
-        <p:nvSpPr>
-          <p:cNvPr id="11" name="Date Placeholder 3">
-            <a:extLst>
-              <a:ext uri="{FF2B5EF4-FFF2-40B4-BE49-F238E27FC236}">
-                <a16:creationId xmlns:a16="http://schemas.microsoft.com/office/drawing/2014/main" id="{49F71F15-28F7-2AFB-0561-2D46D21B76B0}"/>
-              </a:ext>
-            </a:extLst>
-          </p:cNvPr>
-          <p:cNvSpPr>
-            <a:spLocks noGrp="1"/>
-          </p:cNvSpPr>
-          <p:nvPr>
-            <p:ph type="dt" sz="half" idx="10"/>
-          </p:nvPr>
-        </p:nvSpPr>
-        <p:spPr>
-          <a:xfrm>
-            <a:off x="1984248" y="4775147"/>
-            <a:ext cx="1078992" cy="273844"/>
-          </a:xfrm>
-        </p:spPr>
-        <p:txBody>
-          <a:bodyPr/>
-          <a:lstStyle/>
-          <a:p>
-            <a:fld id="{9429820C-B789-AB43-B4E1-4B378514779B}" type="datetime1">
-              <a:rPr lang="it-IT" smtClean="0"/>
-              <a:t>08/02/26</a:t>
-            </a:fld>
-            <a:endParaRPr lang="en-US"/>
           </a:p>
         </p:txBody>
       </p:sp>
@@ -7304,10 +7844,44 @@
       </p:pic>
       <p:sp>
         <p:nvSpPr>
-          <p:cNvPr id="7" name="TextBox 6">
+          <p:cNvPr id="8" name="Date Placeholder 3">
             <a:extLst>
               <a:ext uri="{FF2B5EF4-FFF2-40B4-BE49-F238E27FC236}">
-                <a16:creationId xmlns:a16="http://schemas.microsoft.com/office/drawing/2014/main" id="{2AAF3200-A4E9-67DF-6962-7DE8759EEE6D}"/>
+                <a16:creationId xmlns:a16="http://schemas.microsoft.com/office/drawing/2014/main" id="{1E5CD868-795A-80DD-B851-3B7D64C62FB0}"/>
+              </a:ext>
+            </a:extLst>
+          </p:cNvPr>
+          <p:cNvSpPr>
+            <a:spLocks noGrp="1"/>
+          </p:cNvSpPr>
+          <p:nvPr>
+            <p:ph type="dt" sz="half" idx="10"/>
+          </p:nvPr>
+        </p:nvSpPr>
+        <p:spPr>
+          <a:xfrm>
+            <a:off x="1771427" y="4775147"/>
+            <a:ext cx="1291813" cy="273844"/>
+          </a:xfrm>
+        </p:spPr>
+        <p:txBody>
+          <a:bodyPr/>
+          <a:lstStyle/>
+          <a:p>
+            <a:fld id="{B5A3235C-A5F5-CE4E-B015-39F4D75EC196}" type="datetime1">
+              <a:rPr lang="it-IT" smtClean="0"/>
+              <a:t>17/02/2026</a:t>
+            </a:fld>
+            <a:endParaRPr lang="en-US"/>
+          </a:p>
+        </p:txBody>
+      </p:sp>
+      <p:sp>
+        <p:nvSpPr>
+          <p:cNvPr id="9" name="TextBox 8">
+            <a:extLst>
+              <a:ext uri="{FF2B5EF4-FFF2-40B4-BE49-F238E27FC236}">
+                <a16:creationId xmlns:a16="http://schemas.microsoft.com/office/drawing/2014/main" id="{51D9E150-9323-088D-1DAC-64A83CEBCA7A}"/>
               </a:ext>
             </a:extLst>
           </p:cNvPr>
@@ -7316,7 +7890,7 @@
         </p:nvSpPr>
         <p:spPr>
           <a:xfrm>
-            <a:off x="1499801" y="5009681"/>
+            <a:off x="1499801" y="4604556"/>
             <a:ext cx="6144397" cy="184666"/>
           </a:xfrm>
           <a:prstGeom prst="rect">
@@ -7437,40 +8011,6 @@
               <a:rPr lang="en-US" dirty="0"/>
               <a:t>CLICK TO EDIT MASTER TITLE STYLE</a:t>
             </a:r>
-          </a:p>
-        </p:txBody>
-      </p:sp>
-      <p:sp>
-        <p:nvSpPr>
-          <p:cNvPr id="7" name="Date Placeholder 3">
-            <a:extLst>
-              <a:ext uri="{FF2B5EF4-FFF2-40B4-BE49-F238E27FC236}">
-                <a16:creationId xmlns:a16="http://schemas.microsoft.com/office/drawing/2014/main" id="{3E3EC6A0-D5A9-CC66-04AC-E97B0756CB15}"/>
-              </a:ext>
-            </a:extLst>
-          </p:cNvPr>
-          <p:cNvSpPr>
-            <a:spLocks noGrp="1"/>
-          </p:cNvSpPr>
-          <p:nvPr>
-            <p:ph type="dt" sz="half" idx="10"/>
-          </p:nvPr>
-        </p:nvSpPr>
-        <p:spPr>
-          <a:xfrm>
-            <a:off x="1984248" y="4775147"/>
-            <a:ext cx="1078992" cy="273844"/>
-          </a:xfrm>
-        </p:spPr>
-        <p:txBody>
-          <a:bodyPr/>
-          <a:lstStyle/>
-          <a:p>
-            <a:fld id="{EC46D180-6558-4140-957D-A04D35F919BF}" type="datetime1">
-              <a:rPr lang="it-IT" smtClean="0"/>
-              <a:t>08/02/26</a:t>
-            </a:fld>
-            <a:endParaRPr lang="en-US"/>
           </a:p>
         </p:txBody>
       </p:sp>
@@ -7738,10 +8278,44 @@
       </p:pic>
       <p:sp>
         <p:nvSpPr>
-          <p:cNvPr id="3" name="TextBox 2">
+          <p:cNvPr id="4" name="Date Placeholder 3">
             <a:extLst>
               <a:ext uri="{FF2B5EF4-FFF2-40B4-BE49-F238E27FC236}">
-                <a16:creationId xmlns:a16="http://schemas.microsoft.com/office/drawing/2014/main" id="{8F0BB32C-C6A2-82A8-490B-7538697EFCED}"/>
+                <a16:creationId xmlns:a16="http://schemas.microsoft.com/office/drawing/2014/main" id="{E3F17EBA-EE67-E39D-B24B-51E6B4430B34}"/>
+              </a:ext>
+            </a:extLst>
+          </p:cNvPr>
+          <p:cNvSpPr>
+            <a:spLocks noGrp="1"/>
+          </p:cNvSpPr>
+          <p:nvPr>
+            <p:ph type="dt" sz="half" idx="10"/>
+          </p:nvPr>
+        </p:nvSpPr>
+        <p:spPr>
+          <a:xfrm>
+            <a:off x="1771427" y="4775147"/>
+            <a:ext cx="1291813" cy="273844"/>
+          </a:xfrm>
+        </p:spPr>
+        <p:txBody>
+          <a:bodyPr/>
+          <a:lstStyle/>
+          <a:p>
+            <a:fld id="{B5A3235C-A5F5-CE4E-B015-39F4D75EC196}" type="datetime1">
+              <a:rPr lang="it-IT" smtClean="0"/>
+              <a:t>17/02/2026</a:t>
+            </a:fld>
+            <a:endParaRPr lang="en-US"/>
+          </a:p>
+        </p:txBody>
+      </p:sp>
+      <p:sp>
+        <p:nvSpPr>
+          <p:cNvPr id="5" name="TextBox 4">
+            <a:extLst>
+              <a:ext uri="{FF2B5EF4-FFF2-40B4-BE49-F238E27FC236}">
+                <a16:creationId xmlns:a16="http://schemas.microsoft.com/office/drawing/2014/main" id="{69BA34CF-6BBA-00F0-8C23-D1A0A4CA02B5}"/>
               </a:ext>
             </a:extLst>
           </p:cNvPr>
@@ -7750,7 +8324,7 @@
         </p:nvSpPr>
         <p:spPr>
           <a:xfrm>
-            <a:off x="1499801" y="5009681"/>
+            <a:off x="1499801" y="4604556"/>
             <a:ext cx="6144397" cy="184666"/>
           </a:xfrm>
           <a:prstGeom prst="rect">
@@ -7968,7 +8542,7 @@
           <a:p>
             <a:fld id="{4EE47AEE-98EC-0C43-8D64-9D05BF501A01}" type="datetime1">
               <a:rPr lang="it-IT" smtClean="0"/>
-              <a:t>08/02/26</a:t>
+              <a:t>17/02/2026</a:t>
             </a:fld>
             <a:endParaRPr lang="en-US"/>
           </a:p>
@@ -8414,7 +8988,7 @@
           <a:p>
             <a:fld id="{D1602D0C-839A-CF4F-9D15-89FD2575D155}" type="datetime1">
               <a:rPr lang="it-IT" smtClean="0"/>
-              <a:t>08/02/26</a:t>
+              <a:t>17/02/2026</a:t>
             </a:fld>
             <a:endParaRPr lang="en-US"/>
           </a:p>
@@ -8543,14 +9117,19 @@
             <p:ph type="dt" sz="half" idx="10"/>
           </p:nvPr>
         </p:nvSpPr>
-        <p:spPr/>
+        <p:spPr>
+          <a:xfrm>
+            <a:off x="1984248" y="4775147"/>
+            <a:ext cx="1078992" cy="273844"/>
+          </a:xfrm>
+        </p:spPr>
         <p:txBody>
           <a:bodyPr/>
           <a:lstStyle/>
           <a:p>
             <a:fld id="{9C7945CA-8852-CF4A-A88C-560042723BA1}" type="datetime1">
               <a:rPr lang="it-IT" smtClean="0"/>
-              <a:t>08/02/26</a:t>
+              <a:t>17/02/2026</a:t>
             </a:fld>
             <a:endParaRPr lang="en-US"/>
           </a:p>
@@ -8810,14 +9389,19 @@
             <p:ph type="dt" sz="half" idx="10"/>
           </p:nvPr>
         </p:nvSpPr>
-        <p:spPr/>
+        <p:spPr>
+          <a:xfrm>
+            <a:off x="1984248" y="4775147"/>
+            <a:ext cx="1078992" cy="273844"/>
+          </a:xfrm>
+        </p:spPr>
         <p:txBody>
           <a:bodyPr/>
           <a:lstStyle/>
           <a:p>
             <a:fld id="{64E14661-1291-564D-ADDE-841126F5283D}" type="datetime1">
               <a:rPr lang="it-IT" smtClean="0"/>
-              <a:t>08/02/26</a:t>
+              <a:t>17/02/2026</a:t>
             </a:fld>
             <a:endParaRPr lang="en-US"/>
           </a:p>

</xml_diff>

<commit_message>
[FIX] fixed broken reference pptx file
</commit_message>
<xml_diff>
--- a/_extensions/IDV-Share/quarto-presentation-templates/reference/IDV-template.pptx
+++ b/_extensions/IDV-Share/quarto-presentation-templates/reference/IDV-template.pptx
@@ -132,38 +132,30 @@
 </p:presentation>
 </file>
 
-<file path=ppt/revisionInfo.xml><?xml version="1.0" encoding="utf-8"?>
-<p1510:revInfo xmlns:a="http://schemas.openxmlformats.org/drawingml/2006/main" xmlns:r="http://schemas.openxmlformats.org/officeDocument/2006/relationships" xmlns:p1510="http://schemas.microsoft.com/office/powerpoint/2015/10/main">
-  <p1510:revLst>
-    <p1510:client id="{C0C99BD7-623F-4809-B01E-CFB7750E2573}" v="11" dt="2026-02-16T23:49:20.002"/>
-  </p1510:revLst>
-</p1510:revInfo>
-</file>
-
 <file path=ppt/changesInfos/changesInfo1.xml><?xml version="1.0" encoding="utf-8"?>
 <pc:chgInfo xmlns:a="http://schemas.openxmlformats.org/drawingml/2006/main" xmlns:r="http://schemas.openxmlformats.org/officeDocument/2006/relationships" xmlns:ac="http://schemas.microsoft.com/office/drawing/2013/main/command" xmlns:pc="http://schemas.microsoft.com/office/powerpoint/2013/main/command">
   <pc:docChgLst>
     <pc:chgData name="LARCHER MATTEO (IDV Group)" userId="db0184d6-40e4-497e-a5fe-b974eecd6a99" providerId="ADAL" clId="{C0C99BD7-623F-4809-B01E-CFB7750E2573}"/>
-    <pc:docChg chg="custSel modMainMaster">
-      <pc:chgData name="LARCHER MATTEO (IDV Group)" userId="db0184d6-40e4-497e-a5fe-b974eecd6a99" providerId="ADAL" clId="{C0C99BD7-623F-4809-B01E-CFB7750E2573}" dt="2026-02-16T23:49:20.002" v="61"/>
+    <pc:docChg chg="modMainMaster">
+      <pc:chgData name="LARCHER MATTEO (IDV Group)" userId="db0184d6-40e4-497e-a5fe-b974eecd6a99" providerId="ADAL" clId="{C0C99BD7-623F-4809-B01E-CFB7750E2573}" dt="2026-02-17T00:15:13.315" v="27" actId="14100"/>
       <pc:docMkLst>
         <pc:docMk/>
       </pc:docMkLst>
       <pc:sldMasterChg chg="modSldLayout">
-        <pc:chgData name="LARCHER MATTEO (IDV Group)" userId="db0184d6-40e4-497e-a5fe-b974eecd6a99" providerId="ADAL" clId="{C0C99BD7-623F-4809-B01E-CFB7750E2573}" dt="2026-02-16T23:49:20.002" v="61"/>
+        <pc:chgData name="LARCHER MATTEO (IDV Group)" userId="db0184d6-40e4-497e-a5fe-b974eecd6a99" providerId="ADAL" clId="{C0C99BD7-623F-4809-B01E-CFB7750E2573}" dt="2026-02-17T00:15:13.315" v="27" actId="14100"/>
         <pc:sldMasterMkLst>
           <pc:docMk/>
           <pc:sldMasterMk cId="3676200875" sldId="2147483648"/>
         </pc:sldMasterMkLst>
         <pc:sldLayoutChg chg="modSp mod">
-          <pc:chgData name="LARCHER MATTEO (IDV Group)" userId="db0184d6-40e4-497e-a5fe-b974eecd6a99" providerId="ADAL" clId="{C0C99BD7-623F-4809-B01E-CFB7750E2573}" dt="2026-02-16T23:47:14.802" v="24" actId="1038"/>
+          <pc:chgData name="LARCHER MATTEO (IDV Group)" userId="db0184d6-40e4-497e-a5fe-b974eecd6a99" providerId="ADAL" clId="{C0C99BD7-623F-4809-B01E-CFB7750E2573}" dt="2026-02-17T00:12:50.061" v="13" actId="1037"/>
           <pc:sldLayoutMkLst>
             <pc:docMk/>
             <pc:sldMasterMk cId="3676200875" sldId="2147483648"/>
             <pc:sldLayoutMk cId="1444357513" sldId="2147483649"/>
           </pc:sldLayoutMkLst>
           <pc:spChg chg="mod">
-            <ac:chgData name="LARCHER MATTEO (IDV Group)" userId="db0184d6-40e4-497e-a5fe-b974eecd6a99" providerId="ADAL" clId="{C0C99BD7-623F-4809-B01E-CFB7750E2573}" dt="2026-02-16T23:47:14.802" v="24" actId="1038"/>
+            <ac:chgData name="LARCHER MATTEO (IDV Group)" userId="db0184d6-40e4-497e-a5fe-b974eecd6a99" providerId="ADAL" clId="{C0C99BD7-623F-4809-B01E-CFB7750E2573}" dt="2026-02-17T00:12:50.061" v="13" actId="1037"/>
             <ac:spMkLst>
               <pc:docMk/>
               <pc:sldMasterMk cId="3676200875" sldId="2147483648"/>
@@ -172,15 +164,15 @@
             </ac:spMkLst>
           </pc:spChg>
         </pc:sldLayoutChg>
-        <pc:sldLayoutChg chg="addSp delSp modSp mod">
-          <pc:chgData name="LARCHER MATTEO (IDV Group)" userId="db0184d6-40e4-497e-a5fe-b974eecd6a99" providerId="ADAL" clId="{C0C99BD7-623F-4809-B01E-CFB7750E2573}" dt="2026-02-16T23:48:17.689" v="33"/>
+        <pc:sldLayoutChg chg="modSp mod">
+          <pc:chgData name="LARCHER MATTEO (IDV Group)" userId="db0184d6-40e4-497e-a5fe-b974eecd6a99" providerId="ADAL" clId="{C0C99BD7-623F-4809-B01E-CFB7750E2573}" dt="2026-02-17T00:14:14.364" v="17" actId="14100"/>
           <pc:sldLayoutMkLst>
             <pc:docMk/>
             <pc:sldMasterMk cId="3676200875" sldId="2147483648"/>
             <pc:sldLayoutMk cId="338346009" sldId="2147483650"/>
           </pc:sldLayoutMkLst>
-          <pc:spChg chg="del">
-            <ac:chgData name="LARCHER MATTEO (IDV Group)" userId="db0184d6-40e4-497e-a5fe-b974eecd6a99" providerId="ADAL" clId="{C0C99BD7-623F-4809-B01E-CFB7750E2573}" dt="2026-02-16T23:48:16.589" v="32" actId="478"/>
+          <pc:spChg chg="mod">
+            <ac:chgData name="LARCHER MATTEO (IDV Group)" userId="db0184d6-40e4-497e-a5fe-b974eecd6a99" providerId="ADAL" clId="{C0C99BD7-623F-4809-B01E-CFB7750E2573}" dt="2026-02-17T00:14:14.364" v="17" actId="14100"/>
             <ac:spMkLst>
               <pc:docMk/>
               <pc:sldMasterMk cId="3676200875" sldId="2147483648"/>
@@ -188,70 +180,16 @@
               <ac:spMk id="4" creationId="{00000000-0000-0000-0000-000000000000}"/>
             </ac:spMkLst>
           </pc:spChg>
-          <pc:spChg chg="del mod">
-            <ac:chgData name="LARCHER MATTEO (IDV Group)" userId="db0184d6-40e4-497e-a5fe-b974eecd6a99" providerId="ADAL" clId="{C0C99BD7-623F-4809-B01E-CFB7750E2573}" dt="2026-02-16T23:48:14.800" v="31" actId="478"/>
-            <ac:spMkLst>
-              <pc:docMk/>
-              <pc:sldMasterMk cId="3676200875" sldId="2147483648"/>
-              <pc:sldLayoutMk cId="338346009" sldId="2147483650"/>
-              <ac:spMk id="7" creationId="{DC0F4838-F6BF-C30B-C410-5E532DCDEE34}"/>
-            </ac:spMkLst>
-          </pc:spChg>
-          <pc:spChg chg="add mod">
-            <ac:chgData name="LARCHER MATTEO (IDV Group)" userId="db0184d6-40e4-497e-a5fe-b974eecd6a99" providerId="ADAL" clId="{C0C99BD7-623F-4809-B01E-CFB7750E2573}" dt="2026-02-16T23:48:17.689" v="33"/>
-            <ac:spMkLst>
-              <pc:docMk/>
-              <pc:sldMasterMk cId="3676200875" sldId="2147483648"/>
-              <pc:sldLayoutMk cId="338346009" sldId="2147483650"/>
-              <ac:spMk id="8" creationId="{23853EF7-9530-9CE3-8AAC-163A81EF4EAE}"/>
-            </ac:spMkLst>
-          </pc:spChg>
-          <pc:spChg chg="add mod">
-            <ac:chgData name="LARCHER MATTEO (IDV Group)" userId="db0184d6-40e4-497e-a5fe-b974eecd6a99" providerId="ADAL" clId="{C0C99BD7-623F-4809-B01E-CFB7750E2573}" dt="2026-02-16T23:48:17.689" v="33"/>
-            <ac:spMkLst>
-              <pc:docMk/>
-              <pc:sldMasterMk cId="3676200875" sldId="2147483648"/>
-              <pc:sldLayoutMk cId="338346009" sldId="2147483650"/>
-              <ac:spMk id="12" creationId="{0BCF4466-819F-2857-3C33-DB2BFD6F8B49}"/>
-            </ac:spMkLst>
-          </pc:spChg>
         </pc:sldLayoutChg>
-        <pc:sldLayoutChg chg="addSp delSp modSp mod">
-          <pc:chgData name="LARCHER MATTEO (IDV Group)" userId="db0184d6-40e4-497e-a5fe-b974eecd6a99" providerId="ADAL" clId="{C0C99BD7-623F-4809-B01E-CFB7750E2573}" dt="2026-02-16T23:48:35.326" v="40"/>
+        <pc:sldLayoutChg chg="modSp mod">
+          <pc:chgData name="LARCHER MATTEO (IDV Group)" userId="db0184d6-40e4-497e-a5fe-b974eecd6a99" providerId="ADAL" clId="{C0C99BD7-623F-4809-B01E-CFB7750E2573}" dt="2026-02-17T00:14:22.812" v="19" actId="14100"/>
           <pc:sldLayoutMkLst>
             <pc:docMk/>
             <pc:sldMasterMk cId="3676200875" sldId="2147483648"/>
             <pc:sldLayoutMk cId="2619886245" sldId="2147483652"/>
           </pc:sldLayoutMkLst>
-          <pc:spChg chg="del">
-            <ac:chgData name="LARCHER MATTEO (IDV Group)" userId="db0184d6-40e4-497e-a5fe-b974eecd6a99" providerId="ADAL" clId="{C0C99BD7-623F-4809-B01E-CFB7750E2573}" dt="2026-02-16T23:48:34.365" v="39" actId="478"/>
-            <ac:spMkLst>
-              <pc:docMk/>
-              <pc:sldMasterMk cId="3676200875" sldId="2147483648"/>
-              <pc:sldLayoutMk cId="2619886245" sldId="2147483652"/>
-              <ac:spMk id="5" creationId="{36A728D5-5BBE-C9BE-C8CB-7E6F35D77231}"/>
-            </ac:spMkLst>
-          </pc:spChg>
-          <pc:spChg chg="add mod">
-            <ac:chgData name="LARCHER MATTEO (IDV Group)" userId="db0184d6-40e4-497e-a5fe-b974eecd6a99" providerId="ADAL" clId="{C0C99BD7-623F-4809-B01E-CFB7750E2573}" dt="2026-02-16T23:48:35.326" v="40"/>
-            <ac:spMkLst>
-              <pc:docMk/>
-              <pc:sldMasterMk cId="3676200875" sldId="2147483648"/>
-              <pc:sldLayoutMk cId="2619886245" sldId="2147483652"/>
-              <ac:spMk id="6" creationId="{9DC74560-9E05-FD16-6AD6-A28A46251192}"/>
-            </ac:spMkLst>
-          </pc:spChg>
-          <pc:spChg chg="add mod">
-            <ac:chgData name="LARCHER MATTEO (IDV Group)" userId="db0184d6-40e4-497e-a5fe-b974eecd6a99" providerId="ADAL" clId="{C0C99BD7-623F-4809-B01E-CFB7750E2573}" dt="2026-02-16T23:48:35.326" v="40"/>
-            <ac:spMkLst>
-              <pc:docMk/>
-              <pc:sldMasterMk cId="3676200875" sldId="2147483648"/>
-              <pc:sldLayoutMk cId="2619886245" sldId="2147483652"/>
-              <ac:spMk id="7" creationId="{920AA42E-3654-E284-069F-FC32E2EBEBCE}"/>
-            </ac:spMkLst>
-          </pc:spChg>
-          <pc:spChg chg="del">
-            <ac:chgData name="LARCHER MATTEO (IDV Group)" userId="db0184d6-40e4-497e-a5fe-b974eecd6a99" providerId="ADAL" clId="{C0C99BD7-623F-4809-B01E-CFB7750E2573}" dt="2026-02-16T23:48:32.159" v="38" actId="478"/>
+          <pc:spChg chg="mod">
+            <ac:chgData name="LARCHER MATTEO (IDV Group)" userId="db0184d6-40e4-497e-a5fe-b974eecd6a99" providerId="ADAL" clId="{C0C99BD7-623F-4809-B01E-CFB7750E2573}" dt="2026-02-17T00:14:22.812" v="19" actId="14100"/>
             <ac:spMkLst>
               <pc:docMk/>
               <pc:sldMasterMk cId="3676200875" sldId="2147483648"/>
@@ -260,42 +198,15 @@
             </ac:spMkLst>
           </pc:spChg>
         </pc:sldLayoutChg>
-        <pc:sldLayoutChg chg="addSp delSp modSp mod">
-          <pc:chgData name="LARCHER MATTEO (IDV Group)" userId="db0184d6-40e4-497e-a5fe-b974eecd6a99" providerId="ADAL" clId="{C0C99BD7-623F-4809-B01E-CFB7750E2573}" dt="2026-02-16T23:48:41.814" v="43"/>
+        <pc:sldLayoutChg chg="modSp mod">
+          <pc:chgData name="LARCHER MATTEO (IDV Group)" userId="db0184d6-40e4-497e-a5fe-b974eecd6a99" providerId="ADAL" clId="{C0C99BD7-623F-4809-B01E-CFB7750E2573}" dt="2026-02-17T00:14:26.258" v="20" actId="14100"/>
           <pc:sldLayoutMkLst>
             <pc:docMk/>
             <pc:sldMasterMk cId="3676200875" sldId="2147483648"/>
             <pc:sldLayoutMk cId="2535793967" sldId="2147483653"/>
           </pc:sldLayoutMkLst>
-          <pc:spChg chg="del">
-            <ac:chgData name="LARCHER MATTEO (IDV Group)" userId="db0184d6-40e4-497e-a5fe-b974eecd6a99" providerId="ADAL" clId="{C0C99BD7-623F-4809-B01E-CFB7750E2573}" dt="2026-02-16T23:48:41.021" v="42" actId="478"/>
-            <ac:spMkLst>
-              <pc:docMk/>
-              <pc:sldMasterMk cId="3676200875" sldId="2147483648"/>
-              <pc:sldLayoutMk cId="2535793967" sldId="2147483653"/>
-              <ac:spMk id="7" creationId="{2AAF3200-A4E9-67DF-6962-7DE8759EEE6D}"/>
-            </ac:spMkLst>
-          </pc:spChg>
-          <pc:spChg chg="add mod">
-            <ac:chgData name="LARCHER MATTEO (IDV Group)" userId="db0184d6-40e4-497e-a5fe-b974eecd6a99" providerId="ADAL" clId="{C0C99BD7-623F-4809-B01E-CFB7750E2573}" dt="2026-02-16T23:48:41.814" v="43"/>
-            <ac:spMkLst>
-              <pc:docMk/>
-              <pc:sldMasterMk cId="3676200875" sldId="2147483648"/>
-              <pc:sldLayoutMk cId="2535793967" sldId="2147483653"/>
-              <ac:spMk id="8" creationId="{1E5CD868-795A-80DD-B851-3B7D64C62FB0}"/>
-            </ac:spMkLst>
-          </pc:spChg>
-          <pc:spChg chg="add mod">
-            <ac:chgData name="LARCHER MATTEO (IDV Group)" userId="db0184d6-40e4-497e-a5fe-b974eecd6a99" providerId="ADAL" clId="{C0C99BD7-623F-4809-B01E-CFB7750E2573}" dt="2026-02-16T23:48:41.814" v="43"/>
-            <ac:spMkLst>
-              <pc:docMk/>
-              <pc:sldMasterMk cId="3676200875" sldId="2147483648"/>
-              <pc:sldLayoutMk cId="2535793967" sldId="2147483653"/>
-              <ac:spMk id="9" creationId="{51D9E150-9323-088D-1DAC-64A83CEBCA7A}"/>
-            </ac:spMkLst>
-          </pc:spChg>
-          <pc:spChg chg="del">
-            <ac:chgData name="LARCHER MATTEO (IDV Group)" userId="db0184d6-40e4-497e-a5fe-b974eecd6a99" providerId="ADAL" clId="{C0C99BD7-623F-4809-B01E-CFB7750E2573}" dt="2026-02-16T23:48:39.085" v="41" actId="478"/>
+          <pc:spChg chg="mod">
+            <ac:chgData name="LARCHER MATTEO (IDV Group)" userId="db0184d6-40e4-497e-a5fe-b974eecd6a99" providerId="ADAL" clId="{C0C99BD7-623F-4809-B01E-CFB7750E2573}" dt="2026-02-17T00:14:26.258" v="20" actId="14100"/>
             <ac:spMkLst>
               <pc:docMk/>
               <pc:sldMasterMk cId="3676200875" sldId="2147483648"/>
@@ -304,42 +215,15 @@
             </ac:spMkLst>
           </pc:spChg>
         </pc:sldLayoutChg>
-        <pc:sldLayoutChg chg="addSp delSp modSp mod">
-          <pc:chgData name="LARCHER MATTEO (IDV Group)" userId="db0184d6-40e4-497e-a5fe-b974eecd6a99" providerId="ADAL" clId="{C0C99BD7-623F-4809-B01E-CFB7750E2573}" dt="2026-02-16T23:48:47.911" v="46"/>
+        <pc:sldLayoutChg chg="modSp mod">
+          <pc:chgData name="LARCHER MATTEO (IDV Group)" userId="db0184d6-40e4-497e-a5fe-b974eecd6a99" providerId="ADAL" clId="{C0C99BD7-623F-4809-B01E-CFB7750E2573}" dt="2026-02-17T00:14:30.440" v="21" actId="14100"/>
           <pc:sldLayoutMkLst>
             <pc:docMk/>
             <pc:sldMasterMk cId="3676200875" sldId="2147483648"/>
             <pc:sldLayoutMk cId="3472721253" sldId="2147483654"/>
           </pc:sldLayoutMkLst>
-          <pc:spChg chg="del">
-            <ac:chgData name="LARCHER MATTEO (IDV Group)" userId="db0184d6-40e4-497e-a5fe-b974eecd6a99" providerId="ADAL" clId="{C0C99BD7-623F-4809-B01E-CFB7750E2573}" dt="2026-02-16T23:48:47.044" v="45" actId="478"/>
-            <ac:spMkLst>
-              <pc:docMk/>
-              <pc:sldMasterMk cId="3676200875" sldId="2147483648"/>
-              <pc:sldLayoutMk cId="3472721253" sldId="2147483654"/>
-              <ac:spMk id="3" creationId="{8F0BB32C-C6A2-82A8-490B-7538697EFCED}"/>
-            </ac:spMkLst>
-          </pc:spChg>
-          <pc:spChg chg="add mod">
-            <ac:chgData name="LARCHER MATTEO (IDV Group)" userId="db0184d6-40e4-497e-a5fe-b974eecd6a99" providerId="ADAL" clId="{C0C99BD7-623F-4809-B01E-CFB7750E2573}" dt="2026-02-16T23:48:47.911" v="46"/>
-            <ac:spMkLst>
-              <pc:docMk/>
-              <pc:sldMasterMk cId="3676200875" sldId="2147483648"/>
-              <pc:sldLayoutMk cId="3472721253" sldId="2147483654"/>
-              <ac:spMk id="4" creationId="{E3F17EBA-EE67-E39D-B24B-51E6B4430B34}"/>
-            </ac:spMkLst>
-          </pc:spChg>
-          <pc:spChg chg="add mod">
-            <ac:chgData name="LARCHER MATTEO (IDV Group)" userId="db0184d6-40e4-497e-a5fe-b974eecd6a99" providerId="ADAL" clId="{C0C99BD7-623F-4809-B01E-CFB7750E2573}" dt="2026-02-16T23:48:47.911" v="46"/>
-            <ac:spMkLst>
-              <pc:docMk/>
-              <pc:sldMasterMk cId="3676200875" sldId="2147483648"/>
-              <pc:sldLayoutMk cId="3472721253" sldId="2147483654"/>
-              <ac:spMk id="5" creationId="{69BA34CF-6BBA-00F0-8C23-D1A0A4CA02B5}"/>
-            </ac:spMkLst>
-          </pc:spChg>
-          <pc:spChg chg="del">
-            <ac:chgData name="LARCHER MATTEO (IDV Group)" userId="db0184d6-40e4-497e-a5fe-b974eecd6a99" providerId="ADAL" clId="{C0C99BD7-623F-4809-B01E-CFB7750E2573}" dt="2026-02-16T23:48:44.764" v="44" actId="478"/>
+          <pc:spChg chg="mod">
+            <ac:chgData name="LARCHER MATTEO (IDV Group)" userId="db0184d6-40e4-497e-a5fe-b974eecd6a99" providerId="ADAL" clId="{C0C99BD7-623F-4809-B01E-CFB7750E2573}" dt="2026-02-17T00:14:30.440" v="21" actId="14100"/>
             <ac:spMkLst>
               <pc:docMk/>
               <pc:sldMasterMk cId="3676200875" sldId="2147483648"/>
@@ -348,42 +232,15 @@
             </ac:spMkLst>
           </pc:spChg>
         </pc:sldLayoutChg>
-        <pc:sldLayoutChg chg="addSp delSp modSp mod">
-          <pc:chgData name="LARCHER MATTEO (IDV Group)" userId="db0184d6-40e4-497e-a5fe-b974eecd6a99" providerId="ADAL" clId="{C0C99BD7-623F-4809-B01E-CFB7750E2573}" dt="2026-02-16T23:48:54.079" v="49"/>
+        <pc:sldLayoutChg chg="modSp mod">
+          <pc:chgData name="LARCHER MATTEO (IDV Group)" userId="db0184d6-40e4-497e-a5fe-b974eecd6a99" providerId="ADAL" clId="{C0C99BD7-623F-4809-B01E-CFB7750E2573}" dt="2026-02-17T00:14:34.979" v="22" actId="14100"/>
           <pc:sldLayoutMkLst>
             <pc:docMk/>
             <pc:sldMasterMk cId="3676200875" sldId="2147483648"/>
             <pc:sldLayoutMk cId="2130901097" sldId="2147483655"/>
           </pc:sldLayoutMkLst>
-          <pc:spChg chg="del">
-            <ac:chgData name="LARCHER MATTEO (IDV Group)" userId="db0184d6-40e4-497e-a5fe-b974eecd6a99" providerId="ADAL" clId="{C0C99BD7-623F-4809-B01E-CFB7750E2573}" dt="2026-02-16T23:48:51.809" v="47" actId="478"/>
-            <ac:spMkLst>
-              <pc:docMk/>
-              <pc:sldMasterMk cId="3676200875" sldId="2147483648"/>
-              <pc:sldLayoutMk cId="2130901097" sldId="2147483655"/>
-              <ac:spMk id="2" creationId="{5ECDEA0F-CD3F-E988-8F7E-CF36959BCCB4}"/>
-            </ac:spMkLst>
-          </pc:spChg>
-          <pc:spChg chg="add mod">
-            <ac:chgData name="LARCHER MATTEO (IDV Group)" userId="db0184d6-40e4-497e-a5fe-b974eecd6a99" providerId="ADAL" clId="{C0C99BD7-623F-4809-B01E-CFB7750E2573}" dt="2026-02-16T23:48:54.079" v="49"/>
-            <ac:spMkLst>
-              <pc:docMk/>
-              <pc:sldMasterMk cId="3676200875" sldId="2147483648"/>
-              <pc:sldLayoutMk cId="2130901097" sldId="2147483655"/>
-              <ac:spMk id="3" creationId="{1B942665-9C8D-E154-B4A7-2A3AAC87EFB1}"/>
-            </ac:spMkLst>
-          </pc:spChg>
-          <pc:spChg chg="add mod">
-            <ac:chgData name="LARCHER MATTEO (IDV Group)" userId="db0184d6-40e4-497e-a5fe-b974eecd6a99" providerId="ADAL" clId="{C0C99BD7-623F-4809-B01E-CFB7750E2573}" dt="2026-02-16T23:48:54.079" v="49"/>
-            <ac:spMkLst>
-              <pc:docMk/>
-              <pc:sldMasterMk cId="3676200875" sldId="2147483648"/>
-              <pc:sldLayoutMk cId="2130901097" sldId="2147483655"/>
-              <ac:spMk id="4" creationId="{CFE2E3C1-BE6E-42B1-100C-CFB62BCCA84E}"/>
-            </ac:spMkLst>
-          </pc:spChg>
-          <pc:spChg chg="del">
-            <ac:chgData name="LARCHER MATTEO (IDV Group)" userId="db0184d6-40e4-497e-a5fe-b974eecd6a99" providerId="ADAL" clId="{C0C99BD7-623F-4809-B01E-CFB7750E2573}" dt="2026-02-16T23:48:53.499" v="48" actId="478"/>
+          <pc:spChg chg="mod">
+            <ac:chgData name="LARCHER MATTEO (IDV Group)" userId="db0184d6-40e4-497e-a5fe-b974eecd6a99" providerId="ADAL" clId="{C0C99BD7-623F-4809-B01E-CFB7750E2573}" dt="2026-02-17T00:14:34.979" v="22" actId="14100"/>
             <ac:spMkLst>
               <pc:docMk/>
               <pc:sldMasterMk cId="3676200875" sldId="2147483648"/>
@@ -392,42 +249,15 @@
             </ac:spMkLst>
           </pc:spChg>
         </pc:sldLayoutChg>
-        <pc:sldLayoutChg chg="addSp delSp modSp mod">
-          <pc:chgData name="LARCHER MATTEO (IDV Group)" userId="db0184d6-40e4-497e-a5fe-b974eecd6a99" providerId="ADAL" clId="{C0C99BD7-623F-4809-B01E-CFB7750E2573}" dt="2026-02-16T23:49:00.292" v="52"/>
+        <pc:sldLayoutChg chg="modSp mod">
+          <pc:chgData name="LARCHER MATTEO (IDV Group)" userId="db0184d6-40e4-497e-a5fe-b974eecd6a99" providerId="ADAL" clId="{C0C99BD7-623F-4809-B01E-CFB7750E2573}" dt="2026-02-17T00:14:41.979" v="23" actId="14100"/>
           <pc:sldLayoutMkLst>
             <pc:docMk/>
             <pc:sldMasterMk cId="3676200875" sldId="2147483648"/>
             <pc:sldLayoutMk cId="3540895647" sldId="2147483656"/>
           </pc:sldLayoutMkLst>
-          <pc:spChg chg="del">
-            <ac:chgData name="LARCHER MATTEO (IDV Group)" userId="db0184d6-40e4-497e-a5fe-b974eecd6a99" providerId="ADAL" clId="{C0C99BD7-623F-4809-B01E-CFB7750E2573}" dt="2026-02-16T23:48:57.544" v="50" actId="478"/>
-            <ac:spMkLst>
-              <pc:docMk/>
-              <pc:sldMasterMk cId="3676200875" sldId="2147483648"/>
-              <pc:sldLayoutMk cId="3540895647" sldId="2147483656"/>
-              <ac:spMk id="5" creationId="{E08D9B6F-D6D8-AE83-7546-E14BE6C2E410}"/>
-            </ac:spMkLst>
-          </pc:spChg>
-          <pc:spChg chg="add mod">
-            <ac:chgData name="LARCHER MATTEO (IDV Group)" userId="db0184d6-40e4-497e-a5fe-b974eecd6a99" providerId="ADAL" clId="{C0C99BD7-623F-4809-B01E-CFB7750E2573}" dt="2026-02-16T23:49:00.292" v="52"/>
-            <ac:spMkLst>
-              <pc:docMk/>
-              <pc:sldMasterMk cId="3676200875" sldId="2147483648"/>
-              <pc:sldLayoutMk cId="3540895647" sldId="2147483656"/>
-              <ac:spMk id="6" creationId="{F2CAF3CD-0E8D-01F0-19BA-701272483671}"/>
-            </ac:spMkLst>
-          </pc:spChg>
-          <pc:spChg chg="add mod">
-            <ac:chgData name="LARCHER MATTEO (IDV Group)" userId="db0184d6-40e4-497e-a5fe-b974eecd6a99" providerId="ADAL" clId="{C0C99BD7-623F-4809-B01E-CFB7750E2573}" dt="2026-02-16T23:49:00.292" v="52"/>
-            <ac:spMkLst>
-              <pc:docMk/>
-              <pc:sldMasterMk cId="3676200875" sldId="2147483648"/>
-              <pc:sldLayoutMk cId="3540895647" sldId="2147483656"/>
-              <ac:spMk id="7" creationId="{819FA1F3-6C25-0F24-6531-CEB107608D04}"/>
-            </ac:spMkLst>
-          </pc:spChg>
-          <pc:spChg chg="del">
-            <ac:chgData name="LARCHER MATTEO (IDV Group)" userId="db0184d6-40e4-497e-a5fe-b974eecd6a99" providerId="ADAL" clId="{C0C99BD7-623F-4809-B01E-CFB7750E2573}" dt="2026-02-16T23:48:59.517" v="51" actId="478"/>
+          <pc:spChg chg="mod">
+            <ac:chgData name="LARCHER MATTEO (IDV Group)" userId="db0184d6-40e4-497e-a5fe-b974eecd6a99" providerId="ADAL" clId="{C0C99BD7-623F-4809-B01E-CFB7750E2573}" dt="2026-02-17T00:14:41.979" v="23" actId="14100"/>
             <ac:spMkLst>
               <pc:docMk/>
               <pc:sldMasterMk cId="3676200875" sldId="2147483648"/>
@@ -436,42 +266,15 @@
             </ac:spMkLst>
           </pc:spChg>
         </pc:sldLayoutChg>
-        <pc:sldLayoutChg chg="addSp delSp modSp mod">
-          <pc:chgData name="LARCHER MATTEO (IDV Group)" userId="db0184d6-40e4-497e-a5fe-b974eecd6a99" providerId="ADAL" clId="{C0C99BD7-623F-4809-B01E-CFB7750E2573}" dt="2026-02-16T23:49:07.165" v="55"/>
+        <pc:sldLayoutChg chg="modSp mod">
+          <pc:chgData name="LARCHER MATTEO (IDV Group)" userId="db0184d6-40e4-497e-a5fe-b974eecd6a99" providerId="ADAL" clId="{C0C99BD7-623F-4809-B01E-CFB7750E2573}" dt="2026-02-17T00:14:46.121" v="24" actId="14100"/>
           <pc:sldLayoutMkLst>
             <pc:docMk/>
             <pc:sldMasterMk cId="3676200875" sldId="2147483648"/>
             <pc:sldLayoutMk cId="3566899855" sldId="2147483657"/>
           </pc:sldLayoutMkLst>
-          <pc:spChg chg="del">
-            <ac:chgData name="LARCHER MATTEO (IDV Group)" userId="db0184d6-40e4-497e-a5fe-b974eecd6a99" providerId="ADAL" clId="{C0C99BD7-623F-4809-B01E-CFB7750E2573}" dt="2026-02-16T23:49:04.405" v="53" actId="478"/>
-            <ac:spMkLst>
-              <pc:docMk/>
-              <pc:sldMasterMk cId="3676200875" sldId="2147483648"/>
-              <pc:sldLayoutMk cId="3566899855" sldId="2147483657"/>
-              <ac:spMk id="5" creationId="{FDDE0A73-7F0F-1EE2-B8F1-2B2B4B0427D3}"/>
-            </ac:spMkLst>
-          </pc:spChg>
-          <pc:spChg chg="add mod">
-            <ac:chgData name="LARCHER MATTEO (IDV Group)" userId="db0184d6-40e4-497e-a5fe-b974eecd6a99" providerId="ADAL" clId="{C0C99BD7-623F-4809-B01E-CFB7750E2573}" dt="2026-02-16T23:49:07.165" v="55"/>
-            <ac:spMkLst>
-              <pc:docMk/>
-              <pc:sldMasterMk cId="3676200875" sldId="2147483648"/>
-              <pc:sldLayoutMk cId="3566899855" sldId="2147483657"/>
-              <ac:spMk id="6" creationId="{FE9F7795-AD43-4C27-8F8D-8FA396FDFCB0}"/>
-            </ac:spMkLst>
-          </pc:spChg>
-          <pc:spChg chg="add mod">
-            <ac:chgData name="LARCHER MATTEO (IDV Group)" userId="db0184d6-40e4-497e-a5fe-b974eecd6a99" providerId="ADAL" clId="{C0C99BD7-623F-4809-B01E-CFB7750E2573}" dt="2026-02-16T23:49:07.165" v="55"/>
-            <ac:spMkLst>
-              <pc:docMk/>
-              <pc:sldMasterMk cId="3676200875" sldId="2147483648"/>
-              <pc:sldLayoutMk cId="3566899855" sldId="2147483657"/>
-              <ac:spMk id="7" creationId="{42F1B687-FDBC-951B-A6F8-6A6E00B75E32}"/>
-            </ac:spMkLst>
-          </pc:spChg>
-          <pc:spChg chg="del">
-            <ac:chgData name="LARCHER MATTEO (IDV Group)" userId="db0184d6-40e4-497e-a5fe-b974eecd6a99" providerId="ADAL" clId="{C0C99BD7-623F-4809-B01E-CFB7750E2573}" dt="2026-02-16T23:49:06.237" v="54" actId="478"/>
+          <pc:spChg chg="mod">
+            <ac:chgData name="LARCHER MATTEO (IDV Group)" userId="db0184d6-40e4-497e-a5fe-b974eecd6a99" providerId="ADAL" clId="{C0C99BD7-623F-4809-B01E-CFB7750E2573}" dt="2026-02-17T00:14:46.121" v="24" actId="14100"/>
             <ac:spMkLst>
               <pc:docMk/>
               <pc:sldMasterMk cId="3676200875" sldId="2147483648"/>
@@ -480,42 +283,15 @@
             </ac:spMkLst>
           </pc:spChg>
         </pc:sldLayoutChg>
-        <pc:sldLayoutChg chg="addSp delSp modSp mod">
-          <pc:chgData name="LARCHER MATTEO (IDV Group)" userId="db0184d6-40e4-497e-a5fe-b974eecd6a99" providerId="ADAL" clId="{C0C99BD7-623F-4809-B01E-CFB7750E2573}" dt="2026-02-16T23:49:13.940" v="58"/>
+        <pc:sldLayoutChg chg="modSp mod">
+          <pc:chgData name="LARCHER MATTEO (IDV Group)" userId="db0184d6-40e4-497e-a5fe-b974eecd6a99" providerId="ADAL" clId="{C0C99BD7-623F-4809-B01E-CFB7750E2573}" dt="2026-02-17T00:14:50.415" v="25" actId="14100"/>
           <pc:sldLayoutMkLst>
             <pc:docMk/>
             <pc:sldMasterMk cId="3676200875" sldId="2147483648"/>
             <pc:sldLayoutMk cId="313914798" sldId="2147483658"/>
           </pc:sldLayoutMkLst>
-          <pc:spChg chg="del">
-            <ac:chgData name="LARCHER MATTEO (IDV Group)" userId="db0184d6-40e4-497e-a5fe-b974eecd6a99" providerId="ADAL" clId="{C0C99BD7-623F-4809-B01E-CFB7750E2573}" dt="2026-02-16T23:49:11.726" v="56" actId="478"/>
-            <ac:spMkLst>
-              <pc:docMk/>
-              <pc:sldMasterMk cId="3676200875" sldId="2147483648"/>
-              <pc:sldLayoutMk cId="313914798" sldId="2147483658"/>
-              <ac:spMk id="4" creationId="{F1D6BA0C-FCB1-B18B-A578-8A41AB44F39E}"/>
-            </ac:spMkLst>
-          </pc:spChg>
-          <pc:spChg chg="add mod">
-            <ac:chgData name="LARCHER MATTEO (IDV Group)" userId="db0184d6-40e4-497e-a5fe-b974eecd6a99" providerId="ADAL" clId="{C0C99BD7-623F-4809-B01E-CFB7750E2573}" dt="2026-02-16T23:49:13.940" v="58"/>
-            <ac:spMkLst>
-              <pc:docMk/>
-              <pc:sldMasterMk cId="3676200875" sldId="2147483648"/>
-              <pc:sldLayoutMk cId="313914798" sldId="2147483658"/>
-              <ac:spMk id="5" creationId="{CB1422D4-6CB0-409D-2EF3-11E3418B85C3}"/>
-            </ac:spMkLst>
-          </pc:spChg>
-          <pc:spChg chg="add mod">
-            <ac:chgData name="LARCHER MATTEO (IDV Group)" userId="db0184d6-40e4-497e-a5fe-b974eecd6a99" providerId="ADAL" clId="{C0C99BD7-623F-4809-B01E-CFB7750E2573}" dt="2026-02-16T23:49:13.940" v="58"/>
-            <ac:spMkLst>
-              <pc:docMk/>
-              <pc:sldMasterMk cId="3676200875" sldId="2147483648"/>
-              <pc:sldLayoutMk cId="313914798" sldId="2147483658"/>
-              <ac:spMk id="6" creationId="{ED7B2ECE-9761-BD59-79BA-A1348B20D990}"/>
-            </ac:spMkLst>
-          </pc:spChg>
-          <pc:spChg chg="del">
-            <ac:chgData name="LARCHER MATTEO (IDV Group)" userId="db0184d6-40e4-497e-a5fe-b974eecd6a99" providerId="ADAL" clId="{C0C99BD7-623F-4809-B01E-CFB7750E2573}" dt="2026-02-16T23:49:13.173" v="57" actId="478"/>
+          <pc:spChg chg="mod">
+            <ac:chgData name="LARCHER MATTEO (IDV Group)" userId="db0184d6-40e4-497e-a5fe-b974eecd6a99" providerId="ADAL" clId="{C0C99BD7-623F-4809-B01E-CFB7750E2573}" dt="2026-02-17T00:14:50.415" v="25" actId="14100"/>
             <ac:spMkLst>
               <pc:docMk/>
               <pc:sldMasterMk cId="3676200875" sldId="2147483648"/>
@@ -524,42 +300,15 @@
             </ac:spMkLst>
           </pc:spChg>
         </pc:sldLayoutChg>
-        <pc:sldLayoutChg chg="addSp delSp modSp mod">
-          <pc:chgData name="LARCHER MATTEO (IDV Group)" userId="db0184d6-40e4-497e-a5fe-b974eecd6a99" providerId="ADAL" clId="{C0C99BD7-623F-4809-B01E-CFB7750E2573}" dt="2026-02-16T23:49:20.002" v="61"/>
+        <pc:sldLayoutChg chg="modSp mod">
+          <pc:chgData name="LARCHER MATTEO (IDV Group)" userId="db0184d6-40e4-497e-a5fe-b974eecd6a99" providerId="ADAL" clId="{C0C99BD7-623F-4809-B01E-CFB7750E2573}" dt="2026-02-17T00:14:56.214" v="26" actId="14100"/>
           <pc:sldLayoutMkLst>
             <pc:docMk/>
             <pc:sldMasterMk cId="3676200875" sldId="2147483648"/>
             <pc:sldLayoutMk cId="2581529045" sldId="2147483659"/>
           </pc:sldLayoutMkLst>
-          <pc:spChg chg="del">
-            <ac:chgData name="LARCHER MATTEO (IDV Group)" userId="db0184d6-40e4-497e-a5fe-b974eecd6a99" providerId="ADAL" clId="{C0C99BD7-623F-4809-B01E-CFB7750E2573}" dt="2026-02-16T23:49:19.270" v="60" actId="478"/>
-            <ac:spMkLst>
-              <pc:docMk/>
-              <pc:sldMasterMk cId="3676200875" sldId="2147483648"/>
-              <pc:sldLayoutMk cId="2581529045" sldId="2147483659"/>
-              <ac:spMk id="4" creationId="{116057FF-9082-1A59-4CD5-DE9592F83772}"/>
-            </ac:spMkLst>
-          </pc:spChg>
-          <pc:spChg chg="add mod">
-            <ac:chgData name="LARCHER MATTEO (IDV Group)" userId="db0184d6-40e4-497e-a5fe-b974eecd6a99" providerId="ADAL" clId="{C0C99BD7-623F-4809-B01E-CFB7750E2573}" dt="2026-02-16T23:49:20.002" v="61"/>
-            <ac:spMkLst>
-              <pc:docMk/>
-              <pc:sldMasterMk cId="3676200875" sldId="2147483648"/>
-              <pc:sldLayoutMk cId="2581529045" sldId="2147483659"/>
-              <ac:spMk id="5" creationId="{2E69A76C-B460-2AE3-A17A-1505DDD7451B}"/>
-            </ac:spMkLst>
-          </pc:spChg>
-          <pc:spChg chg="add mod">
-            <ac:chgData name="LARCHER MATTEO (IDV Group)" userId="db0184d6-40e4-497e-a5fe-b974eecd6a99" providerId="ADAL" clId="{C0C99BD7-623F-4809-B01E-CFB7750E2573}" dt="2026-02-16T23:49:20.002" v="61"/>
-            <ac:spMkLst>
-              <pc:docMk/>
-              <pc:sldMasterMk cId="3676200875" sldId="2147483648"/>
-              <pc:sldLayoutMk cId="2581529045" sldId="2147483659"/>
-              <ac:spMk id="6" creationId="{E8B94D98-12F9-B72F-B3E7-937DF9D430A5}"/>
-            </ac:spMkLst>
-          </pc:spChg>
-          <pc:spChg chg="del">
-            <ac:chgData name="LARCHER MATTEO (IDV Group)" userId="db0184d6-40e4-497e-a5fe-b974eecd6a99" providerId="ADAL" clId="{C0C99BD7-623F-4809-B01E-CFB7750E2573}" dt="2026-02-16T23:49:16.653" v="59" actId="478"/>
+          <pc:spChg chg="mod">
+            <ac:chgData name="LARCHER MATTEO (IDV Group)" userId="db0184d6-40e4-497e-a5fe-b974eecd6a99" providerId="ADAL" clId="{C0C99BD7-623F-4809-B01E-CFB7750E2573}" dt="2026-02-17T00:14:56.214" v="26" actId="14100"/>
             <ac:spMkLst>
               <pc:docMk/>
               <pc:sldMasterMk cId="3676200875" sldId="2147483648"/>
@@ -568,15 +317,15 @@
             </ac:spMkLst>
           </pc:spChg>
         </pc:sldLayoutChg>
-        <pc:sldLayoutChg chg="addSp delSp modSp mod">
-          <pc:chgData name="LARCHER MATTEO (IDV Group)" userId="db0184d6-40e4-497e-a5fe-b974eecd6a99" providerId="ADAL" clId="{C0C99BD7-623F-4809-B01E-CFB7750E2573}" dt="2026-02-16T23:48:07.943" v="29"/>
+        <pc:sldLayoutChg chg="modSp mod">
+          <pc:chgData name="LARCHER MATTEO (IDV Group)" userId="db0184d6-40e4-497e-a5fe-b974eecd6a99" providerId="ADAL" clId="{C0C99BD7-623F-4809-B01E-CFB7750E2573}" dt="2026-02-17T00:14:10.118" v="16" actId="14100"/>
           <pc:sldLayoutMkLst>
             <pc:docMk/>
             <pc:sldMasterMk cId="3676200875" sldId="2147483648"/>
             <pc:sldLayoutMk cId="3842282995" sldId="2147483660"/>
           </pc:sldLayoutMkLst>
-          <pc:spChg chg="del">
-            <ac:chgData name="LARCHER MATTEO (IDV Group)" userId="db0184d6-40e4-497e-a5fe-b974eecd6a99" providerId="ADAL" clId="{C0C99BD7-623F-4809-B01E-CFB7750E2573}" dt="2026-02-16T23:48:04.724" v="27" actId="478"/>
+          <pc:spChg chg="mod">
+            <ac:chgData name="LARCHER MATTEO (IDV Group)" userId="db0184d6-40e4-497e-a5fe-b974eecd6a99" providerId="ADAL" clId="{C0C99BD7-623F-4809-B01E-CFB7750E2573}" dt="2026-02-17T00:14:10.118" v="16" actId="14100"/>
             <ac:spMkLst>
               <pc:docMk/>
               <pc:sldMasterMk cId="3676200875" sldId="2147483648"/>
@@ -584,43 +333,16 @@
               <ac:spMk id="4" creationId="{00000000-0000-0000-0000-000000000000}"/>
             </ac:spMkLst>
           </pc:spChg>
-          <pc:spChg chg="del">
-            <ac:chgData name="LARCHER MATTEO (IDV Group)" userId="db0184d6-40e4-497e-a5fe-b974eecd6a99" providerId="ADAL" clId="{C0C99BD7-623F-4809-B01E-CFB7750E2573}" dt="2026-02-16T23:48:06.908" v="28" actId="478"/>
-            <ac:spMkLst>
-              <pc:docMk/>
-              <pc:sldMasterMk cId="3676200875" sldId="2147483648"/>
-              <pc:sldLayoutMk cId="3842282995" sldId="2147483660"/>
-              <ac:spMk id="9" creationId="{B38D46BD-367F-3481-A8D8-E3AB2C324A8C}"/>
-            </ac:spMkLst>
-          </pc:spChg>
-          <pc:spChg chg="add mod">
-            <ac:chgData name="LARCHER MATTEO (IDV Group)" userId="db0184d6-40e4-497e-a5fe-b974eecd6a99" providerId="ADAL" clId="{C0C99BD7-623F-4809-B01E-CFB7750E2573}" dt="2026-02-16T23:48:07.943" v="29"/>
-            <ac:spMkLst>
-              <pc:docMk/>
-              <pc:sldMasterMk cId="3676200875" sldId="2147483648"/>
-              <pc:sldLayoutMk cId="3842282995" sldId="2147483660"/>
-              <ac:spMk id="11" creationId="{2243B617-D1BA-70F0-AB8D-57BB8F9271D0}"/>
-            </ac:spMkLst>
-          </pc:spChg>
-          <pc:spChg chg="add mod">
-            <ac:chgData name="LARCHER MATTEO (IDV Group)" userId="db0184d6-40e4-497e-a5fe-b974eecd6a99" providerId="ADAL" clId="{C0C99BD7-623F-4809-B01E-CFB7750E2573}" dt="2026-02-16T23:48:07.943" v="29"/>
-            <ac:spMkLst>
-              <pc:docMk/>
-              <pc:sldMasterMk cId="3676200875" sldId="2147483648"/>
-              <pc:sldLayoutMk cId="3842282995" sldId="2147483660"/>
-              <ac:spMk id="13" creationId="{A136ED69-A993-F796-0E91-8ED593E08259}"/>
-            </ac:spMkLst>
-          </pc:spChg>
         </pc:sldLayoutChg>
         <pc:sldLayoutChg chg="modSp mod">
-          <pc:chgData name="LARCHER MATTEO (IDV Group)" userId="db0184d6-40e4-497e-a5fe-b974eecd6a99" providerId="ADAL" clId="{C0C99BD7-623F-4809-B01E-CFB7750E2573}" dt="2026-02-16T23:47:47.317" v="26" actId="1076"/>
+          <pc:chgData name="LARCHER MATTEO (IDV Group)" userId="db0184d6-40e4-497e-a5fe-b974eecd6a99" providerId="ADAL" clId="{C0C99BD7-623F-4809-B01E-CFB7750E2573}" dt="2026-02-17T00:15:13.315" v="27" actId="14100"/>
           <pc:sldLayoutMkLst>
             <pc:docMk/>
             <pc:sldMasterMk cId="3676200875" sldId="2147483648"/>
             <pc:sldLayoutMk cId="2127477481" sldId="2147483661"/>
           </pc:sldLayoutMkLst>
           <pc:spChg chg="mod">
-            <ac:chgData name="LARCHER MATTEO (IDV Group)" userId="db0184d6-40e4-497e-a5fe-b974eecd6a99" providerId="ADAL" clId="{C0C99BD7-623F-4809-B01E-CFB7750E2573}" dt="2026-02-16T23:47:34.346" v="25" actId="14100"/>
+            <ac:chgData name="LARCHER MATTEO (IDV Group)" userId="db0184d6-40e4-497e-a5fe-b974eecd6a99" providerId="ADAL" clId="{C0C99BD7-623F-4809-B01E-CFB7750E2573}" dt="2026-02-17T00:15:13.315" v="27" actId="14100"/>
             <ac:spMkLst>
               <pc:docMk/>
               <pc:sldMasterMk cId="3676200875" sldId="2147483648"/>
@@ -628,57 +350,21 @@
               <ac:spMk id="4" creationId="{00000000-0000-0000-0000-000000000000}"/>
             </ac:spMkLst>
           </pc:spChg>
-          <pc:spChg chg="mod">
-            <ac:chgData name="LARCHER MATTEO (IDV Group)" userId="db0184d6-40e4-497e-a5fe-b974eecd6a99" providerId="ADAL" clId="{C0C99BD7-623F-4809-B01E-CFB7750E2573}" dt="2026-02-16T23:47:47.317" v="26" actId="1076"/>
-            <ac:spMkLst>
-              <pc:docMk/>
-              <pc:sldMasterMk cId="3676200875" sldId="2147483648"/>
-              <pc:sldLayoutMk cId="2127477481" sldId="2147483661"/>
-              <ac:spMk id="12" creationId="{9F7F4A68-C94D-DD3E-7EA3-485F462469CC}"/>
-            </ac:spMkLst>
-          </pc:spChg>
         </pc:sldLayoutChg>
-        <pc:sldLayoutChg chg="addSp delSp modSp mod">
-          <pc:chgData name="LARCHER MATTEO (IDV Group)" userId="db0184d6-40e4-497e-a5fe-b974eecd6a99" providerId="ADAL" clId="{C0C99BD7-623F-4809-B01E-CFB7750E2573}" dt="2026-02-16T23:48:25.841" v="37"/>
+        <pc:sldLayoutChg chg="modSp mod">
+          <pc:chgData name="LARCHER MATTEO (IDV Group)" userId="db0184d6-40e4-497e-a5fe-b974eecd6a99" providerId="ADAL" clId="{C0C99BD7-623F-4809-B01E-CFB7750E2573}" dt="2026-02-17T00:14:19.005" v="18" actId="14100"/>
           <pc:sldLayoutMkLst>
             <pc:docMk/>
             <pc:sldMasterMk cId="3676200875" sldId="2147483648"/>
             <pc:sldLayoutMk cId="1234733671" sldId="2147483662"/>
           </pc:sldLayoutMkLst>
-          <pc:spChg chg="del">
-            <ac:chgData name="LARCHER MATTEO (IDV Group)" userId="db0184d6-40e4-497e-a5fe-b974eecd6a99" providerId="ADAL" clId="{C0C99BD7-623F-4809-B01E-CFB7750E2573}" dt="2026-02-16T23:48:21.542" v="34" actId="478"/>
+          <pc:spChg chg="mod">
+            <ac:chgData name="LARCHER MATTEO (IDV Group)" userId="db0184d6-40e4-497e-a5fe-b974eecd6a99" providerId="ADAL" clId="{C0C99BD7-623F-4809-B01E-CFB7750E2573}" dt="2026-02-17T00:14:19.005" v="18" actId="14100"/>
             <ac:spMkLst>
               <pc:docMk/>
               <pc:sldMasterMk cId="3676200875" sldId="2147483648"/>
               <pc:sldLayoutMk cId="1234733671" sldId="2147483662"/>
               <ac:spMk id="4" creationId="{00000000-0000-0000-0000-000000000000}"/>
-            </ac:spMkLst>
-          </pc:spChg>
-          <pc:spChg chg="del mod">
-            <ac:chgData name="LARCHER MATTEO (IDV Group)" userId="db0184d6-40e4-497e-a5fe-b974eecd6a99" providerId="ADAL" clId="{C0C99BD7-623F-4809-B01E-CFB7750E2573}" dt="2026-02-16T23:48:24.921" v="36" actId="478"/>
-            <ac:spMkLst>
-              <pc:docMk/>
-              <pc:sldMasterMk cId="3676200875" sldId="2147483648"/>
-              <pc:sldLayoutMk cId="1234733671" sldId="2147483662"/>
-              <ac:spMk id="7" creationId="{E9A57DD2-0334-0E93-EF42-3A16A5997397}"/>
-            </ac:spMkLst>
-          </pc:spChg>
-          <pc:spChg chg="add mod">
-            <ac:chgData name="LARCHER MATTEO (IDV Group)" userId="db0184d6-40e4-497e-a5fe-b974eecd6a99" providerId="ADAL" clId="{C0C99BD7-623F-4809-B01E-CFB7750E2573}" dt="2026-02-16T23:48:25.841" v="37"/>
-            <ac:spMkLst>
-              <pc:docMk/>
-              <pc:sldMasterMk cId="3676200875" sldId="2147483648"/>
-              <pc:sldLayoutMk cId="1234733671" sldId="2147483662"/>
-              <ac:spMk id="8" creationId="{31778DD8-2E90-7C87-5D64-2149E05D61F3}"/>
-            </ac:spMkLst>
-          </pc:spChg>
-          <pc:spChg chg="add mod">
-            <ac:chgData name="LARCHER MATTEO (IDV Group)" userId="db0184d6-40e4-497e-a5fe-b974eecd6a99" providerId="ADAL" clId="{C0C99BD7-623F-4809-B01E-CFB7750E2573}" dt="2026-02-16T23:48:25.841" v="37"/>
-            <ac:spMkLst>
-              <pc:docMk/>
-              <pc:sldMasterMk cId="3676200875" sldId="2147483648"/>
-              <pc:sldLayoutMk cId="1234733671" sldId="2147483662"/>
-              <ac:spMk id="12" creationId="{231476A2-463A-5A82-D914-E99D9D8159EB}"/>
             </ac:spMkLst>
           </pc:spChg>
         </pc:sldLayoutChg>
@@ -1327,7 +1013,7 @@
         </p:nvSpPr>
         <p:spPr>
           <a:xfrm>
-            <a:off x="1241203" y="2679608"/>
+            <a:off x="1263723" y="2679608"/>
             <a:ext cx="3935506" cy="614922"/>
           </a:xfrm>
         </p:spPr>
@@ -1630,6 +1316,40 @@
       </p:grpSpPr>
       <p:sp>
         <p:nvSpPr>
+          <p:cNvPr id="6" name="Date Placeholder 3">
+            <a:extLst>
+              <a:ext uri="{FF2B5EF4-FFF2-40B4-BE49-F238E27FC236}">
+                <a16:creationId xmlns:a16="http://schemas.microsoft.com/office/drawing/2014/main" id="{9D7B9609-DC00-77FF-632B-7CA52E337E03}"/>
+              </a:ext>
+            </a:extLst>
+          </p:cNvPr>
+          <p:cNvSpPr>
+            <a:spLocks noGrp="1"/>
+          </p:cNvSpPr>
+          <p:nvPr>
+            <p:ph type="dt" sz="half" idx="10"/>
+          </p:nvPr>
+        </p:nvSpPr>
+        <p:spPr>
+          <a:xfrm>
+            <a:off x="1771427" y="4775147"/>
+            <a:ext cx="1291813" cy="273844"/>
+          </a:xfrm>
+        </p:spPr>
+        <p:txBody>
+          <a:bodyPr/>
+          <a:lstStyle/>
+          <a:p>
+            <a:fld id="{85454C68-2B9C-2243-9426-8AA164CE3511}" type="datetime1">
+              <a:rPr lang="it-IT" smtClean="0"/>
+              <a:t>17/02/2026</a:t>
+            </a:fld>
+            <a:endParaRPr lang="en-US"/>
+          </a:p>
+        </p:txBody>
+      </p:sp>
+      <p:sp>
+        <p:nvSpPr>
           <p:cNvPr id="7" name="Footer Placeholder 4">
             <a:extLst>
               <a:ext uri="{FF2B5EF4-FFF2-40B4-BE49-F238E27FC236}">
@@ -1892,44 +1612,10 @@
       </p:pic>
       <p:sp>
         <p:nvSpPr>
-          <p:cNvPr id="3" name="Date Placeholder 3">
+          <p:cNvPr id="2" name="TextBox 1">
             <a:extLst>
               <a:ext uri="{FF2B5EF4-FFF2-40B4-BE49-F238E27FC236}">
-                <a16:creationId xmlns:a16="http://schemas.microsoft.com/office/drawing/2014/main" id="{1B942665-9C8D-E154-B4A7-2A3AAC87EFB1}"/>
-              </a:ext>
-            </a:extLst>
-          </p:cNvPr>
-          <p:cNvSpPr>
-            <a:spLocks noGrp="1"/>
-          </p:cNvSpPr>
-          <p:nvPr>
-            <p:ph type="dt" sz="half" idx="10"/>
-          </p:nvPr>
-        </p:nvSpPr>
-        <p:spPr>
-          <a:xfrm>
-            <a:off x="1771427" y="4775147"/>
-            <a:ext cx="1291813" cy="273844"/>
-          </a:xfrm>
-        </p:spPr>
-        <p:txBody>
-          <a:bodyPr/>
-          <a:lstStyle/>
-          <a:p>
-            <a:fld id="{B5A3235C-A5F5-CE4E-B015-39F4D75EC196}" type="datetime1">
-              <a:rPr lang="it-IT" smtClean="0"/>
-              <a:t>17/02/2026</a:t>
-            </a:fld>
-            <a:endParaRPr lang="en-US"/>
-          </a:p>
-        </p:txBody>
-      </p:sp>
-      <p:sp>
-        <p:nvSpPr>
-          <p:cNvPr id="4" name="TextBox 3">
-            <a:extLst>
-              <a:ext uri="{FF2B5EF4-FFF2-40B4-BE49-F238E27FC236}">
-                <a16:creationId xmlns:a16="http://schemas.microsoft.com/office/drawing/2014/main" id="{CFE2E3C1-BE6E-42B1-100C-CFB62BCCA84E}"/>
+                <a16:creationId xmlns:a16="http://schemas.microsoft.com/office/drawing/2014/main" id="{5ECDEA0F-CD3F-E988-8F7E-CF36959BCCB4}"/>
               </a:ext>
             </a:extLst>
           </p:cNvPr>
@@ -1938,7 +1624,7 @@
         </p:nvSpPr>
         <p:spPr>
           <a:xfrm>
-            <a:off x="1499801" y="4604556"/>
+            <a:off x="1499801" y="5009681"/>
             <a:ext cx="6144397" cy="184666"/>
           </a:xfrm>
           <a:prstGeom prst="rect">
@@ -2202,6 +1888,40 @@
               <a:rPr lang="en-US" dirty="0"/>
               <a:t>Click to edit Master text styles</a:t>
             </a:r>
+          </a:p>
+        </p:txBody>
+      </p:sp>
+      <p:sp>
+        <p:nvSpPr>
+          <p:cNvPr id="9" name="Date Placeholder 3">
+            <a:extLst>
+              <a:ext uri="{FF2B5EF4-FFF2-40B4-BE49-F238E27FC236}">
+                <a16:creationId xmlns:a16="http://schemas.microsoft.com/office/drawing/2014/main" id="{C8F14B97-C2FE-7D33-9A73-677B703E4162}"/>
+              </a:ext>
+            </a:extLst>
+          </p:cNvPr>
+          <p:cNvSpPr>
+            <a:spLocks noGrp="1"/>
+          </p:cNvSpPr>
+          <p:nvPr>
+            <p:ph type="dt" sz="half" idx="10"/>
+          </p:nvPr>
+        </p:nvSpPr>
+        <p:spPr>
+          <a:xfrm>
+            <a:off x="1771427" y="4775147"/>
+            <a:ext cx="1291813" cy="273844"/>
+          </a:xfrm>
+        </p:spPr>
+        <p:txBody>
+          <a:bodyPr/>
+          <a:lstStyle/>
+          <a:p>
+            <a:fld id="{D6CE0B0B-E3C5-EF4A-87B2-86DF446F39DB}" type="datetime1">
+              <a:rPr lang="it-IT" smtClean="0"/>
+              <a:t>17/02/2026</a:t>
+            </a:fld>
+            <a:endParaRPr lang="en-US"/>
           </a:p>
         </p:txBody>
       </p:sp>
@@ -2469,44 +2189,10 @@
       </p:pic>
       <p:sp>
         <p:nvSpPr>
-          <p:cNvPr id="6" name="Date Placeholder 3">
+          <p:cNvPr id="5" name="TextBox 4">
             <a:extLst>
               <a:ext uri="{FF2B5EF4-FFF2-40B4-BE49-F238E27FC236}">
-                <a16:creationId xmlns:a16="http://schemas.microsoft.com/office/drawing/2014/main" id="{F2CAF3CD-0E8D-01F0-19BA-701272483671}"/>
-              </a:ext>
-            </a:extLst>
-          </p:cNvPr>
-          <p:cNvSpPr>
-            <a:spLocks noGrp="1"/>
-          </p:cNvSpPr>
-          <p:nvPr>
-            <p:ph type="dt" sz="half" idx="10"/>
-          </p:nvPr>
-        </p:nvSpPr>
-        <p:spPr>
-          <a:xfrm>
-            <a:off x="1771427" y="4775147"/>
-            <a:ext cx="1291813" cy="273844"/>
-          </a:xfrm>
-        </p:spPr>
-        <p:txBody>
-          <a:bodyPr/>
-          <a:lstStyle/>
-          <a:p>
-            <a:fld id="{B5A3235C-A5F5-CE4E-B015-39F4D75EC196}" type="datetime1">
-              <a:rPr lang="it-IT" smtClean="0"/>
-              <a:t>17/02/2026</a:t>
-            </a:fld>
-            <a:endParaRPr lang="en-US"/>
-          </a:p>
-        </p:txBody>
-      </p:sp>
-      <p:sp>
-        <p:nvSpPr>
-          <p:cNvPr id="7" name="TextBox 6">
-            <a:extLst>
-              <a:ext uri="{FF2B5EF4-FFF2-40B4-BE49-F238E27FC236}">
-                <a16:creationId xmlns:a16="http://schemas.microsoft.com/office/drawing/2014/main" id="{819FA1F3-6C25-0F24-6531-CEB107608D04}"/>
+                <a16:creationId xmlns:a16="http://schemas.microsoft.com/office/drawing/2014/main" id="{E08D9B6F-D6D8-AE83-7546-E14BE6C2E410}"/>
               </a:ext>
             </a:extLst>
           </p:cNvPr>
@@ -2515,7 +2201,7 @@
         </p:nvSpPr>
         <p:spPr>
           <a:xfrm>
-            <a:off x="1499801" y="4604556"/>
+            <a:off x="1499801" y="5009681"/>
             <a:ext cx="6144397" cy="184666"/>
           </a:xfrm>
           <a:prstGeom prst="rect">
@@ -2756,6 +2442,40 @@
               <a:rPr lang="en-US" dirty="0"/>
               <a:t>Click to edit Master text styles</a:t>
             </a:r>
+          </a:p>
+        </p:txBody>
+      </p:sp>
+      <p:sp>
+        <p:nvSpPr>
+          <p:cNvPr id="9" name="Date Placeholder 3">
+            <a:extLst>
+              <a:ext uri="{FF2B5EF4-FFF2-40B4-BE49-F238E27FC236}">
+                <a16:creationId xmlns:a16="http://schemas.microsoft.com/office/drawing/2014/main" id="{55C1476F-4732-ED78-4526-CECED718B05F}"/>
+              </a:ext>
+            </a:extLst>
+          </p:cNvPr>
+          <p:cNvSpPr>
+            <a:spLocks noGrp="1"/>
+          </p:cNvSpPr>
+          <p:nvPr>
+            <p:ph type="dt" sz="half" idx="10"/>
+          </p:nvPr>
+        </p:nvSpPr>
+        <p:spPr>
+          <a:xfrm>
+            <a:off x="1771427" y="4775147"/>
+            <a:ext cx="1291813" cy="273844"/>
+          </a:xfrm>
+        </p:spPr>
+        <p:txBody>
+          <a:bodyPr/>
+          <a:lstStyle/>
+          <a:p>
+            <a:fld id="{AE4AF135-7764-144C-811C-680358D4FB0C}" type="datetime1">
+              <a:rPr lang="it-IT" smtClean="0"/>
+              <a:t>17/02/2026</a:t>
+            </a:fld>
+            <a:endParaRPr lang="en-US"/>
           </a:p>
         </p:txBody>
       </p:sp>
@@ -3023,44 +2743,10 @@
       </p:pic>
       <p:sp>
         <p:nvSpPr>
-          <p:cNvPr id="6" name="Date Placeholder 3">
+          <p:cNvPr id="5" name="TextBox 4">
             <a:extLst>
               <a:ext uri="{FF2B5EF4-FFF2-40B4-BE49-F238E27FC236}">
-                <a16:creationId xmlns:a16="http://schemas.microsoft.com/office/drawing/2014/main" id="{FE9F7795-AD43-4C27-8F8D-8FA396FDFCB0}"/>
-              </a:ext>
-            </a:extLst>
-          </p:cNvPr>
-          <p:cNvSpPr>
-            <a:spLocks noGrp="1"/>
-          </p:cNvSpPr>
-          <p:nvPr>
-            <p:ph type="dt" sz="half" idx="10"/>
-          </p:nvPr>
-        </p:nvSpPr>
-        <p:spPr>
-          <a:xfrm>
-            <a:off x="1771427" y="4775147"/>
-            <a:ext cx="1291813" cy="273844"/>
-          </a:xfrm>
-        </p:spPr>
-        <p:txBody>
-          <a:bodyPr/>
-          <a:lstStyle/>
-          <a:p>
-            <a:fld id="{B5A3235C-A5F5-CE4E-B015-39F4D75EC196}" type="datetime1">
-              <a:rPr lang="it-IT" smtClean="0"/>
-              <a:t>17/02/2026</a:t>
-            </a:fld>
-            <a:endParaRPr lang="en-US"/>
-          </a:p>
-        </p:txBody>
-      </p:sp>
-      <p:sp>
-        <p:nvSpPr>
-          <p:cNvPr id="7" name="TextBox 6">
-            <a:extLst>
-              <a:ext uri="{FF2B5EF4-FFF2-40B4-BE49-F238E27FC236}">
-                <a16:creationId xmlns:a16="http://schemas.microsoft.com/office/drawing/2014/main" id="{42F1B687-FDBC-951B-A6F8-6A6E00B75E32}"/>
+                <a16:creationId xmlns:a16="http://schemas.microsoft.com/office/drawing/2014/main" id="{FDDE0A73-7F0F-1EE2-B8F1-2B2B4B0427D3}"/>
               </a:ext>
             </a:extLst>
           </p:cNvPr>
@@ -3069,7 +2755,7 @@
         </p:nvSpPr>
         <p:spPr>
           <a:xfrm>
-            <a:off x="1499801" y="4604556"/>
+            <a:off x="1499801" y="5009681"/>
             <a:ext cx="6144397" cy="184666"/>
           </a:xfrm>
           <a:prstGeom prst="rect">
@@ -3237,6 +2923,40 @@
               <a:rPr lang="en-US" dirty="0"/>
               <a:t>Fifth level</a:t>
             </a:r>
+          </a:p>
+        </p:txBody>
+      </p:sp>
+      <p:sp>
+        <p:nvSpPr>
+          <p:cNvPr id="8" name="Date Placeholder 3">
+            <a:extLst>
+              <a:ext uri="{FF2B5EF4-FFF2-40B4-BE49-F238E27FC236}">
+                <a16:creationId xmlns:a16="http://schemas.microsoft.com/office/drawing/2014/main" id="{EF5C7BAF-E8DA-2864-BFF7-17DD2169EA66}"/>
+              </a:ext>
+            </a:extLst>
+          </p:cNvPr>
+          <p:cNvSpPr>
+            <a:spLocks noGrp="1"/>
+          </p:cNvSpPr>
+          <p:nvPr>
+            <p:ph type="dt" sz="half" idx="10"/>
+          </p:nvPr>
+        </p:nvSpPr>
+        <p:spPr>
+          <a:xfrm>
+            <a:off x="1771427" y="4775147"/>
+            <a:ext cx="1291813" cy="273844"/>
+          </a:xfrm>
+        </p:spPr>
+        <p:txBody>
+          <a:bodyPr/>
+          <a:lstStyle/>
+          <a:p>
+            <a:fld id="{D7720BFA-E534-EF4D-9BC9-39AC6AC2A1F1}" type="datetime1">
+              <a:rPr lang="it-IT" smtClean="0"/>
+              <a:t>17/02/2026</a:t>
+            </a:fld>
+            <a:endParaRPr lang="en-US"/>
           </a:p>
         </p:txBody>
       </p:sp>
@@ -3504,44 +3224,10 @@
       </p:pic>
       <p:sp>
         <p:nvSpPr>
-          <p:cNvPr id="5" name="Date Placeholder 3">
+          <p:cNvPr id="4" name="TextBox 3">
             <a:extLst>
               <a:ext uri="{FF2B5EF4-FFF2-40B4-BE49-F238E27FC236}">
-                <a16:creationId xmlns:a16="http://schemas.microsoft.com/office/drawing/2014/main" id="{CB1422D4-6CB0-409D-2EF3-11E3418B85C3}"/>
-              </a:ext>
-            </a:extLst>
-          </p:cNvPr>
-          <p:cNvSpPr>
-            <a:spLocks noGrp="1"/>
-          </p:cNvSpPr>
-          <p:nvPr>
-            <p:ph type="dt" sz="half" idx="10"/>
-          </p:nvPr>
-        </p:nvSpPr>
-        <p:spPr>
-          <a:xfrm>
-            <a:off x="1771427" y="4775147"/>
-            <a:ext cx="1291813" cy="273844"/>
-          </a:xfrm>
-        </p:spPr>
-        <p:txBody>
-          <a:bodyPr/>
-          <a:lstStyle/>
-          <a:p>
-            <a:fld id="{B5A3235C-A5F5-CE4E-B015-39F4D75EC196}" type="datetime1">
-              <a:rPr lang="it-IT" smtClean="0"/>
-              <a:t>17/02/2026</a:t>
-            </a:fld>
-            <a:endParaRPr lang="en-US"/>
-          </a:p>
-        </p:txBody>
-      </p:sp>
-      <p:sp>
-        <p:nvSpPr>
-          <p:cNvPr id="6" name="TextBox 5">
-            <a:extLst>
-              <a:ext uri="{FF2B5EF4-FFF2-40B4-BE49-F238E27FC236}">
-                <a16:creationId xmlns:a16="http://schemas.microsoft.com/office/drawing/2014/main" id="{ED7B2ECE-9761-BD59-79BA-A1348B20D990}"/>
+                <a16:creationId xmlns:a16="http://schemas.microsoft.com/office/drawing/2014/main" id="{F1D6BA0C-FCB1-B18B-A578-8A41AB44F39E}"/>
               </a:ext>
             </a:extLst>
           </p:cNvPr>
@@ -3550,7 +3236,7 @@
         </p:nvSpPr>
         <p:spPr>
           <a:xfrm>
-            <a:off x="1499801" y="4604556"/>
+            <a:off x="1499801" y="5009681"/>
             <a:ext cx="6144397" cy="184666"/>
           </a:xfrm>
           <a:prstGeom prst="rect">
@@ -3732,6 +3418,40 @@
               <a:rPr lang="en-US"/>
               <a:t>Fifth level</a:t>
             </a:r>
+          </a:p>
+        </p:txBody>
+      </p:sp>
+      <p:sp>
+        <p:nvSpPr>
+          <p:cNvPr id="8" name="Date Placeholder 3">
+            <a:extLst>
+              <a:ext uri="{FF2B5EF4-FFF2-40B4-BE49-F238E27FC236}">
+                <a16:creationId xmlns:a16="http://schemas.microsoft.com/office/drawing/2014/main" id="{30853B47-A73B-7DD5-78CA-F403E3F053C4}"/>
+              </a:ext>
+            </a:extLst>
+          </p:cNvPr>
+          <p:cNvSpPr>
+            <a:spLocks noGrp="1"/>
+          </p:cNvSpPr>
+          <p:nvPr>
+            <p:ph type="dt" sz="half" idx="10"/>
+          </p:nvPr>
+        </p:nvSpPr>
+        <p:spPr>
+          <a:xfrm>
+            <a:off x="1771427" y="4775147"/>
+            <a:ext cx="1291813" cy="273844"/>
+          </a:xfrm>
+        </p:spPr>
+        <p:txBody>
+          <a:bodyPr/>
+          <a:lstStyle/>
+          <a:p>
+            <a:fld id="{B20FCA3A-31A1-034E-9624-8CD1F736D4F6}" type="datetime1">
+              <a:rPr lang="it-IT" smtClean="0"/>
+              <a:t>17/02/2026</a:t>
+            </a:fld>
+            <a:endParaRPr lang="en-US"/>
           </a:p>
         </p:txBody>
       </p:sp>
@@ -3999,44 +3719,10 @@
       </p:pic>
       <p:sp>
         <p:nvSpPr>
-          <p:cNvPr id="5" name="Date Placeholder 3">
+          <p:cNvPr id="4" name="TextBox 3">
             <a:extLst>
               <a:ext uri="{FF2B5EF4-FFF2-40B4-BE49-F238E27FC236}">
-                <a16:creationId xmlns:a16="http://schemas.microsoft.com/office/drawing/2014/main" id="{2E69A76C-B460-2AE3-A17A-1505DDD7451B}"/>
-              </a:ext>
-            </a:extLst>
-          </p:cNvPr>
-          <p:cNvSpPr>
-            <a:spLocks noGrp="1"/>
-          </p:cNvSpPr>
-          <p:nvPr>
-            <p:ph type="dt" sz="half" idx="10"/>
-          </p:nvPr>
-        </p:nvSpPr>
-        <p:spPr>
-          <a:xfrm>
-            <a:off x="1771427" y="4775147"/>
-            <a:ext cx="1291813" cy="273844"/>
-          </a:xfrm>
-        </p:spPr>
-        <p:txBody>
-          <a:bodyPr/>
-          <a:lstStyle/>
-          <a:p>
-            <a:fld id="{B5A3235C-A5F5-CE4E-B015-39F4D75EC196}" type="datetime1">
-              <a:rPr lang="it-IT" smtClean="0"/>
-              <a:t>17/02/2026</a:t>
-            </a:fld>
-            <a:endParaRPr lang="en-US"/>
-          </a:p>
-        </p:txBody>
-      </p:sp>
-      <p:sp>
-        <p:nvSpPr>
-          <p:cNvPr id="6" name="TextBox 5">
-            <a:extLst>
-              <a:ext uri="{FF2B5EF4-FFF2-40B4-BE49-F238E27FC236}">
-                <a16:creationId xmlns:a16="http://schemas.microsoft.com/office/drawing/2014/main" id="{E8B94D98-12F9-B72F-B3E7-937DF9D430A5}"/>
+                <a16:creationId xmlns:a16="http://schemas.microsoft.com/office/drawing/2014/main" id="{116057FF-9082-1A59-4CD5-DE9592F83772}"/>
               </a:ext>
             </a:extLst>
           </p:cNvPr>
@@ -4045,7 +3731,7 @@
         </p:nvSpPr>
         <p:spPr>
           <a:xfrm>
-            <a:off x="1499801" y="4604556"/>
+            <a:off x="1499801" y="5009681"/>
             <a:ext cx="6144397" cy="184666"/>
           </a:xfrm>
           <a:prstGeom prst="rect">
@@ -4618,7 +4304,7 @@
         </p:nvSpPr>
         <p:spPr>
           <a:xfrm>
-            <a:off x="1499801" y="4604556"/>
+            <a:off x="1499801" y="5009681"/>
             <a:ext cx="6144397" cy="184666"/>
           </a:xfrm>
           <a:prstGeom prst="rect">
@@ -4866,6 +4552,34 @@
               <a:rPr lang="en-US" dirty="0"/>
               <a:t>Fifth level</a:t>
             </a:r>
+          </a:p>
+        </p:txBody>
+      </p:sp>
+      <p:sp>
+        <p:nvSpPr>
+          <p:cNvPr id="4" name="Date Placeholder 3"/>
+          <p:cNvSpPr>
+            <a:spLocks noGrp="1"/>
+          </p:cNvSpPr>
+          <p:nvPr>
+            <p:ph type="dt" sz="half" idx="10"/>
+          </p:nvPr>
+        </p:nvSpPr>
+        <p:spPr>
+          <a:xfrm>
+            <a:off x="1771427" y="4775147"/>
+            <a:ext cx="1291813" cy="273844"/>
+          </a:xfrm>
+        </p:spPr>
+        <p:txBody>
+          <a:bodyPr/>
+          <a:lstStyle/>
+          <a:p>
+            <a:fld id="{9FC0F10B-4FCD-A840-811B-58139C9D20D6}" type="datetime1">
+              <a:rPr lang="it-IT" smtClean="0"/>
+              <a:t>17/02/2026</a:t>
+            </a:fld>
+            <a:endParaRPr lang="en-US"/>
           </a:p>
         </p:txBody>
       </p:sp>
@@ -5172,44 +4886,10 @@
       </p:pic>
       <p:sp>
         <p:nvSpPr>
-          <p:cNvPr id="11" name="Date Placeholder 3">
+          <p:cNvPr id="9" name="TextBox 8">
             <a:extLst>
               <a:ext uri="{FF2B5EF4-FFF2-40B4-BE49-F238E27FC236}">
-                <a16:creationId xmlns:a16="http://schemas.microsoft.com/office/drawing/2014/main" id="{2243B617-D1BA-70F0-AB8D-57BB8F9271D0}"/>
-              </a:ext>
-            </a:extLst>
-          </p:cNvPr>
-          <p:cNvSpPr>
-            <a:spLocks noGrp="1"/>
-          </p:cNvSpPr>
-          <p:nvPr>
-            <p:ph type="dt" sz="half" idx="10"/>
-          </p:nvPr>
-        </p:nvSpPr>
-        <p:spPr>
-          <a:xfrm>
-            <a:off x="1771427" y="4775147"/>
-            <a:ext cx="1291813" cy="273844"/>
-          </a:xfrm>
-        </p:spPr>
-        <p:txBody>
-          <a:bodyPr/>
-          <a:lstStyle/>
-          <a:p>
-            <a:fld id="{B5A3235C-A5F5-CE4E-B015-39F4D75EC196}" type="datetime1">
-              <a:rPr lang="it-IT" smtClean="0"/>
-              <a:t>17/02/2026</a:t>
-            </a:fld>
-            <a:endParaRPr lang="en-US"/>
-          </a:p>
-        </p:txBody>
-      </p:sp>
-      <p:sp>
-        <p:nvSpPr>
-          <p:cNvPr id="13" name="TextBox 12">
-            <a:extLst>
-              <a:ext uri="{FF2B5EF4-FFF2-40B4-BE49-F238E27FC236}">
-                <a16:creationId xmlns:a16="http://schemas.microsoft.com/office/drawing/2014/main" id="{A136ED69-A993-F796-0E91-8ED593E08259}"/>
+                <a16:creationId xmlns:a16="http://schemas.microsoft.com/office/drawing/2014/main" id="{B38D46BD-367F-3481-A8D8-E3AB2C324A8C}"/>
               </a:ext>
             </a:extLst>
           </p:cNvPr>
@@ -5218,7 +4898,7 @@
         </p:nvSpPr>
         <p:spPr>
           <a:xfrm>
-            <a:off x="1499801" y="4604556"/>
+            <a:off x="1499801" y="5009681"/>
             <a:ext cx="6144397" cy="184666"/>
           </a:xfrm>
           <a:prstGeom prst="rect">
@@ -5431,6 +5111,34 @@
               <a:rPr lang="en-US" dirty="0"/>
               <a:t>Fifth level</a:t>
             </a:r>
+          </a:p>
+        </p:txBody>
+      </p:sp>
+      <p:sp>
+        <p:nvSpPr>
+          <p:cNvPr id="4" name="Date Placeholder 3"/>
+          <p:cNvSpPr>
+            <a:spLocks noGrp="1"/>
+          </p:cNvSpPr>
+          <p:nvPr>
+            <p:ph type="dt" sz="half" idx="10"/>
+          </p:nvPr>
+        </p:nvSpPr>
+        <p:spPr>
+          <a:xfrm>
+            <a:off x="1771427" y="4775147"/>
+            <a:ext cx="1291813" cy="273844"/>
+          </a:xfrm>
+        </p:spPr>
+        <p:txBody>
+          <a:bodyPr/>
+          <a:lstStyle/>
+          <a:p>
+            <a:fld id="{88C27D80-F3A7-A741-A1BF-A0356AB69374}" type="datetime1">
+              <a:rPr lang="it-IT" smtClean="0"/>
+              <a:t>17/02/2026</a:t>
+            </a:fld>
+            <a:endParaRPr lang="en-US"/>
           </a:p>
         </p:txBody>
       </p:sp>
@@ -5716,44 +5424,10 @@
       </p:pic>
       <p:sp>
         <p:nvSpPr>
-          <p:cNvPr id="8" name="Date Placeholder 3">
+          <p:cNvPr id="7" name="TextBox 6">
             <a:extLst>
               <a:ext uri="{FF2B5EF4-FFF2-40B4-BE49-F238E27FC236}">
-                <a16:creationId xmlns:a16="http://schemas.microsoft.com/office/drawing/2014/main" id="{23853EF7-9530-9CE3-8AAC-163A81EF4EAE}"/>
-              </a:ext>
-            </a:extLst>
-          </p:cNvPr>
-          <p:cNvSpPr>
-            <a:spLocks noGrp="1"/>
-          </p:cNvSpPr>
-          <p:nvPr>
-            <p:ph type="dt" sz="half" idx="10"/>
-          </p:nvPr>
-        </p:nvSpPr>
-        <p:spPr>
-          <a:xfrm>
-            <a:off x="1771427" y="4775147"/>
-            <a:ext cx="1291813" cy="273844"/>
-          </a:xfrm>
-        </p:spPr>
-        <p:txBody>
-          <a:bodyPr/>
-          <a:lstStyle/>
-          <a:p>
-            <a:fld id="{B5A3235C-A5F5-CE4E-B015-39F4D75EC196}" type="datetime1">
-              <a:rPr lang="it-IT" smtClean="0"/>
-              <a:t>17/02/2026</a:t>
-            </a:fld>
-            <a:endParaRPr lang="en-US"/>
-          </a:p>
-        </p:txBody>
-      </p:sp>
-      <p:sp>
-        <p:nvSpPr>
-          <p:cNvPr id="12" name="TextBox 11">
-            <a:extLst>
-              <a:ext uri="{FF2B5EF4-FFF2-40B4-BE49-F238E27FC236}">
-                <a16:creationId xmlns:a16="http://schemas.microsoft.com/office/drawing/2014/main" id="{0BCF4466-819F-2857-3C33-DB2BFD6F8B49}"/>
+                <a16:creationId xmlns:a16="http://schemas.microsoft.com/office/drawing/2014/main" id="{DC0F4838-F6BF-C30B-C410-5E532DCDEE34}"/>
               </a:ext>
             </a:extLst>
           </p:cNvPr>
@@ -5762,7 +5436,7 @@
         </p:nvSpPr>
         <p:spPr>
           <a:xfrm>
-            <a:off x="1499801" y="4604556"/>
+            <a:off x="1499801" y="5009681"/>
             <a:ext cx="6144397" cy="184666"/>
           </a:xfrm>
           <a:prstGeom prst="rect">
@@ -5991,6 +5665,34 @@
               <a:rPr lang="en-US" dirty="0"/>
               <a:t>Fifth level</a:t>
             </a:r>
+          </a:p>
+        </p:txBody>
+      </p:sp>
+      <p:sp>
+        <p:nvSpPr>
+          <p:cNvPr id="4" name="Date Placeholder 3"/>
+          <p:cNvSpPr>
+            <a:spLocks noGrp="1"/>
+          </p:cNvSpPr>
+          <p:nvPr>
+            <p:ph type="dt" sz="half" idx="10"/>
+          </p:nvPr>
+        </p:nvSpPr>
+        <p:spPr>
+          <a:xfrm>
+            <a:off x="1771427" y="4775147"/>
+            <a:ext cx="1291813" cy="273844"/>
+          </a:xfrm>
+        </p:spPr>
+        <p:txBody>
+          <a:bodyPr/>
+          <a:lstStyle/>
+          <a:p>
+            <a:fld id="{E06934FA-7FD1-0D46-8E1C-1AFE08A73439}" type="datetime1">
+              <a:rPr lang="it-IT" smtClean="0"/>
+              <a:t>17/02/2026</a:t>
+            </a:fld>
+            <a:endParaRPr lang="en-US"/>
           </a:p>
         </p:txBody>
       </p:sp>
@@ -6276,44 +5978,10 @@
       </p:pic>
       <p:sp>
         <p:nvSpPr>
-          <p:cNvPr id="8" name="Date Placeholder 3">
+          <p:cNvPr id="7" name="TextBox 6">
             <a:extLst>
               <a:ext uri="{FF2B5EF4-FFF2-40B4-BE49-F238E27FC236}">
-                <a16:creationId xmlns:a16="http://schemas.microsoft.com/office/drawing/2014/main" id="{31778DD8-2E90-7C87-5D64-2149E05D61F3}"/>
-              </a:ext>
-            </a:extLst>
-          </p:cNvPr>
-          <p:cNvSpPr>
-            <a:spLocks noGrp="1"/>
-          </p:cNvSpPr>
-          <p:nvPr>
-            <p:ph type="dt" sz="half" idx="10"/>
-          </p:nvPr>
-        </p:nvSpPr>
-        <p:spPr>
-          <a:xfrm>
-            <a:off x="1771427" y="4775147"/>
-            <a:ext cx="1291813" cy="273844"/>
-          </a:xfrm>
-        </p:spPr>
-        <p:txBody>
-          <a:bodyPr/>
-          <a:lstStyle/>
-          <a:p>
-            <a:fld id="{B5A3235C-A5F5-CE4E-B015-39F4D75EC196}" type="datetime1">
-              <a:rPr lang="it-IT" smtClean="0"/>
-              <a:t>17/02/2026</a:t>
-            </a:fld>
-            <a:endParaRPr lang="en-US"/>
-          </a:p>
-        </p:txBody>
-      </p:sp>
-      <p:sp>
-        <p:nvSpPr>
-          <p:cNvPr id="12" name="TextBox 11">
-            <a:extLst>
-              <a:ext uri="{FF2B5EF4-FFF2-40B4-BE49-F238E27FC236}">
-                <a16:creationId xmlns:a16="http://schemas.microsoft.com/office/drawing/2014/main" id="{231476A2-463A-5A82-D914-E99D9D8159EB}"/>
+                <a16:creationId xmlns:a16="http://schemas.microsoft.com/office/drawing/2014/main" id="{E9A57DD2-0334-0E93-EF42-3A16A5997397}"/>
               </a:ext>
             </a:extLst>
           </p:cNvPr>
@@ -6322,7 +5990,7 @@
         </p:nvSpPr>
         <p:spPr>
           <a:xfrm>
-            <a:off x="1499801" y="4604556"/>
+            <a:off x="1499801" y="5009681"/>
             <a:ext cx="6144397" cy="184666"/>
           </a:xfrm>
           <a:prstGeom prst="rect">
@@ -6837,6 +6505,40 @@
               <a:rPr lang="en-US" dirty="0"/>
               <a:t>Fifth level</a:t>
             </a:r>
+          </a:p>
+        </p:txBody>
+      </p:sp>
+      <p:sp>
+        <p:nvSpPr>
+          <p:cNvPr id="9" name="Date Placeholder 3">
+            <a:extLst>
+              <a:ext uri="{FF2B5EF4-FFF2-40B4-BE49-F238E27FC236}">
+                <a16:creationId xmlns:a16="http://schemas.microsoft.com/office/drawing/2014/main" id="{C4053F5D-6FBA-B899-9B82-B9093E335267}"/>
+              </a:ext>
+            </a:extLst>
+          </p:cNvPr>
+          <p:cNvSpPr>
+            <a:spLocks noGrp="1"/>
+          </p:cNvSpPr>
+          <p:nvPr>
+            <p:ph type="dt" sz="half" idx="10"/>
+          </p:nvPr>
+        </p:nvSpPr>
+        <p:spPr>
+          <a:xfrm>
+            <a:off x="1771427" y="4775147"/>
+            <a:ext cx="1291813" cy="273844"/>
+          </a:xfrm>
+        </p:spPr>
+        <p:txBody>
+          <a:bodyPr/>
+          <a:lstStyle/>
+          <a:p>
+            <a:fld id="{21E9D82B-7A2C-DA4C-B24C-1024813AE2F0}" type="datetime1">
+              <a:rPr lang="it-IT" smtClean="0"/>
+              <a:t>17/02/2026</a:t>
+            </a:fld>
+            <a:endParaRPr lang="en-US"/>
           </a:p>
         </p:txBody>
       </p:sp>
@@ -7104,44 +6806,10 @@
       </p:pic>
       <p:sp>
         <p:nvSpPr>
-          <p:cNvPr id="6" name="Date Placeholder 3">
+          <p:cNvPr id="5" name="TextBox 4">
             <a:extLst>
               <a:ext uri="{FF2B5EF4-FFF2-40B4-BE49-F238E27FC236}">
-                <a16:creationId xmlns:a16="http://schemas.microsoft.com/office/drawing/2014/main" id="{9DC74560-9E05-FD16-6AD6-A28A46251192}"/>
-              </a:ext>
-            </a:extLst>
-          </p:cNvPr>
-          <p:cNvSpPr>
-            <a:spLocks noGrp="1"/>
-          </p:cNvSpPr>
-          <p:nvPr>
-            <p:ph type="dt" sz="half" idx="10"/>
-          </p:nvPr>
-        </p:nvSpPr>
-        <p:spPr>
-          <a:xfrm>
-            <a:off x="1771427" y="4775147"/>
-            <a:ext cx="1291813" cy="273844"/>
-          </a:xfrm>
-        </p:spPr>
-        <p:txBody>
-          <a:bodyPr/>
-          <a:lstStyle/>
-          <a:p>
-            <a:fld id="{B5A3235C-A5F5-CE4E-B015-39F4D75EC196}" type="datetime1">
-              <a:rPr lang="it-IT" smtClean="0"/>
-              <a:t>17/02/2026</a:t>
-            </a:fld>
-            <a:endParaRPr lang="en-US"/>
-          </a:p>
-        </p:txBody>
-      </p:sp>
-      <p:sp>
-        <p:nvSpPr>
-          <p:cNvPr id="7" name="TextBox 6">
-            <a:extLst>
-              <a:ext uri="{FF2B5EF4-FFF2-40B4-BE49-F238E27FC236}">
-                <a16:creationId xmlns:a16="http://schemas.microsoft.com/office/drawing/2014/main" id="{920AA42E-3654-E284-069F-FC32E2EBEBCE}"/>
+                <a16:creationId xmlns:a16="http://schemas.microsoft.com/office/drawing/2014/main" id="{36A728D5-5BBE-C9BE-C8CB-7E6F35D77231}"/>
               </a:ext>
             </a:extLst>
           </p:cNvPr>
@@ -7150,7 +6818,7 @@
         </p:nvSpPr>
         <p:spPr>
           <a:xfrm>
-            <a:off x="1499801" y="4604556"/>
+            <a:off x="1499801" y="5009681"/>
             <a:ext cx="6144397" cy="184666"/>
           </a:xfrm>
           <a:prstGeom prst="rect">
@@ -7577,6 +7245,40 @@
               <a:rPr lang="en-US" dirty="0"/>
               <a:t>Fifth level</a:t>
             </a:r>
+          </a:p>
+        </p:txBody>
+      </p:sp>
+      <p:sp>
+        <p:nvSpPr>
+          <p:cNvPr id="11" name="Date Placeholder 3">
+            <a:extLst>
+              <a:ext uri="{FF2B5EF4-FFF2-40B4-BE49-F238E27FC236}">
+                <a16:creationId xmlns:a16="http://schemas.microsoft.com/office/drawing/2014/main" id="{49F71F15-28F7-2AFB-0561-2D46D21B76B0}"/>
+              </a:ext>
+            </a:extLst>
+          </p:cNvPr>
+          <p:cNvSpPr>
+            <a:spLocks noGrp="1"/>
+          </p:cNvSpPr>
+          <p:nvPr>
+            <p:ph type="dt" sz="half" idx="10"/>
+          </p:nvPr>
+        </p:nvSpPr>
+        <p:spPr>
+          <a:xfrm>
+            <a:off x="1771427" y="4775147"/>
+            <a:ext cx="1291813" cy="273844"/>
+          </a:xfrm>
+        </p:spPr>
+        <p:txBody>
+          <a:bodyPr/>
+          <a:lstStyle/>
+          <a:p>
+            <a:fld id="{9429820C-B789-AB43-B4E1-4B378514779B}" type="datetime1">
+              <a:rPr lang="it-IT" smtClean="0"/>
+              <a:t>17/02/2026</a:t>
+            </a:fld>
+            <a:endParaRPr lang="en-US"/>
           </a:p>
         </p:txBody>
       </p:sp>
@@ -7844,44 +7546,10 @@
       </p:pic>
       <p:sp>
         <p:nvSpPr>
-          <p:cNvPr id="8" name="Date Placeholder 3">
+          <p:cNvPr id="7" name="TextBox 6">
             <a:extLst>
               <a:ext uri="{FF2B5EF4-FFF2-40B4-BE49-F238E27FC236}">
-                <a16:creationId xmlns:a16="http://schemas.microsoft.com/office/drawing/2014/main" id="{1E5CD868-795A-80DD-B851-3B7D64C62FB0}"/>
-              </a:ext>
-            </a:extLst>
-          </p:cNvPr>
-          <p:cNvSpPr>
-            <a:spLocks noGrp="1"/>
-          </p:cNvSpPr>
-          <p:nvPr>
-            <p:ph type="dt" sz="half" idx="10"/>
-          </p:nvPr>
-        </p:nvSpPr>
-        <p:spPr>
-          <a:xfrm>
-            <a:off x="1771427" y="4775147"/>
-            <a:ext cx="1291813" cy="273844"/>
-          </a:xfrm>
-        </p:spPr>
-        <p:txBody>
-          <a:bodyPr/>
-          <a:lstStyle/>
-          <a:p>
-            <a:fld id="{B5A3235C-A5F5-CE4E-B015-39F4D75EC196}" type="datetime1">
-              <a:rPr lang="it-IT" smtClean="0"/>
-              <a:t>17/02/2026</a:t>
-            </a:fld>
-            <a:endParaRPr lang="en-US"/>
-          </a:p>
-        </p:txBody>
-      </p:sp>
-      <p:sp>
-        <p:nvSpPr>
-          <p:cNvPr id="9" name="TextBox 8">
-            <a:extLst>
-              <a:ext uri="{FF2B5EF4-FFF2-40B4-BE49-F238E27FC236}">
-                <a16:creationId xmlns:a16="http://schemas.microsoft.com/office/drawing/2014/main" id="{51D9E150-9323-088D-1DAC-64A83CEBCA7A}"/>
+                <a16:creationId xmlns:a16="http://schemas.microsoft.com/office/drawing/2014/main" id="{2AAF3200-A4E9-67DF-6962-7DE8759EEE6D}"/>
               </a:ext>
             </a:extLst>
           </p:cNvPr>
@@ -7890,7 +7558,7 @@
         </p:nvSpPr>
         <p:spPr>
           <a:xfrm>
-            <a:off x="1499801" y="4604556"/>
+            <a:off x="1499801" y="5009681"/>
             <a:ext cx="6144397" cy="184666"/>
           </a:xfrm>
           <a:prstGeom prst="rect">
@@ -8011,6 +7679,40 @@
               <a:rPr lang="en-US" dirty="0"/>
               <a:t>CLICK TO EDIT MASTER TITLE STYLE</a:t>
             </a:r>
+          </a:p>
+        </p:txBody>
+      </p:sp>
+      <p:sp>
+        <p:nvSpPr>
+          <p:cNvPr id="7" name="Date Placeholder 3">
+            <a:extLst>
+              <a:ext uri="{FF2B5EF4-FFF2-40B4-BE49-F238E27FC236}">
+                <a16:creationId xmlns:a16="http://schemas.microsoft.com/office/drawing/2014/main" id="{3E3EC6A0-D5A9-CC66-04AC-E97B0756CB15}"/>
+              </a:ext>
+            </a:extLst>
+          </p:cNvPr>
+          <p:cNvSpPr>
+            <a:spLocks noGrp="1"/>
+          </p:cNvSpPr>
+          <p:nvPr>
+            <p:ph type="dt" sz="half" idx="10"/>
+          </p:nvPr>
+        </p:nvSpPr>
+        <p:spPr>
+          <a:xfrm>
+            <a:off x="1771427" y="4775147"/>
+            <a:ext cx="1291813" cy="273844"/>
+          </a:xfrm>
+        </p:spPr>
+        <p:txBody>
+          <a:bodyPr/>
+          <a:lstStyle/>
+          <a:p>
+            <a:fld id="{EC46D180-6558-4140-957D-A04D35F919BF}" type="datetime1">
+              <a:rPr lang="it-IT" smtClean="0"/>
+              <a:t>17/02/2026</a:t>
+            </a:fld>
+            <a:endParaRPr lang="en-US"/>
           </a:p>
         </p:txBody>
       </p:sp>
@@ -8278,44 +7980,10 @@
       </p:pic>
       <p:sp>
         <p:nvSpPr>
-          <p:cNvPr id="4" name="Date Placeholder 3">
+          <p:cNvPr id="3" name="TextBox 2">
             <a:extLst>
               <a:ext uri="{FF2B5EF4-FFF2-40B4-BE49-F238E27FC236}">
-                <a16:creationId xmlns:a16="http://schemas.microsoft.com/office/drawing/2014/main" id="{E3F17EBA-EE67-E39D-B24B-51E6B4430B34}"/>
-              </a:ext>
-            </a:extLst>
-          </p:cNvPr>
-          <p:cNvSpPr>
-            <a:spLocks noGrp="1"/>
-          </p:cNvSpPr>
-          <p:nvPr>
-            <p:ph type="dt" sz="half" idx="10"/>
-          </p:nvPr>
-        </p:nvSpPr>
-        <p:spPr>
-          <a:xfrm>
-            <a:off x="1771427" y="4775147"/>
-            <a:ext cx="1291813" cy="273844"/>
-          </a:xfrm>
-        </p:spPr>
-        <p:txBody>
-          <a:bodyPr/>
-          <a:lstStyle/>
-          <a:p>
-            <a:fld id="{B5A3235C-A5F5-CE4E-B015-39F4D75EC196}" type="datetime1">
-              <a:rPr lang="it-IT" smtClean="0"/>
-              <a:t>17/02/2026</a:t>
-            </a:fld>
-            <a:endParaRPr lang="en-US"/>
-          </a:p>
-        </p:txBody>
-      </p:sp>
-      <p:sp>
-        <p:nvSpPr>
-          <p:cNvPr id="5" name="TextBox 4">
-            <a:extLst>
-              <a:ext uri="{FF2B5EF4-FFF2-40B4-BE49-F238E27FC236}">
-                <a16:creationId xmlns:a16="http://schemas.microsoft.com/office/drawing/2014/main" id="{69BA34CF-6BBA-00F0-8C23-D1A0A4CA02B5}"/>
+                <a16:creationId xmlns:a16="http://schemas.microsoft.com/office/drawing/2014/main" id="{8F0BB32C-C6A2-82A8-490B-7538697EFCED}"/>
               </a:ext>
             </a:extLst>
           </p:cNvPr>
@@ -8324,7 +7992,7 @@
         </p:nvSpPr>
         <p:spPr>
           <a:xfrm>
-            <a:off x="1499801" y="4604556"/>
+            <a:off x="1499801" y="5009681"/>
             <a:ext cx="6144397" cy="184666"/>
           </a:xfrm>
           <a:prstGeom prst="rect">
@@ -9117,12 +8785,7 @@
             <p:ph type="dt" sz="half" idx="10"/>
           </p:nvPr>
         </p:nvSpPr>
-        <p:spPr>
-          <a:xfrm>
-            <a:off x="1984248" y="4775147"/>
-            <a:ext cx="1078992" cy="273844"/>
-          </a:xfrm>
-        </p:spPr>
+        <p:spPr/>
         <p:txBody>
           <a:bodyPr/>
           <a:lstStyle/>
@@ -9389,12 +9052,7 @@
             <p:ph type="dt" sz="half" idx="10"/>
           </p:nvPr>
         </p:nvSpPr>
-        <p:spPr>
-          <a:xfrm>
-            <a:off x="1984248" y="4775147"/>
-            <a:ext cx="1078992" cy="273844"/>
-          </a:xfrm>
-        </p:spPr>
+        <p:spPr/>
         <p:txBody>
           <a:bodyPr/>
           <a:lstStyle/>

</xml_diff>